<commit_message>
Refine poster observations, motivation, method and experimental results
</commit_message>
<xml_diff>
--- a/assets/BFT-NeurIPS2026-Poster.pptx
+++ b/assets/BFT-NeurIPS2026-Poster.pptx
@@ -2,13 +2,13 @@
 <file path=ppt/presentation.xml><?xml version="1.0" encoding="utf-8"?>
 <p:presentation xmlns:p="http://schemas.openxmlformats.org/presentationml/2006/main">
   <p:sldMasterIdLst>
-    <p:sldMasterId xmlns:r="http://schemas.openxmlformats.org/officeDocument/2006/relationships" id="2147483648" r:id="Rfd5d8f91b4f04f44"/>
+    <p:sldMasterId xmlns:r="http://schemas.openxmlformats.org/officeDocument/2006/relationships" id="2147483648" r:id="R941cc4dd03c24da4"/>
   </p:sldMasterIdLst>
   <p:notesMasterIdLst>
-    <p:notesMasterId xmlns:r="http://schemas.openxmlformats.org/officeDocument/2006/relationships" r:id="R0129cc46aa2c4d1f"/>
+    <p:notesMasterId xmlns:r="http://schemas.openxmlformats.org/officeDocument/2006/relationships" r:id="R8e7d700c2cc5485d"/>
   </p:notesMasterIdLst>
   <p:sldIdLst>
-    <p:sldId xmlns:r="http://schemas.openxmlformats.org/officeDocument/2006/relationships" id="256" r:id="R7707c90f59aa424a"/>
+    <p:sldId xmlns:r="http://schemas.openxmlformats.org/officeDocument/2006/relationships" id="256" r:id="Rec2e32ce5a4d4991"/>
   </p:sldIdLst>
   <p:sldSz cx="32918400" cy="21945600"/>
   <p:notesSz cx="6858000" cy="9144000"/>
@@ -646,7 +646,7 @@
           <a:lstStyle xmlns:a="http://schemas.openxmlformats.org/drawingml/2006/main"/>
           <a:p xmlns:a="http://schemas.openxmlformats.org/drawingml/2006/main">
             <a:r>
-              <a:t>Official template: E:/NeurIPS2026/Poster/pptTemplate.pptx. Template download folder supplied by author: https://drive.google.com/drive/u/1/folders/16tSJGJryd7NgQCBblaKxTfXLZXDIJJrt. Source canvas 36x24 inches, 3:2, three columns. Retains original slide/layout/master and original NeurIPS conference logo. Uses template Arial, title 55pt, section headings 34pt, body 21pt, image captions 13pt and links 14pt. Institutional logos limited to author-supplied Tencent and Tencent AI for Life Sciences Lab. Scientific sources: supplied camera-ready neurips_2026_arxiv.tex, original Figures 1, 2, 4, 5, https://arxiv.org/abs/2511.21075. VCWorld chart uses the three-decimal Results section values. Project QR: https://shapsider.github.io/BFT/. Concept enrichment does not directly establish epistemic ground truth; Gemini comparison not significant; RL and representation claims specific to the evaluated setup. Upload format reference: https://wiki.eventhosts.cc/en/reference/posteruploads (landscape PNG, maximum 5120x2880 pixels, at most 10 MB; thumbnail PNG, maximum 320x256 pixels, at most 5 MB; solid background).</a:t>
+              <a:t>Scientific sources: author-supplied camera-ready neurips_2026_arxiv.tex, Figure 1b and 1c crops, original Figures 2, 4, 5, https://arxiv.org/abs/2511.21075. Enrichment chart: diagnostic appendix, PMC 12.5/60.9%, CRAFT 11.2/63.8%, UltraChat 3.6/4.1%, NuminaMath 3.0/3.2% (sparse/dense). CRAFT measures expert concept spans; other corpora use biomedical entity annotations. Confidence regimes are observations, not ground-truth uncertainty labels. Equations: Section 3, numerical token example from the manuscript, masked response loss and detached weights. VCWorld: three-decimal means from the Results section, same shared recipe. Gemini comparison is not significant and exploratory. Figure 2 error bars describe eight decoding passes, not training-seed variability. Representation claims apply to evaluated tasks and do not isolate profile construction from the generating model. Official source template: https://drive.google.com/drive/u/1/folders/16tSJGJryd7NgQCBblaKxTfXLZXDIJJrt, supplied pptTemplate.pptx, 36x24 inches. Institutional logos: author-supplied Tencent and Tencent AI for Life Sciences Lab. Upload specifications: https://wiki.eventhosts.cc/en/reference/posteruploads. Project QR: https://shapsider.github.io/BFT/.</a:t>
             </a:r>
           </a:p>
         </p:txBody>
@@ -693,7 +693,7 @@
           <p:cNvPr id="11" name="Slide Number">
             <a:extLst xmlns:a="http://schemas.openxmlformats.org/drawingml/2006/main">
               <a:ext uri="{FF2B5EF4-FFF2-40B4-BE49-F238E27FC236}">
-                <a16:creationId xmlns:a16="http://schemas.microsoft.com/office/drawing/2014/main" id="{6FA209DD-D4AB-4269-90BE-08D52441223D}"/>
+                <a16:creationId xmlns:a16="http://schemas.microsoft.com/office/drawing/2014/main" id="{26482E30-1069-483B-A4B2-83F854508FF8}"/>
               </a:ext>
             </a:extLst>
           </p:cNvPr>
@@ -742,7 +742,7 @@
           <p:cNvPr id="18" name="Slide Number">
             <a:extLst xmlns:a="http://schemas.openxmlformats.org/drawingml/2006/main">
               <a:ext uri="{FF2B5EF4-FFF2-40B4-BE49-F238E27FC236}">
-                <a16:creationId xmlns:a16="http://schemas.microsoft.com/office/drawing/2014/main" id="{198B63FE-6641-4311-8B28-D0F079094568}"/>
+                <a16:creationId xmlns:a16="http://schemas.microsoft.com/office/drawing/2014/main" id="{04CDA408-B8FA-4B4B-AF1A-3508C3C942A0}"/>
               </a:ext>
             </a:extLst>
           </p:cNvPr>
@@ -798,7 +798,7 @@
           <p:cNvPr id="2" name="Title Text">
             <a:extLst xmlns:a="http://schemas.openxmlformats.org/drawingml/2006/main">
               <a:ext uri="{FF2B5EF4-FFF2-40B4-BE49-F238E27FC236}">
-                <a16:creationId xmlns:a16="http://schemas.microsoft.com/office/drawing/2014/main" id="{A32A8F2F-95D0-40B2-8ABC-C23C900AF59C}"/>
+                <a16:creationId xmlns:a16="http://schemas.microsoft.com/office/drawing/2014/main" id="{79A752D2-44E5-4623-B8EF-B73B7328C550}"/>
               </a:ext>
             </a:extLst>
           </p:cNvPr>
@@ -836,7 +836,7 @@
           <p:cNvPr id="3" name="Body Level One…">
             <a:extLst xmlns:a="http://schemas.openxmlformats.org/drawingml/2006/main">
               <a:ext uri="{FF2B5EF4-FFF2-40B4-BE49-F238E27FC236}">
-                <a16:creationId xmlns:a16="http://schemas.microsoft.com/office/drawing/2014/main" id="{AD7151F0-4B8C-4E1A-8197-EC00CEE8C2AB}"/>
+                <a16:creationId xmlns:a16="http://schemas.microsoft.com/office/drawing/2014/main" id="{913D6584-99B5-41ED-9021-E93A83E07699}"/>
               </a:ext>
             </a:extLst>
           </p:cNvPr>
@@ -906,7 +906,7 @@
           <p:cNvPr id="4" name="Slide Number">
             <a:extLst xmlns:a="http://schemas.openxmlformats.org/drawingml/2006/main">
               <a:ext uri="{FF2B5EF4-FFF2-40B4-BE49-F238E27FC236}">
-                <a16:creationId xmlns:a16="http://schemas.microsoft.com/office/drawing/2014/main" id="{93E421E0-4B59-41BE-B08F-42DC79B177E2}"/>
+                <a16:creationId xmlns:a16="http://schemas.microsoft.com/office/drawing/2014/main" id="{0E21C825-D968-42CC-8745-898FDCAA1DC4}"/>
               </a:ext>
             </a:extLst>
           </p:cNvPr>
@@ -951,8 +951,8 @@
   </p:cSld>
   <p:clrMap bg1="lt1" tx1="dk1" bg2="lt2" tx2="dk2" accent1="accent1" accent2="accent2" accent3="accent3" accent4="accent4" accent5="accent5" accent6="accent6" hlink="hlink" folHlink="folHlink"/>
   <p:sldLayoutIdLst>
-    <p:sldLayoutId xmlns:r="http://schemas.openxmlformats.org/officeDocument/2006/relationships" id="2147483649" r:id="Rda55b9a07333445c"/>
-    <p:sldLayoutId xmlns:r="http://schemas.openxmlformats.org/officeDocument/2006/relationships" id="2147483650" r:id="R2b3b6d90d1cd4f0f"/>
+    <p:sldLayoutId xmlns:r="http://schemas.openxmlformats.org/officeDocument/2006/relationships" id="2147483649" r:id="Rb0032452022e41e4"/>
+    <p:sldLayoutId xmlns:r="http://schemas.openxmlformats.org/officeDocument/2006/relationships" id="2147483650" r:id="Rc38d41dc472c4e45"/>
   </p:sldLayoutIdLst>
   <p:txStyles>
     <p:titleStyle>
@@ -1789,6 +1789,274 @@
           <c:idx val="0"/>
           <c:order val="0"/>
           <c:tx>
+            <c:v>Sparse-low</c:v>
+          </c:tx>
+          <c:spPr>
+            <a:solidFill xmlns:a="http://schemas.openxmlformats.org/drawingml/2006/main">
+              <a:srgbClr val="A5B4C0"/>
+            </a:solidFill>
+          </c:spPr>
+          <c:cat>
+            <c:strRef>
+              <c:f>'Chart Data'!$A$2:$A$5</c:f>
+              <c:strCache>
+                <c:ptCount val="4"/>
+                <c:pt idx="0">
+                  <c:v>PMC</c:v>
+                </c:pt>
+                <c:pt idx="1">
+                  <c:v>CRAFT</c:v>
+                </c:pt>
+                <c:pt idx="2">
+                  <c:v>UltraChat</c:v>
+                </c:pt>
+                <c:pt idx="3">
+                  <c:v>NuminaMath</c:v>
+                </c:pt>
+              </c:strCache>
+            </c:strRef>
+          </c:cat>
+          <c:val>
+            <c:numRef>
+              <c:f>'Chart Data'!$B$2:$B$5</c:f>
+              <c:numCache>
+                <c:formatCode>0</c:formatCode>
+                <c:ptCount val="4"/>
+                <c:pt idx="0">
+                  <c:v>12.5</c:v>
+                </c:pt>
+                <c:pt idx="1">
+                  <c:v>11.2</c:v>
+                </c:pt>
+                <c:pt idx="2">
+                  <c:v>3.6</c:v>
+                </c:pt>
+                <c:pt idx="3">
+                  <c:v>3</c:v>
+                </c:pt>
+              </c:numCache>
+            </c:numRef>
+          </c:val>
+        </c:ser>
+        <c:ser>
+          <c:idx val="1"/>
+          <c:order val="1"/>
+          <c:tx>
+            <c:v>Dense-low</c:v>
+          </c:tx>
+          <c:spPr>
+            <a:solidFill xmlns:a="http://schemas.openxmlformats.org/drawingml/2006/main">
+              <a:srgbClr val="A92C48"/>
+            </a:solidFill>
+          </c:spPr>
+          <c:cat>
+            <c:strRef>
+              <c:f>'Chart Data'!$C$2:$C$5</c:f>
+              <c:strCache>
+                <c:ptCount val="4"/>
+                <c:pt idx="0">
+                  <c:v>PMC</c:v>
+                </c:pt>
+                <c:pt idx="1">
+                  <c:v>CRAFT</c:v>
+                </c:pt>
+                <c:pt idx="2">
+                  <c:v>UltraChat</c:v>
+                </c:pt>
+                <c:pt idx="3">
+                  <c:v>NuminaMath</c:v>
+                </c:pt>
+              </c:strCache>
+            </c:strRef>
+          </c:cat>
+          <c:val>
+            <c:numRef>
+              <c:f>'Chart Data'!$D$2:$D$5</c:f>
+              <c:numCache>
+                <c:formatCode>0</c:formatCode>
+                <c:ptCount val="4"/>
+                <c:pt idx="0">
+                  <c:v>60.9</c:v>
+                </c:pt>
+                <c:pt idx="1">
+                  <c:v>63.8</c:v>
+                </c:pt>
+                <c:pt idx="2">
+                  <c:v>4.1</c:v>
+                </c:pt>
+                <c:pt idx="3">
+                  <c:v>3.2</c:v>
+                </c:pt>
+              </c:numCache>
+            </c:numRef>
+          </c:val>
+        </c:ser>
+        <c:dLbls>
+          <c:numFmt formatCode="0.0" sourceLinked="0"/>
+          <c:txPr>
+            <a:bodyPr xmlns:a="http://schemas.openxmlformats.org/drawingml/2006/main" anchorCtr="1"/>
+            <a:lstStyle xmlns:a="http://schemas.openxmlformats.org/drawingml/2006/main"/>
+            <a:p xmlns:a="http://schemas.openxmlformats.org/drawingml/2006/main">
+              <a:pPr>
+                <a:defRPr sz="1500">
+                  <a:solidFill>
+                    <a:srgbClr val="344854"/>
+                  </a:solidFill>
+                  <a:latin typeface="Arial"/>
+                  <a:ea typeface="Arial"/>
+                  <a:cs typeface="Arial"/>
+                </a:defRPr>
+              </a:pPr>
+            </a:p>
+          </c:txPr>
+          <c:dLblPos val="outEnd"/>
+          <c:showLegendKey val="0"/>
+          <c:showVal val="1"/>
+          <c:showCatName val="0"/>
+          <c:showSerName val="0"/>
+          <c:showPercent val="0"/>
+          <c:showBubbleSize val="0"/>
+          <c:showLeaderLines val="0"/>
+        </c:dLbls>
+        <c:gapWidth val="90"/>
+        <c:axId val="48650112"/>
+        <c:axId val="48672768"/>
+      </c:barChart>
+      <c:catAx>
+        <c:axId val="48650112"/>
+        <c:scaling>
+          <c:orientation val="minMax"/>
+        </c:scaling>
+        <c:delete val="0"/>
+        <c:axPos val="b"/>
+        <c:numFmt formatCode="General"/>
+        <c:majorTickMark val="none"/>
+        <c:minorTickMark val="none"/>
+        <c:spPr>
+          <a:ln xmlns:a="http://schemas.openxmlformats.org/drawingml/2006/main" w="9525">
+            <a:solidFill>
+              <a:srgbClr val="D4D4D4"/>
+            </a:solidFill>
+            <a:prstDash val="solid"/>
+          </a:ln>
+        </c:spPr>
+        <c:txPr>
+          <a:bodyPr xmlns:a="http://schemas.openxmlformats.org/drawingml/2006/main" anchorCtr="1"/>
+          <a:lstStyle xmlns:a="http://schemas.openxmlformats.org/drawingml/2006/main"/>
+          <a:p xmlns:a="http://schemas.openxmlformats.org/drawingml/2006/main">
+            <a:pPr>
+              <a:defRPr sz="1600">
+                <a:solidFill>
+                  <a:srgbClr val="344854"/>
+                </a:solidFill>
+                <a:latin typeface="Arial"/>
+                <a:ea typeface="Arial"/>
+                <a:cs typeface="Arial"/>
+              </a:defRPr>
+            </a:pPr>
+          </a:p>
+        </c:txPr>
+        <c:crossAx val="48672768"/>
+      </c:catAx>
+      <c:valAx>
+        <c:axId val="48672768"/>
+        <c:scaling>
+          <c:orientation val="minMax"/>
+        </c:scaling>
+        <c:delete val="0"/>
+        <c:axPos val="l"/>
+        <c:majorGridlines>
+          <c:spPr>
+            <a:ln xmlns:a="http://schemas.openxmlformats.org/drawingml/2006/main" w="9525">
+              <a:solidFill>
+                <a:srgbClr val="CCD1D4"/>
+              </a:solidFill>
+            </a:ln>
+          </c:spPr>
+        </c:majorGridlines>
+        <c:numFmt formatCode="0"/>
+        <c:majorTickMark val="none"/>
+        <c:minorTickMark val="none"/>
+        <c:spPr>
+          <a:ln xmlns:a="http://schemas.openxmlformats.org/drawingml/2006/main" w="9525">
+            <a:solidFill>
+              <a:srgbClr val="D4D4D4"/>
+            </a:solidFill>
+            <a:prstDash val="solid"/>
+          </a:ln>
+        </c:spPr>
+        <c:txPr>
+          <a:bodyPr xmlns:a="http://schemas.openxmlformats.org/drawingml/2006/main" anchorCtr="1"/>
+          <a:lstStyle xmlns:a="http://schemas.openxmlformats.org/drawingml/2006/main"/>
+          <a:p xmlns:a="http://schemas.openxmlformats.org/drawingml/2006/main">
+            <a:pPr>
+              <a:defRPr sz="1500">
+                <a:solidFill>
+                  <a:srgbClr val="344854"/>
+                </a:solidFill>
+                <a:latin typeface="Arial"/>
+                <a:ea typeface="Arial"/>
+                <a:cs typeface="Arial"/>
+              </a:defRPr>
+            </a:pPr>
+          </a:p>
+        </c:txPr>
+        <c:crossAx val="48650112"/>
+        <c:crossBetween val="between"/>
+        <c:majorUnit val="20"/>
+      </c:valAx>
+      <c:spPr>
+        <a:solidFill xmlns:a="http://schemas.openxmlformats.org/drawingml/2006/main">
+          <a:srgbClr val="FFFFFF"/>
+        </a:solidFill>
+      </c:spPr>
+    </c:plotArea>
+    <c:legend>
+      <c:legendPos val="b"/>
+      <c:overlay val="0"/>
+      <c:txPr>
+        <a:bodyPr xmlns:a="http://schemas.openxmlformats.org/drawingml/2006/main" anchorCtr="1"/>
+        <a:lstStyle xmlns:a="http://schemas.openxmlformats.org/drawingml/2006/main"/>
+        <a:p xmlns:a="http://schemas.openxmlformats.org/drawingml/2006/main">
+          <a:pPr>
+            <a:defRPr sz="1600">
+              <a:solidFill>
+                <a:srgbClr val="344854"/>
+              </a:solidFill>
+              <a:latin typeface="Arial"/>
+              <a:ea typeface="Arial"/>
+              <a:cs typeface="Arial"/>
+            </a:defRPr>
+          </a:pPr>
+        </a:p>
+      </c:txPr>
+    </c:legend>
+    <c:plotVisOnly val="1"/>
+  </c:chart>
+  <c:spPr>
+    <a:solidFill xmlns:a="http://schemas.openxmlformats.org/drawingml/2006/main">
+      <a:srgbClr val="FFFFFF"/>
+    </a:solidFill>
+  </c:spPr>
+  <c:externalData r:id="rIdChartSnapshot1">
+    <c:autoUpdate val="0"/>
+  </c:externalData>
+</c:chartSpace>
+</file>
+
+<file path=ppt/slides/charts/chart2.xml><?xml version="1.0" encoding="utf-8"?>
+<c:chartSpace xmlns:c="http://schemas.openxmlformats.org/drawingml/2006/chart" xmlns:r="http://schemas.openxmlformats.org/officeDocument/2006/relationships">
+  <c:lang val="en-US"/>
+  <c:chart>
+    <c:plotArea>
+      <c:barChart>
+        <c:barDir val="col"/>
+        <c:grouping val="clustered"/>
+        <c:varyColors val="0"/>
+        <c:ser>
+          <c:idx val="0"/>
+          <c:order val="0"/>
+          <c:tx>
             <c:v>Before GRPO</c:v>
           </c:tx>
           <c:spPr>
@@ -1852,7 +2120,7 @@
           </c:tx>
           <c:spPr>
             <a:solidFill xmlns:a="http://schemas.openxmlformats.org/drawingml/2006/main">
-              <a:srgbClr val="344854"/>
+              <a:srgbClr val="0054B8"/>
             </a:solidFill>
           </c:spPr>
           <c:cat>
@@ -2056,6 +2324,298 @@
 </c:chartSpace>
 </file>
 
+<file path=ppt/slides/charts/chart3.xml><?xml version="1.0" encoding="utf-8"?>
+<c:chartSpace xmlns:c="http://schemas.openxmlformats.org/drawingml/2006/chart" xmlns:r="http://schemas.openxmlformats.org/officeDocument/2006/relationships">
+  <c:lang val="en-US"/>
+  <c:chart>
+    <c:plotArea>
+      <c:barChart>
+        <c:barDir val="col"/>
+        <c:grouping val="clustered"/>
+        <c:varyColors val="0"/>
+        <c:ser>
+          <c:idx val="0"/>
+          <c:order val="0"/>
+          <c:tx>
+            <c:v>GenePT</c:v>
+          </c:tx>
+          <c:spPr>
+            <a:solidFill xmlns:a="http://schemas.openxmlformats.org/drawingml/2006/main">
+              <a:srgbClr val="A5B4C0"/>
+            </a:solidFill>
+          </c:spPr>
+          <c:cat>
+            <c:strRef>
+              <c:f>'Chart Data'!$A$2:$A$7</c:f>
+              <c:strCache>
+                <c:ptCount val="6"/>
+                <c:pt idx="0">
+                  <c:v>TF range</c:v>
+                </c:pt>
+                <c:pt idx="1">
+                  <c:v>Dosage</c:v>
+                </c:pt>
+                <c:pt idx="2">
+                  <c:v>No-methy</c:v>
+                </c:pt>
+                <c:pt idx="3">
+                  <c:v>Lys4</c:v>
+                </c:pt>
+                <c:pt idx="4">
+                  <c:v>GGI</c:v>
+                </c:pt>
+                <c:pt idx="5">
+                  <c:v>PPI</c:v>
+                </c:pt>
+              </c:strCache>
+            </c:strRef>
+          </c:cat>
+          <c:val>
+            <c:numRef>
+              <c:f>'Chart Data'!$B$2:$B$7</c:f>
+              <c:numCache>
+                <c:formatCode>0.0</c:formatCode>
+                <c:ptCount val="6"/>
+                <c:pt idx="0">
+                  <c:v>0.585</c:v>
+                </c:pt>
+                <c:pt idx="1">
+                  <c:v>0.891</c:v>
+                </c:pt>
+                <c:pt idx="2">
+                  <c:v>0.91</c:v>
+                </c:pt>
+                <c:pt idx="3">
+                  <c:v>0.939</c:v>
+                </c:pt>
+                <c:pt idx="4">
+                  <c:v>0.806</c:v>
+                </c:pt>
+                <c:pt idx="5">
+                  <c:v>0.681</c:v>
+                </c:pt>
+              </c:numCache>
+            </c:numRef>
+          </c:val>
+        </c:ser>
+        <c:ser>
+          <c:idx val="1"/>
+          <c:order val="1"/>
+          <c:tx>
+            <c:v>BFT</c:v>
+          </c:tx>
+          <c:spPr>
+            <a:solidFill xmlns:a="http://schemas.openxmlformats.org/drawingml/2006/main">
+              <a:srgbClr val="0054B8"/>
+            </a:solidFill>
+          </c:spPr>
+          <c:cat>
+            <c:strRef>
+              <c:f>'Chart Data'!$C$2:$C$7</c:f>
+              <c:strCache>
+                <c:ptCount val="6"/>
+                <c:pt idx="0">
+                  <c:v>TF range</c:v>
+                </c:pt>
+                <c:pt idx="1">
+                  <c:v>Dosage</c:v>
+                </c:pt>
+                <c:pt idx="2">
+                  <c:v>No-methy</c:v>
+                </c:pt>
+                <c:pt idx="3">
+                  <c:v>Lys4</c:v>
+                </c:pt>
+                <c:pt idx="4">
+                  <c:v>GGI</c:v>
+                </c:pt>
+                <c:pt idx="5">
+                  <c:v>PPI</c:v>
+                </c:pt>
+              </c:strCache>
+            </c:strRef>
+          </c:cat>
+          <c:val>
+            <c:numRef>
+              <c:f>'Chart Data'!$D$2:$D$7</c:f>
+              <c:numCache>
+                <c:formatCode>0.0</c:formatCode>
+                <c:ptCount val="6"/>
+                <c:pt idx="0">
+                  <c:v>0.629</c:v>
+                </c:pt>
+                <c:pt idx="1">
+                  <c:v>0.913</c:v>
+                </c:pt>
+                <c:pt idx="2">
+                  <c:v>0.927</c:v>
+                </c:pt>
+                <c:pt idx="3">
+                  <c:v>0.91</c:v>
+                </c:pt>
+                <c:pt idx="4">
+                  <c:v>0.823</c:v>
+                </c:pt>
+                <c:pt idx="5">
+                  <c:v>0.769</c:v>
+                </c:pt>
+              </c:numCache>
+            </c:numRef>
+          </c:val>
+        </c:ser>
+        <c:dLbls>
+          <c:numFmt formatCode="0.000" sourceLinked="0"/>
+          <c:txPr>
+            <a:bodyPr xmlns:a="http://schemas.openxmlformats.org/drawingml/2006/main" anchorCtr="1"/>
+            <a:lstStyle xmlns:a="http://schemas.openxmlformats.org/drawingml/2006/main"/>
+            <a:p xmlns:a="http://schemas.openxmlformats.org/drawingml/2006/main">
+              <a:pPr>
+                <a:defRPr sz="1300">
+                  <a:solidFill>
+                    <a:srgbClr val="344854"/>
+                  </a:solidFill>
+                  <a:latin typeface="Arial"/>
+                  <a:ea typeface="Arial"/>
+                  <a:cs typeface="Arial"/>
+                </a:defRPr>
+              </a:pPr>
+            </a:p>
+          </c:txPr>
+          <c:dLblPos val="outEnd"/>
+          <c:showLegendKey val="0"/>
+          <c:showVal val="1"/>
+          <c:showCatName val="0"/>
+          <c:showSerName val="0"/>
+          <c:showPercent val="0"/>
+          <c:showBubbleSize val="0"/>
+          <c:showLeaderLines val="0"/>
+        </c:dLbls>
+        <c:gapWidth val="90"/>
+        <c:axId val="48650112"/>
+        <c:axId val="48672768"/>
+      </c:barChart>
+      <c:catAx>
+        <c:axId val="48650112"/>
+        <c:scaling>
+          <c:orientation val="minMax"/>
+        </c:scaling>
+        <c:delete val="0"/>
+        <c:axPos val="b"/>
+        <c:numFmt formatCode="General"/>
+        <c:majorTickMark val="none"/>
+        <c:minorTickMark val="none"/>
+        <c:spPr>
+          <a:ln xmlns:a="http://schemas.openxmlformats.org/drawingml/2006/main" w="9525">
+            <a:solidFill>
+              <a:srgbClr val="D4D4D4"/>
+            </a:solidFill>
+            <a:prstDash val="solid"/>
+          </a:ln>
+        </c:spPr>
+        <c:txPr>
+          <a:bodyPr xmlns:a="http://schemas.openxmlformats.org/drawingml/2006/main" anchorCtr="1"/>
+          <a:lstStyle xmlns:a="http://schemas.openxmlformats.org/drawingml/2006/main"/>
+          <a:p xmlns:a="http://schemas.openxmlformats.org/drawingml/2006/main">
+            <a:pPr>
+              <a:defRPr sz="1500">
+                <a:solidFill>
+                  <a:srgbClr val="344854"/>
+                </a:solidFill>
+                <a:latin typeface="Arial"/>
+                <a:ea typeface="Arial"/>
+                <a:cs typeface="Arial"/>
+              </a:defRPr>
+            </a:pPr>
+          </a:p>
+        </c:txPr>
+        <c:crossAx val="48672768"/>
+      </c:catAx>
+      <c:valAx>
+        <c:axId val="48672768"/>
+        <c:scaling>
+          <c:orientation val="minMax"/>
+        </c:scaling>
+        <c:delete val="0"/>
+        <c:axPos val="l"/>
+        <c:majorGridlines>
+          <c:spPr>
+            <a:ln xmlns:a="http://schemas.openxmlformats.org/drawingml/2006/main" w="9525">
+              <a:solidFill>
+                <a:srgbClr val="CCD1D4"/>
+              </a:solidFill>
+            </a:ln>
+          </c:spPr>
+        </c:majorGridlines>
+        <c:numFmt formatCode="0.0"/>
+        <c:majorTickMark val="none"/>
+        <c:minorTickMark val="none"/>
+        <c:spPr>
+          <a:ln xmlns:a="http://schemas.openxmlformats.org/drawingml/2006/main" w="9525">
+            <a:solidFill>
+              <a:srgbClr val="D4D4D4"/>
+            </a:solidFill>
+            <a:prstDash val="solid"/>
+          </a:ln>
+        </c:spPr>
+        <c:txPr>
+          <a:bodyPr xmlns:a="http://schemas.openxmlformats.org/drawingml/2006/main" anchorCtr="1"/>
+          <a:lstStyle xmlns:a="http://schemas.openxmlformats.org/drawingml/2006/main"/>
+          <a:p xmlns:a="http://schemas.openxmlformats.org/drawingml/2006/main">
+            <a:pPr>
+              <a:defRPr sz="1500">
+                <a:solidFill>
+                  <a:srgbClr val="344854"/>
+                </a:solidFill>
+                <a:latin typeface="Arial"/>
+                <a:ea typeface="Arial"/>
+                <a:cs typeface="Arial"/>
+              </a:defRPr>
+            </a:pPr>
+          </a:p>
+        </c:txPr>
+        <c:crossAx val="48650112"/>
+        <c:crossBetween val="between"/>
+        <c:majorUnit val="0.5"/>
+      </c:valAx>
+      <c:spPr>
+        <a:solidFill xmlns:a="http://schemas.openxmlformats.org/drawingml/2006/main">
+          <a:srgbClr val="FFFFFF"/>
+        </a:solidFill>
+      </c:spPr>
+    </c:plotArea>
+    <c:legend>
+      <c:legendPos val="b"/>
+      <c:overlay val="0"/>
+      <c:txPr>
+        <a:bodyPr xmlns:a="http://schemas.openxmlformats.org/drawingml/2006/main" anchorCtr="1"/>
+        <a:lstStyle xmlns:a="http://schemas.openxmlformats.org/drawingml/2006/main"/>
+        <a:p xmlns:a="http://schemas.openxmlformats.org/drawingml/2006/main">
+          <a:pPr>
+            <a:defRPr sz="1600">
+              <a:solidFill>
+                <a:srgbClr val="344854"/>
+              </a:solidFill>
+              <a:latin typeface="Arial"/>
+              <a:ea typeface="Arial"/>
+              <a:cs typeface="Arial"/>
+            </a:defRPr>
+          </a:pPr>
+        </a:p>
+      </c:txPr>
+    </c:legend>
+    <c:plotVisOnly val="1"/>
+  </c:chart>
+  <c:spPr>
+    <a:solidFill xmlns:a="http://schemas.openxmlformats.org/drawingml/2006/main">
+      <a:srgbClr val="FFFFFF"/>
+    </a:solidFill>
+  </c:spPr>
+  <c:externalData r:id="rIdChartSnapshot1">
+    <c:autoUpdate val="0"/>
+  </c:externalData>
+</c:chartSpace>
+</file>
+
 <file path=ppt/slides/slide1.xml><?xml version="1.0" encoding="utf-8"?>
 <p:sld xmlns:p="http://schemas.openxmlformats.org/presentationml/2006/main">
   <p:cSld>
@@ -2073,7 +2633,7 @@
           <p:cNvPr id="30" name="TextBox 35">
             <a:extLst xmlns:a="http://schemas.openxmlformats.org/drawingml/2006/main">
               <a:ext uri="{FF2B5EF4-FFF2-40B4-BE49-F238E27FC236}">
-                <a16:creationId xmlns:a16="http://schemas.microsoft.com/office/drawing/2014/main" id="{40B7D0CF-251D-4090-A4CA-39EC49B241F5}"/>
+                <a16:creationId xmlns:a16="http://schemas.microsoft.com/office/drawing/2014/main" id="{10724BFF-27E0-406D-AA3F-A461E6854D24}"/>
               </a:ext>
             </a:extLst>
           </p:cNvPr>
@@ -2084,7 +2644,7 @@
         </p:nvSpPr>
         <p:spPr>
           <a:xfrm xmlns:a="http://schemas.openxmlformats.org/drawingml/2006/main">
-            <a:off x="971550" y="781050"/>
+            <a:off x="971550" y="685800"/>
             <a:ext cx="25050750" cy="1767840"/>
           </a:xfrm>
           <a:prstGeom xmlns:a="http://schemas.openxmlformats.org/drawingml/2006/main" prst="rect">
@@ -2172,7 +2732,7 @@
           <p:cNvPr id="33" name="TextBox 38">
             <a:extLst xmlns:a="http://schemas.openxmlformats.org/drawingml/2006/main">
               <a:ext uri="{FF2B5EF4-FFF2-40B4-BE49-F238E27FC236}">
-                <a16:creationId xmlns:a16="http://schemas.microsoft.com/office/drawing/2014/main" id="{BE55CB70-C42B-4953-BE22-C7D7051F00AC}"/>
+                <a16:creationId xmlns:a16="http://schemas.microsoft.com/office/drawing/2014/main" id="{DC669000-1602-431C-9A30-9DA4228B5D97}"/>
               </a:ext>
             </a:extLst>
           </p:cNvPr>
@@ -2183,7 +2743,7 @@
         </p:nvSpPr>
         <p:spPr>
           <a:xfrm xmlns:a="http://schemas.openxmlformats.org/drawingml/2006/main">
-            <a:off x="990600" y="5381625"/>
+            <a:off x="990600" y="5238750"/>
             <a:ext cx="9048750" cy="609600"/>
           </a:xfrm>
           <a:prstGeom xmlns:a="http://schemas.openxmlformats.org/drawingml/2006/main" prst="rect">
@@ -2200,9 +2760,9 @@
           </a:bodyPr>
           <a:lstStyle xmlns:a="http://schemas.openxmlformats.org/drawingml/2006/main">
             <a:defPPr algn="l">
-              <a:defRPr sz="3400" b="0">
-                <a:solidFill>
-                  <a:srgbClr val="000000"/>
+              <a:defRPr sz="3400" b="1">
+                <a:solidFill>
+                  <a:srgbClr val="0054B8"/>
                 </a:solidFill>
                 <a:latin typeface="Arial"/>
                 <a:ea typeface="Arial"/>
@@ -2220,9 +2780,9 @@
           </a:lstStyle>
           <a:p xmlns:a="http://schemas.openxmlformats.org/drawingml/2006/main">
             <a:pPr algn="l">
-              <a:defRPr sz="3400" b="0">
-                <a:solidFill>
-                  <a:srgbClr val="000000"/>
+              <a:defRPr sz="3400" b="1">
+                <a:solidFill>
+                  <a:srgbClr val="0054B8"/>
                 </a:solidFill>
                 <a:latin typeface="Arial"/>
                 <a:ea typeface="Arial"/>
@@ -2230,15 +2790,15 @@
               </a:defRPr>
             </a:pPr>
             <a:r>
-              <a:rPr sz="3400" b="0">
-                <a:solidFill>
-                  <a:srgbClr val="000000"/>
+              <a:rPr sz="3400" b="1">
+                <a:solidFill>
+                  <a:srgbClr val="0054B8"/>
                 </a:solidFill>
                 <a:latin typeface="Arial"/>
                 <a:ea typeface="Arial"/>
                 <a:cs typeface="Arial"/>
               </a:rPr>
-              <a:t>Why local confidence matters</a:t>
+              <a:t>01  Experimental observations</a:t>
             </a:r>
           </a:p>
         </p:txBody>
@@ -2248,7 +2808,7 @@
           <p:cNvPr id="34" name="TextBox 39">
             <a:extLst xmlns:a="http://schemas.openxmlformats.org/drawingml/2006/main">
               <a:ext uri="{FF2B5EF4-FFF2-40B4-BE49-F238E27FC236}">
-                <a16:creationId xmlns:a16="http://schemas.microsoft.com/office/drawing/2014/main" id="{9E84B08C-94AE-4509-A1F1-7FB65212F426}"/>
+                <a16:creationId xmlns:a16="http://schemas.microsoft.com/office/drawing/2014/main" id="{D6BA9FF7-ECD5-4E78-BA37-14563517F210}"/>
               </a:ext>
             </a:extLst>
           </p:cNvPr>
@@ -2259,8 +2819,8 @@
         </p:nvSpPr>
         <p:spPr>
           <a:xfrm xmlns:a="http://schemas.openxmlformats.org/drawingml/2006/main">
-            <a:off x="990600" y="6572250"/>
-            <a:ext cx="9048750" cy="1243584"/>
+            <a:off x="990600" y="6048375"/>
+            <a:ext cx="9048750" cy="859536"/>
           </a:xfrm>
           <a:prstGeom xmlns:a="http://schemas.openxmlformats.org/drawingml/2006/main" prst="rect">
             <a:avLst/>
@@ -2320,17 +2880,17 @@
                 <a:ea typeface="Arial"/>
                 <a:cs typeface="Arial"/>
               </a:rPr>
-              <a:t>Dense low-confidence runs in biomedical text are enriched for rare entities and mechanistic steps. DFT weights every token by absolute confidence and can suppress these knowledge-bearing regions.</a:t>
+              <a:t>Teacher-forced PMC text reveals two regimes: isolated low-confidence tokens and contiguous difficult regions (g = 256).</a:t>
             </a:r>
           </a:p>
         </p:txBody>
       </p:sp>
       <p:sp>
         <p:nvSpPr>
-          <p:cNvPr id="35" name="TextBox 41">
+          <p:cNvPr id="37" name="TextBox 43">
             <a:extLst xmlns:a="http://schemas.openxmlformats.org/drawingml/2006/main">
               <a:ext uri="{FF2B5EF4-FFF2-40B4-BE49-F238E27FC236}">
-                <a16:creationId xmlns:a16="http://schemas.microsoft.com/office/drawing/2014/main" id="{EB4E91F4-8113-45C5-9C47-64DD40D7CAB1}"/>
+                <a16:creationId xmlns:a16="http://schemas.microsoft.com/office/drawing/2014/main" id="{6A0FE544-C6BE-438D-9C78-DB76D5464C57}"/>
               </a:ext>
             </a:extLst>
           </p:cNvPr>
@@ -2341,89 +2901,7 @@
         </p:nvSpPr>
         <p:spPr>
           <a:xfrm xmlns:a="http://schemas.openxmlformats.org/drawingml/2006/main">
-            <a:off x="11877675" y="13335000"/>
-            <a:ext cx="9048750" cy="1243584"/>
-          </a:xfrm>
-          <a:prstGeom xmlns:a="http://schemas.openxmlformats.org/drawingml/2006/main" prst="rect">
-            <a:avLst/>
-          </a:prstGeom>
-          <a:noFill xmlns:a="http://schemas.openxmlformats.org/drawingml/2006/main"/>
-          <a:ln xmlns:a="http://schemas.openxmlformats.org/drawingml/2006/main" w="0">
-            <a:noFill/>
-          </a:ln>
-        </p:spPr>
-        <p:txBody>
-          <a:bodyPr xmlns:a="http://schemas.openxmlformats.org/drawingml/2006/main" wrap="square" lIns="0" tIns="0" rIns="0" bIns="0" anchor="t">
-            <a:noAutofit/>
-          </a:bodyPr>
-          <a:lstStyle xmlns:a="http://schemas.openxmlformats.org/drawingml/2006/main">
-            <a:defPPr algn="l">
-              <a:defRPr sz="2100" b="0">
-                <a:solidFill>
-                  <a:srgbClr val="344854"/>
-                </a:solidFill>
-                <a:latin typeface="Arial"/>
-                <a:ea typeface="Arial"/>
-                <a:cs typeface="Arial"/>
-              </a:defRPr>
-            </a:defPPr>
-            <a:lvl1pPr>
-              <a:lnSpc>
-                <a:spcPct val="120000"/>
-              </a:lnSpc>
-              <a:buNone/>
-              <a:defRPr sz="2100">
-                <a:solidFill>
-                  <a:srgbClr val="344854"/>
-                </a:solidFill>
-                <a:latin typeface="Arial"/>
-                <a:ea typeface="Arial"/>
-                <a:cs typeface="Arial"/>
-              </a:defRPr>
-            </a:lvl1pPr>
-          </a:lstStyle>
-          <a:p xmlns:a="http://schemas.openxmlformats.org/drawingml/2006/main">
-            <a:pPr algn="l">
-              <a:defRPr sz="2100" b="0">
-                <a:solidFill>
-                  <a:srgbClr val="344854"/>
-                </a:solidFill>
-                <a:latin typeface="Arial"/>
-                <a:ea typeface="Arial"/>
-                <a:cs typeface="Arial"/>
-              </a:defRPr>
-            </a:pPr>
-            <a:r>
-              <a:rPr sz="2100" b="0">
-                <a:solidFill>
-                  <a:srgbClr val="344854"/>
-                </a:solidFill>
-                <a:latin typeface="Arial"/>
-                <a:ea typeface="Arial"/>
-                <a:cs typeface="Arial"/>
-              </a:rPr>
-              <a:t>BFT improves from 0.696 to 0.736 (+4.0 pp) after GRPO, while SFT and DFT decline. Before GRPO, BFT exceeds SFT by 13.4 pp. Its difference from Gemini-2.5-Flash is not significant (p = 0.088).</a:t>
-            </a:r>
-          </a:p>
-        </p:txBody>
-      </p:sp>
-      <p:sp>
-        <p:nvSpPr>
-          <p:cNvPr id="37" name="TextBox 43">
-            <a:extLst xmlns:a="http://schemas.openxmlformats.org/drawingml/2006/main">
-              <a:ext uri="{FF2B5EF4-FFF2-40B4-BE49-F238E27FC236}">
-                <a16:creationId xmlns:a16="http://schemas.microsoft.com/office/drawing/2014/main" id="{9287DCD3-128B-462E-B480-311E5B39230A}"/>
-              </a:ext>
-            </a:extLst>
-          </p:cNvPr>
-          <p:cNvSpPr>
-            <a:spLocks xmlns:a="http://schemas.openxmlformats.org/drawingml/2006/main" noGrp="1"/>
-          </p:cNvSpPr>
-          <p:nvPr/>
-        </p:nvSpPr>
-        <p:spPr>
-          <a:xfrm xmlns:a="http://schemas.openxmlformats.org/drawingml/2006/main">
-            <a:off x="11877675" y="5381625"/>
+            <a:off x="11877675" y="5238750"/>
             <a:ext cx="9048750" cy="609600"/>
           </a:xfrm>
           <a:prstGeom xmlns:a="http://schemas.openxmlformats.org/drawingml/2006/main" prst="rect">
@@ -2440,9 +2918,9 @@
           </a:bodyPr>
           <a:lstStyle xmlns:a="http://schemas.openxmlformats.org/drawingml/2006/main">
             <a:defPPr algn="l">
-              <a:defRPr sz="3400" b="0">
-                <a:solidFill>
-                  <a:srgbClr val="000000"/>
+              <a:defRPr sz="3400" b="1">
+                <a:solidFill>
+                  <a:srgbClr val="0054B8"/>
                 </a:solidFill>
                 <a:latin typeface="Arial"/>
                 <a:ea typeface="Arial"/>
@@ -2460,9 +2938,9 @@
           </a:lstStyle>
           <a:p xmlns:a="http://schemas.openxmlformats.org/drawingml/2006/main">
             <a:pPr algn="l">
-              <a:defRPr sz="3400" b="0">
-                <a:solidFill>
-                  <a:srgbClr val="000000"/>
+              <a:defRPr sz="3400" b="1">
+                <a:solidFill>
+                  <a:srgbClr val="0054B8"/>
                 </a:solidFill>
                 <a:latin typeface="Arial"/>
                 <a:ea typeface="Arial"/>
@@ -2470,15 +2948,15 @@
               </a:defRPr>
             </a:pPr>
             <a:r>
-              <a:rPr sz="3400" b="0">
-                <a:solidFill>
-                  <a:srgbClr val="000000"/>
+              <a:rPr sz="3400" b="1">
+                <a:solidFill>
+                  <a:srgbClr val="0054B8"/>
                 </a:solidFill>
                 <a:latin typeface="Arial"/>
                 <a:ea typeface="Arial"/>
                 <a:cs typeface="Arial"/>
               </a:rPr>
-              <a:t>Biomedical reasoning and sparse-reward RL</a:t>
+              <a:t>03  Balanced Fine-Tuning</a:t>
             </a:r>
           </a:p>
         </p:txBody>
@@ -2488,7 +2966,7 @@
           <p:cNvPr id="38" name="TextBox 44">
             <a:extLst xmlns:a="http://schemas.openxmlformats.org/drawingml/2006/main">
               <a:ext uri="{FF2B5EF4-FFF2-40B4-BE49-F238E27FC236}">
-                <a16:creationId xmlns:a16="http://schemas.microsoft.com/office/drawing/2014/main" id="{E2EC2FF0-10F2-4846-B174-CCE466BB9150}"/>
+                <a16:creationId xmlns:a16="http://schemas.microsoft.com/office/drawing/2014/main" id="{453B691E-4F3E-4942-8CD2-958EF67DA7F1}"/>
               </a:ext>
             </a:extLst>
           </p:cNvPr>
@@ -2499,7 +2977,7 @@
         </p:nvSpPr>
         <p:spPr>
           <a:xfrm xmlns:a="http://schemas.openxmlformats.org/drawingml/2006/main">
-            <a:off x="11877675" y="6715125"/>
+            <a:off x="11877675" y="6048375"/>
             <a:ext cx="9048750" cy="731520"/>
           </a:xfrm>
           <a:prstGeom xmlns:a="http://schemas.openxmlformats.org/drawingml/2006/main" prst="rect">
@@ -2518,7 +2996,7 @@
             <a:defPPr algn="l">
               <a:defRPr sz="2100" b="0">
                 <a:solidFill>
-                  <a:srgbClr val="000000"/>
+                  <a:srgbClr val="344854"/>
                 </a:solidFill>
                 <a:latin typeface="Arial"/>
                 <a:ea typeface="Arial"/>
@@ -2538,7 +3016,7 @@
             <a:pPr algn="l">
               <a:defRPr sz="2100" b="0">
                 <a:solidFill>
-                  <a:srgbClr val="000000"/>
+                  <a:srgbClr val="344854"/>
                 </a:solidFill>
                 <a:latin typeface="Arial"/>
                 <a:ea typeface="Arial"/>
@@ -2548,36 +3026,13 @@
             <a:r>
               <a:rPr sz="2100" b="0">
                 <a:solidFill>
-                  <a:srgbClr val="000000"/>
+                  <a:srgbClr val="344854"/>
                 </a:solidFill>
                 <a:latin typeface="Arial"/>
                 <a:ea typeface="Arial"/>
                 <a:cs typeface="Arial"/>
               </a:rPr>
-              <a:t>VCWorld accuracy, 70B backbones</a:t>
-            </a:r>
-          </a:p>
-          <a:p xmlns:a="http://schemas.openxmlformats.org/drawingml/2006/main">
-            <a:pPr algn="l">
-              <a:defRPr sz="2100" b="0">
-                <a:solidFill>
-                  <a:srgbClr val="000000"/>
-                </a:solidFill>
-                <a:latin typeface="Arial"/>
-                <a:ea typeface="Arial"/>
-                <a:cs typeface="Arial"/>
-              </a:defRPr>
-            </a:pPr>
-            <a:r>
-              <a:rPr sz="2100" b="0">
-                <a:solidFill>
-                  <a:srgbClr val="000000"/>
-                </a:solidFill>
-                <a:latin typeface="Arial"/>
-                <a:ea typeface="Arial"/>
-                <a:cs typeface="Arial"/>
-              </a:rPr>
-              <a:t>Shared GRPO setup, five held-out cell lines</a:t>
+              <a:t>One local confidence signal allocates training budget within each response and across responses.</a:t>
             </a:r>
           </a:p>
         </p:txBody>
@@ -2587,7 +3042,7 @@
           <p:cNvPr id="39" name="TextBox 45">
             <a:extLst xmlns:a="http://schemas.openxmlformats.org/drawingml/2006/main">
               <a:ext uri="{FF2B5EF4-FFF2-40B4-BE49-F238E27FC236}">
-                <a16:creationId xmlns:a16="http://schemas.microsoft.com/office/drawing/2014/main" id="{77C29B18-806C-4742-803C-C964266085AB}"/>
+                <a16:creationId xmlns:a16="http://schemas.microsoft.com/office/drawing/2014/main" id="{6D6E17A8-0143-4D1A-B8D6-4066E25D9922}"/>
               </a:ext>
             </a:extLst>
           </p:cNvPr>
@@ -2598,7 +3053,7 @@
         </p:nvSpPr>
         <p:spPr>
           <a:xfrm xmlns:a="http://schemas.openxmlformats.org/drawingml/2006/main">
-            <a:off x="990600" y="16097250"/>
+            <a:off x="990600" y="13716000"/>
             <a:ext cx="9048750" cy="609600"/>
           </a:xfrm>
           <a:prstGeom xmlns:a="http://schemas.openxmlformats.org/drawingml/2006/main" prst="rect">
@@ -2615,9 +3070,9 @@
           </a:bodyPr>
           <a:lstStyle xmlns:a="http://schemas.openxmlformats.org/drawingml/2006/main">
             <a:defPPr algn="l">
-              <a:defRPr sz="3400" b="0">
-                <a:solidFill>
-                  <a:srgbClr val="000000"/>
+              <a:defRPr sz="3400" b="1">
+                <a:solidFill>
+                  <a:srgbClr val="0054B8"/>
                 </a:solidFill>
                 <a:latin typeface="Arial"/>
                 <a:ea typeface="Arial"/>
@@ -2635,9 +3090,9 @@
           </a:lstStyle>
           <a:p xmlns:a="http://schemas.openxmlformats.org/drawingml/2006/main">
             <a:pPr algn="l">
-              <a:defRPr sz="3400" b="0">
-                <a:solidFill>
-                  <a:srgbClr val="000000"/>
+              <a:defRPr sz="3400" b="1">
+                <a:solidFill>
+                  <a:srgbClr val="0054B8"/>
                 </a:solidFill>
                 <a:latin typeface="Arial"/>
                 <a:ea typeface="Arial"/>
@@ -2645,15 +3100,15 @@
               </a:defRPr>
             </a:pPr>
             <a:r>
-              <a:rPr sz="3400" b="0">
-                <a:solidFill>
-                  <a:srgbClr val="000000"/>
+              <a:rPr sz="3400" b="1">
+                <a:solidFill>
+                  <a:srgbClr val="0054B8"/>
                 </a:solidFill>
                 <a:latin typeface="Arial"/>
                 <a:ea typeface="Arial"/>
                 <a:cs typeface="Arial"/>
               </a:rPr>
-              <a:t>Balanced Fine-Tuning at two scales</a:t>
+              <a:t>02  Motivation</a:t>
             </a:r>
           </a:p>
         </p:txBody>
@@ -2663,7 +3118,7 @@
           <p:cNvPr id="40" name="TextBox 46">
             <a:extLst xmlns:a="http://schemas.openxmlformats.org/drawingml/2006/main">
               <a:ext uri="{FF2B5EF4-FFF2-40B4-BE49-F238E27FC236}">
-                <a16:creationId xmlns:a16="http://schemas.microsoft.com/office/drawing/2014/main" id="{46794D03-8A4E-4C0C-BEBA-64D18CCAFEC4}"/>
+                <a16:creationId xmlns:a16="http://schemas.microsoft.com/office/drawing/2014/main" id="{F5DE315A-F775-4CBB-8131-F8F4BCA99598}"/>
               </a:ext>
             </a:extLst>
           </p:cNvPr>
@@ -2674,8 +3129,8 @@
         </p:nvSpPr>
         <p:spPr>
           <a:xfrm xmlns:a="http://schemas.openxmlformats.org/drawingml/2006/main">
-            <a:off x="990600" y="17287875"/>
-            <a:ext cx="9048750" cy="411480"/>
+            <a:off x="990600" y="14382750"/>
+            <a:ext cx="9048750" cy="1051560"/>
           </a:xfrm>
           <a:prstGeom xmlns:a="http://schemas.openxmlformats.org/drawingml/2006/main" prst="rect">
             <a:avLst/>
@@ -2693,7 +3148,7 @@
             <a:defPPr algn="l">
               <a:defRPr sz="2100" b="0">
                 <a:solidFill>
-                  <a:srgbClr val="000000"/>
+                  <a:srgbClr val="344854"/>
                 </a:solidFill>
                 <a:latin typeface="Arial"/>
                 <a:ea typeface="Arial"/>
@@ -2713,7 +3168,7 @@
             <a:pPr algn="l">
               <a:defRPr sz="2100" b="0">
                 <a:solidFill>
-                  <a:srgbClr val="000000"/>
+                  <a:srgbClr val="344854"/>
                 </a:solidFill>
                 <a:latin typeface="Arial"/>
                 <a:ea typeface="Arial"/>
@@ -2723,23 +3178,23 @@
             <a:r>
               <a:rPr sz="2100" b="0">
                 <a:solidFill>
-                  <a:srgbClr val="000000"/>
+                  <a:srgbClr val="344854"/>
                 </a:solidFill>
                 <a:latin typeface="Arial"/>
                 <a:ea typeface="Arial"/>
                 <a:cs typeface="Arial"/>
               </a:rPr>
-              <a:t>Relative token weights and bounded sample weights</a:t>
+              <a:t>DFT downweights every low-probability token. Biomedical learning needs to preserve difficult knowledge-bearing runs while controlling isolated outliers, then prioritize sequences containing hard regions.</a:t>
             </a:r>
           </a:p>
         </p:txBody>
       </p:sp>
       <p:sp>
         <p:nvSpPr>
-          <p:cNvPr id="41" name="TextBox 47">
+          <p:cNvPr id="42" name="TextBox 51">
             <a:extLst xmlns:a="http://schemas.openxmlformats.org/drawingml/2006/main">
               <a:ext uri="{FF2B5EF4-FFF2-40B4-BE49-F238E27FC236}">
-                <a16:creationId xmlns:a16="http://schemas.microsoft.com/office/drawing/2014/main" id="{050FAD90-3716-43A2-B27C-315336885338}"/>
+                <a16:creationId xmlns:a16="http://schemas.microsoft.com/office/drawing/2014/main" id="{8C3D0A02-46EA-48DC-8781-FCCA73696421}"/>
               </a:ext>
             </a:extLst>
           </p:cNvPr>
@@ -2750,8 +3205,8 @@
         </p:nvSpPr>
         <p:spPr>
           <a:xfrm xmlns:a="http://schemas.openxmlformats.org/drawingml/2006/main">
-            <a:off x="990600" y="20002500"/>
-            <a:ext cx="9048750" cy="1243584"/>
+            <a:off x="22926675" y="5238750"/>
+            <a:ext cx="9048750" cy="609600"/>
           </a:xfrm>
           <a:prstGeom xmlns:a="http://schemas.openxmlformats.org/drawingml/2006/main" prst="rect">
             <a:avLst/>
@@ -2767,9 +3222,9 @@
           </a:bodyPr>
           <a:lstStyle xmlns:a="http://schemas.openxmlformats.org/drawingml/2006/main">
             <a:defPPr algn="l">
-              <a:defRPr sz="2100" b="0">
-                <a:solidFill>
-                  <a:srgbClr val="344854"/>
+              <a:defRPr sz="3400" b="1">
+                <a:solidFill>
+                  <a:srgbClr val="0054B8"/>
                 </a:solidFill>
                 <a:latin typeface="Arial"/>
                 <a:ea typeface="Arial"/>
@@ -2777,14 +3232,8 @@
               </a:defRPr>
             </a:defPPr>
             <a:lvl1pPr>
-              <a:lnSpc>
-                <a:spcPct val="120000"/>
-              </a:lnSpc>
               <a:buNone/>
-              <a:defRPr sz="2100">
-                <a:solidFill>
-                  <a:srgbClr val="344854"/>
-                </a:solidFill>
+              <a:defRPr sz="3400">
                 <a:latin typeface="Arial"/>
                 <a:ea typeface="Arial"/>
                 <a:cs typeface="Arial"/>
@@ -2793,9 +3242,9 @@
           </a:lstStyle>
           <a:p xmlns:a="http://schemas.openxmlformats.org/drawingml/2006/main">
             <a:pPr algn="l">
-              <a:defRPr sz="2100" b="0">
-                <a:solidFill>
-                  <a:srgbClr val="344854"/>
+              <a:defRPr sz="3400" b="1">
+                <a:solidFill>
+                  <a:srgbClr val="0054B8"/>
                 </a:solidFill>
                 <a:latin typeface="Arial"/>
                 <a:ea typeface="Arial"/>
@@ -2803,25 +3252,25 @@
               </a:defRPr>
             </a:pPr>
             <a:r>
-              <a:rPr sz="2100" b="0">
-                <a:solidFill>
-                  <a:srgbClr val="344854"/>
+              <a:rPr sz="3400" b="1">
+                <a:solidFill>
+                  <a:srgbClr val="0054B8"/>
                 </a:solidFill>
                 <a:latin typeface="Arial"/>
                 <a:ea typeface="Arial"/>
                 <a:cs typeface="Arial"/>
               </a:rPr>
-              <a:t>The loss combines detached token and sample weights with response-token cross-entropy. The centered window g = 256 is the only additional tunable train-time hyperparameter.</a:t>
+              <a:t>04  Experimental results</a:t>
             </a:r>
           </a:p>
         </p:txBody>
       </p:sp>
       <p:sp>
         <p:nvSpPr>
-          <p:cNvPr id="42" name="TextBox 51">
+          <p:cNvPr id="43" name="TextBox 52">
             <a:extLst xmlns:a="http://schemas.openxmlformats.org/drawingml/2006/main">
               <a:ext uri="{FF2B5EF4-FFF2-40B4-BE49-F238E27FC236}">
-                <a16:creationId xmlns:a16="http://schemas.microsoft.com/office/drawing/2014/main" id="{33828F56-4DF2-42E4-9AA8-E5FE5B500641}"/>
+                <a16:creationId xmlns:a16="http://schemas.microsoft.com/office/drawing/2014/main" id="{326D0C0C-31B3-4534-852A-93FC9E39AB07}"/>
               </a:ext>
             </a:extLst>
           </p:cNvPr>
@@ -2832,83 +3281,7 @@
         </p:nvSpPr>
         <p:spPr>
           <a:xfrm xmlns:a="http://schemas.openxmlformats.org/drawingml/2006/main">
-            <a:off x="22926675" y="5381625"/>
-            <a:ext cx="9048750" cy="1127760"/>
-          </a:xfrm>
-          <a:prstGeom xmlns:a="http://schemas.openxmlformats.org/drawingml/2006/main" prst="rect">
-            <a:avLst/>
-          </a:prstGeom>
-          <a:noFill xmlns:a="http://schemas.openxmlformats.org/drawingml/2006/main"/>
-          <a:ln xmlns:a="http://schemas.openxmlformats.org/drawingml/2006/main" w="0">
-            <a:noFill/>
-          </a:ln>
-        </p:spPr>
-        <p:txBody>
-          <a:bodyPr xmlns:a="http://schemas.openxmlformats.org/drawingml/2006/main" wrap="square" lIns="0" tIns="0" rIns="0" bIns="0" anchor="t">
-            <a:noAutofit/>
-          </a:bodyPr>
-          <a:lstStyle xmlns:a="http://schemas.openxmlformats.org/drawingml/2006/main">
-            <a:defPPr algn="l">
-              <a:defRPr sz="3400" b="0">
-                <a:solidFill>
-                  <a:srgbClr val="000000"/>
-                </a:solidFill>
-                <a:latin typeface="Arial"/>
-                <a:ea typeface="Arial"/>
-                <a:cs typeface="Arial"/>
-              </a:defRPr>
-            </a:defPPr>
-            <a:lvl1pPr>
-              <a:buNone/>
-              <a:defRPr sz="3400">
-                <a:latin typeface="Arial"/>
-                <a:ea typeface="Arial"/>
-                <a:cs typeface="Arial"/>
-              </a:defRPr>
-            </a:lvl1pPr>
-          </a:lstStyle>
-          <a:p xmlns:a="http://schemas.openxmlformats.org/drawingml/2006/main">
-            <a:pPr algn="l">
-              <a:defRPr sz="3400" b="0">
-                <a:solidFill>
-                  <a:srgbClr val="000000"/>
-                </a:solidFill>
-                <a:latin typeface="Arial"/>
-                <a:ea typeface="Arial"/>
-                <a:cs typeface="Arial"/>
-              </a:defRPr>
-            </a:pPr>
-            <a:r>
-              <a:rPr sz="3400" b="0">
-                <a:solidFill>
-                  <a:srgbClr val="000000"/>
-                </a:solidFill>
-                <a:latin typeface="Arial"/>
-                <a:ea typeface="Arial"/>
-                <a:cs typeface="Arial"/>
-              </a:rPr>
-              <a:t>Biological representations from generated profiles</a:t>
-            </a:r>
-          </a:p>
-        </p:txBody>
-      </p:sp>
-      <p:sp>
-        <p:nvSpPr>
-          <p:cNvPr id="43" name="TextBox 52">
-            <a:extLst xmlns:a="http://schemas.openxmlformats.org/drawingml/2006/main">
-              <a:ext uri="{FF2B5EF4-FFF2-40B4-BE49-F238E27FC236}">
-                <a16:creationId xmlns:a16="http://schemas.microsoft.com/office/drawing/2014/main" id="{D701A3CA-B9C8-439C-AB3A-BBC5BCC61C35}"/>
-              </a:ext>
-            </a:extLst>
-          </p:cNvPr>
-          <p:cNvSpPr>
-            <a:spLocks xmlns:a="http://schemas.openxmlformats.org/drawingml/2006/main" noGrp="1"/>
-          </p:cNvSpPr>
-          <p:nvPr/>
-        </p:nvSpPr>
-        <p:spPr>
-          <a:xfrm xmlns:a="http://schemas.openxmlformats.org/drawingml/2006/main">
-            <a:off x="22926675" y="6715125"/>
+            <a:off x="22926675" y="6762750"/>
             <a:ext cx="9048750" cy="731520"/>
           </a:xfrm>
           <a:prstGeom xmlns:a="http://schemas.openxmlformats.org/drawingml/2006/main" prst="rect">
@@ -2927,7 +3300,7 @@
             <a:defPPr algn="l">
               <a:defRPr sz="2100" b="0">
                 <a:solidFill>
-                  <a:srgbClr val="000000"/>
+                  <a:srgbClr val="344854"/>
                 </a:solidFill>
                 <a:latin typeface="Arial"/>
                 <a:ea typeface="Arial"/>
@@ -2947,7 +3320,7 @@
             <a:pPr algn="l">
               <a:defRPr sz="2100" b="0">
                 <a:solidFill>
-                  <a:srgbClr val="000000"/>
+                  <a:srgbClr val="344854"/>
                 </a:solidFill>
                 <a:latin typeface="Arial"/>
                 <a:ea typeface="Arial"/>
@@ -2957,20 +3330,20 @@
             <a:r>
               <a:rPr sz="2100" b="0">
                 <a:solidFill>
-                  <a:srgbClr val="000000"/>
+                  <a:srgbClr val="344854"/>
                 </a:solidFill>
                 <a:latin typeface="Arial"/>
                 <a:ea typeface="Arial"/>
                 <a:cs typeface="Arial"/>
               </a:rPr>
-              <a:t>BFT-generated profiles are encoded with</a:t>
+              <a:t>70B backbones, joint Up/Down/No accuracy</a:t>
             </a:r>
           </a:p>
           <a:p xmlns:a="http://schemas.openxmlformats.org/drawingml/2006/main">
             <a:pPr algn="l">
               <a:defRPr sz="2100" b="0">
                 <a:solidFill>
-                  <a:srgbClr val="000000"/>
+                  <a:srgbClr val="344854"/>
                 </a:solidFill>
                 <a:latin typeface="Arial"/>
                 <a:ea typeface="Arial"/>
@@ -2980,23 +3353,23 @@
             <a:r>
               <a:rPr sz="2100" b="0">
                 <a:solidFill>
-                  <a:srgbClr val="000000"/>
+                  <a:srgbClr val="344854"/>
                 </a:solidFill>
                 <a:latin typeface="Arial"/>
                 <a:ea typeface="Arial"/>
                 <a:cs typeface="Arial"/>
               </a:rPr>
-              <a:t>text-embedding-ada-002.</a:t>
+              <a:t>GRPO on 45 cell lines, evaluation on 5 held-out lines</a:t>
             </a:r>
           </a:p>
         </p:txBody>
       </p:sp>
       <p:sp>
         <p:nvSpPr>
-          <p:cNvPr id="44" name="TextBox 53">
+          <p:cNvPr id="50" name="TextBox 37">
             <a:extLst xmlns:a="http://schemas.openxmlformats.org/drawingml/2006/main">
               <a:ext uri="{FF2B5EF4-FFF2-40B4-BE49-F238E27FC236}">
-                <a16:creationId xmlns:a16="http://schemas.microsoft.com/office/drawing/2014/main" id="{9724C120-C10F-4005-9476-184B9DDD2875}"/>
+                <a16:creationId xmlns:a16="http://schemas.microsoft.com/office/drawing/2014/main" id="{DB5EE827-C0A0-4358-99F9-FAF4E76FF244}"/>
               </a:ext>
             </a:extLst>
           </p:cNvPr>
@@ -3007,458 +3380,7 @@
         </p:nvSpPr>
         <p:spPr>
           <a:xfrm xmlns:a="http://schemas.openxmlformats.org/drawingml/2006/main">
-            <a:off x="22926675" y="17716500"/>
-            <a:ext cx="9048750" cy="1243584"/>
-          </a:xfrm>
-          <a:prstGeom xmlns:a="http://schemas.openxmlformats.org/drawingml/2006/main" prst="rect">
-            <a:avLst/>
-          </a:prstGeom>
-          <a:noFill xmlns:a="http://schemas.openxmlformats.org/drawingml/2006/main"/>
-          <a:ln xmlns:a="http://schemas.openxmlformats.org/drawingml/2006/main" w="0">
-            <a:noFill/>
-          </a:ln>
-        </p:spPr>
-        <p:txBody>
-          <a:bodyPr xmlns:a="http://schemas.openxmlformats.org/drawingml/2006/main" wrap="square" lIns="0" tIns="0" rIns="0" bIns="0" anchor="t">
-            <a:noAutofit/>
-          </a:bodyPr>
-          <a:lstStyle xmlns:a="http://schemas.openxmlformats.org/drawingml/2006/main">
-            <a:defPPr algn="l">
-              <a:defRPr sz="2100" b="0">
-                <a:solidFill>
-                  <a:srgbClr val="344854"/>
-                </a:solidFill>
-                <a:latin typeface="Arial"/>
-                <a:ea typeface="Arial"/>
-                <a:cs typeface="Arial"/>
-              </a:defRPr>
-            </a:defPPr>
-            <a:lvl1pPr>
-              <a:lnSpc>
-                <a:spcPct val="120000"/>
-              </a:lnSpc>
-              <a:buNone/>
-              <a:defRPr sz="2100">
-                <a:solidFill>
-                  <a:srgbClr val="344854"/>
-                </a:solidFill>
-                <a:latin typeface="Arial"/>
-                <a:ea typeface="Arial"/>
-                <a:cs typeface="Arial"/>
-              </a:defRPr>
-            </a:lvl1pPr>
-          </a:lstStyle>
-          <a:p xmlns:a="http://schemas.openxmlformats.org/drawingml/2006/main">
-            <a:pPr algn="l">
-              <a:defRPr sz="2100" b="0">
-                <a:solidFill>
-                  <a:srgbClr val="344854"/>
-                </a:solidFill>
-                <a:latin typeface="Arial"/>
-                <a:ea typeface="Arial"/>
-                <a:cs typeface="Arial"/>
-              </a:defRPr>
-            </a:pPr>
-            <a:r>
-              <a:rPr sz="2100" b="0">
-                <a:solidFill>
-                  <a:srgbClr val="344854"/>
-                </a:solidFill>
-                <a:latin typeface="Arial"/>
-                <a:ea typeface="Arial"/>
-                <a:cs typeface="Arial"/>
-              </a:rPr>
-              <a:t>With the STATE decoder retained, BFT embeddings perform comparably to standard inputs across four datasets. Profile generation is zero-shot for these datasets. Decoder training is not.</a:t>
-            </a:r>
-          </a:p>
-        </p:txBody>
-      </p:sp>
-      <p:sp>
-        <p:nvSpPr>
-          <p:cNvPr id="45" name="TextBox 54">
-            <a:extLst xmlns:a="http://schemas.openxmlformats.org/drawingml/2006/main">
-              <a:ext uri="{FF2B5EF4-FFF2-40B4-BE49-F238E27FC236}">
-                <a16:creationId xmlns:a16="http://schemas.microsoft.com/office/drawing/2014/main" id="{F03DEECD-9EEE-4420-B7DC-F68ABA20C8E3}"/>
-              </a:ext>
-            </a:extLst>
-          </p:cNvPr>
-          <p:cNvSpPr>
-            <a:spLocks xmlns:a="http://schemas.openxmlformats.org/drawingml/2006/main" noGrp="1"/>
-          </p:cNvSpPr>
-          <p:nvPr/>
-        </p:nvSpPr>
-        <p:spPr>
-          <a:xfrm xmlns:a="http://schemas.openxmlformats.org/drawingml/2006/main">
-            <a:off x="22926675" y="12287250"/>
-            <a:ext cx="9048750" cy="487680"/>
-          </a:xfrm>
-          <a:prstGeom xmlns:a="http://schemas.openxmlformats.org/drawingml/2006/main" prst="rect">
-            <a:avLst/>
-          </a:prstGeom>
-          <a:noFill xmlns:a="http://schemas.openxmlformats.org/drawingml/2006/main"/>
-          <a:ln xmlns:a="http://schemas.openxmlformats.org/drawingml/2006/main" w="0">
-            <a:noFill/>
-          </a:ln>
-        </p:spPr>
-        <p:txBody>
-          <a:bodyPr xmlns:a="http://schemas.openxmlformats.org/drawingml/2006/main" wrap="square" lIns="0" tIns="0" rIns="0" bIns="0" anchor="t">
-            <a:noAutofit/>
-          </a:bodyPr>
-          <a:lstStyle xmlns:a="http://schemas.openxmlformats.org/drawingml/2006/main">
-            <a:defPPr algn="l">
-              <a:defRPr sz="1300" b="0">
-                <a:solidFill>
-                  <a:srgbClr val="344854"/>
-                </a:solidFill>
-                <a:latin typeface="Arial"/>
-                <a:ea typeface="Arial"/>
-                <a:cs typeface="Arial"/>
-              </a:defRPr>
-            </a:defPPr>
-            <a:lvl1pPr algn="ctr">
-              <a:buNone/>
-              <a:defRPr sz="1300">
-                <a:solidFill>
-                  <a:srgbClr val="344854"/>
-                </a:solidFill>
-                <a:latin typeface="Arial"/>
-                <a:ea typeface="Arial"/>
-                <a:cs typeface="Arial"/>
-              </a:defRPr>
-            </a:lvl1pPr>
-          </a:lstStyle>
-          <a:p xmlns:a="http://schemas.openxmlformats.org/drawingml/2006/main">
-            <a:pPr algn="l">
-              <a:defRPr sz="1300" b="0">
-                <a:solidFill>
-                  <a:srgbClr val="344854"/>
-                </a:solidFill>
-                <a:latin typeface="Arial"/>
-                <a:ea typeface="Arial"/>
-                <a:cs typeface="Arial"/>
-              </a:defRPr>
-            </a:pPr>
-            <a:r>
-              <a:rPr sz="1300" b="0">
-                <a:solidFill>
-                  <a:srgbClr val="344854"/>
-                </a:solidFill>
-                <a:latin typeface="Arial"/>
-                <a:ea typeface="Arial"/>
-                <a:cs typeface="Arial"/>
-              </a:rPr>
-              <a:t>Figure 4. Best average gene-level performance and improved cell clustering on evaluated tasks. GenePT remains higher on Lys4.</a:t>
-            </a:r>
-          </a:p>
-        </p:txBody>
-      </p:sp>
-      <p:sp>
-        <p:nvSpPr>
-          <p:cNvPr id="46" name="TextBox 56">
-            <a:extLst xmlns:a="http://schemas.openxmlformats.org/drawingml/2006/main">
-              <a:ext uri="{FF2B5EF4-FFF2-40B4-BE49-F238E27FC236}">
-                <a16:creationId xmlns:a16="http://schemas.microsoft.com/office/drawing/2014/main" id="{FA35ED86-99D5-4AC0-908B-99C778F00413}"/>
-              </a:ext>
-            </a:extLst>
-          </p:cNvPr>
-          <p:cNvSpPr>
-            <a:spLocks xmlns:a="http://schemas.openxmlformats.org/drawingml/2006/main" noGrp="1"/>
-          </p:cNvSpPr>
-          <p:nvPr/>
-        </p:nvSpPr>
-        <p:spPr>
-          <a:xfrm xmlns:a="http://schemas.openxmlformats.org/drawingml/2006/main">
-            <a:off x="990600" y="14525625"/>
-            <a:ext cx="9048750" cy="487680"/>
-          </a:xfrm>
-          <a:prstGeom xmlns:a="http://schemas.openxmlformats.org/drawingml/2006/main" prst="rect">
-            <a:avLst/>
-          </a:prstGeom>
-          <a:noFill xmlns:a="http://schemas.openxmlformats.org/drawingml/2006/main"/>
-          <a:ln xmlns:a="http://schemas.openxmlformats.org/drawingml/2006/main" w="0">
-            <a:noFill/>
-          </a:ln>
-        </p:spPr>
-        <p:txBody>
-          <a:bodyPr xmlns:a="http://schemas.openxmlformats.org/drawingml/2006/main" wrap="square" lIns="0" tIns="0" rIns="0" bIns="0" anchor="t">
-            <a:noAutofit/>
-          </a:bodyPr>
-          <a:lstStyle xmlns:a="http://schemas.openxmlformats.org/drawingml/2006/main">
-            <a:defPPr algn="l">
-              <a:defRPr sz="1300" b="0">
-                <a:solidFill>
-                  <a:srgbClr val="344854"/>
-                </a:solidFill>
-                <a:latin typeface="Arial"/>
-                <a:ea typeface="Arial"/>
-                <a:cs typeface="Arial"/>
-              </a:defRPr>
-            </a:defPPr>
-            <a:lvl1pPr algn="ctr">
-              <a:buNone/>
-              <a:defRPr sz="1300">
-                <a:solidFill>
-                  <a:srgbClr val="344854"/>
-                </a:solidFill>
-                <a:latin typeface="Arial"/>
-                <a:ea typeface="Arial"/>
-                <a:cs typeface="Arial"/>
-              </a:defRPr>
-            </a:lvl1pPr>
-          </a:lstStyle>
-          <a:p xmlns:a="http://schemas.openxmlformats.org/drawingml/2006/main">
-            <a:pPr algn="l">
-              <a:defRPr sz="1300" b="0">
-                <a:solidFill>
-                  <a:srgbClr val="344854"/>
-                </a:solidFill>
-                <a:latin typeface="Arial"/>
-                <a:ea typeface="Arial"/>
-                <a:cs typeface="Arial"/>
-              </a:defRPr>
-            </a:pPr>
-            <a:r>
-              <a:rPr sz="1300" b="0">
-                <a:solidFill>
-                  <a:srgbClr val="344854"/>
-                </a:solidFill>
-                <a:latin typeface="Arial"/>
-                <a:ea typeface="Arial"/>
-                <a:cs typeface="Arial"/>
-              </a:rPr>
-              <a:t>Figure 1. Local uncertainty structure and BFT. PMC entity share: 60.9% in dense-low versus 12.5% in sparse-low windows. CRAFT expert spans corroborate concept enrichment (63.8% versus 11.2%).</a:t>
-            </a:r>
-          </a:p>
-        </p:txBody>
-      </p:sp>
-      <p:sp>
-        <p:nvSpPr>
-          <p:cNvPr id="48" name="TextBox 60">
-            <a:extLst xmlns:a="http://schemas.openxmlformats.org/drawingml/2006/main">
-              <a:ext uri="{FF2B5EF4-FFF2-40B4-BE49-F238E27FC236}">
-                <a16:creationId xmlns:a16="http://schemas.microsoft.com/office/drawing/2014/main" id="{208C5D04-7DB1-47BB-82C3-2164E9A8BFE3}"/>
-              </a:ext>
-            </a:extLst>
-          </p:cNvPr>
-          <p:cNvSpPr>
-            <a:spLocks xmlns:a="http://schemas.openxmlformats.org/drawingml/2006/main" noGrp="1"/>
-          </p:cNvSpPr>
-          <p:nvPr/>
-        </p:nvSpPr>
-        <p:spPr>
-          <a:xfrm xmlns:a="http://schemas.openxmlformats.org/drawingml/2006/main">
-            <a:off x="22926675" y="19621500"/>
-            <a:ext cx="5810250" cy="411480"/>
-          </a:xfrm>
-          <a:prstGeom xmlns:a="http://schemas.openxmlformats.org/drawingml/2006/main" prst="rect">
-            <a:avLst/>
-          </a:prstGeom>
-          <a:noFill xmlns:a="http://schemas.openxmlformats.org/drawingml/2006/main"/>
-          <a:ln xmlns:a="http://schemas.openxmlformats.org/drawingml/2006/main" w="0">
-            <a:noFill/>
-          </a:ln>
-        </p:spPr>
-        <p:txBody>
-          <a:bodyPr xmlns:a="http://schemas.openxmlformats.org/drawingml/2006/main" wrap="square" lIns="0" tIns="0" rIns="0" bIns="0" anchor="t">
-            <a:noAutofit/>
-          </a:bodyPr>
-          <a:lstStyle xmlns:a="http://schemas.openxmlformats.org/drawingml/2006/main">
-            <a:defPPr algn="l">
-              <a:defRPr sz="2100" b="0">
-                <a:solidFill>
-                  <a:srgbClr val="000000"/>
-                </a:solidFill>
-                <a:latin typeface="Arial"/>
-                <a:ea typeface="Arial"/>
-                <a:cs typeface="Arial"/>
-              </a:defRPr>
-            </a:defPPr>
-            <a:lvl1pPr>
-              <a:buNone/>
-              <a:defRPr sz="2100">
-                <a:latin typeface="Arial"/>
-                <a:ea typeface="Arial"/>
-                <a:cs typeface="Arial"/>
-              </a:defRPr>
-            </a:lvl1pPr>
-          </a:lstStyle>
-          <a:p xmlns:a="http://schemas.openxmlformats.org/drawingml/2006/main">
-            <a:pPr algn="l">
-              <a:defRPr sz="2100" b="0">
-                <a:solidFill>
-                  <a:srgbClr val="000000"/>
-                </a:solidFill>
-                <a:latin typeface="Arial"/>
-                <a:ea typeface="Arial"/>
-                <a:cs typeface="Arial"/>
-              </a:defRPr>
-            </a:pPr>
-            <a:r>
-              <a:rPr sz="2100" b="0">
-                <a:solidFill>
-                  <a:srgbClr val="000000"/>
-                </a:solidFill>
-                <a:latin typeface="Arial"/>
-                <a:ea typeface="Arial"/>
-                <a:cs typeface="Arial"/>
-              </a:rPr>
-              <a:t>Paper and code</a:t>
-            </a:r>
-          </a:p>
-        </p:txBody>
-      </p:sp>
-      <p:sp>
-        <p:nvSpPr>
-          <p:cNvPr id="49" name="TextBox 61">
-            <a:extLst xmlns:a="http://schemas.openxmlformats.org/drawingml/2006/main">
-              <a:ext uri="{FF2B5EF4-FFF2-40B4-BE49-F238E27FC236}">
-                <a16:creationId xmlns:a16="http://schemas.microsoft.com/office/drawing/2014/main" id="{9DD07C2B-04A0-40F4-9B85-E2EB714854E9}"/>
-              </a:ext>
-            </a:extLst>
-          </p:cNvPr>
-          <p:cNvSpPr>
-            <a:spLocks xmlns:a="http://schemas.openxmlformats.org/drawingml/2006/main" noGrp="1"/>
-          </p:cNvSpPr>
-          <p:nvPr/>
-        </p:nvSpPr>
-        <p:spPr>
-          <a:xfrm xmlns:a="http://schemas.openxmlformats.org/drawingml/2006/main">
-            <a:off x="22926675" y="20288250"/>
-            <a:ext cx="6572250" cy="1011936"/>
-          </a:xfrm>
-          <a:prstGeom xmlns:a="http://schemas.openxmlformats.org/drawingml/2006/main" prst="rect">
-            <a:avLst/>
-          </a:prstGeom>
-          <a:noFill xmlns:a="http://schemas.openxmlformats.org/drawingml/2006/main"/>
-          <a:ln xmlns:a="http://schemas.openxmlformats.org/drawingml/2006/main" w="0">
-            <a:noFill/>
-          </a:ln>
-        </p:spPr>
-        <p:txBody>
-          <a:bodyPr xmlns:a="http://schemas.openxmlformats.org/drawingml/2006/main" wrap="square" lIns="0" tIns="0" rIns="0" bIns="0" anchor="t">
-            <a:noAutofit/>
-          </a:bodyPr>
-          <a:lstStyle xmlns:a="http://schemas.openxmlformats.org/drawingml/2006/main">
-            <a:defPPr algn="l">
-              <a:defRPr sz="1400" b="0">
-                <a:solidFill>
-                  <a:srgbClr val="677B8C"/>
-                </a:solidFill>
-                <a:latin typeface="Arial"/>
-                <a:ea typeface="Arial"/>
-                <a:cs typeface="Arial"/>
-              </a:defRPr>
-            </a:defPPr>
-          </a:lstStyle>
-          <a:p xmlns:a="http://schemas.openxmlformats.org/drawingml/2006/main">
-            <a:pPr algn="l">
-              <a:lnSpc>
-                <a:spcPct val="120000"/>
-              </a:lnSpc>
-              <a:spcBef>
-                <a:spcPts val="600"/>
-              </a:spcBef>
-              <a:buNone/>
-              <a:defRPr sz="1400" b="0">
-                <a:solidFill>
-                  <a:srgbClr val="677B8C"/>
-                </a:solidFill>
-                <a:latin typeface="Arial"/>
-                <a:ea typeface="Arial"/>
-                <a:cs typeface="Arial"/>
-              </a:defRPr>
-            </a:pPr>
-            <a:r>
-              <a:rPr sz="1400" b="0">
-                <a:solidFill>
-                  <a:srgbClr val="677B8C"/>
-                </a:solidFill>
-                <a:latin typeface="Arial"/>
-                <a:ea typeface="Arial"/>
-                <a:cs typeface="Arial"/>
-              </a:rPr>
-              <a:t>arxiv.org/abs/2511.21075</a:t>
-            </a:r>
-          </a:p>
-          <a:p xmlns:a="http://schemas.openxmlformats.org/drawingml/2006/main">
-            <a:pPr algn="l">
-              <a:lnSpc>
-                <a:spcPct val="120000"/>
-              </a:lnSpc>
-              <a:spcBef>
-                <a:spcPts val="600"/>
-              </a:spcBef>
-              <a:buNone/>
-              <a:defRPr sz="1400" b="0">
-                <a:solidFill>
-                  <a:srgbClr val="677B8C"/>
-                </a:solidFill>
-                <a:latin typeface="Arial"/>
-                <a:ea typeface="Arial"/>
-                <a:cs typeface="Arial"/>
-              </a:defRPr>
-            </a:pPr>
-            <a:r>
-              <a:rPr sz="1400" b="0">
-                <a:solidFill>
-                  <a:srgbClr val="677B8C"/>
-                </a:solidFill>
-                <a:latin typeface="Arial"/>
-                <a:ea typeface="Arial"/>
-                <a:cs typeface="Arial"/>
-              </a:rPr>
-              <a:t>github.com/TencentAILabHealthcare/BFT</a:t>
-            </a:r>
-          </a:p>
-          <a:p xmlns:a="http://schemas.openxmlformats.org/drawingml/2006/main">
-            <a:pPr algn="l">
-              <a:lnSpc>
-                <a:spcPct val="120000"/>
-              </a:lnSpc>
-              <a:spcBef>
-                <a:spcPts val="600"/>
-              </a:spcBef>
-              <a:buNone/>
-              <a:defRPr sz="1400" b="0">
-                <a:solidFill>
-                  <a:srgbClr val="677B8C"/>
-                </a:solidFill>
-                <a:latin typeface="Arial"/>
-                <a:ea typeface="Arial"/>
-                <a:cs typeface="Arial"/>
-              </a:defRPr>
-            </a:pPr>
-            <a:r>
-              <a:rPr sz="1400" b="0">
-                <a:solidFill>
-                  <a:srgbClr val="677B8C"/>
-                </a:solidFill>
-                <a:latin typeface="Arial"/>
-                <a:ea typeface="Arial"/>
-                <a:cs typeface="Arial"/>
-              </a:rPr>
-              <a:t>Project page: shapsider.github.io/BFT</a:t>
-            </a:r>
-          </a:p>
-        </p:txBody>
-      </p:sp>
-      <p:sp>
-        <p:nvSpPr>
-          <p:cNvPr id="50" name="TextBox 37">
-            <a:extLst xmlns:a="http://schemas.openxmlformats.org/drawingml/2006/main">
-              <a:ext uri="{FF2B5EF4-FFF2-40B4-BE49-F238E27FC236}">
-                <a16:creationId xmlns:a16="http://schemas.microsoft.com/office/drawing/2014/main" id="{117C48EC-DDC6-43B0-986E-517FA2C5C50F}"/>
-              </a:ext>
-            </a:extLst>
-          </p:cNvPr>
-          <p:cNvSpPr>
-            <a:spLocks xmlns:a="http://schemas.openxmlformats.org/drawingml/2006/main" noGrp="1"/>
-          </p:cNvSpPr>
-          <p:nvPr/>
-        </p:nvSpPr>
-        <p:spPr>
-          <a:xfrm xmlns:a="http://schemas.openxmlformats.org/drawingml/2006/main">
-            <a:off x="990600" y="2857500"/>
+            <a:off x="990600" y="2733675"/>
             <a:ext cx="24955500" cy="986536"/>
           </a:xfrm>
           <a:prstGeom xmlns:a="http://schemas.openxmlformats.org/drawingml/2006/main" prst="rect">
@@ -3552,7 +3474,7 @@
           <p:cNvPr id="54" name="neurips_logo.pdf">
             <a:extLst xmlns:a="http://schemas.openxmlformats.org/drawingml/2006/main">
               <a:ext uri="{FF2B5EF4-FFF2-40B4-BE49-F238E27FC236}">
-                <a16:creationId xmlns:a16="http://schemas.microsoft.com/office/drawing/2014/main" id="{F94C0DE4-DF3D-4DBC-B218-0E43B7B38EAD}"/>
+                <a16:creationId xmlns:a16="http://schemas.microsoft.com/office/drawing/2014/main" id="{457B4412-86A0-43B7-8230-CD594B8D7122}"/>
               </a:ext>
             </a:extLst>
           </p:cNvPr>
@@ -3562,7 +3484,7 @@
           <p:nvPr/>
         </p:nvPicPr>
         <p:blipFill>
-          <a:blip xmlns:r="http://schemas.openxmlformats.org/officeDocument/2006/relationships" xmlns:a="http://schemas.openxmlformats.org/drawingml/2006/main" r:embed="R951849df40f64ed3"/>
+          <a:blip xmlns:r="http://schemas.openxmlformats.org/officeDocument/2006/relationships" xmlns:a="http://schemas.openxmlformats.org/drawingml/2006/main" r:embed="Rd0930b372cea48ec"/>
           <a:stretch xmlns:a="http://schemas.openxmlformats.org/drawingml/2006/main">
             <a:fillRect l="0" t="0" r="0" b="0"/>
           </a:stretch>
@@ -3585,7 +3507,7 @@
           <p:cNvPr id="55" name="Affiliations">
             <a:extLst xmlns:a="http://schemas.openxmlformats.org/drawingml/2006/main">
               <a:ext uri="{FF2B5EF4-FFF2-40B4-BE49-F238E27FC236}">
-                <a16:creationId xmlns:a16="http://schemas.microsoft.com/office/drawing/2014/main" id="{17F90830-E335-45D0-B14D-BA2E97A1E09D}"/>
+                <a16:creationId xmlns:a16="http://schemas.microsoft.com/office/drawing/2014/main" id="{936139D5-37D2-4096-95E9-05E99033518F}"/>
               </a:ext>
             </a:extLst>
           </p:cNvPr>
@@ -3596,7 +3518,7 @@
         </p:nvSpPr>
         <p:spPr>
           <a:xfrm xmlns:a="http://schemas.openxmlformats.org/drawingml/2006/main">
-            <a:off x="990600" y="4000500"/>
+            <a:off x="990600" y="3790950"/>
             <a:ext cx="24955500" cy="923925"/>
           </a:xfrm>
           <a:prstGeom xmlns:a="http://schemas.openxmlformats.org/drawingml/2006/main" prst="rect">
@@ -3699,7 +3621,7 @@
           <p:cNvPr id="56" name="">
             <a:extLst xmlns:a="http://schemas.openxmlformats.org/drawingml/2006/main">
               <a:ext uri="{FF2B5EF4-FFF2-40B4-BE49-F238E27FC236}">
-                <a16:creationId xmlns:a16="http://schemas.microsoft.com/office/drawing/2014/main" id="{BF435C6B-9660-45B5-A331-D02749A07B8B}"/>
+                <a16:creationId xmlns:a16="http://schemas.microsoft.com/office/drawing/2014/main" id="{C4AFF25E-2D5A-4A97-ABF7-899248DD181F}"/>
               </a:ext>
             </a:extLst>
           </p:cNvPr>
@@ -3709,7 +3631,7 @@
           <p:nvPr/>
         </p:nvPicPr>
         <p:blipFill>
-          <a:blip xmlns:r="http://schemas.openxmlformats.org/officeDocument/2006/relationships" xmlns:a="http://schemas.openxmlformats.org/drawingml/2006/main" r:embed="R6577d95e027e427a"/>
+          <a:blip xmlns:r="http://schemas.openxmlformats.org/officeDocument/2006/relationships" xmlns:a="http://schemas.openxmlformats.org/drawingml/2006/main" r:embed="Re3f60db65f494f62"/>
           <a:stretch xmlns:a="http://schemas.openxmlformats.org/drawingml/2006/main"/>
         </p:blipFill>
         <p:spPr>
@@ -3727,7 +3649,7 @@
           <p:cNvPr id="57" name="">
             <a:extLst xmlns:a="http://schemas.openxmlformats.org/drawingml/2006/main">
               <a:ext uri="{FF2B5EF4-FFF2-40B4-BE49-F238E27FC236}">
-                <a16:creationId xmlns:a16="http://schemas.microsoft.com/office/drawing/2014/main" id="{68AD6B98-16BC-4AE4-9E84-2143E93EFD66}"/>
+                <a16:creationId xmlns:a16="http://schemas.microsoft.com/office/drawing/2014/main" id="{E2D80F46-C1EE-4DE0-A1C6-CF030D154B5D}"/>
               </a:ext>
             </a:extLst>
           </p:cNvPr>
@@ -3737,7 +3659,7 @@
           <p:nvPr/>
         </p:nvPicPr>
         <p:blipFill>
-          <a:blip xmlns:r="http://schemas.openxmlformats.org/officeDocument/2006/relationships" xmlns:a="http://schemas.openxmlformats.org/drawingml/2006/main" r:embed="R7f41eb2ddcdb4d43"/>
+          <a:blip xmlns:r="http://schemas.openxmlformats.org/officeDocument/2006/relationships" xmlns:a="http://schemas.openxmlformats.org/drawingml/2006/main" r:embed="R248f9486a03d4146"/>
           <a:stretch xmlns:a="http://schemas.openxmlformats.org/drawingml/2006/main"/>
         </p:blipFill>
         <p:spPr>
@@ -3755,7 +3677,7 @@
           <p:cNvPr id="58" name="">
             <a:extLst xmlns:a="http://schemas.openxmlformats.org/drawingml/2006/main">
               <a:ext uri="{FF2B5EF4-FFF2-40B4-BE49-F238E27FC236}">
-                <a16:creationId xmlns:a16="http://schemas.microsoft.com/office/drawing/2014/main" id="{A419CD69-6C52-43E5-B1FD-8B9AFAE9D1D5}"/>
+                <a16:creationId xmlns:a16="http://schemas.microsoft.com/office/drawing/2014/main" id="{126DB016-2044-4B5A-A1FA-37C11B462F24}"/>
               </a:ext>
             </a:extLst>
           </p:cNvPr>
@@ -3765,13 +3687,13 @@
           <p:nvPr/>
         </p:nvPicPr>
         <p:blipFill>
-          <a:blip xmlns:r="http://schemas.openxmlformats.org/officeDocument/2006/relationships" xmlns:a="http://schemas.openxmlformats.org/drawingml/2006/main" r:embed="R62b33426edaf40b9"/>
+          <a:blip xmlns:r="http://schemas.openxmlformats.org/officeDocument/2006/relationships" xmlns:a="http://schemas.openxmlformats.org/drawingml/2006/main" r:embed="R22f308aee2834b82"/>
           <a:stretch xmlns:a="http://schemas.openxmlformats.org/drawingml/2006/main"/>
         </p:blipFill>
         <p:spPr>
           <a:xfrm xmlns:a="http://schemas.openxmlformats.org/drawingml/2006/main">
-            <a:off x="990627" y="8477250"/>
-            <a:ext cx="9048696" cy="5753100"/>
+            <a:off x="990600" y="7197149"/>
+            <a:ext cx="9048750" cy="2369702"/>
           </a:xfrm>
           <a:prstGeom xmlns:a="http://schemas.openxmlformats.org/drawingml/2006/main" prst="rect">
             <a:avLst/>
@@ -3780,10 +3702,10 @@
       </p:pic>
       <p:sp>
         <p:nvSpPr>
-          <p:cNvPr id="59" name="Token equation">
+          <p:cNvPr id="59" name="Observation chart title">
             <a:extLst xmlns:a="http://schemas.openxmlformats.org/drawingml/2006/main">
               <a:ext uri="{FF2B5EF4-FFF2-40B4-BE49-F238E27FC236}">
-                <a16:creationId xmlns:a16="http://schemas.microsoft.com/office/drawing/2014/main" id="{69E6D7D9-513A-4301-8804-A3428BE094E0}"/>
+                <a16:creationId xmlns:a16="http://schemas.microsoft.com/office/drawing/2014/main" id="{71E90885-AEC8-41B4-B197-80B561ECEF1A}"/>
               </a:ext>
             </a:extLst>
           </p:cNvPr>
@@ -3794,7 +3716,1168 @@
         </p:nvSpPr>
         <p:spPr>
           <a:xfrm xmlns:a="http://schemas.openxmlformats.org/drawingml/2006/main">
-            <a:off x="990600" y="18192750"/>
+            <a:off x="990600" y="9715500"/>
+            <a:ext cx="9048750" cy="457200"/>
+          </a:xfrm>
+          <a:prstGeom xmlns:a="http://schemas.openxmlformats.org/drawingml/2006/main" prst="rect">
+            <a:avLst/>
+          </a:prstGeom>
+          <a:noFill xmlns:a="http://schemas.openxmlformats.org/drawingml/2006/main"/>
+          <a:ln xmlns:a="http://schemas.openxmlformats.org/drawingml/2006/main" w="0">
+            <a:noFill/>
+          </a:ln>
+        </p:spPr>
+        <p:txBody>
+          <a:bodyPr xmlns:a="http://schemas.openxmlformats.org/drawingml/2006/main" wrap="square" lIns="0" tIns="0" rIns="0" bIns="0" anchor="t">
+            <a:noAutofit/>
+          </a:bodyPr>
+          <a:lstStyle xmlns:a="http://schemas.openxmlformats.org/drawingml/2006/main">
+            <a:defPPr algn="l">
+              <a:defRPr sz="2100" b="0">
+                <a:solidFill>
+                  <a:srgbClr val="000000"/>
+                </a:solidFill>
+                <a:latin typeface="Arial"/>
+                <a:ea typeface="Arial"/>
+                <a:cs typeface="Arial"/>
+              </a:defRPr>
+            </a:defPPr>
+          </a:lstStyle>
+          <a:p xmlns:a="http://schemas.openxmlformats.org/drawingml/2006/main">
+            <a:pPr algn="l">
+              <a:defRPr sz="2100" b="0">
+                <a:solidFill>
+                  <a:srgbClr val="000000"/>
+                </a:solidFill>
+                <a:latin typeface="Arial"/>
+                <a:ea typeface="Arial"/>
+                <a:cs typeface="Arial"/>
+              </a:defRPr>
+            </a:pPr>
+            <a:r>
+              <a:rPr sz="2100" b="0">
+                <a:solidFill>
+                  <a:srgbClr val="000000"/>
+                </a:solidFill>
+                <a:latin typeface="Arial"/>
+                <a:ea typeface="Arial"/>
+                <a:cs typeface="Arial"/>
+              </a:rPr>
+              <a:t>Biomedical entity / expert-concept share (%)</a:t>
+            </a:r>
+          </a:p>
+        </p:txBody>
+      </p:sp>
+      <p:graphicFrame>
+        <p:nvGraphicFramePr>
+          <p:cNvPr id="60" name="Chart">
+            <a:extLst xmlns:a="http://schemas.openxmlformats.org/drawingml/2006/main">
+              <a:ext uri="{FF2B5EF4-FFF2-40B4-BE49-F238E27FC236}">
+                <a16:creationId xmlns:a16="http://schemas.microsoft.com/office/drawing/2014/main" id="{A264CB37-B4B5-4444-AB56-91C488199F72}"/>
+              </a:ext>
+            </a:extLst>
+          </p:cNvPr>
+          <p:cNvGraphicFramePr/>
+          <p:nvPr/>
+        </p:nvGraphicFramePr>
+        <p:xfrm>
+          <a:off xmlns:a="http://schemas.openxmlformats.org/drawingml/2006/main" x="990600" y="10287000"/>
+          <a:ext xmlns:a="http://schemas.openxmlformats.org/drawingml/2006/main" cx="9048750" cy="2476500"/>
+        </p:xfrm>
+        <a:graphic xmlns:a="http://schemas.openxmlformats.org/drawingml/2006/main">
+          <a:graphicData uri="http://schemas.openxmlformats.org/drawingml/2006/chart">
+            <c:chart xmlns:r="http://schemas.openxmlformats.org/officeDocument/2006/relationships" xmlns:c="http://schemas.openxmlformats.org/drawingml/2006/chart" r:id="Rb69b1350ae674824"/>
+          </a:graphicData>
+        </a:graphic>
+      </p:graphicFrame>
+      <p:sp>
+        <p:nvSpPr>
+          <p:cNvPr id="61" name="Observation caption">
+            <a:extLst xmlns:a="http://schemas.openxmlformats.org/drawingml/2006/main">
+              <a:ext uri="{FF2B5EF4-FFF2-40B4-BE49-F238E27FC236}">
+                <a16:creationId xmlns:a16="http://schemas.microsoft.com/office/drawing/2014/main" id="{15397B6E-AC6A-47C5-A331-0F02498871FD}"/>
+              </a:ext>
+            </a:extLst>
+          </p:cNvPr>
+          <p:cNvSpPr>
+            <a:spLocks xmlns:a="http://schemas.openxmlformats.org/drawingml/2006/main" noGrp="1"/>
+          </p:cNvSpPr>
+          <p:nvPr/>
+        </p:nvSpPr>
+        <p:spPr>
+          <a:xfrm xmlns:a="http://schemas.openxmlformats.org/drawingml/2006/main">
+            <a:off x="990600" y="12858750"/>
+            <a:ext cx="9048750" cy="714375"/>
+          </a:xfrm>
+          <a:prstGeom xmlns:a="http://schemas.openxmlformats.org/drawingml/2006/main" prst="rect">
+            <a:avLst/>
+          </a:prstGeom>
+          <a:noFill xmlns:a="http://schemas.openxmlformats.org/drawingml/2006/main"/>
+          <a:ln xmlns:a="http://schemas.openxmlformats.org/drawingml/2006/main" w="0">
+            <a:noFill/>
+          </a:ln>
+        </p:spPr>
+        <p:txBody>
+          <a:bodyPr xmlns:a="http://schemas.openxmlformats.org/drawingml/2006/main" wrap="square" lIns="0" tIns="0" rIns="0" bIns="0" anchor="t">
+            <a:noAutofit/>
+          </a:bodyPr>
+          <a:lstStyle xmlns:a="http://schemas.openxmlformats.org/drawingml/2006/main">
+            <a:defPPr algn="l">
+              <a:defRPr sz="1300" b="0">
+                <a:solidFill>
+                  <a:srgbClr val="344854"/>
+                </a:solidFill>
+                <a:latin typeface="Arial"/>
+                <a:ea typeface="Arial"/>
+                <a:cs typeface="Arial"/>
+              </a:defRPr>
+            </a:defPPr>
+          </a:lstStyle>
+          <a:p xmlns:a="http://schemas.openxmlformats.org/drawingml/2006/main">
+            <a:pPr algn="l">
+              <a:defRPr sz="1300" b="0">
+                <a:solidFill>
+                  <a:srgbClr val="344854"/>
+                </a:solidFill>
+                <a:latin typeface="Arial"/>
+                <a:ea typeface="Arial"/>
+                <a:cs typeface="Arial"/>
+              </a:defRPr>
+            </a:pPr>
+            <a:r>
+              <a:rPr sz="1300" b="0">
+                <a:solidFill>
+                  <a:srgbClr val="344854"/>
+                </a:solidFill>
+                <a:latin typeface="Arial"/>
+                <a:ea typeface="Arial"/>
+                <a:cs typeface="Arial"/>
+              </a:rPr>
+              <a:t>CRAFT uses expert concept spans. General-domain controls show little entity enrichment. These measurements support a knowledge-gap interpretation, rather than directly labeling epistemic uncertainty.</a:t>
+            </a:r>
+          </a:p>
+        </p:txBody>
+      </p:sp>
+      <p:pic>
+        <p:nvPicPr>
+          <p:cNvPr id="62" name="">
+            <a:extLst xmlns:a="http://schemas.openxmlformats.org/drawingml/2006/main">
+              <a:ext uri="{FF2B5EF4-FFF2-40B4-BE49-F238E27FC236}">
+                <a16:creationId xmlns:a16="http://schemas.microsoft.com/office/drawing/2014/main" id="{B8C5C50E-E8E7-4D62-9E63-B50AC3339078}"/>
+              </a:ext>
+            </a:extLst>
+          </p:cNvPr>
+          <p:cNvPicPr>
+            <a:picLocks xmlns:a="http://schemas.openxmlformats.org/drawingml/2006/main" noChangeAspect="1"/>
+          </p:cNvPicPr>
+          <p:nvPr/>
+        </p:nvPicPr>
+        <p:blipFill>
+          <a:blip xmlns:r="http://schemas.openxmlformats.org/officeDocument/2006/relationships" xmlns:a="http://schemas.openxmlformats.org/drawingml/2006/main" r:embed="R6d28dcf9cdcb4b0a"/>
+          <a:stretch xmlns:a="http://schemas.openxmlformats.org/drawingml/2006/main"/>
+        </p:blipFill>
+        <p:spPr>
+          <a:xfrm xmlns:a="http://schemas.openxmlformats.org/drawingml/2006/main">
+            <a:off x="11877675" y="7144662"/>
+            <a:ext cx="9048750" cy="3360501"/>
+          </a:xfrm>
+          <a:prstGeom xmlns:a="http://schemas.openxmlformats.org/drawingml/2006/main" prst="rect">
+            <a:avLst/>
+          </a:prstGeom>
+        </p:spPr>
+      </p:pic>
+      <p:sp>
+        <p:nvSpPr>
+          <p:cNvPr id="63" name="Token label">
+            <a:extLst xmlns:a="http://schemas.openxmlformats.org/drawingml/2006/main">
+              <a:ext uri="{FF2B5EF4-FFF2-40B4-BE49-F238E27FC236}">
+                <a16:creationId xmlns:a16="http://schemas.microsoft.com/office/drawing/2014/main" id="{CA73F9A1-E8E0-4D04-AED1-3D3537E2A28D}"/>
+              </a:ext>
+            </a:extLst>
+          </p:cNvPr>
+          <p:cNvSpPr>
+            <a:spLocks xmlns:a="http://schemas.openxmlformats.org/drawingml/2006/main" noGrp="1"/>
+          </p:cNvSpPr>
+          <p:nvPr/>
+        </p:nvSpPr>
+        <p:spPr>
+          <a:xfrm xmlns:a="http://schemas.openxmlformats.org/drawingml/2006/main">
+            <a:off x="11877675" y="10715625"/>
+            <a:ext cx="9048750" cy="457200"/>
+          </a:xfrm>
+          <a:prstGeom xmlns:a="http://schemas.openxmlformats.org/drawingml/2006/main" prst="rect">
+            <a:avLst/>
+          </a:prstGeom>
+          <a:noFill xmlns:a="http://schemas.openxmlformats.org/drawingml/2006/main"/>
+          <a:ln xmlns:a="http://schemas.openxmlformats.org/drawingml/2006/main" w="0">
+            <a:noFill/>
+          </a:ln>
+        </p:spPr>
+        <p:txBody>
+          <a:bodyPr xmlns:a="http://schemas.openxmlformats.org/drawingml/2006/main" wrap="square" lIns="0" tIns="0" rIns="0" bIns="0" anchor="t">
+            <a:noAutofit/>
+          </a:bodyPr>
+          <a:lstStyle xmlns:a="http://schemas.openxmlformats.org/drawingml/2006/main">
+            <a:defPPr algn="l">
+              <a:defRPr sz="2100" b="1">
+                <a:solidFill>
+                  <a:srgbClr val="000000"/>
+                </a:solidFill>
+                <a:latin typeface="Arial"/>
+                <a:ea typeface="Arial"/>
+                <a:cs typeface="Arial"/>
+              </a:defRPr>
+            </a:defPPr>
+          </a:lstStyle>
+          <a:p xmlns:a="http://schemas.openxmlformats.org/drawingml/2006/main">
+            <a:pPr algn="l">
+              <a:defRPr sz="2100" b="1">
+                <a:solidFill>
+                  <a:srgbClr val="000000"/>
+                </a:solidFill>
+                <a:latin typeface="Arial"/>
+                <a:ea typeface="Arial"/>
+                <a:cs typeface="Arial"/>
+              </a:defRPr>
+            </a:pPr>
+            <a:r>
+              <a:rPr sz="2100" b="1">
+                <a:solidFill>
+                  <a:srgbClr val="000000"/>
+                </a:solidFill>
+                <a:latin typeface="Arial"/>
+                <a:ea typeface="Arial"/>
+                <a:cs typeface="Arial"/>
+              </a:rPr>
+              <a:t>Within a sequence: local relative confidence</a:t>
+            </a:r>
+          </a:p>
+        </p:txBody>
+      </p:sp>
+      <p:sp>
+        <p:nvSpPr>
+          <p:cNvPr id="64" name="Token equation">
+            <a:extLst xmlns:a="http://schemas.openxmlformats.org/drawingml/2006/main">
+              <a:ext uri="{FF2B5EF4-FFF2-40B4-BE49-F238E27FC236}">
+                <a16:creationId xmlns:a16="http://schemas.microsoft.com/office/drawing/2014/main" id="{F01F9ED5-8401-4B3F-AE2C-D2C57D3F1FF3}"/>
+              </a:ext>
+            </a:extLst>
+          </p:cNvPr>
+          <p:cNvSpPr>
+            <a:spLocks xmlns:a="http://schemas.openxmlformats.org/drawingml/2006/main" noGrp="1"/>
+          </p:cNvSpPr>
+          <p:nvPr/>
+        </p:nvSpPr>
+        <p:spPr>
+          <a:xfrm xmlns:a="http://schemas.openxmlformats.org/drawingml/2006/main">
+            <a:off x="11877675" y="11239500"/>
+            <a:ext cx="9048750" cy="571500"/>
+          </a:xfrm>
+          <a:prstGeom xmlns:a="http://schemas.openxmlformats.org/drawingml/2006/main" prst="rect">
+            <a:avLst/>
+          </a:prstGeom>
+          <a:noFill xmlns:a="http://schemas.openxmlformats.org/drawingml/2006/main"/>
+          <a:ln xmlns:a="http://schemas.openxmlformats.org/drawingml/2006/main" w="0">
+            <a:noFill/>
+          </a:ln>
+        </p:spPr>
+        <p:txBody>
+          <a:bodyPr xmlns:a="http://schemas.openxmlformats.org/drawingml/2006/main" wrap="square" lIns="0" tIns="0" rIns="0" bIns="0" anchor="t">
+            <a:noAutofit/>
+          </a:bodyPr>
+          <a:lstStyle xmlns:a="http://schemas.openxmlformats.org/drawingml/2006/main">
+            <a:defPPr algn="l">
+              <a:defRPr sz="2600" b="0">
+                <a:solidFill>
+                  <a:srgbClr val="0054B8"/>
+                </a:solidFill>
+                <a:latin typeface="Arial"/>
+                <a:ea typeface="Arial"/>
+                <a:cs typeface="Arial"/>
+              </a:defRPr>
+            </a:defPPr>
+          </a:lstStyle>
+          <a:p xmlns:a="http://schemas.openxmlformats.org/drawingml/2006/main">
+            <a:pPr algn="l">
+              <a:defRPr sz="2600" b="0">
+                <a:solidFill>
+                  <a:srgbClr val="0054B8"/>
+                </a:solidFill>
+                <a:latin typeface="Arial"/>
+                <a:ea typeface="Arial"/>
+                <a:cs typeface="Arial"/>
+              </a:defRPr>
+            </a:pPr>
+            <a:r>
+              <a:rPr sz="2600" b="0">
+                <a:solidFill>
+                  <a:srgbClr val="0054B8"/>
+                </a:solidFill>
+                <a:latin typeface="Arial"/>
+                <a:ea typeface="Arial"/>
+                <a:cs typeface="Arial"/>
+              </a:rPr>
+              <a:t>ρᵦ,ₜ = clip(cᵦ,ₜ / (Cᵦ,ₜˡᵒᶜ + ε), 0, 1)</a:t>
+            </a:r>
+          </a:p>
+        </p:txBody>
+      </p:sp>
+      <p:sp>
+        <p:nvSpPr>
+          <p:cNvPr id="65" name="Token interpretation">
+            <a:extLst xmlns:a="http://schemas.openxmlformats.org/drawingml/2006/main">
+              <a:ext uri="{FF2B5EF4-FFF2-40B4-BE49-F238E27FC236}">
+                <a16:creationId xmlns:a16="http://schemas.microsoft.com/office/drawing/2014/main" id="{18ABEFC8-BFB7-4F4C-8217-F7CB63E13901}"/>
+              </a:ext>
+            </a:extLst>
+          </p:cNvPr>
+          <p:cNvSpPr>
+            <a:spLocks xmlns:a="http://schemas.openxmlformats.org/drawingml/2006/main" noGrp="1"/>
+          </p:cNvSpPr>
+          <p:nvPr/>
+        </p:nvSpPr>
+        <p:spPr>
+          <a:xfrm xmlns:a="http://schemas.openxmlformats.org/drawingml/2006/main">
+            <a:off x="11877675" y="11858625"/>
+            <a:ext cx="9048750" cy="857250"/>
+          </a:xfrm>
+          <a:prstGeom xmlns:a="http://schemas.openxmlformats.org/drawingml/2006/main" prst="rect">
+            <a:avLst/>
+          </a:prstGeom>
+          <a:noFill xmlns:a="http://schemas.openxmlformats.org/drawingml/2006/main"/>
+          <a:ln xmlns:a="http://schemas.openxmlformats.org/drawingml/2006/main" w="0">
+            <a:noFill/>
+          </a:ln>
+        </p:spPr>
+        <p:txBody>
+          <a:bodyPr xmlns:a="http://schemas.openxmlformats.org/drawingml/2006/main" wrap="square" lIns="0" tIns="0" rIns="0" bIns="0" anchor="t">
+            <a:noAutofit/>
+          </a:bodyPr>
+          <a:lstStyle xmlns:a="http://schemas.openxmlformats.org/drawingml/2006/main">
+            <a:defPPr algn="l">
+              <a:defRPr sz="2100" b="0">
+                <a:solidFill>
+                  <a:srgbClr val="344854"/>
+                </a:solidFill>
+                <a:latin typeface="Arial"/>
+                <a:ea typeface="Arial"/>
+                <a:cs typeface="Arial"/>
+              </a:defRPr>
+            </a:defPPr>
+          </a:lstStyle>
+          <a:p xmlns:a="http://schemas.openxmlformats.org/drawingml/2006/main">
+            <a:pPr algn="l">
+              <a:defRPr sz="2100" b="0">
+                <a:solidFill>
+                  <a:srgbClr val="344854"/>
+                </a:solidFill>
+                <a:latin typeface="Arial"/>
+                <a:ea typeface="Arial"/>
+                <a:cs typeface="Arial"/>
+              </a:defRPr>
+            </a:pPr>
+            <a:r>
+              <a:rPr sz="2100" b="0">
+                <a:solidFill>
+                  <a:srgbClr val="344854"/>
+                </a:solidFill>
+                <a:latin typeface="Arial"/>
+                <a:ea typeface="Arial"/>
+                <a:cs typeface="Arial"/>
+              </a:rPr>
+              <a:t>For c = 0.10: Cˡᵒᶜ = 0.87 gives ρ = 0.115,</a:t>
+            </a:r>
+          </a:p>
+          <a:p xmlns:a="http://schemas.openxmlformats.org/drawingml/2006/main">
+            <a:pPr algn="l">
+              <a:defRPr sz="2100" b="0">
+                <a:solidFill>
+                  <a:srgbClr val="344854"/>
+                </a:solidFill>
+                <a:latin typeface="Arial"/>
+                <a:ea typeface="Arial"/>
+                <a:cs typeface="Arial"/>
+              </a:defRPr>
+            </a:pPr>
+            <a:r>
+              <a:rPr sz="2100" b="0">
+                <a:solidFill>
+                  <a:srgbClr val="344854"/>
+                </a:solidFill>
+                <a:latin typeface="Arial"/>
+                <a:ea typeface="Arial"/>
+                <a:cs typeface="Arial"/>
+              </a:rPr>
+              <a:t>while Cˡᵒᶜ = 0.20 gives ρ = 0.50.</a:t>
+            </a:r>
+          </a:p>
+        </p:txBody>
+      </p:sp>
+      <p:sp>
+        <p:nvSpPr>
+          <p:cNvPr id="66" name="Sample label">
+            <a:extLst xmlns:a="http://schemas.openxmlformats.org/drawingml/2006/main">
+              <a:ext uri="{FF2B5EF4-FFF2-40B4-BE49-F238E27FC236}">
+                <a16:creationId xmlns:a16="http://schemas.microsoft.com/office/drawing/2014/main" id="{A4F7A47F-7364-4581-90AD-56EBF259312E}"/>
+              </a:ext>
+            </a:extLst>
+          </p:cNvPr>
+          <p:cNvSpPr>
+            <a:spLocks xmlns:a="http://schemas.openxmlformats.org/drawingml/2006/main" noGrp="1"/>
+          </p:cNvSpPr>
+          <p:nvPr/>
+        </p:nvSpPr>
+        <p:spPr>
+          <a:xfrm xmlns:a="http://schemas.openxmlformats.org/drawingml/2006/main">
+            <a:off x="11877675" y="12811125"/>
+            <a:ext cx="9048750" cy="457200"/>
+          </a:xfrm>
+          <a:prstGeom xmlns:a="http://schemas.openxmlformats.org/drawingml/2006/main" prst="rect">
+            <a:avLst/>
+          </a:prstGeom>
+          <a:noFill xmlns:a="http://schemas.openxmlformats.org/drawingml/2006/main"/>
+          <a:ln xmlns:a="http://schemas.openxmlformats.org/drawingml/2006/main" w="0">
+            <a:noFill/>
+          </a:ln>
+        </p:spPr>
+        <p:txBody>
+          <a:bodyPr xmlns:a="http://schemas.openxmlformats.org/drawingml/2006/main" wrap="square" lIns="0" tIns="0" rIns="0" bIns="0" anchor="t">
+            <a:noAutofit/>
+          </a:bodyPr>
+          <a:lstStyle xmlns:a="http://schemas.openxmlformats.org/drawingml/2006/main">
+            <a:defPPr algn="l">
+              <a:defRPr sz="2100" b="1">
+                <a:solidFill>
+                  <a:srgbClr val="000000"/>
+                </a:solidFill>
+                <a:latin typeface="Arial"/>
+                <a:ea typeface="Arial"/>
+                <a:cs typeface="Arial"/>
+              </a:defRPr>
+            </a:defPPr>
+          </a:lstStyle>
+          <a:p xmlns:a="http://schemas.openxmlformats.org/drawingml/2006/main">
+            <a:pPr algn="l">
+              <a:defRPr sz="2100" b="1">
+                <a:solidFill>
+                  <a:srgbClr val="000000"/>
+                </a:solidFill>
+                <a:latin typeface="Arial"/>
+                <a:ea typeface="Arial"/>
+                <a:cs typeface="Arial"/>
+              </a:defRPr>
+            </a:pPr>
+            <a:r>
+              <a:rPr sz="2100" b="1">
+                <a:solidFill>
+                  <a:srgbClr val="000000"/>
+                </a:solidFill>
+                <a:latin typeface="Arial"/>
+                <a:ea typeface="Arial"/>
+                <a:cs typeface="Arial"/>
+              </a:rPr>
+              <a:t>Across sequences: weakest local region</a:t>
+            </a:r>
+          </a:p>
+        </p:txBody>
+      </p:sp>
+      <p:sp>
+        <p:nvSpPr>
+          <p:cNvPr id="67" name="Sample equation">
+            <a:extLst xmlns:a="http://schemas.openxmlformats.org/drawingml/2006/main">
+              <a:ext uri="{FF2B5EF4-FFF2-40B4-BE49-F238E27FC236}">
+                <a16:creationId xmlns:a16="http://schemas.microsoft.com/office/drawing/2014/main" id="{DF706C5C-4D0D-4542-ACE1-36633F284020}"/>
+              </a:ext>
+            </a:extLst>
+          </p:cNvPr>
+          <p:cNvSpPr>
+            <a:spLocks xmlns:a="http://schemas.openxmlformats.org/drawingml/2006/main" noGrp="1"/>
+          </p:cNvSpPr>
+          <p:nvPr/>
+        </p:nvSpPr>
+        <p:spPr>
+          <a:xfrm xmlns:a="http://schemas.openxmlformats.org/drawingml/2006/main">
+            <a:off x="11877675" y="13335000"/>
+            <a:ext cx="9048750" cy="571500"/>
+          </a:xfrm>
+          <a:prstGeom xmlns:a="http://schemas.openxmlformats.org/drawingml/2006/main" prst="rect">
+            <a:avLst/>
+          </a:prstGeom>
+          <a:noFill xmlns:a="http://schemas.openxmlformats.org/drawingml/2006/main"/>
+          <a:ln xmlns:a="http://schemas.openxmlformats.org/drawingml/2006/main" w="0">
+            <a:noFill/>
+          </a:ln>
+        </p:spPr>
+        <p:txBody>
+          <a:bodyPr xmlns:a="http://schemas.openxmlformats.org/drawingml/2006/main" wrap="square" lIns="0" tIns="0" rIns="0" bIns="0" anchor="t">
+            <a:noAutofit/>
+          </a:bodyPr>
+          <a:lstStyle xmlns:a="http://schemas.openxmlformats.org/drawingml/2006/main">
+            <a:defPPr algn="l">
+              <a:defRPr sz="2600" b="0">
+                <a:solidFill>
+                  <a:srgbClr val="0054B8"/>
+                </a:solidFill>
+                <a:latin typeface="Arial"/>
+                <a:ea typeface="Arial"/>
+                <a:cs typeface="Arial"/>
+              </a:defRPr>
+            </a:defPPr>
+          </a:lstStyle>
+          <a:p xmlns:a="http://schemas.openxmlformats.org/drawingml/2006/main">
+            <a:pPr algn="l">
+              <a:defRPr sz="2600" b="0">
+                <a:solidFill>
+                  <a:srgbClr val="0054B8"/>
+                </a:solidFill>
+                <a:latin typeface="Arial"/>
+                <a:ea typeface="Arial"/>
+                <a:cs typeface="Arial"/>
+              </a:defRPr>
+            </a:pPr>
+            <a:r>
+              <a:rPr sz="2600" b="0">
+                <a:solidFill>
+                  <a:srgbClr val="0054B8"/>
+                </a:solidFill>
+                <a:latin typeface="Arial"/>
+                <a:ea typeface="Arial"/>
+                <a:cs typeface="Arial"/>
+              </a:rPr>
+              <a:t>sᵦ = sg(1 − minₜ Cᵦ,ₜˡᵒᶜ)</a:t>
+            </a:r>
+          </a:p>
+        </p:txBody>
+      </p:sp>
+      <p:sp>
+        <p:nvSpPr>
+          <p:cNvPr id="68" name="Loss equation">
+            <a:extLst xmlns:a="http://schemas.openxmlformats.org/drawingml/2006/main">
+              <a:ext uri="{FF2B5EF4-FFF2-40B4-BE49-F238E27FC236}">
+                <a16:creationId xmlns:a16="http://schemas.microsoft.com/office/drawing/2014/main" id="{F3A205B8-1B19-40EA-A328-962CDFBE08E0}"/>
+              </a:ext>
+            </a:extLst>
+          </p:cNvPr>
+          <p:cNvSpPr>
+            <a:spLocks xmlns:a="http://schemas.openxmlformats.org/drawingml/2006/main" noGrp="1"/>
+          </p:cNvSpPr>
+          <p:nvPr/>
+        </p:nvSpPr>
+        <p:spPr>
+          <a:xfrm xmlns:a="http://schemas.openxmlformats.org/drawingml/2006/main">
+            <a:off x="11877675" y="14001750"/>
+            <a:ext cx="9048750" cy="838200"/>
+          </a:xfrm>
+          <a:prstGeom xmlns:a="http://schemas.openxmlformats.org/drawingml/2006/main" prst="rect">
+            <a:avLst/>
+          </a:prstGeom>
+          <a:noFill xmlns:a="http://schemas.openxmlformats.org/drawingml/2006/main"/>
+          <a:ln xmlns:a="http://schemas.openxmlformats.org/drawingml/2006/main" w="0">
+            <a:noFill/>
+          </a:ln>
+        </p:spPr>
+        <p:txBody>
+          <a:bodyPr xmlns:a="http://schemas.openxmlformats.org/drawingml/2006/main" wrap="square" lIns="0" tIns="0" rIns="0" bIns="0" anchor="t">
+            <a:noAutofit/>
+          </a:bodyPr>
+          <a:lstStyle xmlns:a="http://schemas.openxmlformats.org/drawingml/2006/main">
+            <a:defPPr algn="l">
+              <a:defRPr sz="2100" b="0">
+                <a:solidFill>
+                  <a:srgbClr val="000000"/>
+                </a:solidFill>
+                <a:latin typeface="Arial"/>
+                <a:ea typeface="Arial"/>
+                <a:cs typeface="Arial"/>
+              </a:defRPr>
+            </a:defPPr>
+          </a:lstStyle>
+          <a:p xmlns:a="http://schemas.openxmlformats.org/drawingml/2006/main">
+            <a:pPr algn="l">
+              <a:defRPr sz="2100" b="0">
+                <a:solidFill>
+                  <a:srgbClr val="000000"/>
+                </a:solidFill>
+                <a:latin typeface="Arial"/>
+                <a:ea typeface="Arial"/>
+                <a:cs typeface="Arial"/>
+              </a:defRPr>
+            </a:pPr>
+            <a:r>
+              <a:rPr sz="2100" b="0">
+                <a:solidFill>
+                  <a:srgbClr val="000000"/>
+                </a:solidFill>
+                <a:latin typeface="Arial"/>
+                <a:ea typeface="Arial"/>
+                <a:cs typeface="Arial"/>
+              </a:rPr>
+              <a:t>L = (1/B) Σᵦ sᵦ [Σₜ mᵦ,ₜ sg(ρᵦ,ₜ) ℓᵦ,ₜ]</a:t>
+            </a:r>
+          </a:p>
+          <a:p xmlns:a="http://schemas.openxmlformats.org/drawingml/2006/main">
+            <a:pPr algn="l">
+              <a:defRPr sz="2100" b="0">
+                <a:solidFill>
+                  <a:srgbClr val="000000"/>
+                </a:solidFill>
+                <a:latin typeface="Arial"/>
+                <a:ea typeface="Arial"/>
+                <a:cs typeface="Arial"/>
+              </a:defRPr>
+            </a:pPr>
+            <a:r>
+              <a:rPr sz="2100" b="0">
+                <a:solidFill>
+                  <a:srgbClr val="000000"/>
+                </a:solidFill>
+                <a:latin typeface="Arial"/>
+                <a:ea typeface="Arial"/>
+                <a:cs typeface="Arial"/>
+              </a:rPr>
+              <a:t>                           / [Σₜ mᵦ,ₜ + ε]</a:t>
+            </a:r>
+          </a:p>
+        </p:txBody>
+      </p:sp>
+      <p:sp>
+        <p:nvSpPr>
+          <p:cNvPr id="69" name="Method definitions">
+            <a:extLst xmlns:a="http://schemas.openxmlformats.org/drawingml/2006/main">
+              <a:ext uri="{FF2B5EF4-FFF2-40B4-BE49-F238E27FC236}">
+                <a16:creationId xmlns:a16="http://schemas.microsoft.com/office/drawing/2014/main" id="{700CC461-641E-484E-B472-6B2C40A59A7F}"/>
+              </a:ext>
+            </a:extLst>
+          </p:cNvPr>
+          <p:cNvSpPr>
+            <a:spLocks xmlns:a="http://schemas.openxmlformats.org/drawingml/2006/main" noGrp="1"/>
+          </p:cNvSpPr>
+          <p:nvPr/>
+        </p:nvSpPr>
+        <p:spPr>
+          <a:xfrm xmlns:a="http://schemas.openxmlformats.org/drawingml/2006/main">
+            <a:off x="11877675" y="14954250"/>
+            <a:ext cx="9048750" cy="628650"/>
+          </a:xfrm>
+          <a:prstGeom xmlns:a="http://schemas.openxmlformats.org/drawingml/2006/main" prst="rect">
+            <a:avLst/>
+          </a:prstGeom>
+          <a:noFill xmlns:a="http://schemas.openxmlformats.org/drawingml/2006/main"/>
+          <a:ln xmlns:a="http://schemas.openxmlformats.org/drawingml/2006/main" w="0">
+            <a:noFill/>
+          </a:ln>
+        </p:spPr>
+        <p:txBody>
+          <a:bodyPr xmlns:a="http://schemas.openxmlformats.org/drawingml/2006/main" wrap="square" lIns="0" tIns="0" rIns="0" bIns="0" anchor="t">
+            <a:noAutofit/>
+          </a:bodyPr>
+          <a:lstStyle xmlns:a="http://schemas.openxmlformats.org/drawingml/2006/main">
+            <a:defPPr algn="l">
+              <a:defRPr sz="1300" b="0">
+                <a:solidFill>
+                  <a:srgbClr val="344854"/>
+                </a:solidFill>
+                <a:latin typeface="Arial"/>
+                <a:ea typeface="Arial"/>
+                <a:cs typeface="Arial"/>
+              </a:defRPr>
+            </a:defPPr>
+          </a:lstStyle>
+          <a:p xmlns:a="http://schemas.openxmlformats.org/drawingml/2006/main">
+            <a:pPr algn="l">
+              <a:defRPr sz="1300" b="0">
+                <a:solidFill>
+                  <a:srgbClr val="344854"/>
+                </a:solidFill>
+                <a:latin typeface="Arial"/>
+                <a:ea typeface="Arial"/>
+                <a:cs typeface="Arial"/>
+              </a:defRPr>
+            </a:pPr>
+            <a:r>
+              <a:rPr sz="1300" b="0">
+                <a:solidFill>
+                  <a:srgbClr val="344854"/>
+                </a:solidFill>
+                <a:latin typeface="Arial"/>
+                <a:ea typeface="Arial"/>
+                <a:cs typeface="Arial"/>
+              </a:rPr>
+              <a:t>Cˡᵒᶜ: centered-window mean of target probabilities. ℓ = −log c. m selects response tokens. Both weights use stop-gradient (sg). g = 256 is the only added tunable hyperparameter.</a:t>
+            </a:r>
+          </a:p>
+        </p:txBody>
+      </p:sp>
+      <p:sp>
+        <p:nvSpPr>
+          <p:cNvPr id="70" name="VCWorld subheading">
+            <a:extLst xmlns:a="http://schemas.openxmlformats.org/drawingml/2006/main">
+              <a:ext uri="{FF2B5EF4-FFF2-40B4-BE49-F238E27FC236}">
+                <a16:creationId xmlns:a16="http://schemas.microsoft.com/office/drawing/2014/main" id="{E3CD4F8B-5CE1-4849-AC23-75BCA408F852}"/>
+              </a:ext>
+            </a:extLst>
+          </p:cNvPr>
+          <p:cNvSpPr>
+            <a:spLocks xmlns:a="http://schemas.openxmlformats.org/drawingml/2006/main" noGrp="1"/>
+          </p:cNvSpPr>
+          <p:nvPr/>
+        </p:nvSpPr>
+        <p:spPr>
+          <a:xfrm xmlns:a="http://schemas.openxmlformats.org/drawingml/2006/main">
+            <a:off x="22926675" y="6048375"/>
+            <a:ext cx="9048750" cy="571500"/>
+          </a:xfrm>
+          <a:prstGeom xmlns:a="http://schemas.openxmlformats.org/drawingml/2006/main" prst="rect">
+            <a:avLst/>
+          </a:prstGeom>
+          <a:noFill xmlns:a="http://schemas.openxmlformats.org/drawingml/2006/main"/>
+          <a:ln xmlns:a="http://schemas.openxmlformats.org/drawingml/2006/main" w="0">
+            <a:noFill/>
+          </a:ln>
+        </p:spPr>
+        <p:txBody>
+          <a:bodyPr xmlns:a="http://schemas.openxmlformats.org/drawingml/2006/main" wrap="square" lIns="0" tIns="0" rIns="0" bIns="0" anchor="t">
+            <a:noAutofit/>
+          </a:bodyPr>
+          <a:lstStyle xmlns:a="http://schemas.openxmlformats.org/drawingml/2006/main">
+            <a:defPPr algn="l">
+              <a:defRPr sz="2600" b="1">
+                <a:solidFill>
+                  <a:srgbClr val="000000"/>
+                </a:solidFill>
+                <a:latin typeface="Arial"/>
+                <a:ea typeface="Arial"/>
+                <a:cs typeface="Arial"/>
+              </a:defRPr>
+            </a:defPPr>
+          </a:lstStyle>
+          <a:p xmlns:a="http://schemas.openxmlformats.org/drawingml/2006/main">
+            <a:pPr algn="l">
+              <a:defRPr sz="2600" b="1">
+                <a:solidFill>
+                  <a:srgbClr val="000000"/>
+                </a:solidFill>
+                <a:latin typeface="Arial"/>
+                <a:ea typeface="Arial"/>
+                <a:cs typeface="Arial"/>
+              </a:defRPr>
+            </a:pPr>
+            <a:r>
+              <a:rPr sz="2600" b="1">
+                <a:solidFill>
+                  <a:srgbClr val="000000"/>
+                </a:solidFill>
+                <a:latin typeface="Arial"/>
+                <a:ea typeface="Arial"/>
+                <a:cs typeface="Arial"/>
+              </a:rPr>
+              <a:t>Chemical perturbation reasoning</a:t>
+            </a:r>
+          </a:p>
+        </p:txBody>
+      </p:sp>
+      <p:graphicFrame>
+        <p:nvGraphicFramePr>
+          <p:cNvPr id="71" name="Chart">
+            <a:extLst xmlns:a="http://schemas.openxmlformats.org/drawingml/2006/main">
+              <a:ext uri="{FF2B5EF4-FFF2-40B4-BE49-F238E27FC236}">
+                <a16:creationId xmlns:a16="http://schemas.microsoft.com/office/drawing/2014/main" id="{4E59ECDD-7A98-4B8C-B16F-0557ABF4159F}"/>
+              </a:ext>
+            </a:extLst>
+          </p:cNvPr>
+          <p:cNvGraphicFramePr/>
+          <p:nvPr/>
+        </p:nvGraphicFramePr>
+        <p:xfrm>
+          <a:off xmlns:a="http://schemas.openxmlformats.org/drawingml/2006/main" x="22926675" y="8001000"/>
+          <a:ext xmlns:a="http://schemas.openxmlformats.org/drawingml/2006/main" cx="9048750" cy="4000500"/>
+        </p:xfrm>
+        <a:graphic xmlns:a="http://schemas.openxmlformats.org/drawingml/2006/main">
+          <a:graphicData uri="http://schemas.openxmlformats.org/drawingml/2006/chart">
+            <c:chart xmlns:r="http://schemas.openxmlformats.org/officeDocument/2006/relationships" xmlns:c="http://schemas.openxmlformats.org/drawingml/2006/chart" r:id="R43889262f3f343be"/>
+          </a:graphicData>
+        </a:graphic>
+      </p:graphicFrame>
+      <p:sp>
+        <p:nvSpPr>
+          <p:cNvPr id="72" name="VCWorld improvement">
+            <a:extLst xmlns:a="http://schemas.openxmlformats.org/drawingml/2006/main">
+              <a:ext uri="{FF2B5EF4-FFF2-40B4-BE49-F238E27FC236}">
+                <a16:creationId xmlns:a16="http://schemas.microsoft.com/office/drawing/2014/main" id="{4BFD45B8-710E-427C-813A-25471490A5B8}"/>
+              </a:ext>
+            </a:extLst>
+          </p:cNvPr>
+          <p:cNvSpPr>
+            <a:spLocks xmlns:a="http://schemas.openxmlformats.org/drawingml/2006/main" noGrp="1"/>
+          </p:cNvSpPr>
+          <p:nvPr/>
+        </p:nvSpPr>
+        <p:spPr>
+          <a:xfrm xmlns:a="http://schemas.openxmlformats.org/drawingml/2006/main">
+            <a:off x="22926675" y="12287250"/>
+            <a:ext cx="9048750" cy="552450"/>
+          </a:xfrm>
+          <a:prstGeom xmlns:a="http://schemas.openxmlformats.org/drawingml/2006/main" prst="rect">
+            <a:avLst/>
+          </a:prstGeom>
+          <a:noFill xmlns:a="http://schemas.openxmlformats.org/drawingml/2006/main"/>
+          <a:ln xmlns:a="http://schemas.openxmlformats.org/drawingml/2006/main" w="0">
+            <a:noFill/>
+          </a:ln>
+        </p:spPr>
+        <p:txBody>
+          <a:bodyPr xmlns:a="http://schemas.openxmlformats.org/drawingml/2006/main" wrap="square" lIns="0" tIns="0" rIns="0" bIns="0" anchor="t">
+            <a:noAutofit/>
+          </a:bodyPr>
+          <a:lstStyle xmlns:a="http://schemas.openxmlformats.org/drawingml/2006/main">
+            <a:defPPr algn="l">
+              <a:defRPr sz="2600" b="1">
+                <a:solidFill>
+                  <a:srgbClr val="0054B8"/>
+                </a:solidFill>
+                <a:latin typeface="Arial"/>
+                <a:ea typeface="Arial"/>
+                <a:cs typeface="Arial"/>
+              </a:defRPr>
+            </a:defPPr>
+          </a:lstStyle>
+          <a:p xmlns:a="http://schemas.openxmlformats.org/drawingml/2006/main">
+            <a:pPr algn="l">
+              <a:defRPr sz="2600" b="1">
+                <a:solidFill>
+                  <a:srgbClr val="0054B8"/>
+                </a:solidFill>
+                <a:latin typeface="Arial"/>
+                <a:ea typeface="Arial"/>
+                <a:cs typeface="Arial"/>
+              </a:defRPr>
+            </a:pPr>
+            <a:r>
+              <a:rPr sz="2600" b="1">
+                <a:solidFill>
+                  <a:srgbClr val="0054B8"/>
+                </a:solidFill>
+                <a:latin typeface="Arial"/>
+                <a:ea typeface="Arial"/>
+                <a:cs typeface="Arial"/>
+              </a:rPr>
+              <a:t>+13.4 pp over SFT before GRPO</a:t>
+            </a:r>
+          </a:p>
+        </p:txBody>
+      </p:sp>
+      <p:sp>
+        <p:nvSpPr>
+          <p:cNvPr id="73" name="VCWorld comparison">
+            <a:extLst xmlns:a="http://schemas.openxmlformats.org/drawingml/2006/main">
+              <a:ext uri="{FF2B5EF4-FFF2-40B4-BE49-F238E27FC236}">
+                <a16:creationId xmlns:a16="http://schemas.microsoft.com/office/drawing/2014/main" id="{66540740-49BE-4850-B105-5013EDE9EA62}"/>
+              </a:ext>
+            </a:extLst>
+          </p:cNvPr>
+          <p:cNvSpPr>
+            <a:spLocks xmlns:a="http://schemas.openxmlformats.org/drawingml/2006/main" noGrp="1"/>
+          </p:cNvSpPr>
+          <p:nvPr/>
+        </p:nvSpPr>
+        <p:spPr>
+          <a:xfrm xmlns:a="http://schemas.openxmlformats.org/drawingml/2006/main">
+            <a:off x="22926675" y="12906375"/>
+            <a:ext cx="9048750" cy="838200"/>
+          </a:xfrm>
+          <a:prstGeom xmlns:a="http://schemas.openxmlformats.org/drawingml/2006/main" prst="rect">
+            <a:avLst/>
+          </a:prstGeom>
+          <a:noFill xmlns:a="http://schemas.openxmlformats.org/drawingml/2006/main"/>
+          <a:ln xmlns:a="http://schemas.openxmlformats.org/drawingml/2006/main" w="0">
+            <a:noFill/>
+          </a:ln>
+        </p:spPr>
+        <p:txBody>
+          <a:bodyPr xmlns:a="http://schemas.openxmlformats.org/drawingml/2006/main" wrap="square" lIns="0" tIns="0" rIns="0" bIns="0" anchor="t">
+            <a:noAutofit/>
+          </a:bodyPr>
+          <a:lstStyle xmlns:a="http://schemas.openxmlformats.org/drawingml/2006/main">
+            <a:defPPr algn="l">
+              <a:defRPr sz="2100" b="0">
+                <a:solidFill>
+                  <a:srgbClr val="344854"/>
+                </a:solidFill>
+                <a:latin typeface="Arial"/>
+                <a:ea typeface="Arial"/>
+                <a:cs typeface="Arial"/>
+              </a:defRPr>
+            </a:defPPr>
+          </a:lstStyle>
+          <a:p xmlns:a="http://schemas.openxmlformats.org/drawingml/2006/main">
+            <a:pPr algn="l">
+              <a:defRPr sz="2100" b="0">
+                <a:solidFill>
+                  <a:srgbClr val="344854"/>
+                </a:solidFill>
+                <a:latin typeface="Arial"/>
+                <a:ea typeface="Arial"/>
+                <a:cs typeface="Arial"/>
+              </a:defRPr>
+            </a:pPr>
+            <a:r>
+              <a:rPr sz="2100" b="0">
+                <a:solidFill>
+                  <a:srgbClr val="344854"/>
+                </a:solidFill>
+                <a:latin typeface="Arial"/>
+                <a:ea typeface="Arial"/>
+                <a:cs typeface="Arial"/>
+              </a:rPr>
+              <a:t>BFT 0.696 vs SFT 0.562 under the shared recipe.</a:t>
+            </a:r>
+          </a:p>
+          <a:p xmlns:a="http://schemas.openxmlformats.org/drawingml/2006/main">
+            <a:pPr algn="l">
+              <a:defRPr sz="2100" b="0">
+                <a:solidFill>
+                  <a:srgbClr val="344854"/>
+                </a:solidFill>
+                <a:latin typeface="Arial"/>
+                <a:ea typeface="Arial"/>
+                <a:cs typeface="Arial"/>
+              </a:defRPr>
+            </a:pPr>
+            <a:r>
+              <a:rPr sz="2100" b="0">
+                <a:solidFill>
+                  <a:srgbClr val="344854"/>
+                </a:solidFill>
+                <a:latin typeface="Arial"/>
+                <a:ea typeface="Arial"/>
+                <a:cs typeface="Arial"/>
+              </a:rPr>
+              <a:t>Token-only 0.660 and sample-only 0.596 are intermediate.</a:t>
+            </a:r>
+          </a:p>
+        </p:txBody>
+      </p:sp>
+      <p:sp>
+        <p:nvSpPr>
+          <p:cNvPr id="74" name="RL improvement">
+            <a:extLst xmlns:a="http://schemas.openxmlformats.org/drawingml/2006/main">
+              <a:ext uri="{FF2B5EF4-FFF2-40B4-BE49-F238E27FC236}">
+                <a16:creationId xmlns:a16="http://schemas.microsoft.com/office/drawing/2014/main" id="{5B4B415E-05DE-4808-8F2D-526AF7104826}"/>
+              </a:ext>
+            </a:extLst>
+          </p:cNvPr>
+          <p:cNvSpPr>
+            <a:spLocks xmlns:a="http://schemas.openxmlformats.org/drawingml/2006/main" noGrp="1"/>
+          </p:cNvSpPr>
+          <p:nvPr/>
+        </p:nvSpPr>
+        <p:spPr>
+          <a:xfrm xmlns:a="http://schemas.openxmlformats.org/drawingml/2006/main">
+            <a:off x="22926675" y="13906500"/>
+            <a:ext cx="9048750" cy="552450"/>
+          </a:xfrm>
+          <a:prstGeom xmlns:a="http://schemas.openxmlformats.org/drawingml/2006/main" prst="rect">
+            <a:avLst/>
+          </a:prstGeom>
+          <a:noFill xmlns:a="http://schemas.openxmlformats.org/drawingml/2006/main"/>
+          <a:ln xmlns:a="http://schemas.openxmlformats.org/drawingml/2006/main" w="0">
+            <a:noFill/>
+          </a:ln>
+        </p:spPr>
+        <p:txBody>
+          <a:bodyPr xmlns:a="http://schemas.openxmlformats.org/drawingml/2006/main" wrap="square" lIns="0" tIns="0" rIns="0" bIns="0" anchor="t">
+            <a:noAutofit/>
+          </a:bodyPr>
+          <a:lstStyle xmlns:a="http://schemas.openxmlformats.org/drawingml/2006/main">
+            <a:defPPr algn="l">
+              <a:defRPr sz="2600" b="1">
+                <a:solidFill>
+                  <a:srgbClr val="0054B8"/>
+                </a:solidFill>
+                <a:latin typeface="Arial"/>
+                <a:ea typeface="Arial"/>
+                <a:cs typeface="Arial"/>
+              </a:defRPr>
+            </a:defPPr>
+          </a:lstStyle>
+          <a:p xmlns:a="http://schemas.openxmlformats.org/drawingml/2006/main">
+            <a:pPr algn="l">
+              <a:defRPr sz="2600" b="1">
+                <a:solidFill>
+                  <a:srgbClr val="0054B8"/>
+                </a:solidFill>
+                <a:latin typeface="Arial"/>
+                <a:ea typeface="Arial"/>
+                <a:cs typeface="Arial"/>
+              </a:defRPr>
+            </a:pPr>
+            <a:r>
+              <a:rPr sz="2600" b="1">
+                <a:solidFill>
+                  <a:srgbClr val="0054B8"/>
+                </a:solidFill>
+                <a:latin typeface="Arial"/>
+                <a:ea typeface="Arial"/>
+                <a:cs typeface="Arial"/>
+              </a:rPr>
+              <a:t>+4.0 pp after sparse-reward GRPO</a:t>
+            </a:r>
+          </a:p>
+        </p:txBody>
+      </p:sp>
+      <p:sp>
+        <p:nvSpPr>
+          <p:cNvPr id="75" name="RL comparison">
+            <a:extLst xmlns:a="http://schemas.openxmlformats.org/drawingml/2006/main">
+              <a:ext uri="{FF2B5EF4-FFF2-40B4-BE49-F238E27FC236}">
+                <a16:creationId xmlns:a16="http://schemas.microsoft.com/office/drawing/2014/main" id="{13C63E96-F355-4D23-94E1-A9D1E35CFDFA}"/>
+              </a:ext>
+            </a:extLst>
+          </p:cNvPr>
+          <p:cNvSpPr>
+            <a:spLocks xmlns:a="http://schemas.openxmlformats.org/drawingml/2006/main" noGrp="1"/>
+          </p:cNvSpPr>
+          <p:nvPr/>
+        </p:nvSpPr>
+        <p:spPr>
+          <a:xfrm xmlns:a="http://schemas.openxmlformats.org/drawingml/2006/main">
+            <a:off x="22926675" y="14525625"/>
+            <a:ext cx="9048750" cy="857250"/>
+          </a:xfrm>
+          <a:prstGeom xmlns:a="http://schemas.openxmlformats.org/drawingml/2006/main" prst="rect">
+            <a:avLst/>
+          </a:prstGeom>
+          <a:noFill xmlns:a="http://schemas.openxmlformats.org/drawingml/2006/main"/>
+          <a:ln xmlns:a="http://schemas.openxmlformats.org/drawingml/2006/main" w="0">
+            <a:noFill/>
+          </a:ln>
+        </p:spPr>
+        <p:txBody>
+          <a:bodyPr xmlns:a="http://schemas.openxmlformats.org/drawingml/2006/main" wrap="square" lIns="0" tIns="0" rIns="0" bIns="0" anchor="t">
+            <a:noAutofit/>
+          </a:bodyPr>
+          <a:lstStyle xmlns:a="http://schemas.openxmlformats.org/drawingml/2006/main">
+            <a:defPPr algn="l">
+              <a:defRPr sz="2100" b="0">
+                <a:solidFill>
+                  <a:srgbClr val="344854"/>
+                </a:solidFill>
+                <a:latin typeface="Arial"/>
+                <a:ea typeface="Arial"/>
+                <a:cs typeface="Arial"/>
+              </a:defRPr>
+            </a:defPPr>
+          </a:lstStyle>
+          <a:p xmlns:a="http://schemas.openxmlformats.org/drawingml/2006/main">
+            <a:pPr algn="l">
+              <a:defRPr sz="2100" b="0">
+                <a:solidFill>
+                  <a:srgbClr val="344854"/>
+                </a:solidFill>
+                <a:latin typeface="Arial"/>
+                <a:ea typeface="Arial"/>
+                <a:cs typeface="Arial"/>
+              </a:defRPr>
+            </a:pPr>
+            <a:r>
+              <a:rPr sz="2100" b="0">
+                <a:solidFill>
+                  <a:srgbClr val="344854"/>
+                </a:solidFill>
+                <a:latin typeface="Arial"/>
+                <a:ea typeface="Arial"/>
+                <a:cs typeface="Arial"/>
+              </a:rPr>
+              <a:t>All BFT variants improve. SFT loses 7.6 pp and DFT loses 7.0 pp under the same GRPO setup.</a:t>
+            </a:r>
+          </a:p>
+        </p:txBody>
+      </p:sp>
+      <p:sp>
+        <p:nvSpPr>
+          <p:cNvPr id="76" name="VCWorld uncertainty">
+            <a:extLst xmlns:a="http://schemas.openxmlformats.org/drawingml/2006/main">
+              <a:ext uri="{FF2B5EF4-FFF2-40B4-BE49-F238E27FC236}">
+                <a16:creationId xmlns:a16="http://schemas.microsoft.com/office/drawing/2014/main" id="{0ACBAF8B-C024-490B-8388-068FCD4DE495}"/>
+              </a:ext>
+            </a:extLst>
+          </p:cNvPr>
+          <p:cNvSpPr>
+            <a:spLocks xmlns:a="http://schemas.openxmlformats.org/drawingml/2006/main" noGrp="1"/>
+          </p:cNvSpPr>
+          <p:nvPr/>
+        </p:nvSpPr>
+        <p:spPr>
+          <a:xfrm xmlns:a="http://schemas.openxmlformats.org/drawingml/2006/main">
+            <a:off x="22926675" y="15430500"/>
+            <a:ext cx="9048750" cy="457200"/>
+          </a:xfrm>
+          <a:prstGeom xmlns:a="http://schemas.openxmlformats.org/drawingml/2006/main" prst="rect">
+            <a:avLst/>
+          </a:prstGeom>
+          <a:noFill xmlns:a="http://schemas.openxmlformats.org/drawingml/2006/main"/>
+          <a:ln xmlns:a="http://schemas.openxmlformats.org/drawingml/2006/main" w="0">
+            <a:noFill/>
+          </a:ln>
+        </p:spPr>
+        <p:txBody>
+          <a:bodyPr xmlns:a="http://schemas.openxmlformats.org/drawingml/2006/main" wrap="square" lIns="0" tIns="0" rIns="0" bIns="0" anchor="t">
+            <a:noAutofit/>
+          </a:bodyPr>
+          <a:lstStyle xmlns:a="http://schemas.openxmlformats.org/drawingml/2006/main">
+            <a:defPPr algn="l">
+              <a:defRPr sz="1300" b="0">
+                <a:solidFill>
+                  <a:srgbClr val="344854"/>
+                </a:solidFill>
+                <a:latin typeface="Arial"/>
+                <a:ea typeface="Arial"/>
+                <a:cs typeface="Arial"/>
+              </a:defRPr>
+            </a:defPPr>
+          </a:lstStyle>
+          <a:p xmlns:a="http://schemas.openxmlformats.org/drawingml/2006/main">
+            <a:pPr algn="l">
+              <a:defRPr sz="1300" b="0">
+                <a:solidFill>
+                  <a:srgbClr val="344854"/>
+                </a:solidFill>
+                <a:latin typeface="Arial"/>
+                <a:ea typeface="Arial"/>
+                <a:cs typeface="Arial"/>
+              </a:defRPr>
+            </a:pPr>
+            <a:r>
+              <a:rPr sz="1300" b="0">
+                <a:solidFill>
+                  <a:srgbClr val="344854"/>
+                </a:solidFill>
+                <a:latin typeface="Arial"/>
+                <a:ea typeface="Arial"/>
+                <a:cs typeface="Arial"/>
+              </a:rPr>
+              <a:t>BFT vs Gemini-2.5-Flash: +0.018, 95% CI [−0.004, 0.040], p = 0.088. The difference is not statistically significant.</a:t>
+            </a:r>
+          </a:p>
+        </p:txBody>
+      </p:sp>
+      <p:sp>
+        <p:nvSpPr>
+          <p:cNvPr id="77" name="Medical heading">
+            <a:extLst xmlns:a="http://schemas.openxmlformats.org/drawingml/2006/main">
+              <a:ext uri="{FF2B5EF4-FFF2-40B4-BE49-F238E27FC236}">
+                <a16:creationId xmlns:a16="http://schemas.microsoft.com/office/drawing/2014/main" id="{869AFA77-F92E-4587-93B0-8C01F9421B1F}"/>
+              </a:ext>
+            </a:extLst>
+          </p:cNvPr>
+          <p:cNvSpPr>
+            <a:spLocks xmlns:a="http://schemas.openxmlformats.org/drawingml/2006/main" noGrp="1"/>
+          </p:cNvSpPr>
+          <p:nvPr/>
+        </p:nvSpPr>
+        <p:spPr>
+          <a:xfrm xmlns:a="http://schemas.openxmlformats.org/drawingml/2006/main">
+            <a:off x="990600" y="16097250"/>
             <a:ext cx="9048750" cy="666750"/>
           </a:xfrm>
           <a:prstGeom xmlns:a="http://schemas.openxmlformats.org/drawingml/2006/main" prst="rect">
@@ -3811,9 +4894,9 @@
           </a:bodyPr>
           <a:lstStyle xmlns:a="http://schemas.openxmlformats.org/drawingml/2006/main">
             <a:defPPr algn="l">
-              <a:defRPr sz="2600" b="0">
-                <a:solidFill>
-                  <a:srgbClr val="344854"/>
+              <a:defRPr sz="3400" b="0">
+                <a:solidFill>
+                  <a:srgbClr val="000000"/>
                 </a:solidFill>
                 <a:latin typeface="Arial"/>
                 <a:ea typeface="Arial"/>
@@ -3823,9 +4906,9 @@
           </a:lstStyle>
           <a:p xmlns:a="http://schemas.openxmlformats.org/drawingml/2006/main">
             <a:pPr algn="l">
-              <a:defRPr sz="2600" b="0">
-                <a:solidFill>
-                  <a:srgbClr val="344854"/>
+              <a:defRPr sz="3400" b="0">
+                <a:solidFill>
+                  <a:srgbClr val="000000"/>
                 </a:solidFill>
                 <a:latin typeface="Arial"/>
                 <a:ea typeface="Arial"/>
@@ -3833,25 +4916,25 @@
               </a:defRPr>
             </a:pPr>
             <a:r>
-              <a:rPr sz="2600" b="0">
-                <a:solidFill>
-                  <a:srgbClr val="344854"/>
+              <a:rPr sz="3400" b="0">
+                <a:solidFill>
+                  <a:srgbClr val="000000"/>
                 </a:solidFill>
                 <a:latin typeface="Arial"/>
                 <a:ea typeface="Arial"/>
                 <a:cs typeface="Arial"/>
               </a:rPr>
-              <a:t>ρᵦ,ₜ = clip(cᵦ,ₜ / (Cᵦ,ₜˡᵒᶜ + ε), 0, 1)</a:t>
+              <a:t>Medical &amp; biological reasoning</a:t>
             </a:r>
           </a:p>
         </p:txBody>
       </p:sp>
       <p:sp>
         <p:nvSpPr>
-          <p:cNvPr id="60" name="Sample equation">
+          <p:cNvPr id="78" name="Medical setup">
             <a:extLst xmlns:a="http://schemas.openxmlformats.org/drawingml/2006/main">
               <a:ext uri="{FF2B5EF4-FFF2-40B4-BE49-F238E27FC236}">
-                <a16:creationId xmlns:a16="http://schemas.microsoft.com/office/drawing/2014/main" id="{26A85C8A-679B-4711-B16F-51F796776BDE}"/>
+                <a16:creationId xmlns:a16="http://schemas.microsoft.com/office/drawing/2014/main" id="{4579F6ED-E86F-4FC2-8BDE-CD2F73EBB30C}"/>
               </a:ext>
             </a:extLst>
           </p:cNvPr>
@@ -3862,8 +4945,8 @@
         </p:nvSpPr>
         <p:spPr>
           <a:xfrm xmlns:a="http://schemas.openxmlformats.org/drawingml/2006/main">
-            <a:off x="990600" y="19050000"/>
-            <a:ext cx="9048750" cy="619125"/>
+            <a:off x="990600" y="16906875"/>
+            <a:ext cx="9048750" cy="457200"/>
           </a:xfrm>
           <a:prstGeom xmlns:a="http://schemas.openxmlformats.org/drawingml/2006/main" prst="rect">
             <a:avLst/>
@@ -3879,7 +4962,7 @@
           </a:bodyPr>
           <a:lstStyle xmlns:a="http://schemas.openxmlformats.org/drawingml/2006/main">
             <a:defPPr algn="l">
-              <a:defRPr sz="2600" b="0">
+              <a:defRPr sz="2100" b="0">
                 <a:solidFill>
                   <a:srgbClr val="344854"/>
                 </a:solidFill>
@@ -3891,7 +4974,7 @@
           </a:lstStyle>
           <a:p xmlns:a="http://schemas.openxmlformats.org/drawingml/2006/main">
             <a:pPr algn="l">
-              <a:defRPr sz="2600" b="0">
+              <a:defRPr sz="2100" b="0">
                 <a:solidFill>
                   <a:srgbClr val="344854"/>
                 </a:solidFill>
@@ -3901,7 +4984,7 @@
               </a:defRPr>
             </a:pPr>
             <a:r>
-              <a:rPr sz="2600" b="0">
+              <a:rPr sz="2100" b="0">
                 <a:solidFill>
                   <a:srgbClr val="344854"/>
                 </a:solidFill>
@@ -3909,39 +4992,73 @@
                 <a:ea typeface="Arial"/>
                 <a:cs typeface="Arial"/>
               </a:rPr>
-              <a:t>sᵦ = sg(1 − minₜ Cᵦ,ₜˡᵒᶜ)</a:t>
+              <a:t>HealthBench Hard, 70B axis- and theme-wise scores</a:t>
             </a:r>
           </a:p>
         </p:txBody>
       </p:sp>
-      <p:graphicFrame>
-        <p:nvGraphicFramePr>
-          <p:cNvPr id="61" name="Chart">
+      <p:pic>
+        <p:nvPicPr>
+          <p:cNvPr id="79" name="">
             <a:extLst xmlns:a="http://schemas.openxmlformats.org/drawingml/2006/main">
               <a:ext uri="{FF2B5EF4-FFF2-40B4-BE49-F238E27FC236}">
-                <a16:creationId xmlns:a16="http://schemas.microsoft.com/office/drawing/2014/main" id="{06A72AF8-83E4-47ED-9E39-DC13A144A34D}"/>
+                <a16:creationId xmlns:a16="http://schemas.microsoft.com/office/drawing/2014/main" id="{C4151016-301A-4B64-8D72-1457952C38A7}"/>
               </a:ext>
             </a:extLst>
           </p:cNvPr>
-          <p:cNvGraphicFramePr/>
+          <p:cNvPicPr>
+            <a:picLocks xmlns:a="http://schemas.openxmlformats.org/drawingml/2006/main" noChangeAspect="1"/>
+          </p:cNvPicPr>
           <p:nvPr/>
-        </p:nvGraphicFramePr>
-        <p:xfrm>
-          <a:off xmlns:a="http://schemas.openxmlformats.org/drawingml/2006/main" x="11877675" y="7953375"/>
-          <a:ext xmlns:a="http://schemas.openxmlformats.org/drawingml/2006/main" cx="9048750" cy="4953000"/>
-        </p:xfrm>
-        <a:graphic xmlns:a="http://schemas.openxmlformats.org/drawingml/2006/main">
-          <a:graphicData uri="http://schemas.openxmlformats.org/drawingml/2006/chart">
-            <c:chart xmlns:r="http://schemas.openxmlformats.org/officeDocument/2006/relationships" xmlns:c="http://schemas.openxmlformats.org/drawingml/2006/chart" r:id="R02c5582d5eb0494c"/>
-          </a:graphicData>
-        </a:graphic>
-      </p:graphicFrame>
+        </p:nvPicPr>
+        <p:blipFill>
+          <a:blip xmlns:r="http://schemas.openxmlformats.org/officeDocument/2006/relationships" xmlns:a="http://schemas.openxmlformats.org/drawingml/2006/main" r:embed="Re87059b431884081"/>
+          <a:stretch xmlns:a="http://schemas.openxmlformats.org/drawingml/2006/main"/>
+        </p:blipFill>
+        <p:spPr>
+          <a:xfrm xmlns:a="http://schemas.openxmlformats.org/drawingml/2006/main">
+            <a:off x="998323" y="17526000"/>
+            <a:ext cx="9033304" cy="2762250"/>
+          </a:xfrm>
+          <a:prstGeom xmlns:a="http://schemas.openxmlformats.org/drawingml/2006/main" prst="rect">
+            <a:avLst/>
+          </a:prstGeom>
+        </p:spPr>
+      </p:pic>
+      <p:pic>
+        <p:nvPicPr>
+          <p:cNvPr id="80" name="">
+            <a:extLst xmlns:a="http://schemas.openxmlformats.org/drawingml/2006/main">
+              <a:ext uri="{FF2B5EF4-FFF2-40B4-BE49-F238E27FC236}">
+                <a16:creationId xmlns:a16="http://schemas.microsoft.com/office/drawing/2014/main" id="{D2629740-799E-47BB-9045-ED493D6F5E36}"/>
+              </a:ext>
+            </a:extLst>
+          </p:cNvPr>
+          <p:cNvPicPr>
+            <a:picLocks xmlns:a="http://schemas.openxmlformats.org/drawingml/2006/main" noChangeAspect="1"/>
+          </p:cNvPicPr>
+          <p:nvPr/>
+        </p:nvPicPr>
+        <p:blipFill>
+          <a:blip xmlns:r="http://schemas.openxmlformats.org/officeDocument/2006/relationships" xmlns:a="http://schemas.openxmlformats.org/drawingml/2006/main" r:embed="R11ef9c2eeb814a25"/>
+          <a:stretch xmlns:a="http://schemas.openxmlformats.org/drawingml/2006/main"/>
+        </p:blipFill>
+        <p:spPr>
+          <a:xfrm xmlns:a="http://schemas.openxmlformats.org/drawingml/2006/main">
+            <a:off x="1993371" y="20288250"/>
+            <a:ext cx="7043208" cy="523875"/>
+          </a:xfrm>
+          <a:prstGeom xmlns:a="http://schemas.openxmlformats.org/drawingml/2006/main" prst="rect">
+            <a:avLst/>
+          </a:prstGeom>
+        </p:spPr>
+      </p:pic>
       <p:sp>
         <p:nvSpPr>
-          <p:cNvPr id="62" name="Medical heading">
+          <p:cNvPr id="81" name="Medical caption">
             <a:extLst xmlns:a="http://schemas.openxmlformats.org/drawingml/2006/main">
               <a:ext uri="{FF2B5EF4-FFF2-40B4-BE49-F238E27FC236}">
-                <a16:creationId xmlns:a16="http://schemas.microsoft.com/office/drawing/2014/main" id="{7C51549E-3805-4F5E-9F0B-9B8B38A63880}"/>
+                <a16:creationId xmlns:a16="http://schemas.microsoft.com/office/drawing/2014/main" id="{B1B3DE22-3ADC-4F4A-B155-07943520DF36}"/>
               </a:ext>
             </a:extLst>
           </p:cNvPr>
@@ -3952,103 +5069,7 @@
         </p:nvSpPr>
         <p:spPr>
           <a:xfrm xmlns:a="http://schemas.openxmlformats.org/drawingml/2006/main">
-            <a:off x="11877675" y="15621000"/>
-            <a:ext cx="9048750" cy="1047750"/>
-          </a:xfrm>
-          <a:prstGeom xmlns:a="http://schemas.openxmlformats.org/drawingml/2006/main" prst="rect">
-            <a:avLst/>
-          </a:prstGeom>
-          <a:noFill xmlns:a="http://schemas.openxmlformats.org/drawingml/2006/main"/>
-          <a:ln xmlns:a="http://schemas.openxmlformats.org/drawingml/2006/main" w="0">
-            <a:noFill/>
-          </a:ln>
-        </p:spPr>
-        <p:txBody>
-          <a:bodyPr xmlns:a="http://schemas.openxmlformats.org/drawingml/2006/main" wrap="square" lIns="0" tIns="0" rIns="0" bIns="0" anchor="t">
-            <a:noAutofit/>
-          </a:bodyPr>
-          <a:lstStyle xmlns:a="http://schemas.openxmlformats.org/drawingml/2006/main">
-            <a:defPPr algn="l">
-              <a:defRPr sz="3400" b="0">
-                <a:solidFill>
-                  <a:srgbClr val="000000"/>
-                </a:solidFill>
-                <a:latin typeface="Arial"/>
-                <a:ea typeface="Arial"/>
-                <a:cs typeface="Arial"/>
-              </a:defRPr>
-            </a:defPPr>
-          </a:lstStyle>
-          <a:p xmlns:a="http://schemas.openxmlformats.org/drawingml/2006/main">
-            <a:pPr algn="l">
-              <a:defRPr sz="3400" b="0">
-                <a:solidFill>
-                  <a:srgbClr val="000000"/>
-                </a:solidFill>
-                <a:latin typeface="Arial"/>
-                <a:ea typeface="Arial"/>
-                <a:cs typeface="Arial"/>
-              </a:defRPr>
-            </a:pPr>
-            <a:r>
-              <a:rPr sz="3400" b="0">
-                <a:solidFill>
-                  <a:srgbClr val="000000"/>
-                </a:solidFill>
-                <a:latin typeface="Arial"/>
-                <a:ea typeface="Arial"/>
-                <a:cs typeface="Arial"/>
-              </a:rPr>
-              <a:t>Medical competence and biological reasoning</a:t>
-            </a:r>
-          </a:p>
-        </p:txBody>
-      </p:sp>
-      <p:pic>
-        <p:nvPicPr>
-          <p:cNvPr id="63" name="">
-            <a:extLst xmlns:a="http://schemas.openxmlformats.org/drawingml/2006/main">
-              <a:ext uri="{FF2B5EF4-FFF2-40B4-BE49-F238E27FC236}">
-                <a16:creationId xmlns:a16="http://schemas.microsoft.com/office/drawing/2014/main" id="{5A56BD02-C0E5-4976-8017-BE341DF226ED}"/>
-              </a:ext>
-            </a:extLst>
-          </p:cNvPr>
-          <p:cNvPicPr>
-            <a:picLocks xmlns:a="http://schemas.openxmlformats.org/drawingml/2006/main" noChangeAspect="1"/>
-          </p:cNvPicPr>
-          <p:nvPr/>
-        </p:nvPicPr>
-        <p:blipFill>
-          <a:blip xmlns:r="http://schemas.openxmlformats.org/officeDocument/2006/relationships" xmlns:a="http://schemas.openxmlformats.org/drawingml/2006/main" r:embed="Reea3081bc4b0417b"/>
-          <a:stretch xmlns:a="http://schemas.openxmlformats.org/drawingml/2006/main"/>
-        </p:blipFill>
-        <p:spPr>
-          <a:xfrm xmlns:a="http://schemas.openxmlformats.org/drawingml/2006/main">
-            <a:off x="11877675" y="17051536"/>
-            <a:ext cx="9048750" cy="3958828"/>
-          </a:xfrm>
-          <a:prstGeom xmlns:a="http://schemas.openxmlformats.org/drawingml/2006/main" prst="rect">
-            <a:avLst/>
-          </a:prstGeom>
-        </p:spPr>
-      </p:pic>
-      <p:sp>
-        <p:nvSpPr>
-          <p:cNvPr id="64" name="Medical caption">
-            <a:extLst xmlns:a="http://schemas.openxmlformats.org/drawingml/2006/main">
-              <a:ext uri="{FF2B5EF4-FFF2-40B4-BE49-F238E27FC236}">
-                <a16:creationId xmlns:a16="http://schemas.microsoft.com/office/drawing/2014/main" id="{C40548C7-FCE5-4632-A218-50F4296998F5}"/>
-              </a:ext>
-            </a:extLst>
-          </p:cNvPr>
-          <p:cNvSpPr>
-            <a:spLocks xmlns:a="http://schemas.openxmlformats.org/drawingml/2006/main" noGrp="1"/>
-          </p:cNvSpPr>
-          <p:nvPr/>
-        </p:nvSpPr>
-        <p:spPr>
-          <a:xfrm xmlns:a="http://schemas.openxmlformats.org/drawingml/2006/main">
-            <a:off x="11877675" y="21240750"/>
+            <a:off x="990600" y="20955000"/>
             <a:ext cx="9048750" cy="685800"/>
           </a:xfrm>
           <a:prstGeom xmlns:a="http://schemas.openxmlformats.org/drawingml/2006/main" prst="rect">
@@ -4095,45 +5116,17 @@
                 <a:ea typeface="Arial"/>
                 <a:cs typeface="Arial"/>
               </a:rPr>
-              <a:t>Figure 2. HealthBench Hard and GeneAgent results across 14B, 32B and 70B under a shared supervised training recipe. Error bars quantify decoding variability, not training-seed variability.</a:t>
+              <a:t>BFT improves more consistently across 14B / 32B / 70B. In GeneAgent, it achieves the best overall ROUGE among aligned open-weight models. Error bars denote decoding variability, not training-seed variability.</a:t>
             </a:r>
           </a:p>
         </p:txBody>
       </p:sp>
-      <p:pic>
-        <p:nvPicPr>
-          <p:cNvPr id="65" name="">
+      <p:sp>
+        <p:nvSpPr>
+          <p:cNvPr id="82" name="Representation heading">
             <a:extLst xmlns:a="http://schemas.openxmlformats.org/drawingml/2006/main">
               <a:ext uri="{FF2B5EF4-FFF2-40B4-BE49-F238E27FC236}">
-                <a16:creationId xmlns:a16="http://schemas.microsoft.com/office/drawing/2014/main" id="{017A20AE-3BD8-49D0-8416-9E0A9506D1E8}"/>
-              </a:ext>
-            </a:extLst>
-          </p:cNvPr>
-          <p:cNvPicPr>
-            <a:picLocks xmlns:a="http://schemas.openxmlformats.org/drawingml/2006/main" noChangeAspect="1"/>
-          </p:cNvPicPr>
-          <p:nvPr/>
-        </p:nvPicPr>
-        <p:blipFill>
-          <a:blip xmlns:r="http://schemas.openxmlformats.org/officeDocument/2006/relationships" xmlns:a="http://schemas.openxmlformats.org/drawingml/2006/main" r:embed="R0629cdf714474c1c"/>
-          <a:stretch xmlns:a="http://schemas.openxmlformats.org/drawingml/2006/main"/>
-        </p:blipFill>
-        <p:spPr>
-          <a:xfrm xmlns:a="http://schemas.openxmlformats.org/drawingml/2006/main">
-            <a:off x="22926675" y="7955212"/>
-            <a:ext cx="9048750" cy="3996827"/>
-          </a:xfrm>
-          <a:prstGeom xmlns:a="http://schemas.openxmlformats.org/drawingml/2006/main" prst="rect">
-            <a:avLst/>
-          </a:prstGeom>
-        </p:spPr>
-      </p:pic>
-      <p:sp>
-        <p:nvSpPr>
-          <p:cNvPr id="66" name="Perturbation heading">
-            <a:extLst xmlns:a="http://schemas.openxmlformats.org/drawingml/2006/main">
-              <a:ext uri="{FF2B5EF4-FFF2-40B4-BE49-F238E27FC236}">
-                <a16:creationId xmlns:a16="http://schemas.microsoft.com/office/drawing/2014/main" id="{8A168BDB-F9B4-4197-A2F6-03A78F912576}"/>
+                <a16:creationId xmlns:a16="http://schemas.microsoft.com/office/drawing/2014/main" id="{B41E26F9-A364-4994-9E46-545E51D25B0E}"/>
               </a:ext>
             </a:extLst>
           </p:cNvPr>
@@ -4144,8 +5137,8 @@
         </p:nvSpPr>
         <p:spPr>
           <a:xfrm xmlns:a="http://schemas.openxmlformats.org/drawingml/2006/main">
-            <a:off x="22926675" y="13716000"/>
-            <a:ext cx="9048750" cy="1047750"/>
+            <a:off x="11877675" y="16097250"/>
+            <a:ext cx="9048750" cy="666750"/>
           </a:xfrm>
           <a:prstGeom xmlns:a="http://schemas.openxmlformats.org/drawingml/2006/main" prst="rect">
             <a:avLst/>
@@ -4191,6 +5184,323 @@
                 <a:ea typeface="Arial"/>
                 <a:cs typeface="Arial"/>
               </a:rPr>
+              <a:t>Gene &amp; cell representations</a:t>
+            </a:r>
+          </a:p>
+        </p:txBody>
+      </p:sp>
+      <p:sp>
+        <p:nvSpPr>
+          <p:cNvPr id="83" name="Representation setup">
+            <a:extLst xmlns:a="http://schemas.openxmlformats.org/drawingml/2006/main">
+              <a:ext uri="{FF2B5EF4-FFF2-40B4-BE49-F238E27FC236}">
+                <a16:creationId xmlns:a16="http://schemas.microsoft.com/office/drawing/2014/main" id="{4D2A2BC2-3020-4E85-B774-4271D44856F7}"/>
+              </a:ext>
+            </a:extLst>
+          </p:cNvPr>
+          <p:cNvSpPr>
+            <a:spLocks xmlns:a="http://schemas.openxmlformats.org/drawingml/2006/main" noGrp="1"/>
+          </p:cNvSpPr>
+          <p:nvPr/>
+        </p:nvSpPr>
+        <p:spPr>
+          <a:xfrm xmlns:a="http://schemas.openxmlformats.org/drawingml/2006/main">
+            <a:off x="11877675" y="16906875"/>
+            <a:ext cx="9048750" cy="457200"/>
+          </a:xfrm>
+          <a:prstGeom xmlns:a="http://schemas.openxmlformats.org/drawingml/2006/main" prst="rect">
+            <a:avLst/>
+          </a:prstGeom>
+          <a:noFill xmlns:a="http://schemas.openxmlformats.org/drawingml/2006/main"/>
+          <a:ln xmlns:a="http://schemas.openxmlformats.org/drawingml/2006/main" w="0">
+            <a:noFill/>
+          </a:ln>
+        </p:spPr>
+        <p:txBody>
+          <a:bodyPr xmlns:a="http://schemas.openxmlformats.org/drawingml/2006/main" wrap="square" lIns="0" tIns="0" rIns="0" bIns="0" anchor="t">
+            <a:noAutofit/>
+          </a:bodyPr>
+          <a:lstStyle xmlns:a="http://schemas.openxmlformats.org/drawingml/2006/main">
+            <a:defPPr algn="l">
+              <a:defRPr sz="2100" b="0">
+                <a:solidFill>
+                  <a:srgbClr val="344854"/>
+                </a:solidFill>
+                <a:latin typeface="Arial"/>
+                <a:ea typeface="Arial"/>
+                <a:cs typeface="Arial"/>
+              </a:defRPr>
+            </a:defPPr>
+          </a:lstStyle>
+          <a:p xmlns:a="http://schemas.openxmlformats.org/drawingml/2006/main">
+            <a:pPr algn="l">
+              <a:defRPr sz="2100" b="0">
+                <a:solidFill>
+                  <a:srgbClr val="344854"/>
+                </a:solidFill>
+                <a:latin typeface="Arial"/>
+                <a:ea typeface="Arial"/>
+                <a:cs typeface="Arial"/>
+              </a:defRPr>
+            </a:pPr>
+            <a:r>
+              <a:rPr sz="2100" b="0">
+                <a:solidFill>
+                  <a:srgbClr val="344854"/>
+                </a:solidFill>
+                <a:latin typeface="Arial"/>
+                <a:ea typeface="Arial"/>
+                <a:cs typeface="Arial"/>
+              </a:rPr>
+              <a:t>Gene-level AUC, matched ada-002 encoder</a:t>
+            </a:r>
+          </a:p>
+        </p:txBody>
+      </p:sp>
+      <p:graphicFrame>
+        <p:nvGraphicFramePr>
+          <p:cNvPr id="84" name="Chart">
+            <a:extLst xmlns:a="http://schemas.openxmlformats.org/drawingml/2006/main">
+              <a:ext uri="{FF2B5EF4-FFF2-40B4-BE49-F238E27FC236}">
+                <a16:creationId xmlns:a16="http://schemas.microsoft.com/office/drawing/2014/main" id="{C44CF05F-68BF-4D8F-8F37-1C340B7B48D7}"/>
+              </a:ext>
+            </a:extLst>
+          </p:cNvPr>
+          <p:cNvGraphicFramePr/>
+          <p:nvPr/>
+        </p:nvGraphicFramePr>
+        <p:xfrm>
+          <a:off xmlns:a="http://schemas.openxmlformats.org/drawingml/2006/main" x="11877675" y="17526000"/>
+          <a:ext xmlns:a="http://schemas.openxmlformats.org/drawingml/2006/main" cx="9048750" cy="2762250"/>
+        </p:xfrm>
+        <a:graphic xmlns:a="http://schemas.openxmlformats.org/drawingml/2006/main">
+          <a:graphicData uri="http://schemas.openxmlformats.org/drawingml/2006/chart">
+            <c:chart xmlns:r="http://schemas.openxmlformats.org/officeDocument/2006/relationships" xmlns:c="http://schemas.openxmlformats.org/drawingml/2006/chart" r:id="Rd8cbf83510294920"/>
+          </a:graphicData>
+        </a:graphic>
+      </p:graphicFrame>
+      <p:sp>
+        <p:nvSpPr>
+          <p:cNvPr id="85" name="Cell results">
+            <a:extLst xmlns:a="http://schemas.openxmlformats.org/drawingml/2006/main">
+              <a:ext uri="{FF2B5EF4-FFF2-40B4-BE49-F238E27FC236}">
+                <a16:creationId xmlns:a16="http://schemas.microsoft.com/office/drawing/2014/main" id="{1C456421-AA44-44F4-BD75-89B1ED98701C}"/>
+              </a:ext>
+            </a:extLst>
+          </p:cNvPr>
+          <p:cNvSpPr>
+            <a:spLocks xmlns:a="http://schemas.openxmlformats.org/drawingml/2006/main" noGrp="1"/>
+          </p:cNvSpPr>
+          <p:nvPr/>
+        </p:nvSpPr>
+        <p:spPr>
+          <a:xfrm xmlns:a="http://schemas.openxmlformats.org/drawingml/2006/main">
+            <a:off x="11877675" y="20383500"/>
+            <a:ext cx="9048750" cy="809625"/>
+          </a:xfrm>
+          <a:prstGeom xmlns:a="http://schemas.openxmlformats.org/drawingml/2006/main" prst="rect">
+            <a:avLst/>
+          </a:prstGeom>
+          <a:noFill xmlns:a="http://schemas.openxmlformats.org/drawingml/2006/main"/>
+          <a:ln xmlns:a="http://schemas.openxmlformats.org/drawingml/2006/main" w="0">
+            <a:noFill/>
+          </a:ln>
+        </p:spPr>
+        <p:txBody>
+          <a:bodyPr xmlns:a="http://schemas.openxmlformats.org/drawingml/2006/main" wrap="square" lIns="0" tIns="0" rIns="0" bIns="0" anchor="t">
+            <a:noAutofit/>
+          </a:bodyPr>
+          <a:lstStyle xmlns:a="http://schemas.openxmlformats.org/drawingml/2006/main">
+            <a:defPPr algn="l">
+              <a:defRPr sz="2100" b="0">
+                <a:solidFill>
+                  <a:srgbClr val="344854"/>
+                </a:solidFill>
+                <a:latin typeface="Arial"/>
+                <a:ea typeface="Arial"/>
+                <a:cs typeface="Arial"/>
+              </a:defRPr>
+            </a:defPPr>
+          </a:lstStyle>
+          <a:p xmlns:a="http://schemas.openxmlformats.org/drawingml/2006/main">
+            <a:pPr algn="l">
+              <a:defRPr sz="2100" b="0">
+                <a:solidFill>
+                  <a:srgbClr val="344854"/>
+                </a:solidFill>
+                <a:latin typeface="Arial"/>
+                <a:ea typeface="Arial"/>
+                <a:cs typeface="Arial"/>
+              </a:defRPr>
+            </a:pPr>
+            <a:r>
+              <a:rPr sz="2100" b="0">
+                <a:solidFill>
+                  <a:srgbClr val="344854"/>
+                </a:solidFill>
+                <a:latin typeface="Arial"/>
+                <a:ea typeface="Arial"/>
+                <a:cs typeface="Arial"/>
+              </a:rPr>
+              <a:t>BFT cell-type clustering: ARI 0.34, AMI 0.58,</a:t>
+            </a:r>
+          </a:p>
+          <a:p xmlns:a="http://schemas.openxmlformats.org/drawingml/2006/main">
+            <a:pPr algn="l">
+              <a:defRPr sz="2100" b="0">
+                <a:solidFill>
+                  <a:srgbClr val="344854"/>
+                </a:solidFill>
+                <a:latin typeface="Arial"/>
+                <a:ea typeface="Arial"/>
+                <a:cs typeface="Arial"/>
+              </a:defRPr>
+            </a:pPr>
+            <a:r>
+              <a:rPr sz="2100" b="0">
+                <a:solidFill>
+                  <a:srgbClr val="344854"/>
+                </a:solidFill>
+                <a:latin typeface="Arial"/>
+                <a:ea typeface="Arial"/>
+                <a:cs typeface="Arial"/>
+              </a:rPr>
+              <a:t>ASW 0.061, best among evaluated methods.</a:t>
+            </a:r>
+          </a:p>
+        </p:txBody>
+      </p:sp>
+      <p:sp>
+        <p:nvSpPr>
+          <p:cNvPr id="86" name="Representation caption">
+            <a:extLst xmlns:a="http://schemas.openxmlformats.org/drawingml/2006/main">
+              <a:ext uri="{FF2B5EF4-FFF2-40B4-BE49-F238E27FC236}">
+                <a16:creationId xmlns:a16="http://schemas.microsoft.com/office/drawing/2014/main" id="{6AFD1D51-7C58-49BF-9A8B-EE9DDD6637F8}"/>
+              </a:ext>
+            </a:extLst>
+          </p:cNvPr>
+          <p:cNvSpPr>
+            <a:spLocks xmlns:a="http://schemas.openxmlformats.org/drawingml/2006/main" noGrp="1"/>
+          </p:cNvSpPr>
+          <p:nvPr/>
+        </p:nvSpPr>
+        <p:spPr>
+          <a:xfrm xmlns:a="http://schemas.openxmlformats.org/drawingml/2006/main">
+            <a:off x="11877675" y="21336000"/>
+            <a:ext cx="9048750" cy="447675"/>
+          </a:xfrm>
+          <a:prstGeom xmlns:a="http://schemas.openxmlformats.org/drawingml/2006/main" prst="rect">
+            <a:avLst/>
+          </a:prstGeom>
+          <a:noFill xmlns:a="http://schemas.openxmlformats.org/drawingml/2006/main"/>
+          <a:ln xmlns:a="http://schemas.openxmlformats.org/drawingml/2006/main" w="0">
+            <a:noFill/>
+          </a:ln>
+        </p:spPr>
+        <p:txBody>
+          <a:bodyPr xmlns:a="http://schemas.openxmlformats.org/drawingml/2006/main" wrap="square" lIns="0" tIns="0" rIns="0" bIns="0" anchor="t">
+            <a:noAutofit/>
+          </a:bodyPr>
+          <a:lstStyle xmlns:a="http://schemas.openxmlformats.org/drawingml/2006/main">
+            <a:defPPr algn="l">
+              <a:defRPr sz="1300" b="0">
+                <a:solidFill>
+                  <a:srgbClr val="344854"/>
+                </a:solidFill>
+                <a:latin typeface="Arial"/>
+                <a:ea typeface="Arial"/>
+                <a:cs typeface="Arial"/>
+              </a:defRPr>
+            </a:defPPr>
+          </a:lstStyle>
+          <a:p xmlns:a="http://schemas.openxmlformats.org/drawingml/2006/main">
+            <a:pPr algn="l">
+              <a:defRPr sz="1300" b="0">
+                <a:solidFill>
+                  <a:srgbClr val="344854"/>
+                </a:solidFill>
+                <a:latin typeface="Arial"/>
+                <a:ea typeface="Arial"/>
+                <a:cs typeface="Arial"/>
+              </a:defRPr>
+            </a:pPr>
+            <a:r>
+              <a:rPr sz="1300" b="0">
+                <a:solidFill>
+                  <a:srgbClr val="344854"/>
+                </a:solidFill>
+                <a:latin typeface="Arial"/>
+                <a:ea typeface="Arial"/>
+                <a:cs typeface="Arial"/>
+              </a:rPr>
+              <a:t>Best average gene AUC: BFT 0.829 vs GenePT 0.802. GenePT remains higher on Lys4. BFT-generated profiles and NCBI summaries differ in source and construction.</a:t>
+            </a:r>
+          </a:p>
+        </p:txBody>
+      </p:sp>
+      <p:sp>
+        <p:nvSpPr>
+          <p:cNvPr id="87" name="Perturbation heading">
+            <a:extLst xmlns:a="http://schemas.openxmlformats.org/drawingml/2006/main">
+              <a:ext uri="{FF2B5EF4-FFF2-40B4-BE49-F238E27FC236}">
+                <a16:creationId xmlns:a16="http://schemas.microsoft.com/office/drawing/2014/main" id="{84A87A3F-1DA1-435E-9BDA-C5E0994F9747}"/>
+              </a:ext>
+            </a:extLst>
+          </p:cNvPr>
+          <p:cNvSpPr>
+            <a:spLocks xmlns:a="http://schemas.openxmlformats.org/drawingml/2006/main" noGrp="1"/>
+          </p:cNvSpPr>
+          <p:nvPr/>
+        </p:nvSpPr>
+        <p:spPr>
+          <a:xfrm xmlns:a="http://schemas.openxmlformats.org/drawingml/2006/main">
+            <a:off x="22926675" y="16097250"/>
+            <a:ext cx="9048750" cy="666750"/>
+          </a:xfrm>
+          <a:prstGeom xmlns:a="http://schemas.openxmlformats.org/drawingml/2006/main" prst="rect">
+            <a:avLst/>
+          </a:prstGeom>
+          <a:noFill xmlns:a="http://schemas.openxmlformats.org/drawingml/2006/main"/>
+          <a:ln xmlns:a="http://schemas.openxmlformats.org/drawingml/2006/main" w="0">
+            <a:noFill/>
+          </a:ln>
+        </p:spPr>
+        <p:txBody>
+          <a:bodyPr xmlns:a="http://schemas.openxmlformats.org/drawingml/2006/main" wrap="square" lIns="0" tIns="0" rIns="0" bIns="0" anchor="t">
+            <a:noAutofit/>
+          </a:bodyPr>
+          <a:lstStyle xmlns:a="http://schemas.openxmlformats.org/drawingml/2006/main">
+            <a:defPPr algn="l">
+              <a:defRPr sz="3400" b="0">
+                <a:solidFill>
+                  <a:srgbClr val="000000"/>
+                </a:solidFill>
+                <a:latin typeface="Arial"/>
+                <a:ea typeface="Arial"/>
+                <a:cs typeface="Arial"/>
+              </a:defRPr>
+            </a:defPPr>
+          </a:lstStyle>
+          <a:p xmlns:a="http://schemas.openxmlformats.org/drawingml/2006/main">
+            <a:pPr algn="l">
+              <a:defRPr sz="3400" b="0">
+                <a:solidFill>
+                  <a:srgbClr val="000000"/>
+                </a:solidFill>
+                <a:latin typeface="Arial"/>
+                <a:ea typeface="Arial"/>
+                <a:cs typeface="Arial"/>
+              </a:defRPr>
+            </a:pPr>
+            <a:r>
+              <a:rPr sz="3400" b="0">
+                <a:solidFill>
+                  <a:srgbClr val="000000"/>
+                </a:solidFill>
+                <a:latin typeface="Arial"/>
+                <a:ea typeface="Arial"/>
+                <a:cs typeface="Arial"/>
+              </a:rPr>
               <a:t>Perturbation-response prediction</a:t>
             </a:r>
           </a:p>
@@ -4198,10 +5508,10 @@
       </p:sp>
       <p:pic>
         <p:nvPicPr>
-          <p:cNvPr id="67" name="">
+          <p:cNvPr id="88" name="">
             <a:extLst xmlns:a="http://schemas.openxmlformats.org/drawingml/2006/main">
               <a:ext uri="{FF2B5EF4-FFF2-40B4-BE49-F238E27FC236}">
-                <a16:creationId xmlns:a16="http://schemas.microsoft.com/office/drawing/2014/main" id="{0E8F69FD-C619-49A3-BB44-721C2CE0152C}"/>
+                <a16:creationId xmlns:a16="http://schemas.microsoft.com/office/drawing/2014/main" id="{7B22847D-BED8-4B1D-B1E2-0EE706AB802F}"/>
               </a:ext>
             </a:extLst>
           </p:cNvPr>
@@ -4211,12 +5521,12 @@
           <p:nvPr/>
         </p:nvPicPr>
         <p:blipFill>
-          <a:blip xmlns:r="http://schemas.openxmlformats.org/officeDocument/2006/relationships" xmlns:a="http://schemas.openxmlformats.org/drawingml/2006/main" r:embed="R0a3275b63ad74b88"/>
+          <a:blip xmlns:r="http://schemas.openxmlformats.org/officeDocument/2006/relationships" xmlns:a="http://schemas.openxmlformats.org/drawingml/2006/main" r:embed="Rd9992ff5f939443a"/>
           <a:stretch xmlns:a="http://schemas.openxmlformats.org/drawingml/2006/main"/>
         </p:blipFill>
         <p:spPr>
           <a:xfrm xmlns:a="http://schemas.openxmlformats.org/drawingml/2006/main">
-            <a:off x="22926675" y="14859462"/>
+            <a:off x="22926675" y="16954962"/>
             <a:ext cx="9048750" cy="2475576"/>
           </a:xfrm>
           <a:prstGeom xmlns:a="http://schemas.openxmlformats.org/drawingml/2006/main" prst="rect">
@@ -4224,12 +5534,194 @@
           </a:prstGeom>
         </p:spPr>
       </p:pic>
+      <p:sp>
+        <p:nvSpPr>
+          <p:cNvPr id="89" name="Perturbation interpretation">
+            <a:extLst xmlns:a="http://schemas.openxmlformats.org/drawingml/2006/main">
+              <a:ext uri="{FF2B5EF4-FFF2-40B4-BE49-F238E27FC236}">
+                <a16:creationId xmlns:a16="http://schemas.microsoft.com/office/drawing/2014/main" id="{85AAF45B-F0BE-4EFB-B8A2-AEFCD061CCF4}"/>
+              </a:ext>
+            </a:extLst>
+          </p:cNvPr>
+          <p:cNvSpPr>
+            <a:spLocks xmlns:a="http://schemas.openxmlformats.org/drawingml/2006/main" noGrp="1"/>
+          </p:cNvSpPr>
+          <p:nvPr/>
+        </p:nvSpPr>
+        <p:spPr>
+          <a:xfrm xmlns:a="http://schemas.openxmlformats.org/drawingml/2006/main">
+            <a:off x="22926675" y="19526250"/>
+            <a:ext cx="6667500" cy="1238250"/>
+          </a:xfrm>
+          <a:prstGeom xmlns:a="http://schemas.openxmlformats.org/drawingml/2006/main" prst="rect">
+            <a:avLst/>
+          </a:prstGeom>
+          <a:noFill xmlns:a="http://schemas.openxmlformats.org/drawingml/2006/main"/>
+          <a:ln xmlns:a="http://schemas.openxmlformats.org/drawingml/2006/main" w="0">
+            <a:noFill/>
+          </a:ln>
+        </p:spPr>
+        <p:txBody>
+          <a:bodyPr xmlns:a="http://schemas.openxmlformats.org/drawingml/2006/main" wrap="square" lIns="0" tIns="0" rIns="0" bIns="0" anchor="t">
+            <a:noAutofit/>
+          </a:bodyPr>
+          <a:lstStyle xmlns:a="http://schemas.openxmlformats.org/drawingml/2006/main">
+            <a:defPPr algn="l">
+              <a:defRPr sz="2100" b="0">
+                <a:solidFill>
+                  <a:srgbClr val="344854"/>
+                </a:solidFill>
+                <a:latin typeface="Arial"/>
+                <a:ea typeface="Arial"/>
+                <a:cs typeface="Arial"/>
+              </a:defRPr>
+            </a:defPPr>
+          </a:lstStyle>
+          <a:p xmlns:a="http://schemas.openxmlformats.org/drawingml/2006/main">
+            <a:pPr algn="l">
+              <a:defRPr sz="2100" b="0">
+                <a:solidFill>
+                  <a:srgbClr val="344854"/>
+                </a:solidFill>
+                <a:latin typeface="Arial"/>
+                <a:ea typeface="Arial"/>
+                <a:cs typeface="Arial"/>
+              </a:defRPr>
+            </a:pPr>
+            <a:r>
+              <a:rPr sz="2100" b="0">
+                <a:solidFill>
+                  <a:srgbClr val="344854"/>
+                </a:solidFill>
+                <a:latin typeface="Arial"/>
+                <a:ea typeface="Arial"/>
+                <a:cs typeface="Arial"/>
+              </a:rPr>
+              <a:t>BFT profile embeddings perform comparably to standard STATE inputs across four datasets. Profile generation is zero-shot for these datasets. The STATE decoder remains trained.</a:t>
+            </a:r>
+          </a:p>
+        </p:txBody>
+      </p:sp>
+      <p:sp>
+        <p:nvSpPr>
+          <p:cNvPr id="90" name="Links">
+            <a:extLst xmlns:a="http://schemas.openxmlformats.org/drawingml/2006/main">
+              <a:ext uri="{FF2B5EF4-FFF2-40B4-BE49-F238E27FC236}">
+                <a16:creationId xmlns:a16="http://schemas.microsoft.com/office/drawing/2014/main" id="{028D4D40-26B3-4EE4-AF74-7CFF893F1745}"/>
+              </a:ext>
+            </a:extLst>
+          </p:cNvPr>
+          <p:cNvSpPr>
+            <a:spLocks xmlns:a="http://schemas.openxmlformats.org/drawingml/2006/main" noGrp="1"/>
+          </p:cNvSpPr>
+          <p:nvPr/>
+        </p:nvSpPr>
+        <p:spPr>
+          <a:xfrm xmlns:a="http://schemas.openxmlformats.org/drawingml/2006/main">
+            <a:off x="22926675" y="20955000"/>
+            <a:ext cx="6953250" cy="685800"/>
+          </a:xfrm>
+          <a:prstGeom xmlns:a="http://schemas.openxmlformats.org/drawingml/2006/main" prst="rect">
+            <a:avLst/>
+          </a:prstGeom>
+          <a:noFill xmlns:a="http://schemas.openxmlformats.org/drawingml/2006/main"/>
+          <a:ln xmlns:a="http://schemas.openxmlformats.org/drawingml/2006/main" w="0">
+            <a:noFill/>
+          </a:ln>
+        </p:spPr>
+        <p:txBody>
+          <a:bodyPr xmlns:a="http://schemas.openxmlformats.org/drawingml/2006/main" wrap="square" lIns="0" tIns="0" rIns="0" bIns="0" anchor="t">
+            <a:noAutofit/>
+          </a:bodyPr>
+          <a:lstStyle xmlns:a="http://schemas.openxmlformats.org/drawingml/2006/main">
+            <a:defPPr algn="l">
+              <a:defRPr sz="1300" b="0">
+                <a:solidFill>
+                  <a:srgbClr val="677B8C"/>
+                </a:solidFill>
+                <a:latin typeface="Arial"/>
+                <a:ea typeface="Arial"/>
+                <a:cs typeface="Arial"/>
+              </a:defRPr>
+            </a:defPPr>
+          </a:lstStyle>
+          <a:p xmlns:a="http://schemas.openxmlformats.org/drawingml/2006/main">
+            <a:pPr algn="l">
+              <a:defRPr sz="1300" b="0">
+                <a:solidFill>
+                  <a:srgbClr val="677B8C"/>
+                </a:solidFill>
+                <a:latin typeface="Arial"/>
+                <a:ea typeface="Arial"/>
+                <a:cs typeface="Arial"/>
+              </a:defRPr>
+            </a:pPr>
+            <a:r>
+              <a:rPr sz="1300" b="0">
+                <a:solidFill>
+                  <a:srgbClr val="677B8C"/>
+                </a:solidFill>
+                <a:latin typeface="Arial"/>
+                <a:ea typeface="Arial"/>
+                <a:cs typeface="Arial"/>
+              </a:rPr>
+              <a:t>arxiv.org/abs/2511.21075</a:t>
+            </a:r>
+          </a:p>
+          <a:p xmlns:a="http://schemas.openxmlformats.org/drawingml/2006/main">
+            <a:pPr algn="l">
+              <a:defRPr sz="1300" b="0">
+                <a:solidFill>
+                  <a:srgbClr val="677B8C"/>
+                </a:solidFill>
+                <a:latin typeface="Arial"/>
+                <a:ea typeface="Arial"/>
+                <a:cs typeface="Arial"/>
+              </a:defRPr>
+            </a:pPr>
+            <a:r>
+              <a:rPr sz="1300" b="0">
+                <a:solidFill>
+                  <a:srgbClr val="677B8C"/>
+                </a:solidFill>
+                <a:latin typeface="Arial"/>
+                <a:ea typeface="Arial"/>
+                <a:cs typeface="Arial"/>
+              </a:rPr>
+              <a:t>github.com/TencentAILabHealthcare/BFT</a:t>
+            </a:r>
+          </a:p>
+          <a:p xmlns:a="http://schemas.openxmlformats.org/drawingml/2006/main">
+            <a:pPr algn="l">
+              <a:defRPr sz="1300" b="0">
+                <a:solidFill>
+                  <a:srgbClr val="677B8C"/>
+                </a:solidFill>
+                <a:latin typeface="Arial"/>
+                <a:ea typeface="Arial"/>
+                <a:cs typeface="Arial"/>
+              </a:defRPr>
+            </a:pPr>
+            <a:r>
+              <a:rPr sz="1300" b="0">
+                <a:solidFill>
+                  <a:srgbClr val="677B8C"/>
+                </a:solidFill>
+                <a:latin typeface="Arial"/>
+                <a:ea typeface="Arial"/>
+                <a:cs typeface="Arial"/>
+              </a:rPr>
+              <a:t>shapsider.github.io/BFT</a:t>
+            </a:r>
+          </a:p>
+        </p:txBody>
+      </p:sp>
       <p:pic>
         <p:nvPicPr>
-          <p:cNvPr id="68" name="">
+          <p:cNvPr id="91" name="">
             <a:extLst xmlns:a="http://schemas.openxmlformats.org/drawingml/2006/main">
               <a:ext uri="{FF2B5EF4-FFF2-40B4-BE49-F238E27FC236}">
-                <a16:creationId xmlns:a16="http://schemas.microsoft.com/office/drawing/2014/main" id="{31A8B669-28B0-48E3-97B1-79696AE308D7}"/>
+                <a16:creationId xmlns:a16="http://schemas.microsoft.com/office/drawing/2014/main" id="{56C2D29B-9FBD-44A8-9FD4-FA17C7E9F41C}"/>
               </a:ext>
             </a:extLst>
           </p:cNvPr>
@@ -4239,13 +5731,13 @@
           <p:nvPr/>
         </p:nvPicPr>
         <p:blipFill>
-          <a:blip xmlns:r="http://schemas.openxmlformats.org/officeDocument/2006/relationships" xmlns:a="http://schemas.openxmlformats.org/drawingml/2006/main" r:embed="R240935500e4d47e9"/>
+          <a:blip xmlns:r="http://schemas.openxmlformats.org/officeDocument/2006/relationships" xmlns:a="http://schemas.openxmlformats.org/drawingml/2006/main" r:embed="Ra688a09cd42d4deb"/>
           <a:stretch xmlns:a="http://schemas.openxmlformats.org/drawingml/2006/main"/>
         </p:blipFill>
         <p:spPr>
           <a:xfrm xmlns:a="http://schemas.openxmlformats.org/drawingml/2006/main">
-            <a:off x="30622875" y="19411950"/>
-            <a:ext cx="2162175" cy="2162175"/>
+            <a:off x="30670500" y="19716750"/>
+            <a:ext cx="1714500" cy="1714500"/>
           </a:xfrm>
           <a:prstGeom xmlns:a="http://schemas.openxmlformats.org/drawingml/2006/main" prst="rect">
             <a:avLst/>
@@ -4255,7 +5747,7 @@
     </p:spTree>
     <p:extLst>
       <p:ext uri="{BB962C8B-B14F-4D97-AF65-F5344CB8AC3E}">
-        <p14:creationId xmlns:p14="http://schemas.microsoft.com/office/powerpoint/2010/main" val="2014342618"/>
+        <p14:creationId xmlns:p14="http://schemas.microsoft.com/office/powerpoint/2010/main" val="923348487"/>
       </p:ext>
     </p:extLst>
   </p:cSld>

</xml_diff>

<commit_message>
Enlarge poster method and evidence with a compact centered header
</commit_message>
<xml_diff>
--- a/assets/BFT-NeurIPS2026-Poster.pptx
+++ b/assets/BFT-NeurIPS2026-Poster.pptx
@@ -2,13 +2,13 @@
 <file path=ppt/presentation.xml><?xml version="1.0" encoding="utf-8"?>
 <p:presentation xmlns:p="http://schemas.openxmlformats.org/presentationml/2006/main">
   <p:sldMasterIdLst>
-    <p:sldMasterId xmlns:r="http://schemas.openxmlformats.org/officeDocument/2006/relationships" id="2147483648" r:id="R07f1a284514f4a0b"/>
+    <p:sldMasterId xmlns:r="http://schemas.openxmlformats.org/officeDocument/2006/relationships" id="2147483648" r:id="R214ee48e4bf74cf6"/>
   </p:sldMasterIdLst>
   <p:notesMasterIdLst>
-    <p:notesMasterId xmlns:r="http://schemas.openxmlformats.org/officeDocument/2006/relationships" r:id="R5f13b0899a144988"/>
+    <p:notesMasterId xmlns:r="http://schemas.openxmlformats.org/officeDocument/2006/relationships" r:id="R2de4414bcfb94c78"/>
   </p:notesMasterIdLst>
   <p:sldIdLst>
-    <p:sldId xmlns:r="http://schemas.openxmlformats.org/officeDocument/2006/relationships" id="256" r:id="R1a95c48342e646b8"/>
+    <p:sldId xmlns:r="http://schemas.openxmlformats.org/officeDocument/2006/relationships" id="256" r:id="Rd28bd3056f344602"/>
   </p:sldIdLst>
   <p:sldSz cx="32918400" cy="21945600"/>
   <p:notesSz cx="6858000" cy="9144000"/>
@@ -646,7 +646,7 @@
           <a:lstStyle xmlns:a="http://schemas.openxmlformats.org/drawingml/2006/main"/>
           <a:p xmlns:a="http://schemas.openxmlformats.org/drawingml/2006/main">
             <a:r>
-              <a:t>Edited from author-selected BFT-NeurIPS2026-Plain-Language-Final-R2.pptx. All scientific visuals are unchanged-pixel crops from supplied camera-ready Figure1-5. Crop boxes and masks of letter-only margins are recorded in .build/poster-paper-figures/crop-manifest.json. Challenge uses Figure1b, motivation Figure1a, method Figure1c, biomedical results Figure2a/b, general retention original 70B panels and legend from Figure3a, gene representation Figure4b, single-cell response Figure5. No reconstructed chart, diagram, or evidence table. Native text explains token as word for a broad audience. Main paper Section3 and Results provide scientific claims. General ability is retained better than SFT, not without loss, and DFT forgets least. STEM extension is demonstrated specifically in medicine and biology, not tested across all STEM fields. Gene mean AUC 0.829 vs GenePT0.802, with Lys4 exception. Same text encoder but different profile source. Only profile generation is zero-shot on perturbation datasets. Source: https://arxiv.org/abs/2511.21075 and supplied neurips_2026_arxiv.tex. Logos and original master retained. No displayed equations added.</a:t>
+              <a:t>Edited from author-selected BFT-NeurIPS2026-Plain-Language-Final-R2.pptx. All scientific visuals are unchanged-pixel crops from supplied camera-ready Figure1-5. Crop boxes and masks of letter-only margins are recorded in .build/poster-paper-figures/crop-manifest.json. Challenge uses Figure1b, motivation Figure1a, method Figure1c, biomedical results Figure2a/b; HealthBench plot is cropped above angled category labels, whose original order is stated in adjacent editable text, general retention original 70B MMLU panel and legend from Figure3a; CMMLU ordering described in text per Results, gene representation Figure4b, single-cell response Figure5. No reconstructed chart, diagram, or evidence table. Native text explains token as word for a broad audience. Main paper Section3 and Results provide scientific claims. General ability is retained better than SFT, not without loss, and DFT forgets least. STEM extension is demonstrated specifically in medicine and biology, not tested across all STEM fields. Gene mean AUC 0.829 vs GenePT0.802, with Lys4 exception. Same text encoder but different profile source. Only profile generation is zero-shot on perturbation datasets. Source: https://arxiv.org/abs/2511.21075 and supplied neurips_2026_arxiv.tex. Logos and original master retained. No displayed equations added.</a:t>
             </a:r>
           </a:p>
         </p:txBody>
@@ -951,8 +951,8 @@
   </p:cSld>
   <p:clrMap bg1="lt1" tx1="dk1" bg2="lt2" tx2="dk2" accent1="accent1" accent2="accent2" accent3="accent3" accent4="accent4" accent5="accent5" accent6="accent6" hlink="hlink" folHlink="folHlink"/>
   <p:sldLayoutIdLst>
-    <p:sldLayoutId xmlns:r="http://schemas.openxmlformats.org/officeDocument/2006/relationships" id="2147483649" r:id="Rf23ce95bb9794a2a"/>
-    <p:sldLayoutId xmlns:r="http://schemas.openxmlformats.org/officeDocument/2006/relationships" id="2147483650" r:id="R51150b536ed5439d"/>
+    <p:sldLayoutId xmlns:r="http://schemas.openxmlformats.org/officeDocument/2006/relationships" id="2147483649" r:id="R287ddb39550a4874"/>
+    <p:sldLayoutId xmlns:r="http://schemas.openxmlformats.org/officeDocument/2006/relationships" id="2147483650" r:id="R9df839cf6168431f"/>
   </p:sldLayoutIdLst>
   <p:txStyles>
     <p:titleStyle>
@@ -1804,8 +1804,8 @@
         </p:nvSpPr>
         <p:spPr>
           <a:xfrm xmlns:a="http://schemas.openxmlformats.org/drawingml/2006/main">
-            <a:off x="666750" y="257175"/>
-            <a:ext cx="25336500" cy="1695450"/>
+            <a:off x="3714750" y="190500"/>
+            <a:ext cx="24098250" cy="1714500"/>
           </a:xfrm>
           <a:prstGeom xmlns:a="http://schemas.openxmlformats.org/drawingml/2006/main" prst="rect">
             <a:avLst/>
@@ -1820,8 +1820,8 @@
             <a:noAutofit/>
           </a:bodyPr>
           <a:lstStyle xmlns:a="http://schemas.openxmlformats.org/drawingml/2006/main">
-            <a:defPPr algn="l">
-              <a:defRPr sz="5500" b="1">
+            <a:defPPr algn="ctr">
+              <a:defRPr sz="6300" b="1">
                 <a:solidFill>
                   <a:srgbClr val="183B66"/>
                 </a:solidFill>
@@ -1840,9 +1840,9 @@
             </a:lvl1pPr>
           </a:lstStyle>
           <a:p xmlns:a="http://schemas.openxmlformats.org/drawingml/2006/main">
-            <a:pPr algn="l">
+            <a:pPr algn="ctr">
               <a:buNone/>
-              <a:defRPr sz="5500" b="1">
+              <a:defRPr sz="6300" b="1">
                 <a:solidFill>
                   <a:srgbClr val="183B66"/>
                 </a:solidFill>
@@ -1852,7 +1852,7 @@
               </a:defRPr>
             </a:pPr>
             <a:r>
-              <a:rPr sz="5500" b="1">
+              <a:rPr sz="6300" b="1">
                 <a:solidFill>
                   <a:srgbClr val="183B66"/>
                 </a:solidFill>
@@ -1864,9 +1864,9 @@
             </a:r>
           </a:p>
           <a:p xmlns:a="http://schemas.openxmlformats.org/drawingml/2006/main">
-            <a:pPr algn="l">
+            <a:pPr algn="ctr">
               <a:buNone/>
-              <a:defRPr sz="5500" b="1">
+              <a:defRPr sz="6300" b="1">
                 <a:solidFill>
                   <a:srgbClr val="183B66"/>
                 </a:solidFill>
@@ -1876,7 +1876,7 @@
               </a:defRPr>
             </a:pPr>
             <a:r>
-              <a:rPr sz="5500" b="1">
+              <a:rPr sz="6300" b="1">
                 <a:solidFill>
                   <a:srgbClr val="183B66"/>
                 </a:solidFill>
@@ -1905,7 +1905,7 @@
         </p:nvSpPr>
         <p:spPr>
           <a:xfrm xmlns:a="http://schemas.openxmlformats.org/drawingml/2006/main">
-            <a:off x="666750" y="3905250"/>
+            <a:off x="666750" y="3381375"/>
             <a:ext cx="10172700" cy="609600"/>
           </a:xfrm>
           <a:prstGeom xmlns:a="http://schemas.openxmlformats.org/drawingml/2006/main" prst="rect">
@@ -1963,7 +1963,7 @@
                 <a:ea typeface="Arial"/>
                 <a:cs typeface="Arial"/>
               </a:rPr>
-              <a:t>1  Challenge: learning unfamiliar science</a:t>
+              <a:t>1  Challenge: useful knowledge is difficult</a:t>
             </a:r>
           </a:p>
         </p:txBody>
@@ -1984,8 +1984,8 @@
         </p:nvSpPr>
         <p:spPr>
           <a:xfrm xmlns:a="http://schemas.openxmlformats.org/drawingml/2006/main">
-            <a:off x="666750" y="4667250"/>
-            <a:ext cx="10172700" cy="1190625"/>
+            <a:off x="666750" y="4143375"/>
+            <a:ext cx="10172700" cy="762000"/>
           </a:xfrm>
           <a:prstGeom xmlns:a="http://schemas.openxmlformats.org/drawingml/2006/main" prst="rect">
             <a:avLst/>
@@ -2046,7 +2046,7 @@
                 <a:ea typeface="Arial"/>
                 <a:cs typeface="Arial"/>
               </a:rPr>
-              <a:t>LLMs need to learn unfamiliar gene names and biological mechanisms from limited expert supervision. Confidence-based training (DFT) reduces attention to difficult words, including those carrying useful scientific knowledge.</a:t>
+              <a:t>Confidence-based training can suppress unfamiliar biomedical words. An isolated difficult word and a whole difficult passage need different treatment.</a:t>
             </a:r>
           </a:p>
         </p:txBody>
@@ -2067,8 +2067,8 @@
         </p:nvSpPr>
         <p:spPr>
           <a:xfrm xmlns:a="http://schemas.openxmlformats.org/drawingml/2006/main">
-            <a:off x="11372850" y="3905250"/>
-            <a:ext cx="10172700" cy="609600"/>
+            <a:off x="11372850" y="3381375"/>
+            <a:ext cx="20878800" cy="609600"/>
           </a:xfrm>
           <a:prstGeom xmlns:a="http://schemas.openxmlformats.org/drawingml/2006/main" prst="rect">
             <a:avLst/>
@@ -2146,8 +2146,164 @@
         </p:nvSpPr>
         <p:spPr>
           <a:xfrm xmlns:a="http://schemas.openxmlformats.org/drawingml/2006/main">
-            <a:off x="11372850" y="4667250"/>
-            <a:ext cx="10172700" cy="857250"/>
+            <a:off x="11372850" y="4143375"/>
+            <a:ext cx="20878800" cy="571500"/>
+          </a:xfrm>
+          <a:prstGeom xmlns:a="http://schemas.openxmlformats.org/drawingml/2006/main" prst="rect">
+            <a:avLst/>
+          </a:prstGeom>
+          <a:noFill xmlns:a="http://schemas.openxmlformats.org/drawingml/2006/main"/>
+          <a:ln xmlns:a="http://schemas.openxmlformats.org/drawingml/2006/main" w="0">
+            <a:noFill/>
+          </a:ln>
+        </p:spPr>
+        <p:txBody>
+          <a:bodyPr xmlns:a="http://schemas.openxmlformats.org/drawingml/2006/main" wrap="square" lIns="0" tIns="0" rIns="0" bIns="0" anchor="t">
+            <a:noAutofit/>
+          </a:bodyPr>
+          <a:lstStyle xmlns:a="http://schemas.openxmlformats.org/drawingml/2006/main">
+            <a:defPPr algn="l">
+              <a:defRPr sz="2250" b="0">
+                <a:solidFill>
+                  <a:srgbClr val="344854"/>
+                </a:solidFill>
+                <a:latin typeface="Arial"/>
+                <a:ea typeface="Arial"/>
+                <a:cs typeface="Arial"/>
+              </a:defRPr>
+            </a:defPPr>
+            <a:lvl1pPr>
+              <a:buNone/>
+              <a:defRPr sz="2100">
+                <a:latin typeface="Arial"/>
+                <a:ea typeface="Arial"/>
+                <a:cs typeface="Arial"/>
+              </a:defRPr>
+            </a:lvl1pPr>
+          </a:lstStyle>
+          <a:p xmlns:a="http://schemas.openxmlformats.org/drawingml/2006/main">
+            <a:pPr algn="l">
+              <a:buNone/>
+              <a:defRPr sz="2250" b="0">
+                <a:solidFill>
+                  <a:srgbClr val="344854"/>
+                </a:solidFill>
+                <a:latin typeface="Arial"/>
+                <a:ea typeface="Arial"/>
+                <a:cs typeface="Arial"/>
+              </a:defRPr>
+            </a:pPr>
+            <a:r>
+              <a:rPr sz="2250" b="0">
+                <a:solidFill>
+                  <a:srgbClr val="344854"/>
+                </a:solidFill>
+                <a:latin typeface="Arial"/>
+                <a:ea typeface="Arial"/>
+                <a:cs typeface="Arial"/>
+              </a:rPr>
+              <a:t>A simple change to supervised training: use nearby context to decide which words and training examples deserve more learning attention.</a:t>
+            </a:r>
+          </a:p>
+        </p:txBody>
+      </p:sp>
+      <p:sp>
+        <p:nvSpPr>
+          <p:cNvPr id="39" name="TextBox 45">
+            <a:extLst xmlns:a="http://schemas.openxmlformats.org/drawingml/2006/main">
+              <a:ext uri="{FF2B5EF4-FFF2-40B4-BE49-F238E27FC236}">
+                <a16:creationId xmlns:a16="http://schemas.microsoft.com/office/drawing/2014/main" id="{79CDD081-FE7A-4614-94A4-3F10DFF8FF83}"/>
+              </a:ext>
+            </a:extLst>
+          </p:cNvPr>
+          <p:cNvSpPr>
+            <a:spLocks xmlns:a="http://schemas.openxmlformats.org/drawingml/2006/main" noGrp="1"/>
+          </p:cNvSpPr>
+          <p:nvPr/>
+        </p:nvSpPr>
+        <p:spPr>
+          <a:xfrm xmlns:a="http://schemas.openxmlformats.org/drawingml/2006/main">
+            <a:off x="666750" y="7000875"/>
+            <a:ext cx="10172700" cy="609600"/>
+          </a:xfrm>
+          <a:prstGeom xmlns:a="http://schemas.openxmlformats.org/drawingml/2006/main" prst="rect">
+            <a:avLst/>
+          </a:prstGeom>
+          <a:solidFill xmlns:a="http://schemas.openxmlformats.org/drawingml/2006/main">
+            <a:srgbClr val="183B66"/>
+          </a:solidFill>
+          <a:ln xmlns:a="http://schemas.openxmlformats.org/drawingml/2006/main" w="0">
+            <a:noFill/>
+          </a:ln>
+        </p:spPr>
+        <p:txBody>
+          <a:bodyPr xmlns:a="http://schemas.openxmlformats.org/drawingml/2006/main" wrap="square" lIns="171450" tIns="38100" rIns="114300" bIns="38100" anchor="ctr">
+            <a:noAutofit/>
+          </a:bodyPr>
+          <a:lstStyle xmlns:a="http://schemas.openxmlformats.org/drawingml/2006/main">
+            <a:defPPr algn="l">
+              <a:defRPr sz="3225" b="1">
+                <a:solidFill>
+                  <a:srgbClr val="FFFFFF"/>
+                </a:solidFill>
+                <a:latin typeface="Arial"/>
+                <a:ea typeface="Arial"/>
+                <a:cs typeface="Arial"/>
+              </a:defRPr>
+            </a:defPPr>
+            <a:lvl1pPr>
+              <a:buNone/>
+              <a:defRPr sz="3400">
+                <a:latin typeface="Arial"/>
+                <a:ea typeface="Arial"/>
+                <a:cs typeface="Arial"/>
+              </a:defRPr>
+            </a:lvl1pPr>
+          </a:lstStyle>
+          <a:p xmlns:a="http://schemas.openxmlformats.org/drawingml/2006/main">
+            <a:pPr algn="l">
+              <a:buNone/>
+              <a:defRPr sz="3225" b="1">
+                <a:solidFill>
+                  <a:srgbClr val="FFFFFF"/>
+                </a:solidFill>
+                <a:latin typeface="Arial"/>
+                <a:ea typeface="Arial"/>
+                <a:cs typeface="Arial"/>
+              </a:defRPr>
+            </a:pPr>
+            <a:r>
+              <a:rPr sz="3225" b="1">
+                <a:solidFill>
+                  <a:srgbClr val="FFFFFF"/>
+                </a:solidFill>
+                <a:latin typeface="Arial"/>
+                <a:ea typeface="Arial"/>
+                <a:cs typeface="Arial"/>
+              </a:rPr>
+              <a:t>2  Motivation: learn difficult passages</a:t>
+            </a:r>
+          </a:p>
+        </p:txBody>
+      </p:sp>
+      <p:sp>
+        <p:nvSpPr>
+          <p:cNvPr id="40" name="TextBox 46">
+            <a:extLst xmlns:a="http://schemas.openxmlformats.org/drawingml/2006/main">
+              <a:ext uri="{FF2B5EF4-FFF2-40B4-BE49-F238E27FC236}">
+                <a16:creationId xmlns:a16="http://schemas.microsoft.com/office/drawing/2014/main" id="{4CBAF464-5EDA-480B-A823-9D2226CEA054}"/>
+              </a:ext>
+            </a:extLst>
+          </p:cNvPr>
+          <p:cNvSpPr>
+            <a:spLocks xmlns:a="http://schemas.openxmlformats.org/drawingml/2006/main" noGrp="1"/>
+          </p:cNvSpPr>
+          <p:nvPr/>
+        </p:nvSpPr>
+        <p:spPr>
+          <a:xfrm xmlns:a="http://schemas.openxmlformats.org/drawingml/2006/main">
+            <a:off x="6096000" y="7762875"/>
+            <a:ext cx="4743450" cy="1143000"/>
           </a:xfrm>
           <a:prstGeom xmlns:a="http://schemas.openxmlformats.org/drawingml/2006/main" prst="rect">
             <a:avLst/>
@@ -2202,319 +2358,7 @@
                 <a:ea typeface="Arial"/>
                 <a:cs typeface="Arial"/>
               </a:rPr>
-              <a:t>BFT changes how much attention each part of the training data receives. It uses the model’s own confidence and nearby text, with two connected decisions.</a:t>
-            </a:r>
-          </a:p>
-        </p:txBody>
-      </p:sp>
-      <p:sp>
-        <p:nvSpPr>
-          <p:cNvPr id="39" name="TextBox 45">
-            <a:extLst xmlns:a="http://schemas.openxmlformats.org/drawingml/2006/main">
-              <a:ext uri="{FF2B5EF4-FFF2-40B4-BE49-F238E27FC236}">
-                <a16:creationId xmlns:a16="http://schemas.microsoft.com/office/drawing/2014/main" id="{79CDD081-FE7A-4614-94A4-3F10DFF8FF83}"/>
-              </a:ext>
-            </a:extLst>
-          </p:cNvPr>
-          <p:cNvSpPr>
-            <a:spLocks xmlns:a="http://schemas.openxmlformats.org/drawingml/2006/main" noGrp="1"/>
-          </p:cNvSpPr>
-          <p:nvPr/>
-        </p:nvSpPr>
-        <p:spPr>
-          <a:xfrm xmlns:a="http://schemas.openxmlformats.org/drawingml/2006/main">
-            <a:off x="666750" y="11811000"/>
-            <a:ext cx="10172700" cy="609600"/>
-          </a:xfrm>
-          <a:prstGeom xmlns:a="http://schemas.openxmlformats.org/drawingml/2006/main" prst="rect">
-            <a:avLst/>
-          </a:prstGeom>
-          <a:solidFill xmlns:a="http://schemas.openxmlformats.org/drawingml/2006/main">
-            <a:srgbClr val="183B66"/>
-          </a:solidFill>
-          <a:ln xmlns:a="http://schemas.openxmlformats.org/drawingml/2006/main" w="0">
-            <a:noFill/>
-          </a:ln>
-        </p:spPr>
-        <p:txBody>
-          <a:bodyPr xmlns:a="http://schemas.openxmlformats.org/drawingml/2006/main" wrap="square" lIns="171450" tIns="38100" rIns="114300" bIns="38100" anchor="ctr">
-            <a:noAutofit/>
-          </a:bodyPr>
-          <a:lstStyle xmlns:a="http://schemas.openxmlformats.org/drawingml/2006/main">
-            <a:defPPr algn="l">
-              <a:defRPr sz="3225" b="1">
-                <a:solidFill>
-                  <a:srgbClr val="FFFFFF"/>
-                </a:solidFill>
-                <a:latin typeface="Arial"/>
-                <a:ea typeface="Arial"/>
-                <a:cs typeface="Arial"/>
-              </a:defRPr>
-            </a:defPPr>
-            <a:lvl1pPr>
-              <a:buNone/>
-              <a:defRPr sz="3400">
-                <a:latin typeface="Arial"/>
-                <a:ea typeface="Arial"/>
-                <a:cs typeface="Arial"/>
-              </a:defRPr>
-            </a:lvl1pPr>
-          </a:lstStyle>
-          <a:p xmlns:a="http://schemas.openxmlformats.org/drawingml/2006/main">
-            <a:pPr algn="l">
-              <a:buNone/>
-              <a:defRPr sz="3225" b="1">
-                <a:solidFill>
-                  <a:srgbClr val="FFFFFF"/>
-                </a:solidFill>
-                <a:latin typeface="Arial"/>
-                <a:ea typeface="Arial"/>
-                <a:cs typeface="Arial"/>
-              </a:defRPr>
-            </a:pPr>
-            <a:r>
-              <a:rPr sz="3225" b="1">
-                <a:solidFill>
-                  <a:srgbClr val="FFFFFF"/>
-                </a:solidFill>
-                <a:latin typeface="Arial"/>
-                <a:ea typeface="Arial"/>
-                <a:cs typeface="Arial"/>
-              </a:rPr>
-              <a:t>2  Motivation: preserve useful difficulty</a:t>
-            </a:r>
-          </a:p>
-        </p:txBody>
-      </p:sp>
-      <p:sp>
-        <p:nvSpPr>
-          <p:cNvPr id="40" name="TextBox 46">
-            <a:extLst xmlns:a="http://schemas.openxmlformats.org/drawingml/2006/main">
-              <a:ext uri="{FF2B5EF4-FFF2-40B4-BE49-F238E27FC236}">
-                <a16:creationId xmlns:a16="http://schemas.microsoft.com/office/drawing/2014/main" id="{4CBAF464-5EDA-480B-A823-9D2226CEA054}"/>
-              </a:ext>
-            </a:extLst>
-          </p:cNvPr>
-          <p:cNvSpPr>
-            <a:spLocks xmlns:a="http://schemas.openxmlformats.org/drawingml/2006/main" noGrp="1"/>
-          </p:cNvSpPr>
-          <p:nvPr/>
-        </p:nvSpPr>
-        <p:spPr>
-          <a:xfrm xmlns:a="http://schemas.openxmlformats.org/drawingml/2006/main">
-            <a:off x="666750" y="12573000"/>
-            <a:ext cx="10172700" cy="904875"/>
-          </a:xfrm>
-          <a:prstGeom xmlns:a="http://schemas.openxmlformats.org/drawingml/2006/main" prst="rect">
-            <a:avLst/>
-          </a:prstGeom>
-          <a:noFill xmlns:a="http://schemas.openxmlformats.org/drawingml/2006/main"/>
-          <a:ln xmlns:a="http://schemas.openxmlformats.org/drawingml/2006/main" w="0">
-            <a:noFill/>
-          </a:ln>
-        </p:spPr>
-        <p:txBody>
-          <a:bodyPr xmlns:a="http://schemas.openxmlformats.org/drawingml/2006/main" wrap="square" lIns="0" tIns="0" rIns="0" bIns="0" anchor="t">
-            <a:noAutofit/>
-          </a:bodyPr>
-          <a:lstStyle xmlns:a="http://schemas.openxmlformats.org/drawingml/2006/main">
-            <a:defPPr algn="l">
-              <a:defRPr sz="2100" b="0">
-                <a:solidFill>
-                  <a:srgbClr val="344854"/>
-                </a:solidFill>
-                <a:latin typeface="Arial"/>
-                <a:ea typeface="Arial"/>
-                <a:cs typeface="Arial"/>
-              </a:defRPr>
-            </a:defPPr>
-            <a:lvl1pPr>
-              <a:buNone/>
-              <a:defRPr sz="2100">
-                <a:latin typeface="Arial"/>
-                <a:ea typeface="Arial"/>
-                <a:cs typeface="Arial"/>
-              </a:defRPr>
-            </a:lvl1pPr>
-          </a:lstStyle>
-          <a:p xmlns:a="http://schemas.openxmlformats.org/drawingml/2006/main">
-            <a:pPr algn="l">
-              <a:buNone/>
-              <a:defRPr sz="2100" b="0">
-                <a:solidFill>
-                  <a:srgbClr val="344854"/>
-                </a:solidFill>
-                <a:latin typeface="Arial"/>
-                <a:ea typeface="Arial"/>
-                <a:cs typeface="Arial"/>
-              </a:defRPr>
-            </a:pPr>
-            <a:r>
-              <a:rPr sz="2100" b="0">
-                <a:solidFill>
-                  <a:srgbClr val="344854"/>
-                </a:solidFill>
-                <a:latin typeface="Arial"/>
-                <a:ea typeface="Arial"/>
-                <a:cs typeface="Arial"/>
-              </a:rPr>
-              <a:t>The grouped difficult passages contain more biomedical entities and reasoning steps. Suppressing them can remove the very knowledge needed for domain adaptation.</a:t>
-            </a:r>
-          </a:p>
-        </p:txBody>
-      </p:sp>
-      <p:sp>
-        <p:nvSpPr>
-          <p:cNvPr id="42" name="TextBox 51">
-            <a:extLst xmlns:a="http://schemas.openxmlformats.org/drawingml/2006/main">
-              <a:ext uri="{FF2B5EF4-FFF2-40B4-BE49-F238E27FC236}">
-                <a16:creationId xmlns:a16="http://schemas.microsoft.com/office/drawing/2014/main" id="{9C45D058-3353-4D1E-A3F2-E59CD2A2183A}"/>
-              </a:ext>
-            </a:extLst>
-          </p:cNvPr>
-          <p:cNvSpPr>
-            <a:spLocks xmlns:a="http://schemas.openxmlformats.org/drawingml/2006/main" noGrp="1"/>
-          </p:cNvSpPr>
-          <p:nvPr/>
-        </p:nvSpPr>
-        <p:spPr>
-          <a:xfrm xmlns:a="http://schemas.openxmlformats.org/drawingml/2006/main">
-            <a:off x="22078950" y="3905250"/>
-            <a:ext cx="10172700" cy="609600"/>
-          </a:xfrm>
-          <a:prstGeom xmlns:a="http://schemas.openxmlformats.org/drawingml/2006/main" prst="rect">
-            <a:avLst/>
-          </a:prstGeom>
-          <a:solidFill xmlns:a="http://schemas.openxmlformats.org/drawingml/2006/main">
-            <a:srgbClr val="183B66"/>
-          </a:solidFill>
-          <a:ln xmlns:a="http://schemas.openxmlformats.org/drawingml/2006/main" w="0">
-            <a:noFill/>
-          </a:ln>
-        </p:spPr>
-        <p:txBody>
-          <a:bodyPr xmlns:a="http://schemas.openxmlformats.org/drawingml/2006/main" wrap="square" lIns="171450" tIns="38100" rIns="114300" bIns="38100" anchor="ctr">
-            <a:noAutofit/>
-          </a:bodyPr>
-          <a:lstStyle xmlns:a="http://schemas.openxmlformats.org/drawingml/2006/main">
-            <a:defPPr algn="l">
-              <a:defRPr sz="3225" b="1">
-                <a:solidFill>
-                  <a:srgbClr val="FFFFFF"/>
-                </a:solidFill>
-                <a:latin typeface="Arial"/>
-                <a:ea typeface="Arial"/>
-                <a:cs typeface="Arial"/>
-              </a:defRPr>
-            </a:defPPr>
-            <a:lvl1pPr>
-              <a:buNone/>
-              <a:defRPr sz="3400">
-                <a:latin typeface="Arial"/>
-                <a:ea typeface="Arial"/>
-                <a:cs typeface="Arial"/>
-              </a:defRPr>
-            </a:lvl1pPr>
-          </a:lstStyle>
-          <a:p xmlns:a="http://schemas.openxmlformats.org/drawingml/2006/main">
-            <a:pPr algn="l">
-              <a:buNone/>
-              <a:defRPr sz="3225" b="1">
-                <a:solidFill>
-                  <a:srgbClr val="FFFFFF"/>
-                </a:solidFill>
-                <a:latin typeface="Arial"/>
-                <a:ea typeface="Arial"/>
-                <a:cs typeface="Arial"/>
-              </a:defRPr>
-            </a:pPr>
-            <a:r>
-              <a:rPr sz="3225" b="1">
-                <a:solidFill>
-                  <a:srgbClr val="FFFFFF"/>
-                </a:solidFill>
-                <a:latin typeface="Arial"/>
-                <a:ea typeface="Arial"/>
-                <a:cs typeface="Arial"/>
-              </a:rPr>
-              <a:t>4  Results: STEM adaptation &amp; retention</a:t>
-            </a:r>
-          </a:p>
-        </p:txBody>
-      </p:sp>
-      <p:sp>
-        <p:nvSpPr>
-          <p:cNvPr id="43" name="TextBox 52">
-            <a:extLst xmlns:a="http://schemas.openxmlformats.org/drawingml/2006/main">
-              <a:ext uri="{FF2B5EF4-FFF2-40B4-BE49-F238E27FC236}">
-                <a16:creationId xmlns:a16="http://schemas.microsoft.com/office/drawing/2014/main" id="{9DB2D713-0C18-4814-959A-973F37A8A205}"/>
-              </a:ext>
-            </a:extLst>
-          </p:cNvPr>
-          <p:cNvSpPr>
-            <a:spLocks xmlns:a="http://schemas.openxmlformats.org/drawingml/2006/main" noGrp="1"/>
-          </p:cNvSpPr>
-          <p:nvPr/>
-        </p:nvSpPr>
-        <p:spPr>
-          <a:xfrm xmlns:a="http://schemas.openxmlformats.org/drawingml/2006/main">
-            <a:off x="22078950" y="4667250"/>
-            <a:ext cx="10172700" cy="904875"/>
-          </a:xfrm>
-          <a:prstGeom xmlns:a="http://schemas.openxmlformats.org/drawingml/2006/main" prst="rect">
-            <a:avLst/>
-          </a:prstGeom>
-          <a:noFill xmlns:a="http://schemas.openxmlformats.org/drawingml/2006/main"/>
-          <a:ln xmlns:a="http://schemas.openxmlformats.org/drawingml/2006/main" w="0">
-            <a:noFill/>
-          </a:ln>
-        </p:spPr>
-        <p:txBody>
-          <a:bodyPr xmlns:a="http://schemas.openxmlformats.org/drawingml/2006/main" wrap="square" lIns="0" tIns="0" rIns="0" bIns="0" anchor="t">
-            <a:noAutofit/>
-          </a:bodyPr>
-          <a:lstStyle xmlns:a="http://schemas.openxmlformats.org/drawingml/2006/main">
-            <a:defPPr algn="l">
-              <a:defRPr sz="2100" b="0">
-                <a:solidFill>
-                  <a:srgbClr val="344854"/>
-                </a:solidFill>
-                <a:latin typeface="Arial"/>
-                <a:ea typeface="Arial"/>
-                <a:cs typeface="Arial"/>
-              </a:defRPr>
-            </a:defPPr>
-            <a:lvl1pPr>
-              <a:buNone/>
-              <a:defRPr sz="2100">
-                <a:latin typeface="Arial"/>
-                <a:ea typeface="Arial"/>
-                <a:cs typeface="Arial"/>
-              </a:defRPr>
-            </a:lvl1pPr>
-          </a:lstStyle>
-          <a:p xmlns:a="http://schemas.openxmlformats.org/drawingml/2006/main">
-            <a:pPr algn="l">
-              <a:buNone/>
-              <a:defRPr sz="2100" b="0">
-                <a:solidFill>
-                  <a:srgbClr val="344854"/>
-                </a:solidFill>
-                <a:latin typeface="Arial"/>
-                <a:ea typeface="Arial"/>
-                <a:cs typeface="Arial"/>
-              </a:defRPr>
-            </a:pPr>
-            <a:r>
-              <a:rPr sz="2100" b="0">
-                <a:solidFill>
-                  <a:srgbClr val="344854"/>
-                </a:solidFill>
-                <a:latin typeface="Arial"/>
-                <a:ea typeface="Arial"/>
-                <a:cs typeface="Arial"/>
-              </a:rPr>
-              <a:t>BFT expands medical and biological skills while retaining more broad knowledge than SFT. MMLU and CMMLU test broad knowledge across three model sizes. The 70B results appear below.</a:t>
+              <a:t>Grouped difficult passages contain more biomedical entities (60.9% vs 12.5%) and reasoning content (30.6% vs 8.4%).</a:t>
             </a:r>
           </a:p>
         </p:txBody>
@@ -2535,8 +2379,8 @@
         </p:nvSpPr>
         <p:spPr>
           <a:xfrm xmlns:a="http://schemas.openxmlformats.org/drawingml/2006/main">
-            <a:off x="666750" y="2076450"/>
-            <a:ext cx="25431750" cy="361950"/>
+            <a:off x="3714750" y="2047875"/>
+            <a:ext cx="24098250" cy="333375"/>
           </a:xfrm>
           <a:prstGeom xmlns:a="http://schemas.openxmlformats.org/drawingml/2006/main" prst="rect">
             <a:avLst/>
@@ -2551,8 +2395,8 @@
             <a:noAutofit/>
           </a:bodyPr>
           <a:lstStyle xmlns:a="http://schemas.openxmlformats.org/drawingml/2006/main">
-            <a:defPPr algn="l">
-              <a:defRPr sz="2100" b="0">
+            <a:defPPr algn="ctr">
+              <a:defRPr sz="1950" b="0">
                 <a:solidFill>
                   <a:srgbClr val="000000"/>
                 </a:solidFill>
@@ -2563,7 +2407,7 @@
             </a:defPPr>
           </a:lstStyle>
           <a:p xmlns:a="http://schemas.openxmlformats.org/drawingml/2006/main">
-            <a:pPr algn="l">
+            <a:pPr algn="ctr">
               <a:lnSpc>
                 <a:spcPct val="120000"/>
               </a:lnSpc>
@@ -2571,7 +2415,7 @@
                 <a:spcPts val="1000"/>
               </a:spcBef>
               <a:buNone/>
-              <a:defRPr sz="2100" b="0">
+              <a:defRPr sz="1950" b="0">
                 <a:solidFill>
                   <a:srgbClr val="000000"/>
                 </a:solidFill>
@@ -2581,7 +2425,7 @@
               </a:defRPr>
             </a:pPr>
             <a:r>
-              <a:rPr sz="2100" b="0">
+              <a:rPr sz="1950" b="0">
                 <a:solidFill>
                   <a:srgbClr val="000000"/>
                 </a:solidFill>
@@ -2599,7 +2443,7 @@
           <p:cNvPr id="54" name="neurips_logo.pdf">
             <a:extLst xmlns:a="http://schemas.openxmlformats.org/drawingml/2006/main">
               <a:ext uri="{FF2B5EF4-FFF2-40B4-BE49-F238E27FC236}">
-                <a16:creationId xmlns:a16="http://schemas.microsoft.com/office/drawing/2014/main" id="{FCE881D5-2D42-4266-9E1D-194429AF50EA}"/>
+                <a16:creationId xmlns:a16="http://schemas.microsoft.com/office/drawing/2014/main" id="{441CBA61-600D-4C16-B917-A545A41D5820}"/>
               </a:ext>
             </a:extLst>
           </p:cNvPr>
@@ -2609,15 +2453,15 @@
           <p:nvPr/>
         </p:nvPicPr>
         <p:blipFill>
-          <a:blip xmlns:r="http://schemas.openxmlformats.org/officeDocument/2006/relationships" xmlns:a="http://schemas.openxmlformats.org/drawingml/2006/main" r:embed="R78af988122be4074"/>
+          <a:blip xmlns:r="http://schemas.openxmlformats.org/officeDocument/2006/relationships" xmlns:a="http://schemas.openxmlformats.org/drawingml/2006/main" r:embed="Rec525c132f9d42e5"/>
           <a:stretch xmlns:a="http://schemas.openxmlformats.org/drawingml/2006/main">
             <a:fillRect l="0" t="0" r="0" b="0"/>
           </a:stretch>
         </p:blipFill>
         <p:spPr>
           <a:xfrm xmlns:a="http://schemas.openxmlformats.org/drawingml/2006/main">
-            <a:off x="27336750" y="238125"/>
-            <a:ext cx="4857750" cy="2190750"/>
+            <a:off x="28479750" y="333375"/>
+            <a:ext cx="3714750" cy="1676400"/>
           </a:xfrm>
           <a:prstGeom xmlns:a="http://schemas.openxmlformats.org/drawingml/2006/main" prst="rect">
             <a:avLst/>
@@ -2643,8 +2487,8 @@
         </p:nvSpPr>
         <p:spPr>
           <a:xfrm xmlns:a="http://schemas.openxmlformats.org/drawingml/2006/main">
-            <a:off x="666750" y="2486025"/>
-            <a:ext cx="25431750" cy="361950"/>
+            <a:off x="3714750" y="2390775"/>
+            <a:ext cx="24098250" cy="333375"/>
           </a:xfrm>
           <a:prstGeom xmlns:a="http://schemas.openxmlformats.org/drawingml/2006/main" prst="rect">
             <a:avLst/>
@@ -2659,8 +2503,8 @@
             <a:noAutofit/>
           </a:bodyPr>
           <a:lstStyle xmlns:a="http://schemas.openxmlformats.org/drawingml/2006/main">
-            <a:defPPr algn="l">
-              <a:defRPr sz="2100" b="0">
+            <a:defPPr algn="ctr">
+              <a:defRPr sz="1950" b="0">
                 <a:solidFill>
                   <a:srgbClr val="000000"/>
                 </a:solidFill>
@@ -2671,9 +2515,9 @@
             </a:defPPr>
           </a:lstStyle>
           <a:p xmlns:a="http://schemas.openxmlformats.org/drawingml/2006/main">
-            <a:pPr algn="l">
+            <a:pPr algn="ctr">
               <a:buNone/>
-              <a:defRPr sz="2100" b="0">
+              <a:defRPr sz="1950" b="0">
                 <a:solidFill>
                   <a:srgbClr val="000000"/>
                 </a:solidFill>
@@ -2683,7 +2527,7 @@
               </a:defRPr>
             </a:pPr>
             <a:r>
-              <a:rPr sz="2100" b="0">
+              <a:rPr sz="1950" b="0">
                 <a:solidFill>
                   <a:srgbClr val="000000"/>
                 </a:solidFill>
@@ -2712,8 +2556,8 @@
         </p:nvSpPr>
         <p:spPr>
           <a:xfrm xmlns:a="http://schemas.openxmlformats.org/drawingml/2006/main">
-            <a:off x="666750" y="2905125"/>
-            <a:ext cx="25431750" cy="704850"/>
+            <a:off x="3714750" y="2752725"/>
+            <a:ext cx="24098250" cy="476250"/>
           </a:xfrm>
           <a:prstGeom xmlns:a="http://schemas.openxmlformats.org/drawingml/2006/main" prst="rect">
             <a:avLst/>
@@ -2728,8 +2572,8 @@
             <a:noAutofit/>
           </a:bodyPr>
           <a:lstStyle xmlns:a="http://schemas.openxmlformats.org/drawingml/2006/main">
-            <a:defPPr algn="l">
-              <a:defRPr sz="1600" b="0">
+            <a:defPPr algn="ctr">
+              <a:defRPr sz="1650" b="0">
                 <a:solidFill>
                   <a:srgbClr val="344854"/>
                 </a:solidFill>
@@ -2740,9 +2584,9 @@
             </a:defPPr>
           </a:lstStyle>
           <a:p xmlns:a="http://schemas.openxmlformats.org/drawingml/2006/main">
-            <a:pPr algn="l">
+            <a:pPr algn="ctr">
               <a:buNone/>
-              <a:defRPr sz="1600" b="0">
+              <a:defRPr sz="1650" b="0">
                 <a:solidFill>
                   <a:srgbClr val="344854"/>
                 </a:solidFill>
@@ -2752,7 +2596,7 @@
               </a:defRPr>
             </a:pPr>
             <a:r>
-              <a:rPr sz="1600" b="0">
+              <a:rPr sz="1650" b="0">
                 <a:solidFill>
                   <a:srgbClr val="344854"/>
                 </a:solidFill>
@@ -2760,7 +2604,7 @@
                 <a:ea typeface="Arial"/>
                 <a:cs typeface="Arial"/>
               </a:rPr>
-              <a:t>¹Tencent AI for Life Sciences Lab  ²Nankai University  ³Sun Yat-sen University</a:t>
+              <a:t>¹Tencent AI for Life Sciences Lab  ²Nankai University  ³Sun Yat-sen University  ⁴HKUST  ⁵Tsinghua University</a:t>
             </a:r>
             <a:endParaRPr sz="2400" b="0">
               <a:solidFill>
@@ -2772,9 +2616,9 @@
             </a:endParaRPr>
           </a:p>
           <a:p xmlns:a="http://schemas.openxmlformats.org/drawingml/2006/main">
-            <a:pPr algn="l">
+            <a:pPr algn="ctr">
               <a:buNone/>
-              <a:defRPr sz="1600" b="0">
+              <a:defRPr sz="1650" b="0">
                 <a:solidFill>
                   <a:srgbClr val="344854"/>
                 </a:solidFill>
@@ -2784,7 +2628,7 @@
               </a:defRPr>
             </a:pPr>
             <a:r>
-              <a:rPr sz="1600" b="0">
+              <a:rPr sz="1650" b="0">
                 <a:solidFill>
                   <a:srgbClr val="344854"/>
                 </a:solidFill>
@@ -2792,7 +2636,7 @@
                 <a:ea typeface="Arial"/>
                 <a:cs typeface="Arial"/>
               </a:rPr>
-              <a:t>⁴The Hong Kong University of Science and Technology  ⁵Tsinghua University</a:t>
+              <a:t>*Equal contribution  †Correspondence: avonwanghit@gmail.com, jianhua.yao@gmail.com</a:t>
             </a:r>
             <a:endParaRPr sz="2400" b="0">
               <a:solidFill>
@@ -2803,30 +2647,6 @@
               <a:cs typeface="Arial"/>
             </a:endParaRPr>
           </a:p>
-          <a:p xmlns:a="http://schemas.openxmlformats.org/drawingml/2006/main">
-            <a:pPr algn="l">
-              <a:buNone/>
-              <a:defRPr sz="1600" b="0">
-                <a:solidFill>
-                  <a:srgbClr val="344854"/>
-                </a:solidFill>
-                <a:latin typeface="Arial"/>
-                <a:ea typeface="Arial"/>
-                <a:cs typeface="Arial"/>
-              </a:defRPr>
-            </a:pPr>
-            <a:r>
-              <a:rPr sz="1600" b="0">
-                <a:solidFill>
-                  <a:srgbClr val="344854"/>
-                </a:solidFill>
-                <a:latin typeface="Arial"/>
-                <a:ea typeface="Arial"/>
-                <a:cs typeface="Arial"/>
-              </a:rPr>
-              <a:t>*Equal contribution  †Correspondence: avonwanghit@gmail.com, jianhua.yao@gmail.com</a:t>
-            </a:r>
-          </a:p>
         </p:txBody>
       </p:sp>
       <p:pic>
@@ -2834,7 +2654,7 @@
           <p:cNvPr id="57" name="图片 56">
             <a:extLst xmlns:a="http://schemas.openxmlformats.org/drawingml/2006/main">
               <a:ext uri="{FF2B5EF4-FFF2-40B4-BE49-F238E27FC236}">
-                <a16:creationId xmlns:a16="http://schemas.microsoft.com/office/drawing/2014/main" id="{2F0D54C4-7EB9-416A-ACED-D74BD94CD97F}"/>
+                <a16:creationId xmlns:a16="http://schemas.microsoft.com/office/drawing/2014/main" id="{390DD568-BA3A-4FEF-A944-8D1D9BA4C03C}"/>
               </a:ext>
             </a:extLst>
           </p:cNvPr>
@@ -2844,13 +2664,13 @@
           <p:nvPr/>
         </p:nvPicPr>
         <p:blipFill>
-          <a:blip xmlns:r="http://schemas.openxmlformats.org/officeDocument/2006/relationships" xmlns:a="http://schemas.openxmlformats.org/drawingml/2006/main" r:embed="R547da54d02b34365"/>
+          <a:blip xmlns:r="http://schemas.openxmlformats.org/officeDocument/2006/relationships" xmlns:a="http://schemas.openxmlformats.org/drawingml/2006/main" r:embed="Rf93cbb0572d5483b"/>
           <a:stretch xmlns:a="http://schemas.openxmlformats.org/drawingml/2006/main"/>
         </p:blipFill>
         <p:spPr>
           <a:xfrm xmlns:a="http://schemas.openxmlformats.org/drawingml/2006/main">
-            <a:off x="26480320" y="2514600"/>
-            <a:ext cx="1760486" cy="723900"/>
+            <a:off x="666750" y="590550"/>
+            <a:ext cx="2381250" cy="981075"/>
           </a:xfrm>
           <a:prstGeom xmlns:a="http://schemas.openxmlformats.org/drawingml/2006/main" prst="rect">
             <a:avLst/>
@@ -2862,7 +2682,7 @@
           <p:cNvPr id="58" name="图片 57">
             <a:extLst xmlns:a="http://schemas.openxmlformats.org/drawingml/2006/main">
               <a:ext uri="{FF2B5EF4-FFF2-40B4-BE49-F238E27FC236}">
-                <a16:creationId xmlns:a16="http://schemas.microsoft.com/office/drawing/2014/main" id="{822F5F41-4FD8-49F6-8015-4712E0B62793}"/>
+                <a16:creationId xmlns:a16="http://schemas.microsoft.com/office/drawing/2014/main" id="{33086AA6-8EB1-44F8-B6B3-46F300349A82}"/>
               </a:ext>
             </a:extLst>
           </p:cNvPr>
@@ -2872,13 +2692,13 @@
           <p:nvPr/>
         </p:nvPicPr>
         <p:blipFill>
-          <a:blip xmlns:r="http://schemas.openxmlformats.org/officeDocument/2006/relationships" xmlns:a="http://schemas.openxmlformats.org/drawingml/2006/main" r:embed="R1c6b8860e9704400"/>
+          <a:blip xmlns:r="http://schemas.openxmlformats.org/officeDocument/2006/relationships" xmlns:a="http://schemas.openxmlformats.org/drawingml/2006/main" r:embed="R2e45f85250a044ab"/>
           <a:stretch xmlns:a="http://schemas.openxmlformats.org/drawingml/2006/main"/>
         </p:blipFill>
         <p:spPr>
           <a:xfrm xmlns:a="http://schemas.openxmlformats.org/drawingml/2006/main">
-            <a:off x="28336875" y="2514985"/>
-            <a:ext cx="2476500" cy="875530"/>
+            <a:off x="666750" y="1733550"/>
+            <a:ext cx="2714625" cy="962025"/>
           </a:xfrm>
           <a:prstGeom xmlns:a="http://schemas.openxmlformats.org/drawingml/2006/main" prst="rect">
             <a:avLst/>
@@ -2890,7 +2710,7 @@
           <p:cNvPr id="59" name="图片 58">
             <a:extLst xmlns:a="http://schemas.openxmlformats.org/drawingml/2006/main">
               <a:ext uri="{FF2B5EF4-FFF2-40B4-BE49-F238E27FC236}">
-                <a16:creationId xmlns:a16="http://schemas.microsoft.com/office/drawing/2014/main" id="{9F846846-808B-4056-A94E-663402C5EF7C}"/>
+                <a16:creationId xmlns:a16="http://schemas.microsoft.com/office/drawing/2014/main" id="{E5B04989-64E6-4762-A191-EBA0166DE57F}"/>
               </a:ext>
             </a:extLst>
           </p:cNvPr>
@@ -2900,13 +2720,13 @@
           <p:nvPr/>
         </p:nvPicPr>
         <p:blipFill>
-          <a:blip xmlns:r="http://schemas.openxmlformats.org/officeDocument/2006/relationships" xmlns:a="http://schemas.openxmlformats.org/drawingml/2006/main" r:embed="Rcea422af9f9e42b0"/>
+          <a:blip xmlns:r="http://schemas.openxmlformats.org/officeDocument/2006/relationships" xmlns:a="http://schemas.openxmlformats.org/drawingml/2006/main" r:embed="R334767bfca894947"/>
           <a:stretch xmlns:a="http://schemas.openxmlformats.org/drawingml/2006/main"/>
         </p:blipFill>
         <p:spPr>
           <a:xfrm xmlns:a="http://schemas.openxmlformats.org/drawingml/2006/main">
-            <a:off x="30956250" y="2514600"/>
-            <a:ext cx="1238250" cy="1238250"/>
+            <a:off x="30765750" y="2076450"/>
+            <a:ext cx="952500" cy="952500"/>
           </a:xfrm>
           <a:prstGeom xmlns:a="http://schemas.openxmlformats.org/drawingml/2006/main" prst="rect">
             <a:avLst/>
@@ -2929,8 +2749,8 @@
         </p:nvSpPr>
         <p:spPr>
           <a:xfrm xmlns:a="http://schemas.openxmlformats.org/drawingml/2006/main">
-            <a:off x="26479500" y="3429000"/>
-            <a:ext cx="4381500" cy="400050"/>
+            <a:off x="28432125" y="2257425"/>
+            <a:ext cx="2238375" cy="685800"/>
           </a:xfrm>
           <a:prstGeom xmlns:a="http://schemas.openxmlformats.org/drawingml/2006/main" prst="rect">
             <a:avLst/>
@@ -2946,7 +2766,7 @@
           </a:bodyPr>
           <a:lstStyle xmlns:a="http://schemas.openxmlformats.org/drawingml/2006/main">
             <a:defPPr algn="l">
-              <a:defRPr sz="1300" b="0">
+              <a:defRPr sz="1350" b="0">
                 <a:solidFill>
                   <a:srgbClr val="344854"/>
                 </a:solidFill>
@@ -2959,7 +2779,7 @@
           <a:p xmlns:a="http://schemas.openxmlformats.org/drawingml/2006/main">
             <a:pPr algn="l">
               <a:buNone/>
-              <a:defRPr sz="1300" b="0">
+              <a:defRPr sz="1350" b="0">
                 <a:solidFill>
                   <a:srgbClr val="344854"/>
                 </a:solidFill>
@@ -2969,7 +2789,7 @@
               </a:defRPr>
             </a:pPr>
             <a:r>
-              <a:rPr sz="1300" b="0">
+              <a:rPr sz="1350" b="0">
                 <a:solidFill>
                   <a:srgbClr val="344854"/>
                 </a:solidFill>
@@ -2977,13 +2797,13 @@
                 <a:ea typeface="Arial"/>
                 <a:cs typeface="Arial"/>
               </a:rPr>
-              <a:t>NeurIPS 2026   arxiv.org/abs/2511.21075</a:t>
+              <a:t>NeurIPS 2026</a:t>
             </a:r>
           </a:p>
           <a:p xmlns:a="http://schemas.openxmlformats.org/drawingml/2006/main">
             <a:pPr algn="l">
               <a:buNone/>
-              <a:defRPr sz="1300" b="0">
+              <a:defRPr sz="1350" b="0">
                 <a:solidFill>
                   <a:srgbClr val="344854"/>
                 </a:solidFill>
@@ -2993,7 +2813,7 @@
               </a:defRPr>
             </a:pPr>
             <a:r>
-              <a:rPr sz="1300" b="0">
+              <a:rPr sz="1350" b="0">
                 <a:solidFill>
                   <a:srgbClr val="344854"/>
                 </a:solidFill>
@@ -3001,17 +2821,41 @@
                 <a:ea typeface="Arial"/>
                 <a:cs typeface="Arial"/>
               </a:rPr>
-              <a:t>Project and code: shapsider.github.io/BFT</a:t>
+              <a:t>arxiv.org/abs/2511.21075</a:t>
+            </a:r>
+          </a:p>
+          <a:p xmlns:a="http://schemas.openxmlformats.org/drawingml/2006/main">
+            <a:pPr algn="l">
+              <a:buNone/>
+              <a:defRPr sz="1350" b="0">
+                <a:solidFill>
+                  <a:srgbClr val="344854"/>
+                </a:solidFill>
+                <a:latin typeface="Arial"/>
+                <a:ea typeface="Arial"/>
+                <a:cs typeface="Arial"/>
+              </a:defRPr>
+            </a:pPr>
+            <a:r>
+              <a:rPr sz="1350" b="0">
+                <a:solidFill>
+                  <a:srgbClr val="344854"/>
+                </a:solidFill>
+                <a:latin typeface="Arial"/>
+                <a:ea typeface="Arial"/>
+                <a:cs typeface="Arial"/>
+              </a:rPr>
+              <a:t>shapsider.github.io/BFT</a:t>
             </a:r>
           </a:p>
         </p:txBody>
       </p:sp>
       <p:sp>
         <p:nvSpPr>
-          <p:cNvPr id="61" name="Observation heading">
-            <a:extLst xmlns:a="http://schemas.openxmlformats.org/drawingml/2006/main">
-              <a:ext uri="{FF2B5EF4-FFF2-40B4-BE49-F238E27FC236}">
-                <a16:creationId xmlns:a16="http://schemas.microsoft.com/office/drawing/2014/main" id="{111FA220-7ACF-410A-BB55-C8E11409419D}"/>
+          <p:cNvPr id="70" name="Retention conclusion">
+            <a:extLst xmlns:a="http://schemas.openxmlformats.org/drawingml/2006/main">
+              <a:ext uri="{FF2B5EF4-FFF2-40B4-BE49-F238E27FC236}">
+                <a16:creationId xmlns:a16="http://schemas.microsoft.com/office/drawing/2014/main" id="{70B3DBD5-9598-4D00-BBC6-EBCFB4AFF8A4}"/>
               </a:ext>
             </a:extLst>
           </p:cNvPr>
@@ -3022,7 +2866,76 @@
         </p:nvSpPr>
         <p:spPr>
           <a:xfrm xmlns:a="http://schemas.openxmlformats.org/drawingml/2006/main">
-            <a:off x="666750" y="6096000"/>
+            <a:off x="11372850" y="20383500"/>
+            <a:ext cx="10172700" cy="666750"/>
+          </a:xfrm>
+          <a:prstGeom xmlns:a="http://schemas.openxmlformats.org/drawingml/2006/main" prst="rect">
+            <a:avLst/>
+          </a:prstGeom>
+          <a:noFill xmlns:a="http://schemas.openxmlformats.org/drawingml/2006/main"/>
+          <a:ln xmlns:a="http://schemas.openxmlformats.org/drawingml/2006/main" w="0">
+            <a:noFill/>
+          </a:ln>
+        </p:spPr>
+        <p:txBody>
+          <a:bodyPr xmlns:a="http://schemas.openxmlformats.org/drawingml/2006/main" wrap="square" lIns="0" tIns="0" rIns="0" bIns="0" anchor="t">
+            <a:noAutofit/>
+          </a:bodyPr>
+          <a:lstStyle xmlns:a="http://schemas.openxmlformats.org/drawingml/2006/main">
+            <a:defPPr algn="l">
+              <a:defRPr sz="1950" b="0">
+                <a:solidFill>
+                  <a:srgbClr val="344854"/>
+                </a:solidFill>
+                <a:latin typeface="Arial"/>
+                <a:ea typeface="Arial"/>
+                <a:cs typeface="Arial"/>
+              </a:defRPr>
+            </a:defPPr>
+          </a:lstStyle>
+          <a:p xmlns:a="http://schemas.openxmlformats.org/drawingml/2006/main">
+            <a:pPr algn="l">
+              <a:buNone/>
+              <a:defRPr sz="1950" b="0">
+                <a:solidFill>
+                  <a:srgbClr val="344854"/>
+                </a:solidFill>
+                <a:latin typeface="Arial"/>
+                <a:ea typeface="Arial"/>
+                <a:cs typeface="Arial"/>
+              </a:defRPr>
+            </a:pPr>
+            <a:r>
+              <a:rPr sz="1950" b="0">
+                <a:solidFill>
+                  <a:srgbClr val="344854"/>
+                </a:solidFill>
+                <a:latin typeface="Arial"/>
+                <a:ea typeface="Arial"/>
+                <a:cs typeface="Arial"/>
+              </a:rPr>
+              <a:t>CMMLU shows the same retention ordering. Some forgetting remains, and DFT forgets least.</a:t>
+            </a:r>
+          </a:p>
+        </p:txBody>
+      </p:sp>
+      <p:sp>
+        <p:nvSpPr>
+          <p:cNvPr id="88" name="Medical heading">
+            <a:extLst xmlns:a="http://schemas.openxmlformats.org/drawingml/2006/main">
+              <a:ext uri="{FF2B5EF4-FFF2-40B4-BE49-F238E27FC236}">
+                <a16:creationId xmlns:a16="http://schemas.microsoft.com/office/drawing/2014/main" id="{60989384-94D8-4EC4-A645-303D45E264CA}"/>
+              </a:ext>
+            </a:extLst>
+          </p:cNvPr>
+          <p:cNvSpPr>
+            <a:spLocks xmlns:a="http://schemas.openxmlformats.org/drawingml/2006/main" noGrp="1"/>
+          </p:cNvSpPr>
+          <p:nvPr/>
+        </p:nvSpPr>
+        <p:spPr>
+          <a:xfrm xmlns:a="http://schemas.openxmlformats.org/drawingml/2006/main">
+            <a:off x="666750" y="11811000"/>
             <a:ext cx="10172700" cy="457200"/>
           </a:xfrm>
           <a:prstGeom xmlns:a="http://schemas.openxmlformats.org/drawingml/2006/main" prst="rect">
@@ -3070,17 +2983,17 @@
                 <a:ea typeface="Arial"/>
                 <a:cs typeface="Arial"/>
               </a:rPr>
-              <a:t>Difficult words can form meaningful passages</a:t>
+              <a:t>Stronger biomedical reasoning</a:t>
             </a:r>
           </a:p>
         </p:txBody>
       </p:sp>
       <p:sp>
         <p:nvSpPr>
-          <p:cNvPr id="62" name="Diagnostic setup">
-            <a:extLst xmlns:a="http://schemas.openxmlformats.org/drawingml/2006/main">
-              <a:ext uri="{FF2B5EF4-FFF2-40B4-BE49-F238E27FC236}">
-                <a16:creationId xmlns:a16="http://schemas.microsoft.com/office/drawing/2014/main" id="{68AD73F2-AAE9-452F-9275-0EFDD2FF38AE}"/>
+          <p:cNvPr id="97" name="Representation heading">
+            <a:extLst xmlns:a="http://schemas.openxmlformats.org/drawingml/2006/main">
+              <a:ext uri="{FF2B5EF4-FFF2-40B4-BE49-F238E27FC236}">
+                <a16:creationId xmlns:a16="http://schemas.microsoft.com/office/drawing/2014/main" id="{9D49E91F-FC43-4AA3-88BB-79FCE6178656}"/>
               </a:ext>
             </a:extLst>
           </p:cNvPr>
@@ -3091,8 +3004,8 @@
         </p:nvSpPr>
         <p:spPr>
           <a:xfrm xmlns:a="http://schemas.openxmlformats.org/drawingml/2006/main">
-            <a:off x="666750" y="6619875"/>
-            <a:ext cx="10172700" cy="904875"/>
+            <a:off x="22078950" y="11811000"/>
+            <a:ext cx="10172700" cy="457200"/>
           </a:xfrm>
           <a:prstGeom xmlns:a="http://schemas.openxmlformats.org/drawingml/2006/main" prst="rect">
             <a:avLst/>
@@ -3108,9 +3021,9 @@
           </a:bodyPr>
           <a:lstStyle xmlns:a="http://schemas.openxmlformats.org/drawingml/2006/main">
             <a:defPPr algn="l">
-              <a:defRPr sz="2100" b="0">
-                <a:solidFill>
-                  <a:srgbClr val="344854"/>
+              <a:defRPr sz="2600" b="1">
+                <a:solidFill>
+                  <a:srgbClr val="183B66"/>
                 </a:solidFill>
                 <a:latin typeface="Arial"/>
                 <a:ea typeface="Arial"/>
@@ -3121,9 +3034,9 @@
           <a:p xmlns:a="http://schemas.openxmlformats.org/drawingml/2006/main">
             <a:pPr algn="l">
               <a:buNone/>
-              <a:defRPr sz="2100" b="0">
-                <a:solidFill>
-                  <a:srgbClr val="344854"/>
+              <a:defRPr sz="2600" b="1">
+                <a:solidFill>
+                  <a:srgbClr val="183B66"/>
                 </a:solidFill>
                 <a:latin typeface="Arial"/>
                 <a:ea typeface="Arial"/>
@@ -3131,25 +3044,25 @@
               </a:defRPr>
             </a:pPr>
             <a:r>
-              <a:rPr sz="2100" b="0">
-                <a:solidFill>
-                  <a:srgbClr val="344854"/>
+              <a:rPr sz="2600" b="1">
+                <a:solidFill>
+                  <a:srgbClr val="183B66"/>
                 </a:solidFill>
                 <a:latin typeface="Arial"/>
                 <a:ea typeface="Arial"/>
                 <a:cs typeface="Arial"/>
               </a:rPr>
-              <a:t>The model is uncertain about one word in an easy passage, or about many words in a difficult passage. These situations need different treatment.</a:t>
+              <a:t>Useful scientific representations</a:t>
             </a:r>
           </a:p>
         </p:txBody>
       </p:sp>
       <p:sp>
         <p:nvSpPr>
-          <p:cNvPr id="66" name="Observation conclusion">
-            <a:extLst xmlns:a="http://schemas.openxmlformats.org/drawingml/2006/main">
-              <a:ext uri="{FF2B5EF4-FFF2-40B4-BE49-F238E27FC236}">
-                <a16:creationId xmlns:a16="http://schemas.microsoft.com/office/drawing/2014/main" id="{7876B269-5BD0-45D7-B188-095A31B5DAD4}"/>
+          <p:cNvPr id="98" name="Representation setup">
+            <a:extLst xmlns:a="http://schemas.openxmlformats.org/drawingml/2006/main">
+              <a:ext uri="{FF2B5EF4-FFF2-40B4-BE49-F238E27FC236}">
+                <a16:creationId xmlns:a16="http://schemas.microsoft.com/office/drawing/2014/main" id="{1DDC6388-55E7-4466-B1C1-F301ADEF083A}"/>
               </a:ext>
             </a:extLst>
           </p:cNvPr>
@@ -3160,8 +3073,77 @@
         </p:nvSpPr>
         <p:spPr>
           <a:xfrm xmlns:a="http://schemas.openxmlformats.org/drawingml/2006/main">
-            <a:off x="666750" y="10763250"/>
-            <a:ext cx="10172700" cy="762000"/>
+            <a:off x="22078950" y="12334875"/>
+            <a:ext cx="10172700" cy="619125"/>
+          </a:xfrm>
+          <a:prstGeom xmlns:a="http://schemas.openxmlformats.org/drawingml/2006/main" prst="rect">
+            <a:avLst/>
+          </a:prstGeom>
+          <a:noFill xmlns:a="http://schemas.openxmlformats.org/drawingml/2006/main"/>
+          <a:ln xmlns:a="http://schemas.openxmlformats.org/drawingml/2006/main" w="0">
+            <a:noFill/>
+          </a:ln>
+        </p:spPr>
+        <p:txBody>
+          <a:bodyPr xmlns:a="http://schemas.openxmlformats.org/drawingml/2006/main" wrap="square" lIns="0" tIns="0" rIns="0" bIns="0" anchor="t">
+            <a:noAutofit/>
+          </a:bodyPr>
+          <a:lstStyle xmlns:a="http://schemas.openxmlformats.org/drawingml/2006/main">
+            <a:defPPr algn="l">
+              <a:defRPr sz="2025" b="0">
+                <a:solidFill>
+                  <a:srgbClr val="344854"/>
+                </a:solidFill>
+                <a:latin typeface="Arial"/>
+                <a:ea typeface="Arial"/>
+                <a:cs typeface="Arial"/>
+              </a:defRPr>
+            </a:defPPr>
+          </a:lstStyle>
+          <a:p xmlns:a="http://schemas.openxmlformats.org/drawingml/2006/main">
+            <a:pPr algn="l">
+              <a:buNone/>
+              <a:defRPr sz="2025" b="0">
+                <a:solidFill>
+                  <a:srgbClr val="344854"/>
+                </a:solidFill>
+                <a:latin typeface="Arial"/>
+                <a:ea typeface="Arial"/>
+                <a:cs typeface="Arial"/>
+              </a:defRPr>
+            </a:pPr>
+            <a:r>
+              <a:rPr sz="2025" b="0">
+                <a:solidFill>
+                  <a:srgbClr val="344854"/>
+                </a:solidFill>
+                <a:latin typeface="Arial"/>
+                <a:ea typeface="Arial"/>
+                <a:cs typeface="Arial"/>
+              </a:rPr>
+              <a:t>Gene descriptions become inputs for gene prediction and single-cell response modeling.</a:t>
+            </a:r>
+          </a:p>
+        </p:txBody>
+      </p:sp>
+      <p:sp>
+        <p:nvSpPr>
+          <p:cNvPr id="100" name="Gene conclusion">
+            <a:extLst xmlns:a="http://schemas.openxmlformats.org/drawingml/2006/main">
+              <a:ext uri="{FF2B5EF4-FFF2-40B4-BE49-F238E27FC236}">
+                <a16:creationId xmlns:a16="http://schemas.microsoft.com/office/drawing/2014/main" id="{4644E453-5A9F-4946-B990-C37168DB81CC}"/>
+              </a:ext>
+            </a:extLst>
+          </p:cNvPr>
+          <p:cNvSpPr>
+            <a:spLocks xmlns:a="http://schemas.openxmlformats.org/drawingml/2006/main" noGrp="1"/>
+          </p:cNvSpPr>
+          <p:nvPr/>
+        </p:nvSpPr>
+        <p:spPr>
+          <a:xfrm xmlns:a="http://schemas.openxmlformats.org/drawingml/2006/main">
+            <a:off x="22078950" y="17859375"/>
+            <a:ext cx="10172700" cy="666750"/>
           </a:xfrm>
           <a:prstGeom xmlns:a="http://schemas.openxmlformats.org/drawingml/2006/main" prst="rect">
             <a:avLst/>
@@ -3208,17 +3190,17 @@
                 <a:ea typeface="Arial"/>
                 <a:cs typeface="Arial"/>
               </a:rPr>
-              <a:t>Left: an isolated difficult word. Right: a whole difficult passage. A low prediction confidence alone cannot tell us which content the model needs to learn.</a:t>
+              <a:t>Mean gene score: BFT 0.829 vs GenePT 0.802. GenePT remains higher on Lys4. Both use the same text encoder.</a:t>
             </a:r>
           </a:p>
         </p:txBody>
       </p:sp>
       <p:sp>
         <p:nvSpPr>
-          <p:cNvPr id="70" name="Retention conclusion">
-            <a:extLst xmlns:a="http://schemas.openxmlformats.org/drawingml/2006/main">
-              <a:ext uri="{FF2B5EF4-FFF2-40B4-BE49-F238E27FC236}">
-                <a16:creationId xmlns:a16="http://schemas.microsoft.com/office/drawing/2014/main" id="{70B3DBD5-9598-4D00-BBC6-EBCFB4AFF8A4}"/>
+          <p:cNvPr id="105" name="Perturbation caption">
+            <a:extLst xmlns:a="http://schemas.openxmlformats.org/drawingml/2006/main">
+              <a:ext uri="{FF2B5EF4-FFF2-40B4-BE49-F238E27FC236}">
+                <a16:creationId xmlns:a16="http://schemas.microsoft.com/office/drawing/2014/main" id="{BA5AEACB-0DB7-4829-A6C2-11814877AFA1}"/>
               </a:ext>
             </a:extLst>
           </p:cNvPr>
@@ -3229,8 +3211,8 @@
         </p:nvSpPr>
         <p:spPr>
           <a:xfrm xmlns:a="http://schemas.openxmlformats.org/drawingml/2006/main">
-            <a:off x="22078950" y="10287000"/>
-            <a:ext cx="10172700" cy="714375"/>
+            <a:off x="22078950" y="21526500"/>
+            <a:ext cx="10172700" cy="361950"/>
           </a:xfrm>
           <a:prstGeom xmlns:a="http://schemas.openxmlformats.org/drawingml/2006/main" prst="rect">
             <a:avLst/>
@@ -3246,7 +3228,7 @@
           </a:bodyPr>
           <a:lstStyle xmlns:a="http://schemas.openxmlformats.org/drawingml/2006/main">
             <a:defPPr algn="l">
-              <a:defRPr sz="1800" b="0">
+              <a:defRPr sz="1350" b="0">
                 <a:solidFill>
                   <a:srgbClr val="344854"/>
                 </a:solidFill>
@@ -3259,7 +3241,7 @@
           <a:p xmlns:a="http://schemas.openxmlformats.org/drawingml/2006/main">
             <a:pPr algn="l">
               <a:buNone/>
-              <a:defRPr sz="1800" b="0">
+              <a:defRPr sz="1350" b="0">
                 <a:solidFill>
                   <a:srgbClr val="344854"/>
                 </a:solidFill>
@@ -3269,7 +3251,7 @@
               </a:defRPr>
             </a:pPr>
             <a:r>
-              <a:rPr sz="1800" b="0">
+              <a:rPr sz="1350" b="0">
                 <a:solidFill>
                   <a:srgbClr val="344854"/>
                 </a:solidFill>
@@ -3277,17 +3259,17 @@
                 <a:ea typeface="Arial"/>
                 <a:cs typeface="Arial"/>
               </a:rPr>
-              <a:t>BFT retains more general capability than SFT and sample-only BFT. Some forgetting remains. DFT forgets least, while BFT offers stronger biomedical adaptation.</a:t>
+              <a:t>Comparable STATE results across four datasets. Profile generation is zero-shot here; the STATE model is still trained.</a:t>
             </a:r>
           </a:p>
         </p:txBody>
       </p:sp>
       <p:sp>
         <p:nvSpPr>
-          <p:cNvPr id="88" name="Medical heading">
-            <a:extLst xmlns:a="http://schemas.openxmlformats.org/drawingml/2006/main">
-              <a:ext uri="{FF2B5EF4-FFF2-40B4-BE49-F238E27FC236}">
-                <a16:creationId xmlns:a16="http://schemas.microsoft.com/office/drawing/2014/main" id="{60989384-94D8-4EC4-A645-303D45E264CA}"/>
+          <p:cNvPr id="109" name="Motivation takeaway">
+            <a:extLst xmlns:a="http://schemas.openxmlformats.org/drawingml/2006/main">
+              <a:ext uri="{FF2B5EF4-FFF2-40B4-BE49-F238E27FC236}">
+                <a16:creationId xmlns:a16="http://schemas.microsoft.com/office/drawing/2014/main" id="{21B64C01-32F5-4D1E-8625-621E92995CBC}"/>
               </a:ext>
             </a:extLst>
           </p:cNvPr>
@@ -3298,7 +3280,238 @@
         </p:nvSpPr>
         <p:spPr>
           <a:xfrm xmlns:a="http://schemas.openxmlformats.org/drawingml/2006/main">
-            <a:off x="11372850" y="12525375"/>
+            <a:off x="6096000" y="9001125"/>
+            <a:ext cx="4743450" cy="857250"/>
+          </a:xfrm>
+          <a:prstGeom xmlns:a="http://schemas.openxmlformats.org/drawingml/2006/main" prst="rect">
+            <a:avLst/>
+          </a:prstGeom>
+          <a:noFill xmlns:a="http://schemas.openxmlformats.org/drawingml/2006/main"/>
+          <a:ln xmlns:a="http://schemas.openxmlformats.org/drawingml/2006/main" w="0">
+            <a:noFill/>
+          </a:ln>
+        </p:spPr>
+        <p:txBody>
+          <a:bodyPr xmlns:a="http://schemas.openxmlformats.org/drawingml/2006/main" wrap="square" lIns="0" tIns="0" rIns="0" bIns="0" anchor="t">
+            <a:noAutofit/>
+          </a:bodyPr>
+          <a:lstStyle xmlns:a="http://schemas.openxmlformats.org/drawingml/2006/main">
+            <a:defPPr algn="l">
+              <a:defRPr sz="2325" b="1">
+                <a:solidFill>
+                  <a:srgbClr val="0054B8"/>
+                </a:solidFill>
+                <a:latin typeface="Arial"/>
+                <a:ea typeface="Arial"/>
+                <a:cs typeface="Arial"/>
+              </a:defRPr>
+            </a:defPPr>
+          </a:lstStyle>
+          <a:p xmlns:a="http://schemas.openxmlformats.org/drawingml/2006/main">
+            <a:pPr algn="l">
+              <a:buNone/>
+              <a:defRPr sz="2325" b="1">
+                <a:solidFill>
+                  <a:srgbClr val="0054B8"/>
+                </a:solidFill>
+                <a:latin typeface="Arial"/>
+                <a:ea typeface="Arial"/>
+                <a:cs typeface="Arial"/>
+              </a:defRPr>
+            </a:pPr>
+            <a:r>
+              <a:rPr sz="2325" b="1">
+                <a:solidFill>
+                  <a:srgbClr val="0054B8"/>
+                </a:solidFill>
+                <a:latin typeface="Arial"/>
+                <a:ea typeface="Arial"/>
+                <a:cs typeface="Arial"/>
+              </a:rPr>
+              <a:t>Preserve useful difficulty while retaining broad knowledge.</a:t>
+            </a:r>
+          </a:p>
+        </p:txBody>
+      </p:sp>
+      <p:sp>
+        <p:nvSpPr>
+          <p:cNvPr id="112" name="Method explanation">
+            <a:extLst xmlns:a="http://schemas.openxmlformats.org/drawingml/2006/main">
+              <a:ext uri="{FF2B5EF4-FFF2-40B4-BE49-F238E27FC236}">
+                <a16:creationId xmlns:a16="http://schemas.microsoft.com/office/drawing/2014/main" id="{68D6E2D3-B5B5-4B88-9C2C-84FFD27BB233}"/>
+              </a:ext>
+            </a:extLst>
+          </p:cNvPr>
+          <p:cNvSpPr>
+            <a:spLocks xmlns:a="http://schemas.openxmlformats.org/drawingml/2006/main" noGrp="1"/>
+          </p:cNvSpPr>
+          <p:nvPr/>
+        </p:nvSpPr>
+        <p:spPr>
+          <a:xfrm xmlns:a="http://schemas.openxmlformats.org/drawingml/2006/main">
+            <a:off x="11372850" y="10191750"/>
+            <a:ext cx="20878800" cy="714375"/>
+          </a:xfrm>
+          <a:prstGeom xmlns:a="http://schemas.openxmlformats.org/drawingml/2006/main" prst="rect">
+            <a:avLst/>
+          </a:prstGeom>
+          <a:noFill xmlns:a="http://schemas.openxmlformats.org/drawingml/2006/main"/>
+          <a:ln xmlns:a="http://schemas.openxmlformats.org/drawingml/2006/main" w="0">
+            <a:noFill/>
+          </a:ln>
+        </p:spPr>
+        <p:txBody>
+          <a:bodyPr xmlns:a="http://schemas.openxmlformats.org/drawingml/2006/main" wrap="square" lIns="0" tIns="0" rIns="0" bIns="0" anchor="t">
+            <a:noAutofit/>
+          </a:bodyPr>
+          <a:lstStyle xmlns:a="http://schemas.openxmlformats.org/drawingml/2006/main">
+            <a:defPPr algn="l">
+              <a:defRPr sz="2025" b="0">
+                <a:solidFill>
+                  <a:srgbClr val="344854"/>
+                </a:solidFill>
+                <a:latin typeface="Arial"/>
+                <a:ea typeface="Arial"/>
+                <a:cs typeface="Arial"/>
+              </a:defRPr>
+            </a:defPPr>
+          </a:lstStyle>
+          <a:p xmlns:a="http://schemas.openxmlformats.org/drawingml/2006/main">
+            <a:pPr algn="l">
+              <a:buNone/>
+              <a:defRPr sz="2025" b="0">
+                <a:solidFill>
+                  <a:srgbClr val="344854"/>
+                </a:solidFill>
+                <a:latin typeface="Arial"/>
+                <a:ea typeface="Arial"/>
+                <a:cs typeface="Arial"/>
+              </a:defRPr>
+            </a:pPr>
+            <a:r>
+              <a:rPr sz="2025" b="0">
+                <a:solidFill>
+                  <a:srgbClr val="344854"/>
+                </a:solidFill>
+                <a:latin typeface="Arial"/>
+                <a:ea typeface="Arial"/>
+                <a:cs typeface="Arial"/>
+              </a:rPr>
+              <a:t>Left: retain words inside difficult passages. Right: emphasize examples containing hard passages, within a limit.</a:t>
+            </a:r>
+          </a:p>
+          <a:p xmlns:a="http://schemas.openxmlformats.org/drawingml/2006/main">
+            <a:pPr algn="l">
+              <a:buNone/>
+              <a:defRPr sz="2025" b="0">
+                <a:solidFill>
+                  <a:srgbClr val="344854"/>
+                </a:solidFill>
+                <a:latin typeface="Arial"/>
+                <a:ea typeface="Arial"/>
+                <a:cs typeface="Arial"/>
+              </a:defRPr>
+            </a:pPr>
+            <a:r>
+              <a:rPr sz="2025" b="0">
+                <a:solidFill>
+                  <a:srgbClr val="344854"/>
+                </a:solidFill>
+                <a:latin typeface="Arial"/>
+                <a:ea typeface="Arial"/>
+                <a:cs typeface="Arial"/>
+              </a:rPr>
+              <a:t>BFT uses the model’s own confidence, without a reward model or external uncertainty estimator.</a:t>
+            </a:r>
+          </a:p>
+        </p:txBody>
+      </p:sp>
+      <p:sp>
+        <p:nvSpPr>
+          <p:cNvPr id="115" name="Biomedical overview">
+            <a:extLst xmlns:a="http://schemas.openxmlformats.org/drawingml/2006/main">
+              <a:ext uri="{FF2B5EF4-FFF2-40B4-BE49-F238E27FC236}">
+                <a16:creationId xmlns:a16="http://schemas.microsoft.com/office/drawing/2014/main" id="{4DDEB3B2-8AE1-4625-AA68-B1FE4B4AE2DB}"/>
+              </a:ext>
+            </a:extLst>
+          </p:cNvPr>
+          <p:cNvSpPr>
+            <a:spLocks xmlns:a="http://schemas.openxmlformats.org/drawingml/2006/main" noGrp="1"/>
+          </p:cNvSpPr>
+          <p:nvPr/>
+        </p:nvSpPr>
+        <p:spPr>
+          <a:xfrm xmlns:a="http://schemas.openxmlformats.org/drawingml/2006/main">
+            <a:off x="666750" y="12334875"/>
+            <a:ext cx="10172700" cy="666750"/>
+          </a:xfrm>
+          <a:prstGeom xmlns:a="http://schemas.openxmlformats.org/drawingml/2006/main" prst="rect">
+            <a:avLst/>
+          </a:prstGeom>
+          <a:noFill xmlns:a="http://schemas.openxmlformats.org/drawingml/2006/main"/>
+          <a:ln xmlns:a="http://schemas.openxmlformats.org/drawingml/2006/main" w="0">
+            <a:noFill/>
+          </a:ln>
+        </p:spPr>
+        <p:txBody>
+          <a:bodyPr xmlns:a="http://schemas.openxmlformats.org/drawingml/2006/main" wrap="square" lIns="0" tIns="0" rIns="0" bIns="0" anchor="t">
+            <a:noAutofit/>
+          </a:bodyPr>
+          <a:lstStyle xmlns:a="http://schemas.openxmlformats.org/drawingml/2006/main">
+            <a:defPPr algn="l">
+              <a:defRPr sz="2025" b="0">
+                <a:solidFill>
+                  <a:srgbClr val="344854"/>
+                </a:solidFill>
+                <a:latin typeface="Arial"/>
+                <a:ea typeface="Arial"/>
+                <a:cs typeface="Arial"/>
+              </a:defRPr>
+            </a:defPPr>
+          </a:lstStyle>
+          <a:p xmlns:a="http://schemas.openxmlformats.org/drawingml/2006/main">
+            <a:pPr algn="l">
+              <a:buNone/>
+              <a:defRPr sz="2025" b="0">
+                <a:solidFill>
+                  <a:srgbClr val="344854"/>
+                </a:solidFill>
+                <a:latin typeface="Arial"/>
+                <a:ea typeface="Arial"/>
+                <a:cs typeface="Arial"/>
+              </a:defRPr>
+            </a:pPr>
+            <a:r>
+              <a:rPr sz="2025" b="0">
+                <a:solidFill>
+                  <a:srgbClr val="344854"/>
+                </a:solidFill>
+                <a:latin typeface="Arial"/>
+                <a:ea typeface="Arial"/>
+                <a:cs typeface="Arial"/>
+              </a:rPr>
+              <a:t>HealthBench Hard (70B). Categories, left to right: accuracy, communication quality, completeness, context, instruction following.</a:t>
+            </a:r>
+          </a:p>
+        </p:txBody>
+      </p:sp>
+      <p:sp>
+        <p:nvSpPr>
+          <p:cNvPr id="118" name="GeneAgent heading">
+            <a:extLst xmlns:a="http://schemas.openxmlformats.org/drawingml/2006/main">
+              <a:ext uri="{FF2B5EF4-FFF2-40B4-BE49-F238E27FC236}">
+                <a16:creationId xmlns:a16="http://schemas.microsoft.com/office/drawing/2014/main" id="{4E8E0B09-4ECE-4037-81B5-C438AC12C810}"/>
+              </a:ext>
+            </a:extLst>
+          </p:cNvPr>
+          <p:cNvSpPr>
+            <a:spLocks xmlns:a="http://schemas.openxmlformats.org/drawingml/2006/main" noGrp="1"/>
+          </p:cNvSpPr>
+          <p:nvPr/>
+        </p:nvSpPr>
+        <p:spPr>
+          <a:xfrm xmlns:a="http://schemas.openxmlformats.org/drawingml/2006/main">
+            <a:off x="666750" y="17621250"/>
             <a:ext cx="10172700" cy="457200"/>
           </a:xfrm>
           <a:prstGeom xmlns:a="http://schemas.openxmlformats.org/drawingml/2006/main" prst="rect">
@@ -3346,17 +3559,73 @@
                 <a:ea typeface="Arial"/>
                 <a:cs typeface="Arial"/>
               </a:rPr>
-              <a:t>Medical competence: HealthBench Hard (70B)</a:t>
+              <a:t>Biological process reasoning</a:t>
             </a:r>
           </a:p>
         </p:txBody>
       </p:sp>
+      <p:pic>
+        <p:nvPicPr>
+          <p:cNvPr id="128" name="">
+            <a:extLst xmlns:a="http://schemas.openxmlformats.org/drawingml/2006/main">
+              <a:ext uri="{FF2B5EF4-FFF2-40B4-BE49-F238E27FC236}">
+                <a16:creationId xmlns:a16="http://schemas.microsoft.com/office/drawing/2014/main" id="{495703A7-B984-443F-94BB-28983BAB4A25}"/>
+              </a:ext>
+            </a:extLst>
+          </p:cNvPr>
+          <p:cNvPicPr>
+            <a:picLocks xmlns:a="http://schemas.openxmlformats.org/drawingml/2006/main" noChangeAspect="1"/>
+          </p:cNvPicPr>
+          <p:nvPr/>
+        </p:nvPicPr>
+        <p:blipFill>
+          <a:blip xmlns:r="http://schemas.openxmlformats.org/officeDocument/2006/relationships" xmlns:a="http://schemas.openxmlformats.org/drawingml/2006/main" r:embed="R0bdc39f0fae547bc"/>
+          <a:stretch xmlns:a="http://schemas.openxmlformats.org/drawingml/2006/main"/>
+        </p:blipFill>
+        <p:spPr>
+          <a:xfrm xmlns:a="http://schemas.openxmlformats.org/drawingml/2006/main">
+            <a:off x="2388747" y="5048250"/>
+            <a:ext cx="6728707" cy="1762125"/>
+          </a:xfrm>
+          <a:prstGeom xmlns:a="http://schemas.openxmlformats.org/drawingml/2006/main" prst="rect">
+            <a:avLst/>
+          </a:prstGeom>
+        </p:spPr>
+      </p:pic>
+      <p:pic>
+        <p:nvPicPr>
+          <p:cNvPr id="129" name="">
+            <a:extLst xmlns:a="http://schemas.openxmlformats.org/drawingml/2006/main">
+              <a:ext uri="{FF2B5EF4-FFF2-40B4-BE49-F238E27FC236}">
+                <a16:creationId xmlns:a16="http://schemas.microsoft.com/office/drawing/2014/main" id="{B347CB04-5F97-427A-81C0-2115298846E9}"/>
+              </a:ext>
+            </a:extLst>
+          </p:cNvPr>
+          <p:cNvPicPr>
+            <a:picLocks xmlns:a="http://schemas.openxmlformats.org/drawingml/2006/main" noChangeAspect="1"/>
+          </p:cNvPicPr>
+          <p:nvPr/>
+        </p:nvPicPr>
+        <p:blipFill>
+          <a:blip xmlns:r="http://schemas.openxmlformats.org/officeDocument/2006/relationships" xmlns:a="http://schemas.openxmlformats.org/drawingml/2006/main" r:embed="Rbafdc4b9e53646ff"/>
+          <a:stretch xmlns:a="http://schemas.openxmlformats.org/drawingml/2006/main"/>
+        </p:blipFill>
+        <p:spPr>
+          <a:xfrm xmlns:a="http://schemas.openxmlformats.org/drawingml/2006/main">
+            <a:off x="982510" y="7810500"/>
+            <a:ext cx="4511979" cy="2667000"/>
+          </a:xfrm>
+          <a:prstGeom xmlns:a="http://schemas.openxmlformats.org/drawingml/2006/main" prst="rect">
+            <a:avLst/>
+          </a:prstGeom>
+        </p:spPr>
+      </p:pic>
       <p:sp>
         <p:nvSpPr>
-          <p:cNvPr id="91" name="Medical caption">
-            <a:extLst xmlns:a="http://schemas.openxmlformats.org/drawingml/2006/main">
-              <a:ext uri="{FF2B5EF4-FFF2-40B4-BE49-F238E27FC236}">
-                <a16:creationId xmlns:a16="http://schemas.microsoft.com/office/drawing/2014/main" id="{052BDBD2-04C0-4E4F-BF02-ED455AC5A352}"/>
+          <p:cNvPr id="130" name="Motivation scope">
+            <a:extLst xmlns:a="http://schemas.openxmlformats.org/drawingml/2006/main">
+              <a:ext uri="{FF2B5EF4-FFF2-40B4-BE49-F238E27FC236}">
+                <a16:creationId xmlns:a16="http://schemas.microsoft.com/office/drawing/2014/main" id="{2311A676-5CBC-447F-8696-28F21AEC9C42}"/>
               </a:ext>
             </a:extLst>
           </p:cNvPr>
@@ -3367,8 +3636,8 @@
         </p:nvSpPr>
         <p:spPr>
           <a:xfrm xmlns:a="http://schemas.openxmlformats.org/drawingml/2006/main">
-            <a:off x="11372850" y="16383000"/>
-            <a:ext cx="10172700" cy="714375"/>
+            <a:off x="6096000" y="9953625"/>
+            <a:ext cx="4743450" cy="809625"/>
           </a:xfrm>
           <a:prstGeom xmlns:a="http://schemas.openxmlformats.org/drawingml/2006/main" prst="rect">
             <a:avLst/>
@@ -3384,7 +3653,7 @@
           </a:bodyPr>
           <a:lstStyle xmlns:a="http://schemas.openxmlformats.org/drawingml/2006/main">
             <a:defPPr algn="l">
-              <a:defRPr sz="1800" b="0">
+              <a:defRPr sz="1725" b="0">
                 <a:solidFill>
                   <a:srgbClr val="344854"/>
                 </a:solidFill>
@@ -3396,8 +3665,7 @@
           </a:lstStyle>
           <a:p xmlns:a="http://schemas.openxmlformats.org/drawingml/2006/main">
             <a:pPr algn="l">
-              <a:buNone/>
-              <a:defRPr sz="1800" b="0">
+              <a:defRPr sz="1725" b="0">
                 <a:solidFill>
                   <a:srgbClr val="344854"/>
                 </a:solidFill>
@@ -3407,7 +3675,7 @@
               </a:defRPr>
             </a:pPr>
             <a:r>
-              <a:rPr sz="1800" b="0">
+              <a:rPr sz="1725" b="0">
                 <a:solidFill>
                   <a:srgbClr val="344854"/>
                 </a:solidFill>
@@ -3415,17 +3683,45 @@
                 <a:ea typeface="Arial"/>
                 <a:cs typeface="Arial"/>
               </a:rPr>
-              <a:t>BFT improves medical competence more consistently across model sizes. On VCWorld, BFT reaches 0.696 vs SFT 0.562, then 0.736 after feedback training.</a:t>
+              <a:t>These associations motivate BFT. They do not identify every uncertain word as useful knowledge.</a:t>
             </a:r>
           </a:p>
         </p:txBody>
       </p:sp>
+      <p:pic>
+        <p:nvPicPr>
+          <p:cNvPr id="131" name="">
+            <a:extLst xmlns:a="http://schemas.openxmlformats.org/drawingml/2006/main">
+              <a:ext uri="{FF2B5EF4-FFF2-40B4-BE49-F238E27FC236}">
+                <a16:creationId xmlns:a16="http://schemas.microsoft.com/office/drawing/2014/main" id="{9FD7D50C-495C-4B42-B415-9A7DA668154C}"/>
+              </a:ext>
+            </a:extLst>
+          </p:cNvPr>
+          <p:cNvPicPr>
+            <a:picLocks xmlns:a="http://schemas.openxmlformats.org/drawingml/2006/main" noChangeAspect="1"/>
+          </p:cNvPicPr>
+          <p:nvPr/>
+        </p:nvPicPr>
+        <p:blipFill>
+          <a:blip xmlns:r="http://schemas.openxmlformats.org/officeDocument/2006/relationships" xmlns:a="http://schemas.openxmlformats.org/drawingml/2006/main" r:embed="R3f6be4bc225d4b1b"/>
+          <a:stretch xmlns:a="http://schemas.openxmlformats.org/drawingml/2006/main"/>
+        </p:blipFill>
+        <p:spPr>
+          <a:xfrm xmlns:a="http://schemas.openxmlformats.org/drawingml/2006/main">
+            <a:off x="14524596" y="4810125"/>
+            <a:ext cx="14575309" cy="5238750"/>
+          </a:xfrm>
+          <a:prstGeom xmlns:a="http://schemas.openxmlformats.org/drawingml/2006/main" prst="rect">
+            <a:avLst/>
+          </a:prstGeom>
+        </p:spPr>
+      </p:pic>
       <p:sp>
         <p:nvSpPr>
-          <p:cNvPr id="97" name="Representation heading">
-            <a:extLst xmlns:a="http://schemas.openxmlformats.org/drawingml/2006/main">
-              <a:ext uri="{FF2B5EF4-FFF2-40B4-BE49-F238E27FC236}">
-                <a16:creationId xmlns:a16="http://schemas.microsoft.com/office/drawing/2014/main" id="{9D49E91F-FC43-4AA3-88BB-79FCE6178656}"/>
+          <p:cNvPr id="132" name="Results banner">
+            <a:extLst xmlns:a="http://schemas.openxmlformats.org/drawingml/2006/main">
+              <a:ext uri="{FF2B5EF4-FFF2-40B4-BE49-F238E27FC236}">
+                <a16:creationId xmlns:a16="http://schemas.microsoft.com/office/drawing/2014/main" id="{ED60C6FF-E797-4C11-9E2B-598EECFAFF59}"/>
               </a:ext>
             </a:extLst>
           </p:cNvPr>
@@ -3436,7 +3732,189 @@
         </p:nvSpPr>
         <p:spPr>
           <a:xfrm xmlns:a="http://schemas.openxmlformats.org/drawingml/2006/main">
-            <a:off x="22078950" y="11144250"/>
+            <a:off x="666750" y="11049000"/>
+            <a:ext cx="31584900" cy="609600"/>
+          </a:xfrm>
+          <a:prstGeom xmlns:a="http://schemas.openxmlformats.org/drawingml/2006/main" prst="rect">
+            <a:avLst/>
+          </a:prstGeom>
+          <a:solidFill xmlns:a="http://schemas.openxmlformats.org/drawingml/2006/main">
+            <a:srgbClr val="183B66"/>
+          </a:solidFill>
+          <a:ln xmlns:a="http://schemas.openxmlformats.org/drawingml/2006/main" w="0">
+            <a:noFill/>
+          </a:ln>
+        </p:spPr>
+        <p:txBody>
+          <a:bodyPr xmlns:a="http://schemas.openxmlformats.org/drawingml/2006/main" wrap="square" lIns="171450" tIns="38100" rIns="114300" bIns="38100" anchor="ctr">
+            <a:noAutofit/>
+          </a:bodyPr>
+          <a:lstStyle xmlns:a="http://schemas.openxmlformats.org/drawingml/2006/main">
+            <a:defPPr algn="l">
+              <a:defRPr sz="3225" b="1">
+                <a:solidFill>
+                  <a:srgbClr val="FFFFFF"/>
+                </a:solidFill>
+                <a:latin typeface="Arial"/>
+                <a:ea typeface="Arial"/>
+                <a:cs typeface="Arial"/>
+              </a:defRPr>
+            </a:defPPr>
+          </a:lstStyle>
+          <a:p xmlns:a="http://schemas.openxmlformats.org/drawingml/2006/main">
+            <a:pPr algn="l">
+              <a:defRPr sz="3225" b="1">
+                <a:solidFill>
+                  <a:srgbClr val="FFFFFF"/>
+                </a:solidFill>
+                <a:latin typeface="Arial"/>
+                <a:ea typeface="Arial"/>
+                <a:cs typeface="Arial"/>
+              </a:defRPr>
+            </a:pPr>
+            <a:r>
+              <a:rPr sz="3225" b="1">
+                <a:solidFill>
+                  <a:srgbClr val="FFFFFF"/>
+                </a:solidFill>
+                <a:latin typeface="Arial"/>
+                <a:ea typeface="Arial"/>
+                <a:cs typeface="Arial"/>
+              </a:rPr>
+              <a:t>4  Experimental results: biomedical gains with less general forgetting</a:t>
+            </a:r>
+          </a:p>
+        </p:txBody>
+      </p:sp>
+      <p:pic>
+        <p:nvPicPr>
+          <p:cNvPr id="133" name="">
+            <a:extLst xmlns:a="http://schemas.openxmlformats.org/drawingml/2006/main">
+              <a:ext uri="{FF2B5EF4-FFF2-40B4-BE49-F238E27FC236}">
+                <a16:creationId xmlns:a16="http://schemas.microsoft.com/office/drawing/2014/main" id="{A30C5F74-B96C-4684-9C9F-CCD258080F04}"/>
+              </a:ext>
+            </a:extLst>
+          </p:cNvPr>
+          <p:cNvPicPr>
+            <a:picLocks xmlns:a="http://schemas.openxmlformats.org/drawingml/2006/main" noChangeAspect="1"/>
+          </p:cNvPicPr>
+          <p:nvPr/>
+        </p:nvPicPr>
+        <p:blipFill>
+          <a:blip xmlns:r="http://schemas.openxmlformats.org/officeDocument/2006/relationships" xmlns:a="http://schemas.openxmlformats.org/drawingml/2006/main" r:embed="Rb4bca09aeeae445e"/>
+          <a:stretch xmlns:a="http://schemas.openxmlformats.org/drawingml/2006/main"/>
+        </p:blipFill>
+        <p:spPr>
+          <a:xfrm xmlns:a="http://schemas.openxmlformats.org/drawingml/2006/main">
+            <a:off x="1232279" y="13144500"/>
+            <a:ext cx="9041642" cy="3810000"/>
+          </a:xfrm>
+          <a:prstGeom xmlns:a="http://schemas.openxmlformats.org/drawingml/2006/main" prst="rect">
+            <a:avLst/>
+          </a:prstGeom>
+        </p:spPr>
+      </p:pic>
+      <p:pic>
+        <p:nvPicPr>
+          <p:cNvPr id="134" name="">
+            <a:extLst xmlns:a="http://schemas.openxmlformats.org/drawingml/2006/main">
+              <a:ext uri="{FF2B5EF4-FFF2-40B4-BE49-F238E27FC236}">
+                <a16:creationId xmlns:a16="http://schemas.microsoft.com/office/drawing/2014/main" id="{A669B4B7-3B03-49DC-91EA-DF98075C8381}"/>
+              </a:ext>
+            </a:extLst>
+          </p:cNvPr>
+          <p:cNvPicPr>
+            <a:picLocks xmlns:a="http://schemas.openxmlformats.org/drawingml/2006/main" noChangeAspect="1"/>
+          </p:cNvPicPr>
+          <p:nvPr/>
+        </p:nvPicPr>
+        <p:blipFill>
+          <a:blip xmlns:r="http://schemas.openxmlformats.org/officeDocument/2006/relationships" xmlns:a="http://schemas.openxmlformats.org/drawingml/2006/main" r:embed="R1ebe896ff15348c4"/>
+          <a:stretch xmlns:a="http://schemas.openxmlformats.org/drawingml/2006/main"/>
+        </p:blipFill>
+        <p:spPr>
+          <a:xfrm xmlns:a="http://schemas.openxmlformats.org/drawingml/2006/main">
+            <a:off x="666750" y="17129968"/>
+            <a:ext cx="10172700" cy="268189"/>
+          </a:xfrm>
+          <a:prstGeom xmlns:a="http://schemas.openxmlformats.org/drawingml/2006/main" prst="rect">
+            <a:avLst/>
+          </a:prstGeom>
+        </p:spPr>
+      </p:pic>
+      <p:pic>
+        <p:nvPicPr>
+          <p:cNvPr id="135" name="">
+            <a:extLst xmlns:a="http://schemas.openxmlformats.org/drawingml/2006/main">
+              <a:ext uri="{FF2B5EF4-FFF2-40B4-BE49-F238E27FC236}">
+                <a16:creationId xmlns:a16="http://schemas.microsoft.com/office/drawing/2014/main" id="{378BAD28-E066-4BC4-B4E1-4981D03FA366}"/>
+              </a:ext>
+            </a:extLst>
+          </p:cNvPr>
+          <p:cNvPicPr>
+            <a:picLocks xmlns:a="http://schemas.openxmlformats.org/drawingml/2006/main" noChangeAspect="1"/>
+          </p:cNvPicPr>
+          <p:nvPr/>
+        </p:nvPicPr>
+        <p:blipFill>
+          <a:blip xmlns:r="http://schemas.openxmlformats.org/officeDocument/2006/relationships" xmlns:a="http://schemas.openxmlformats.org/drawingml/2006/main" r:embed="R77f436eac8e94bf6"/>
+          <a:stretch xmlns:a="http://schemas.openxmlformats.org/drawingml/2006/main"/>
+        </p:blipFill>
+        <p:spPr>
+          <a:xfrm xmlns:a="http://schemas.openxmlformats.org/drawingml/2006/main">
+            <a:off x="1681598" y="18192750"/>
+            <a:ext cx="8143003" cy="3333750"/>
+          </a:xfrm>
+          <a:prstGeom xmlns:a="http://schemas.openxmlformats.org/drawingml/2006/main" prst="rect">
+            <a:avLst/>
+          </a:prstGeom>
+        </p:spPr>
+      </p:pic>
+      <p:pic>
+        <p:nvPicPr>
+          <p:cNvPr id="136" name="">
+            <a:extLst xmlns:a="http://schemas.openxmlformats.org/drawingml/2006/main">
+              <a:ext uri="{FF2B5EF4-FFF2-40B4-BE49-F238E27FC236}">
+                <a16:creationId xmlns:a16="http://schemas.microsoft.com/office/drawing/2014/main" id="{B1602355-EBCE-475D-B786-0C4FC77BF84F}"/>
+              </a:ext>
+            </a:extLst>
+          </p:cNvPr>
+          <p:cNvPicPr>
+            <a:picLocks xmlns:a="http://schemas.openxmlformats.org/drawingml/2006/main" noChangeAspect="1"/>
+          </p:cNvPicPr>
+          <p:nvPr/>
+        </p:nvPicPr>
+        <p:blipFill>
+          <a:blip xmlns:r="http://schemas.openxmlformats.org/officeDocument/2006/relationships" xmlns:a="http://schemas.openxmlformats.org/drawingml/2006/main" r:embed="R11a6d1747a074698"/>
+          <a:stretch xmlns:a="http://schemas.openxmlformats.org/drawingml/2006/main"/>
+        </p:blipFill>
+        <p:spPr>
+          <a:xfrm xmlns:a="http://schemas.openxmlformats.org/drawingml/2006/main">
+            <a:off x="666750" y="21634601"/>
+            <a:ext cx="10172700" cy="212423"/>
+          </a:xfrm>
+          <a:prstGeom xmlns:a="http://schemas.openxmlformats.org/drawingml/2006/main" prst="rect">
+            <a:avLst/>
+          </a:prstGeom>
+        </p:spPr>
+      </p:pic>
+      <p:sp>
+        <p:nvSpPr>
+          <p:cNvPr id="137" name="Retention heading">
+            <a:extLst xmlns:a="http://schemas.openxmlformats.org/drawingml/2006/main">
+              <a:ext uri="{FF2B5EF4-FFF2-40B4-BE49-F238E27FC236}">
+                <a16:creationId xmlns:a16="http://schemas.microsoft.com/office/drawing/2014/main" id="{C408CA4A-9D4F-4177-B765-5F5979A1C602}"/>
+              </a:ext>
+            </a:extLst>
+          </p:cNvPr>
+          <p:cNvSpPr>
+            <a:spLocks xmlns:a="http://schemas.openxmlformats.org/drawingml/2006/main" noGrp="1"/>
+          </p:cNvSpPr>
+          <p:nvPr/>
+        </p:nvSpPr>
+        <p:spPr>
+          <a:xfrm xmlns:a="http://schemas.openxmlformats.org/drawingml/2006/main">
+            <a:off x="11372850" y="11811000"/>
             <a:ext cx="10172700" cy="457200"/>
           </a:xfrm>
           <a:prstGeom xmlns:a="http://schemas.openxmlformats.org/drawingml/2006/main" prst="rect">
@@ -3465,7 +3943,6 @@
           </a:lstStyle>
           <a:p xmlns:a="http://schemas.openxmlformats.org/drawingml/2006/main">
             <a:pPr algn="l">
-              <a:buNone/>
               <a:defRPr sz="2600" b="1">
                 <a:solidFill>
                   <a:srgbClr val="183B66"/>
@@ -3484,17 +3961,17 @@
                 <a:ea typeface="Arial"/>
                 <a:cs typeface="Arial"/>
               </a:rPr>
-              <a:t>Gene descriptions support scientific prediction</a:t>
+              <a:t>Preserving general capability</a:t>
             </a:r>
           </a:p>
         </p:txBody>
       </p:sp>
       <p:sp>
         <p:nvSpPr>
-          <p:cNvPr id="98" name="Representation setup">
-            <a:extLst xmlns:a="http://schemas.openxmlformats.org/drawingml/2006/main">
-              <a:ext uri="{FF2B5EF4-FFF2-40B4-BE49-F238E27FC236}">
-                <a16:creationId xmlns:a16="http://schemas.microsoft.com/office/drawing/2014/main" id="{1DDC6388-55E7-4466-B1C1-F301ADEF083A}"/>
+          <p:cNvPr id="138" name="Retention intro">
+            <a:extLst xmlns:a="http://schemas.openxmlformats.org/drawingml/2006/main">
+              <a:ext uri="{FF2B5EF4-FFF2-40B4-BE49-F238E27FC236}">
+                <a16:creationId xmlns:a16="http://schemas.microsoft.com/office/drawing/2014/main" id="{05043B58-6EF1-4301-BF29-956E67B2CC91}"/>
               </a:ext>
             </a:extLst>
           </p:cNvPr>
@@ -3505,8 +3982,8 @@
         </p:nvSpPr>
         <p:spPr>
           <a:xfrm xmlns:a="http://schemas.openxmlformats.org/drawingml/2006/main">
-            <a:off x="22078950" y="11668125"/>
-            <a:ext cx="10172700" cy="714375"/>
+            <a:off x="11372850" y="12334875"/>
+            <a:ext cx="10172700" cy="666750"/>
           </a:xfrm>
           <a:prstGeom xmlns:a="http://schemas.openxmlformats.org/drawingml/2006/main" prst="rect">
             <a:avLst/>
@@ -3522,7 +3999,7 @@
           </a:bodyPr>
           <a:lstStyle xmlns:a="http://schemas.openxmlformats.org/drawingml/2006/main">
             <a:defPPr algn="l">
-              <a:defRPr sz="2100" b="0">
+              <a:defRPr sz="2025" b="0">
                 <a:solidFill>
                   <a:srgbClr val="344854"/>
                 </a:solidFill>
@@ -3534,8 +4011,7 @@
           </a:lstStyle>
           <a:p xmlns:a="http://schemas.openxmlformats.org/drawingml/2006/main">
             <a:pPr algn="l">
-              <a:buNone/>
-              <a:defRPr sz="2100" b="0">
+              <a:defRPr sz="2025" b="0">
                 <a:solidFill>
                   <a:srgbClr val="344854"/>
                 </a:solidFill>
@@ -3545,7 +4021,7 @@
               </a:defRPr>
             </a:pPr>
             <a:r>
-              <a:rPr sz="2100" b="0">
+              <a:rPr sz="2025" b="0">
                 <a:solidFill>
                   <a:srgbClr val="344854"/>
                 </a:solidFill>
@@ -3553,17 +4029,141 @@
                 <a:ea typeface="Arial"/>
                 <a:cs typeface="Arial"/>
               </a:rPr>
-              <a:t>BFT writes gene descriptions. A shared text encoder converts them into numerical representations for predicting gene properties and interactions.</a:t>
+              <a:t>MMLU, 70B: BFT preserves more broad knowledge than SFT while adding biomedical capability.</a:t>
+            </a:r>
+          </a:p>
+        </p:txBody>
+      </p:sp>
+      <p:pic>
+        <p:nvPicPr>
+          <p:cNvPr id="139" name="">
+            <a:extLst xmlns:a="http://schemas.openxmlformats.org/drawingml/2006/main">
+              <a:ext uri="{FF2B5EF4-FFF2-40B4-BE49-F238E27FC236}">
+                <a16:creationId xmlns:a16="http://schemas.microsoft.com/office/drawing/2014/main" id="{15D5A681-40C1-49B5-BD28-E17965A7D9F8}"/>
+              </a:ext>
+            </a:extLst>
+          </p:cNvPr>
+          <p:cNvPicPr>
+            <a:picLocks xmlns:a="http://schemas.openxmlformats.org/drawingml/2006/main" noChangeAspect="1"/>
+          </p:cNvPicPr>
+          <p:nvPr/>
+        </p:nvPicPr>
+        <p:blipFill>
+          <a:blip xmlns:r="http://schemas.openxmlformats.org/officeDocument/2006/relationships" xmlns:a="http://schemas.openxmlformats.org/drawingml/2006/main" r:embed="R848db29787f344ea"/>
+          <a:stretch xmlns:a="http://schemas.openxmlformats.org/drawingml/2006/main"/>
+        </p:blipFill>
+        <p:spPr>
+          <a:xfrm xmlns:a="http://schemas.openxmlformats.org/drawingml/2006/main">
+            <a:off x="11384207" y="13239750"/>
+            <a:ext cx="8121162" cy="6477000"/>
+          </a:xfrm>
+          <a:prstGeom xmlns:a="http://schemas.openxmlformats.org/drawingml/2006/main" prst="rect">
+            <a:avLst/>
+          </a:prstGeom>
+        </p:spPr>
+      </p:pic>
+      <p:pic>
+        <p:nvPicPr>
+          <p:cNvPr id="140" name="">
+            <a:extLst xmlns:a="http://schemas.openxmlformats.org/drawingml/2006/main">
+              <a:ext uri="{FF2B5EF4-FFF2-40B4-BE49-F238E27FC236}">
+                <a16:creationId xmlns:a16="http://schemas.microsoft.com/office/drawing/2014/main" id="{DDC51E73-0540-41F6-BE74-08F562E96039}"/>
+              </a:ext>
+            </a:extLst>
+          </p:cNvPr>
+          <p:cNvPicPr>
+            <a:picLocks xmlns:a="http://schemas.openxmlformats.org/drawingml/2006/main" noChangeAspect="1"/>
+          </p:cNvPicPr>
+          <p:nvPr/>
+        </p:nvPicPr>
+        <p:blipFill>
+          <a:blip xmlns:r="http://schemas.openxmlformats.org/officeDocument/2006/relationships" xmlns:a="http://schemas.openxmlformats.org/drawingml/2006/main" r:embed="Rb7e1a2a8b1ca41e6"/>
+          <a:stretch xmlns:a="http://schemas.openxmlformats.org/drawingml/2006/main"/>
+        </p:blipFill>
+        <p:spPr>
+          <a:xfrm xmlns:a="http://schemas.openxmlformats.org/drawingml/2006/main">
+            <a:off x="19707225" y="15149868"/>
+            <a:ext cx="1838325" cy="2085264"/>
+          </a:xfrm>
+          <a:prstGeom xmlns:a="http://schemas.openxmlformats.org/drawingml/2006/main" prst="rect">
+            <a:avLst/>
+          </a:prstGeom>
+        </p:spPr>
+      </p:pic>
+      <p:sp>
+        <p:nvSpPr>
+          <p:cNvPr id="141" name="Retention categories">
+            <a:extLst xmlns:a="http://schemas.openxmlformats.org/drawingml/2006/main">
+              <a:ext uri="{FF2B5EF4-FFF2-40B4-BE49-F238E27FC236}">
+                <a16:creationId xmlns:a16="http://schemas.microsoft.com/office/drawing/2014/main" id="{86F04A25-518E-4DFB-8073-F1560376E99C}"/>
+              </a:ext>
+            </a:extLst>
+          </p:cNvPr>
+          <p:cNvSpPr>
+            <a:spLocks xmlns:a="http://schemas.openxmlformats.org/drawingml/2006/main" noGrp="1"/>
+          </p:cNvSpPr>
+          <p:nvPr/>
+        </p:nvSpPr>
+        <p:spPr>
+          <a:xfrm xmlns:a="http://schemas.openxmlformats.org/drawingml/2006/main">
+            <a:off x="11372850" y="19907250"/>
+            <a:ext cx="10172700" cy="333375"/>
+          </a:xfrm>
+          <a:prstGeom xmlns:a="http://schemas.openxmlformats.org/drawingml/2006/main" prst="rect">
+            <a:avLst/>
+          </a:prstGeom>
+          <a:noFill xmlns:a="http://schemas.openxmlformats.org/drawingml/2006/main"/>
+          <a:ln xmlns:a="http://schemas.openxmlformats.org/drawingml/2006/main" w="0">
+            <a:noFill/>
+          </a:ln>
+        </p:spPr>
+        <p:txBody>
+          <a:bodyPr xmlns:a="http://schemas.openxmlformats.org/drawingml/2006/main" wrap="square" lIns="0" tIns="0" rIns="0" bIns="0" anchor="t">
+            <a:noAutofit/>
+          </a:bodyPr>
+          <a:lstStyle xmlns:a="http://schemas.openxmlformats.org/drawingml/2006/main">
+            <a:defPPr algn="l">
+              <a:defRPr sz="1725" b="0">
+                <a:solidFill>
+                  <a:srgbClr val="344854"/>
+                </a:solidFill>
+                <a:latin typeface="Arial"/>
+                <a:ea typeface="Arial"/>
+                <a:cs typeface="Arial"/>
+              </a:defRPr>
+            </a:defPPr>
+          </a:lstStyle>
+          <a:p xmlns:a="http://schemas.openxmlformats.org/drawingml/2006/main">
+            <a:pPr algn="l">
+              <a:defRPr sz="1725" b="0">
+                <a:solidFill>
+                  <a:srgbClr val="344854"/>
+                </a:solidFill>
+                <a:latin typeface="Arial"/>
+                <a:ea typeface="Arial"/>
+                <a:cs typeface="Arial"/>
+              </a:defRPr>
+            </a:pPr>
+            <a:r>
+              <a:rPr sz="1725" b="0">
+                <a:solidFill>
+                  <a:srgbClr val="344854"/>
+                </a:solidFill>
+                <a:latin typeface="Arial"/>
+                <a:ea typeface="Arial"/>
+                <a:cs typeface="Arial"/>
+              </a:rPr>
+              <a:t>Categories: average, STEM, social sciences, humanities, other.</a:t>
             </a:r>
           </a:p>
         </p:txBody>
       </p:sp>
       <p:sp>
         <p:nvSpPr>
-          <p:cNvPr id="100" name="Gene conclusion">
-            <a:extLst xmlns:a="http://schemas.openxmlformats.org/drawingml/2006/main">
-              <a:ext uri="{FF2B5EF4-FFF2-40B4-BE49-F238E27FC236}">
-                <a16:creationId xmlns:a16="http://schemas.microsoft.com/office/drawing/2014/main" id="{4644E453-5A9F-4946-B990-C37168DB81CC}"/>
+          <p:cNvPr id="142" name="STEM takeaway">
+            <a:extLst xmlns:a="http://schemas.openxmlformats.org/drawingml/2006/main">
+              <a:ext uri="{FF2B5EF4-FFF2-40B4-BE49-F238E27FC236}">
+                <a16:creationId xmlns:a16="http://schemas.microsoft.com/office/drawing/2014/main" id="{2908C676-CBD7-4691-810A-94D25CD429F0}"/>
               </a:ext>
             </a:extLst>
           </p:cNvPr>
@@ -3574,8 +4174,8 @@
         </p:nvSpPr>
         <p:spPr>
           <a:xfrm xmlns:a="http://schemas.openxmlformats.org/drawingml/2006/main">
-            <a:off x="22078950" y="17097375"/>
-            <a:ext cx="10172700" cy="714375"/>
+            <a:off x="11372850" y="21240750"/>
+            <a:ext cx="10172700" cy="619125"/>
           </a:xfrm>
           <a:prstGeom xmlns:a="http://schemas.openxmlformats.org/drawingml/2006/main" prst="rect">
             <a:avLst/>
@@ -3591,9 +4191,9 @@
           </a:bodyPr>
           <a:lstStyle xmlns:a="http://schemas.openxmlformats.org/drawingml/2006/main">
             <a:defPPr algn="l">
-              <a:defRPr sz="1800" b="0">
-                <a:solidFill>
-                  <a:srgbClr val="344854"/>
+              <a:defRPr sz="2100" b="1">
+                <a:solidFill>
+                  <a:srgbClr val="0054B8"/>
                 </a:solidFill>
                 <a:latin typeface="Arial"/>
                 <a:ea typeface="Arial"/>
@@ -3603,10 +4203,9 @@
           </a:lstStyle>
           <a:p xmlns:a="http://schemas.openxmlformats.org/drawingml/2006/main">
             <a:pPr algn="l">
-              <a:buNone/>
-              <a:defRPr sz="1800" b="0">
-                <a:solidFill>
-                  <a:srgbClr val="344854"/>
+              <a:defRPr sz="2100" b="1">
+                <a:solidFill>
+                  <a:srgbClr val="0054B8"/>
                 </a:solidFill>
                 <a:latin typeface="Arial"/>
                 <a:ea typeface="Arial"/>
@@ -3614,163 +4213,25 @@
               </a:defRPr>
             </a:pPr>
             <a:r>
-              <a:rPr sz="1800" b="0">
-                <a:solidFill>
-                  <a:srgbClr val="344854"/>
+              <a:rPr sz="2100" b="1">
+                <a:solidFill>
+                  <a:srgbClr val="0054B8"/>
                 </a:solidFill>
                 <a:latin typeface="Arial"/>
                 <a:ea typeface="Arial"/>
                 <a:cs typeface="Arial"/>
               </a:rPr>
-              <a:t>Average gene prediction score: BFT 0.829 vs GenePT 0.802. GenePT remains higher on Lys4. Both use the same text encoder, with different source descriptions.</a:t>
-            </a:r>
-          </a:p>
-        </p:txBody>
-      </p:sp>
-      <p:sp>
-        <p:nvSpPr>
-          <p:cNvPr id="103" name="Perturbation heading">
-            <a:extLst xmlns:a="http://schemas.openxmlformats.org/drawingml/2006/main">
-              <a:ext uri="{FF2B5EF4-FFF2-40B4-BE49-F238E27FC236}">
-                <a16:creationId xmlns:a16="http://schemas.microsoft.com/office/drawing/2014/main" id="{97E197E5-4924-4A7E-BCFC-72BA695F081C}"/>
-              </a:ext>
-            </a:extLst>
-          </p:cNvPr>
-          <p:cNvSpPr>
-            <a:spLocks xmlns:a="http://schemas.openxmlformats.org/drawingml/2006/main" noGrp="1"/>
-          </p:cNvSpPr>
-          <p:nvPr/>
-        </p:nvSpPr>
-        <p:spPr>
-          <a:xfrm xmlns:a="http://schemas.openxmlformats.org/drawingml/2006/main">
-            <a:off x="22078950" y="18002250"/>
-            <a:ext cx="10172700" cy="457200"/>
-          </a:xfrm>
-          <a:prstGeom xmlns:a="http://schemas.openxmlformats.org/drawingml/2006/main" prst="rect">
-            <a:avLst/>
-          </a:prstGeom>
-          <a:noFill xmlns:a="http://schemas.openxmlformats.org/drawingml/2006/main"/>
-          <a:ln xmlns:a="http://schemas.openxmlformats.org/drawingml/2006/main" w="0">
-            <a:noFill/>
-          </a:ln>
-        </p:spPr>
-        <p:txBody>
-          <a:bodyPr xmlns:a="http://schemas.openxmlformats.org/drawingml/2006/main" wrap="square" lIns="0" tIns="0" rIns="0" bIns="0" anchor="t">
-            <a:noAutofit/>
-          </a:bodyPr>
-          <a:lstStyle xmlns:a="http://schemas.openxmlformats.org/drawingml/2006/main">
-            <a:defPPr algn="l">
-              <a:defRPr sz="2600" b="1">
-                <a:solidFill>
-                  <a:srgbClr val="183B66"/>
-                </a:solidFill>
-                <a:latin typeface="Arial"/>
-                <a:ea typeface="Arial"/>
-                <a:cs typeface="Arial"/>
-              </a:defRPr>
-            </a:defPPr>
-          </a:lstStyle>
-          <a:p xmlns:a="http://schemas.openxmlformats.org/drawingml/2006/main">
-            <a:pPr algn="l">
-              <a:buNone/>
-              <a:defRPr sz="2600" b="1">
-                <a:solidFill>
-                  <a:srgbClr val="183B66"/>
-                </a:solidFill>
-                <a:latin typeface="Arial"/>
-                <a:ea typeface="Arial"/>
-                <a:cs typeface="Arial"/>
-              </a:defRPr>
-            </a:pPr>
-            <a:r>
-              <a:rPr sz="2600" b="1">
-                <a:solidFill>
-                  <a:srgbClr val="183B66"/>
-                </a:solidFill>
-                <a:latin typeface="Arial"/>
-                <a:ea typeface="Arial"/>
-                <a:cs typeface="Arial"/>
-              </a:rPr>
-              <a:t>Single-cell response prediction</a:t>
-            </a:r>
-          </a:p>
-        </p:txBody>
-      </p:sp>
-      <p:sp>
-        <p:nvSpPr>
-          <p:cNvPr id="105" name="Perturbation caption">
-            <a:extLst xmlns:a="http://schemas.openxmlformats.org/drawingml/2006/main">
-              <a:ext uri="{FF2B5EF4-FFF2-40B4-BE49-F238E27FC236}">
-                <a16:creationId xmlns:a16="http://schemas.microsoft.com/office/drawing/2014/main" id="{BA5AEACB-0DB7-4829-A6C2-11814877AFA1}"/>
-              </a:ext>
-            </a:extLst>
-          </p:cNvPr>
-          <p:cNvSpPr>
-            <a:spLocks xmlns:a="http://schemas.openxmlformats.org/drawingml/2006/main" noGrp="1"/>
-          </p:cNvSpPr>
-          <p:nvPr/>
-        </p:nvSpPr>
-        <p:spPr>
-          <a:xfrm xmlns:a="http://schemas.openxmlformats.org/drawingml/2006/main">
-            <a:off x="22078950" y="21336000"/>
-            <a:ext cx="10172700" cy="523875"/>
-          </a:xfrm>
-          <a:prstGeom xmlns:a="http://schemas.openxmlformats.org/drawingml/2006/main" prst="rect">
-            <a:avLst/>
-          </a:prstGeom>
-          <a:noFill xmlns:a="http://schemas.openxmlformats.org/drawingml/2006/main"/>
-          <a:ln xmlns:a="http://schemas.openxmlformats.org/drawingml/2006/main" w="0">
-            <a:noFill/>
-          </a:ln>
-        </p:spPr>
-        <p:txBody>
-          <a:bodyPr xmlns:a="http://schemas.openxmlformats.org/drawingml/2006/main" wrap="square" lIns="0" tIns="0" rIns="0" bIns="0" anchor="t">
-            <a:noAutofit/>
-          </a:bodyPr>
-          <a:lstStyle xmlns:a="http://schemas.openxmlformats.org/drawingml/2006/main">
-            <a:defPPr algn="l">
-              <a:defRPr sz="1600" b="0">
-                <a:solidFill>
-                  <a:srgbClr val="344854"/>
-                </a:solidFill>
-                <a:latin typeface="Arial"/>
-                <a:ea typeface="Arial"/>
-                <a:cs typeface="Arial"/>
-              </a:defRPr>
-            </a:defPPr>
-          </a:lstStyle>
-          <a:p xmlns:a="http://schemas.openxmlformats.org/drawingml/2006/main">
-            <a:pPr algn="l">
-              <a:buNone/>
-              <a:defRPr sz="1600" b="0">
-                <a:solidFill>
-                  <a:srgbClr val="344854"/>
-                </a:solidFill>
-                <a:latin typeface="Arial"/>
-                <a:ea typeface="Arial"/>
-                <a:cs typeface="Arial"/>
-              </a:defRPr>
-            </a:pPr>
-            <a:r>
-              <a:rPr sz="1600" b="0">
-                <a:solidFill>
-                  <a:srgbClr val="344854"/>
-                </a:solidFill>
-                <a:latin typeface="Arial"/>
-                <a:ea typeface="Arial"/>
-                <a:cs typeface="Arial"/>
-              </a:rPr>
-              <a:t>BFT profiles give comparable STATE prediction results across four datasets. Profile generation uses no training on these datasets. The STATE prediction model is still trained.</a:t>
+              <a:t>A simple training method for STEM adaptation, demonstrated in medicine and biology.</a:t>
             </a:r>
           </a:p>
         </p:txBody>
       </p:sp>
       <p:pic>
         <p:nvPicPr>
-          <p:cNvPr id="106" name="">
-            <a:extLst xmlns:a="http://schemas.openxmlformats.org/drawingml/2006/main">
-              <a:ext uri="{FF2B5EF4-FFF2-40B4-BE49-F238E27FC236}">
-                <a16:creationId xmlns:a16="http://schemas.microsoft.com/office/drawing/2014/main" id="{7D25FBBA-1B10-488C-A430-8582A9D9BC78}"/>
+          <p:cNvPr id="143" name="">
+            <a:extLst xmlns:a="http://schemas.openxmlformats.org/drawingml/2006/main">
+              <a:ext uri="{FF2B5EF4-FFF2-40B4-BE49-F238E27FC236}">
+                <a16:creationId xmlns:a16="http://schemas.microsoft.com/office/drawing/2014/main" id="{A2803D23-BE70-440B-8863-8798E7168990}"/>
               </a:ext>
             </a:extLst>
           </p:cNvPr>
@@ -3780,13 +4241,13 @@
           <p:nvPr/>
         </p:nvPicPr>
         <p:blipFill>
-          <a:blip xmlns:r="http://schemas.openxmlformats.org/officeDocument/2006/relationships" xmlns:a="http://schemas.openxmlformats.org/drawingml/2006/main" r:embed="Rb68e616839e74603"/>
+          <a:blip xmlns:r="http://schemas.openxmlformats.org/officeDocument/2006/relationships" xmlns:a="http://schemas.openxmlformats.org/drawingml/2006/main" r:embed="R402613dc89cd4aaa"/>
           <a:stretch xmlns:a="http://schemas.openxmlformats.org/drawingml/2006/main"/>
         </p:blipFill>
         <p:spPr>
           <a:xfrm xmlns:a="http://schemas.openxmlformats.org/drawingml/2006/main">
-            <a:off x="666750" y="7859603"/>
-            <a:ext cx="10172700" cy="2664044"/>
+            <a:off x="22628469" y="13096875"/>
+            <a:ext cx="9073662" cy="4572000"/>
           </a:xfrm>
           <a:prstGeom xmlns:a="http://schemas.openxmlformats.org/drawingml/2006/main" prst="rect">
             <a:avLst/>
@@ -3795,10 +4256,10 @@
       </p:pic>
       <p:pic>
         <p:nvPicPr>
-          <p:cNvPr id="107" name="">
-            <a:extLst xmlns:a="http://schemas.openxmlformats.org/drawingml/2006/main">
-              <a:ext uri="{FF2B5EF4-FFF2-40B4-BE49-F238E27FC236}">
-                <a16:creationId xmlns:a16="http://schemas.microsoft.com/office/drawing/2014/main" id="{6E68EB4F-A566-4658-8EFC-D5D687F777DA}"/>
+          <p:cNvPr id="144" name="">
+            <a:extLst xmlns:a="http://schemas.openxmlformats.org/drawingml/2006/main">
+              <a:ext uri="{FF2B5EF4-FFF2-40B4-BE49-F238E27FC236}">
+                <a16:creationId xmlns:a16="http://schemas.microsoft.com/office/drawing/2014/main" id="{2177B992-79B5-400C-92E7-F1762F9A6BE1}"/>
               </a:ext>
             </a:extLst>
           </p:cNvPr>
@@ -3808,1133 +4269,12 @@
           <p:nvPr/>
         </p:nvPicPr>
         <p:blipFill>
-          <a:blip xmlns:r="http://schemas.openxmlformats.org/officeDocument/2006/relationships" xmlns:a="http://schemas.openxmlformats.org/drawingml/2006/main" r:embed="R17b4fcfde53f4059"/>
+          <a:blip xmlns:r="http://schemas.openxmlformats.org/officeDocument/2006/relationships" xmlns:a="http://schemas.openxmlformats.org/drawingml/2006/main" r:embed="R5d21b097dbfe45b6"/>
           <a:stretch xmlns:a="http://schemas.openxmlformats.org/drawingml/2006/main"/>
         </p:blipFill>
         <p:spPr>
           <a:xfrm xmlns:a="http://schemas.openxmlformats.org/drawingml/2006/main">
-            <a:off x="757694" y="13716000"/>
-            <a:ext cx="9990812" cy="5905500"/>
-          </a:xfrm>
-          <a:prstGeom xmlns:a="http://schemas.openxmlformats.org/drawingml/2006/main" prst="rect">
-            <a:avLst/>
-          </a:prstGeom>
-        </p:spPr>
-      </p:pic>
-      <p:sp>
-        <p:nvSpPr>
-          <p:cNvPr id="108" name="Motivation evidence">
-            <a:extLst xmlns:a="http://schemas.openxmlformats.org/drawingml/2006/main">
-              <a:ext uri="{FF2B5EF4-FFF2-40B4-BE49-F238E27FC236}">
-                <a16:creationId xmlns:a16="http://schemas.microsoft.com/office/drawing/2014/main" id="{CF383F37-900F-4150-BC3A-84412B3BBBD5}"/>
-              </a:ext>
-            </a:extLst>
-          </p:cNvPr>
-          <p:cNvSpPr>
-            <a:spLocks xmlns:a="http://schemas.openxmlformats.org/drawingml/2006/main" noGrp="1"/>
-          </p:cNvSpPr>
-          <p:nvPr/>
-        </p:nvSpPr>
-        <p:spPr>
-          <a:xfrm xmlns:a="http://schemas.openxmlformats.org/drawingml/2006/main">
-            <a:off x="666750" y="19812000"/>
-            <a:ext cx="10172700" cy="1000125"/>
-          </a:xfrm>
-          <a:prstGeom xmlns:a="http://schemas.openxmlformats.org/drawingml/2006/main" prst="rect">
-            <a:avLst/>
-          </a:prstGeom>
-          <a:noFill xmlns:a="http://schemas.openxmlformats.org/drawingml/2006/main"/>
-          <a:ln xmlns:a="http://schemas.openxmlformats.org/drawingml/2006/main" w="0">
-            <a:noFill/>
-          </a:ln>
-        </p:spPr>
-        <p:txBody>
-          <a:bodyPr xmlns:a="http://schemas.openxmlformats.org/drawingml/2006/main" wrap="square" lIns="0" tIns="0" rIns="0" bIns="0" anchor="t">
-            <a:noAutofit/>
-          </a:bodyPr>
-          <a:lstStyle xmlns:a="http://schemas.openxmlformats.org/drawingml/2006/main">
-            <a:defPPr algn="l">
-              <a:defRPr sz="1800" b="0">
-                <a:solidFill>
-                  <a:srgbClr val="344854"/>
-                </a:solidFill>
-                <a:latin typeface="Arial"/>
-                <a:ea typeface="Arial"/>
-                <a:cs typeface="Arial"/>
-              </a:defRPr>
-            </a:defPPr>
-          </a:lstStyle>
-          <a:p xmlns:a="http://schemas.openxmlformats.org/drawingml/2006/main">
-            <a:pPr algn="l">
-              <a:defRPr sz="1800" b="0">
-                <a:solidFill>
-                  <a:srgbClr val="344854"/>
-                </a:solidFill>
-                <a:latin typeface="Arial"/>
-                <a:ea typeface="Arial"/>
-                <a:cs typeface="Arial"/>
-              </a:defRPr>
-            </a:pPr>
-            <a:r>
-              <a:rPr sz="1800" b="0">
-                <a:solidFill>
-                  <a:srgbClr val="344854"/>
-                </a:solidFill>
-                <a:latin typeface="Arial"/>
-                <a:ea typeface="Arial"/>
-                <a:cs typeface="Arial"/>
-              </a:rPr>
-              <a:t>Biomedical entities rise from 12.5% in isolated-difficulty windows to 60.9% in grouped-difficulty windows. Causal and reasoning content rises from 8.4% to 30.6%. These are descriptive associations.</a:t>
-            </a:r>
-          </a:p>
-        </p:txBody>
-      </p:sp>
-      <p:sp>
-        <p:nvSpPr>
-          <p:cNvPr id="109" name="Motivation takeaway">
-            <a:extLst xmlns:a="http://schemas.openxmlformats.org/drawingml/2006/main">
-              <a:ext uri="{FF2B5EF4-FFF2-40B4-BE49-F238E27FC236}">
-                <a16:creationId xmlns:a16="http://schemas.microsoft.com/office/drawing/2014/main" id="{21B64C01-32F5-4D1E-8625-621E92995CBC}"/>
-              </a:ext>
-            </a:extLst>
-          </p:cNvPr>
-          <p:cNvSpPr>
-            <a:spLocks xmlns:a="http://schemas.openxmlformats.org/drawingml/2006/main" noGrp="1"/>
-          </p:cNvSpPr>
-          <p:nvPr/>
-        </p:nvSpPr>
-        <p:spPr>
-          <a:xfrm xmlns:a="http://schemas.openxmlformats.org/drawingml/2006/main">
-            <a:off x="666750" y="21050250"/>
-            <a:ext cx="10172700" cy="381000"/>
-          </a:xfrm>
-          <a:prstGeom xmlns:a="http://schemas.openxmlformats.org/drawingml/2006/main" prst="rect">
-            <a:avLst/>
-          </a:prstGeom>
-          <a:noFill xmlns:a="http://schemas.openxmlformats.org/drawingml/2006/main"/>
-          <a:ln xmlns:a="http://schemas.openxmlformats.org/drawingml/2006/main" w="0">
-            <a:noFill/>
-          </a:ln>
-        </p:spPr>
-        <p:txBody>
-          <a:bodyPr xmlns:a="http://schemas.openxmlformats.org/drawingml/2006/main" wrap="square" lIns="0" tIns="0" rIns="0" bIns="0" anchor="t">
-            <a:noAutofit/>
-          </a:bodyPr>
-          <a:lstStyle xmlns:a="http://schemas.openxmlformats.org/drawingml/2006/main">
-            <a:defPPr algn="l">
-              <a:defRPr sz="2250" b="1">
-                <a:solidFill>
-                  <a:srgbClr val="0054B8"/>
-                </a:solidFill>
-                <a:latin typeface="Arial"/>
-                <a:ea typeface="Arial"/>
-                <a:cs typeface="Arial"/>
-              </a:defRPr>
-            </a:defPPr>
-          </a:lstStyle>
-          <a:p xmlns:a="http://schemas.openxmlformats.org/drawingml/2006/main">
-            <a:pPr algn="l">
-              <a:defRPr sz="2250" b="1">
-                <a:solidFill>
-                  <a:srgbClr val="0054B8"/>
-                </a:solidFill>
-                <a:latin typeface="Arial"/>
-                <a:ea typeface="Arial"/>
-                <a:cs typeface="Arial"/>
-              </a:defRPr>
-            </a:pPr>
-            <a:r>
-              <a:rPr sz="2250" b="1">
-                <a:solidFill>
-                  <a:srgbClr val="0054B8"/>
-                </a:solidFill>
-                <a:latin typeface="Arial"/>
-                <a:ea typeface="Arial"/>
-                <a:cs typeface="Arial"/>
-              </a:rPr>
-              <a:t>Goal: extending LLM capabilities to STEM</a:t>
-            </a:r>
-          </a:p>
-        </p:txBody>
-      </p:sp>
-      <p:sp>
-        <p:nvSpPr>
-          <p:cNvPr id="110" name="STEM goal">
-            <a:extLst xmlns:a="http://schemas.openxmlformats.org/drawingml/2006/main">
-              <a:ext uri="{FF2B5EF4-FFF2-40B4-BE49-F238E27FC236}">
-                <a16:creationId xmlns:a16="http://schemas.microsoft.com/office/drawing/2014/main" id="{C971254A-0AA5-4FEC-B4F5-016788910F35}"/>
-              </a:ext>
-            </a:extLst>
-          </p:cNvPr>
-          <p:cNvSpPr>
-            <a:spLocks xmlns:a="http://schemas.openxmlformats.org/drawingml/2006/main" noGrp="1"/>
-          </p:cNvSpPr>
-          <p:nvPr/>
-        </p:nvSpPr>
-        <p:spPr>
-          <a:xfrm xmlns:a="http://schemas.openxmlformats.org/drawingml/2006/main">
-            <a:off x="666750" y="21478875"/>
-            <a:ext cx="10172700" cy="428625"/>
-          </a:xfrm>
-          <a:prstGeom xmlns:a="http://schemas.openxmlformats.org/drawingml/2006/main" prst="rect">
-            <a:avLst/>
-          </a:prstGeom>
-          <a:noFill xmlns:a="http://schemas.openxmlformats.org/drawingml/2006/main"/>
-          <a:ln xmlns:a="http://schemas.openxmlformats.org/drawingml/2006/main" w="0">
-            <a:noFill/>
-          </a:ln>
-        </p:spPr>
-        <p:txBody>
-          <a:bodyPr xmlns:a="http://schemas.openxmlformats.org/drawingml/2006/main" wrap="square" lIns="0" tIns="0" rIns="0" bIns="0" anchor="t">
-            <a:noAutofit/>
-          </a:bodyPr>
-          <a:lstStyle xmlns:a="http://schemas.openxmlformats.org/drawingml/2006/main">
-            <a:defPPr algn="l">
-              <a:defRPr sz="1800" b="0">
-                <a:solidFill>
-                  <a:srgbClr val="344854"/>
-                </a:solidFill>
-                <a:latin typeface="Arial"/>
-                <a:ea typeface="Arial"/>
-                <a:cs typeface="Arial"/>
-              </a:defRPr>
-            </a:defPPr>
-          </a:lstStyle>
-          <a:p xmlns:a="http://schemas.openxmlformats.org/drawingml/2006/main">
-            <a:pPr algn="l">
-              <a:defRPr sz="1800" b="0">
-                <a:solidFill>
-                  <a:srgbClr val="344854"/>
-                </a:solidFill>
-                <a:latin typeface="Arial"/>
-                <a:ea typeface="Arial"/>
-                <a:cs typeface="Arial"/>
-              </a:defRPr>
-            </a:pPr>
-            <a:r>
-              <a:rPr sz="1800" b="0">
-                <a:solidFill>
-                  <a:srgbClr val="344854"/>
-                </a:solidFill>
-                <a:latin typeface="Arial"/>
-                <a:ea typeface="Arial"/>
-                <a:cs typeface="Arial"/>
-              </a:rPr>
-              <a:t>Learn scientific content while preserving broad knowledge. We test this in medicine and biology.</a:t>
-            </a:r>
-          </a:p>
-        </p:txBody>
-      </p:sp>
-      <p:pic>
-        <p:nvPicPr>
-          <p:cNvPr id="111" name="">
-            <a:extLst xmlns:a="http://schemas.openxmlformats.org/drawingml/2006/main">
-              <a:ext uri="{FF2B5EF4-FFF2-40B4-BE49-F238E27FC236}">
-                <a16:creationId xmlns:a16="http://schemas.microsoft.com/office/drawing/2014/main" id="{304890ED-5A33-44D1-9CB3-0DA63D3723CB}"/>
-              </a:ext>
-            </a:extLst>
-          </p:cNvPr>
-          <p:cNvPicPr>
-            <a:picLocks xmlns:a="http://schemas.openxmlformats.org/drawingml/2006/main" noChangeAspect="1"/>
-          </p:cNvPicPr>
-          <p:nvPr/>
-        </p:nvPicPr>
-        <p:blipFill>
-          <a:blip xmlns:r="http://schemas.openxmlformats.org/officeDocument/2006/relationships" xmlns:a="http://schemas.openxmlformats.org/drawingml/2006/main" r:embed="R9d6ec67db27843cc"/>
-          <a:stretch xmlns:a="http://schemas.openxmlformats.org/drawingml/2006/main"/>
-        </p:blipFill>
-        <p:spPr>
-          <a:xfrm xmlns:a="http://schemas.openxmlformats.org/drawingml/2006/main">
-            <a:off x="11755350" y="5572125"/>
-            <a:ext cx="9407699" cy="3381375"/>
-          </a:xfrm>
-          <a:prstGeom xmlns:a="http://schemas.openxmlformats.org/drawingml/2006/main" prst="rect">
-            <a:avLst/>
-          </a:prstGeom>
-        </p:spPr>
-      </p:pic>
-      <p:sp>
-        <p:nvSpPr>
-          <p:cNvPr id="112" name="Method explanation">
-            <a:extLst xmlns:a="http://schemas.openxmlformats.org/drawingml/2006/main">
-              <a:ext uri="{FF2B5EF4-FFF2-40B4-BE49-F238E27FC236}">
-                <a16:creationId xmlns:a16="http://schemas.microsoft.com/office/drawing/2014/main" id="{68D6E2D3-B5B5-4B88-9C2C-84FFD27BB233}"/>
-              </a:ext>
-            </a:extLst>
-          </p:cNvPr>
-          <p:cNvSpPr>
-            <a:spLocks xmlns:a="http://schemas.openxmlformats.org/drawingml/2006/main" noGrp="1"/>
-          </p:cNvSpPr>
-          <p:nvPr/>
-        </p:nvSpPr>
-        <p:spPr>
-          <a:xfrm xmlns:a="http://schemas.openxmlformats.org/drawingml/2006/main">
-            <a:off x="11372850" y="9144000"/>
-            <a:ext cx="10172700" cy="809625"/>
-          </a:xfrm>
-          <a:prstGeom xmlns:a="http://schemas.openxmlformats.org/drawingml/2006/main" prst="rect">
-            <a:avLst/>
-          </a:prstGeom>
-          <a:noFill xmlns:a="http://schemas.openxmlformats.org/drawingml/2006/main"/>
-          <a:ln xmlns:a="http://schemas.openxmlformats.org/drawingml/2006/main" w="0">
-            <a:noFill/>
-          </a:ln>
-        </p:spPr>
-        <p:txBody>
-          <a:bodyPr xmlns:a="http://schemas.openxmlformats.org/drawingml/2006/main" wrap="square" lIns="0" tIns="0" rIns="0" bIns="0" anchor="t">
-            <a:noAutofit/>
-          </a:bodyPr>
-          <a:lstStyle xmlns:a="http://schemas.openxmlformats.org/drawingml/2006/main">
-            <a:defPPr algn="l">
-              <a:defRPr sz="1950" b="0">
-                <a:solidFill>
-                  <a:srgbClr val="344854"/>
-                </a:solidFill>
-                <a:latin typeface="Arial"/>
-                <a:ea typeface="Arial"/>
-                <a:cs typeface="Arial"/>
-              </a:defRPr>
-            </a:defPPr>
-          </a:lstStyle>
-          <a:p xmlns:a="http://schemas.openxmlformats.org/drawingml/2006/main">
-            <a:pPr algn="l">
-              <a:defRPr sz="1950" b="0">
-                <a:solidFill>
-                  <a:srgbClr val="344854"/>
-                </a:solidFill>
-                <a:latin typeface="Arial"/>
-                <a:ea typeface="Arial"/>
-                <a:cs typeface="Arial"/>
-              </a:defRPr>
-            </a:pPr>
-            <a:r>
-              <a:rPr sz="1950" b="0">
-                <a:solidFill>
-                  <a:srgbClr val="344854"/>
-                </a:solidFill>
-                <a:latin typeface="Arial"/>
-                <a:ea typeface="Arial"/>
-                <a:cs typeface="Arial"/>
-              </a:rPr>
-              <a:t>Left: compare each word with its surroundings, preserving difficult biomedical passages. Right: give examples containing hard passages more attention, with a bounded contribution.</a:t>
-            </a:r>
-          </a:p>
-        </p:txBody>
-      </p:sp>
-      <p:sp>
-        <p:nvSpPr>
-          <p:cNvPr id="113" name="Simple implementation">
-            <a:extLst xmlns:a="http://schemas.openxmlformats.org/drawingml/2006/main">
-              <a:ext uri="{FF2B5EF4-FFF2-40B4-BE49-F238E27FC236}">
-                <a16:creationId xmlns:a16="http://schemas.microsoft.com/office/drawing/2014/main" id="{A98AB023-B450-492B-8FD6-4080B57912AF}"/>
-              </a:ext>
-            </a:extLst>
-          </p:cNvPr>
-          <p:cNvSpPr>
-            <a:spLocks xmlns:a="http://schemas.openxmlformats.org/drawingml/2006/main" noGrp="1"/>
-          </p:cNvSpPr>
-          <p:nvPr/>
-        </p:nvSpPr>
-        <p:spPr>
-          <a:xfrm xmlns:a="http://schemas.openxmlformats.org/drawingml/2006/main">
-            <a:off x="11372850" y="10144125"/>
-            <a:ext cx="10172700" cy="571500"/>
-          </a:xfrm>
-          <a:prstGeom xmlns:a="http://schemas.openxmlformats.org/drawingml/2006/main" prst="rect">
-            <a:avLst/>
-          </a:prstGeom>
-          <a:noFill xmlns:a="http://schemas.openxmlformats.org/drawingml/2006/main"/>
-          <a:ln xmlns:a="http://schemas.openxmlformats.org/drawingml/2006/main" w="0">
-            <a:noFill/>
-          </a:ln>
-        </p:spPr>
-        <p:txBody>
-          <a:bodyPr xmlns:a="http://schemas.openxmlformats.org/drawingml/2006/main" wrap="square" lIns="0" tIns="0" rIns="0" bIns="0" anchor="t">
-            <a:noAutofit/>
-          </a:bodyPr>
-          <a:lstStyle xmlns:a="http://schemas.openxmlformats.org/drawingml/2006/main">
-            <a:defPPr algn="l">
-              <a:defRPr sz="1800" b="0">
-                <a:solidFill>
-                  <a:srgbClr val="344854"/>
-                </a:solidFill>
-                <a:latin typeface="Arial"/>
-                <a:ea typeface="Arial"/>
-                <a:cs typeface="Arial"/>
-              </a:defRPr>
-            </a:defPPr>
-          </a:lstStyle>
-          <a:p xmlns:a="http://schemas.openxmlformats.org/drawingml/2006/main">
-            <a:pPr algn="l">
-              <a:defRPr sz="1800" b="0">
-                <a:solidFill>
-                  <a:srgbClr val="344854"/>
-                </a:solidFill>
-                <a:latin typeface="Arial"/>
-                <a:ea typeface="Arial"/>
-                <a:cs typeface="Arial"/>
-              </a:defRPr>
-            </a:pPr>
-            <a:r>
-              <a:rPr sz="1800" b="0">
-                <a:solidFill>
-                  <a:srgbClr val="344854"/>
-                </a:solidFill>
-                <a:latin typeface="Arial"/>
-                <a:ea typeface="Arial"/>
-                <a:cs typeface="Arial"/>
-              </a:rPr>
-              <a:t>A small change to supervised training. No reward model or external uncertainty estimator is needed. One extra setting controls context size.</a:t>
-            </a:r>
-          </a:p>
-        </p:txBody>
-      </p:sp>
-      <p:sp>
-        <p:nvSpPr>
-          <p:cNvPr id="114" name="Biomedical results bar">
-            <a:extLst xmlns:a="http://schemas.openxmlformats.org/drawingml/2006/main">
-              <a:ext uri="{FF2B5EF4-FFF2-40B4-BE49-F238E27FC236}">
-                <a16:creationId xmlns:a16="http://schemas.microsoft.com/office/drawing/2014/main" id="{BA8BE2DD-5F2C-4731-9F9D-1A15D9B399E1}"/>
-              </a:ext>
-            </a:extLst>
-          </p:cNvPr>
-          <p:cNvSpPr>
-            <a:spLocks xmlns:a="http://schemas.openxmlformats.org/drawingml/2006/main" noGrp="1"/>
-          </p:cNvSpPr>
-          <p:nvPr/>
-        </p:nvSpPr>
-        <p:spPr>
-          <a:xfrm xmlns:a="http://schemas.openxmlformats.org/drawingml/2006/main">
-            <a:off x="11372850" y="10906125"/>
-            <a:ext cx="10172700" cy="609600"/>
-          </a:xfrm>
-          <a:prstGeom xmlns:a="http://schemas.openxmlformats.org/drawingml/2006/main" prst="rect">
-            <a:avLst/>
-          </a:prstGeom>
-          <a:solidFill xmlns:a="http://schemas.openxmlformats.org/drawingml/2006/main">
-            <a:srgbClr val="183B66"/>
-          </a:solidFill>
-          <a:ln xmlns:a="http://schemas.openxmlformats.org/drawingml/2006/main" w="0">
-            <a:noFill/>
-          </a:ln>
-        </p:spPr>
-        <p:txBody>
-          <a:bodyPr xmlns:a="http://schemas.openxmlformats.org/drawingml/2006/main" wrap="square" lIns="171450" tIns="38100" rIns="114300" bIns="38100" anchor="ctr">
-            <a:noAutofit/>
-          </a:bodyPr>
-          <a:lstStyle xmlns:a="http://schemas.openxmlformats.org/drawingml/2006/main">
-            <a:defPPr algn="l">
-              <a:defRPr sz="3225" b="1">
-                <a:solidFill>
-                  <a:srgbClr val="FFFFFF"/>
-                </a:solidFill>
-                <a:latin typeface="Arial"/>
-                <a:ea typeface="Arial"/>
-                <a:cs typeface="Arial"/>
-              </a:defRPr>
-            </a:defPPr>
-          </a:lstStyle>
-          <a:p xmlns:a="http://schemas.openxmlformats.org/drawingml/2006/main">
-            <a:pPr algn="l">
-              <a:defRPr sz="3225" b="1">
-                <a:solidFill>
-                  <a:srgbClr val="FFFFFF"/>
-                </a:solidFill>
-                <a:latin typeface="Arial"/>
-                <a:ea typeface="Arial"/>
-                <a:cs typeface="Arial"/>
-              </a:defRPr>
-            </a:pPr>
-            <a:r>
-              <a:rPr sz="3225" b="1">
-                <a:solidFill>
-                  <a:srgbClr val="FFFFFF"/>
-                </a:solidFill>
-                <a:latin typeface="Arial"/>
-                <a:ea typeface="Arial"/>
-                <a:cs typeface="Arial"/>
-              </a:rPr>
-              <a:t>4  Results: biomedical reasoning</a:t>
-            </a:r>
-          </a:p>
-        </p:txBody>
-      </p:sp>
-      <p:sp>
-        <p:nvSpPr>
-          <p:cNvPr id="115" name="Biomedical overview">
-            <a:extLst xmlns:a="http://schemas.openxmlformats.org/drawingml/2006/main">
-              <a:ext uri="{FF2B5EF4-FFF2-40B4-BE49-F238E27FC236}">
-                <a16:creationId xmlns:a16="http://schemas.microsoft.com/office/drawing/2014/main" id="{4DDEB3B2-8AE1-4625-AA68-B1FE4B4AE2DB}"/>
-              </a:ext>
-            </a:extLst>
-          </p:cNvPr>
-          <p:cNvSpPr>
-            <a:spLocks xmlns:a="http://schemas.openxmlformats.org/drawingml/2006/main" noGrp="1"/>
-          </p:cNvSpPr>
-          <p:nvPr/>
-        </p:nvSpPr>
-        <p:spPr>
-          <a:xfrm xmlns:a="http://schemas.openxmlformats.org/drawingml/2006/main">
-            <a:off x="11372850" y="11668125"/>
-            <a:ext cx="10172700" cy="714375"/>
-          </a:xfrm>
-          <a:prstGeom xmlns:a="http://schemas.openxmlformats.org/drawingml/2006/main" prst="rect">
-            <a:avLst/>
-          </a:prstGeom>
-          <a:noFill xmlns:a="http://schemas.openxmlformats.org/drawingml/2006/main"/>
-          <a:ln xmlns:a="http://schemas.openxmlformats.org/drawingml/2006/main" w="0">
-            <a:noFill/>
-          </a:ln>
-        </p:spPr>
-        <p:txBody>
-          <a:bodyPr xmlns:a="http://schemas.openxmlformats.org/drawingml/2006/main" wrap="square" lIns="0" tIns="0" rIns="0" bIns="0" anchor="t">
-            <a:noAutofit/>
-          </a:bodyPr>
-          <a:lstStyle xmlns:a="http://schemas.openxmlformats.org/drawingml/2006/main">
-            <a:defPPr algn="l">
-              <a:defRPr sz="2100" b="0">
-                <a:solidFill>
-                  <a:srgbClr val="344854"/>
-                </a:solidFill>
-                <a:latin typeface="Arial"/>
-                <a:ea typeface="Arial"/>
-                <a:cs typeface="Arial"/>
-              </a:defRPr>
-            </a:defPPr>
-          </a:lstStyle>
-          <a:p xmlns:a="http://schemas.openxmlformats.org/drawingml/2006/main">
-            <a:pPr algn="l">
-              <a:defRPr sz="2100" b="0">
-                <a:solidFill>
-                  <a:srgbClr val="344854"/>
-                </a:solidFill>
-                <a:latin typeface="Arial"/>
-                <a:ea typeface="Arial"/>
-                <a:cs typeface="Arial"/>
-              </a:defRPr>
-            </a:pPr>
-            <a:r>
-              <a:rPr sz="2100" b="0">
-                <a:solidFill>
-                  <a:srgbClr val="344854"/>
-                </a:solidFill>
-                <a:latin typeface="Arial"/>
-                <a:ea typeface="Arial"/>
-                <a:cs typeface="Arial"/>
-              </a:rPr>
-              <a:t>Matched training settings across 14B, 32B and 70B models. Original results below show medical competence and biological process reasoning.</a:t>
-            </a:r>
-          </a:p>
-        </p:txBody>
-      </p:sp>
-      <p:pic>
-        <p:nvPicPr>
-          <p:cNvPr id="116" name="">
-            <a:extLst xmlns:a="http://schemas.openxmlformats.org/drawingml/2006/main">
-              <a:ext uri="{FF2B5EF4-FFF2-40B4-BE49-F238E27FC236}">
-                <a16:creationId xmlns:a16="http://schemas.microsoft.com/office/drawing/2014/main" id="{E4996FBB-9843-4745-B553-41909735D7B0}"/>
-              </a:ext>
-            </a:extLst>
-          </p:cNvPr>
-          <p:cNvPicPr>
-            <a:picLocks xmlns:a="http://schemas.openxmlformats.org/drawingml/2006/main" noChangeAspect="1"/>
-          </p:cNvPicPr>
-          <p:nvPr/>
-        </p:nvPicPr>
-        <p:blipFill>
-          <a:blip xmlns:r="http://schemas.openxmlformats.org/officeDocument/2006/relationships" xmlns:a="http://schemas.openxmlformats.org/drawingml/2006/main" r:embed="Rd337ecdc324f4197"/>
-          <a:stretch xmlns:a="http://schemas.openxmlformats.org/drawingml/2006/main"/>
-        </p:blipFill>
-        <p:spPr>
-          <a:xfrm xmlns:a="http://schemas.openxmlformats.org/drawingml/2006/main">
-            <a:off x="12020421" y="13096875"/>
-            <a:ext cx="8877557" cy="2714625"/>
-          </a:xfrm>
-          <a:prstGeom xmlns:a="http://schemas.openxmlformats.org/drawingml/2006/main" prst="rect">
-            <a:avLst/>
-          </a:prstGeom>
-        </p:spPr>
-      </p:pic>
-      <p:pic>
-        <p:nvPicPr>
-          <p:cNvPr id="117" name="">
-            <a:extLst xmlns:a="http://schemas.openxmlformats.org/drawingml/2006/main">
-              <a:ext uri="{FF2B5EF4-FFF2-40B4-BE49-F238E27FC236}">
-                <a16:creationId xmlns:a16="http://schemas.microsoft.com/office/drawing/2014/main" id="{88CEB567-5501-4799-8CC4-66DBAD1DC287}"/>
-              </a:ext>
-            </a:extLst>
-          </p:cNvPr>
-          <p:cNvPicPr>
-            <a:picLocks xmlns:a="http://schemas.openxmlformats.org/drawingml/2006/main" noChangeAspect="1"/>
-          </p:cNvPicPr>
-          <p:nvPr/>
-        </p:nvPicPr>
-        <p:blipFill>
-          <a:blip xmlns:r="http://schemas.openxmlformats.org/officeDocument/2006/relationships" xmlns:a="http://schemas.openxmlformats.org/drawingml/2006/main" r:embed="R28af945720c948bb"/>
-          <a:stretch xmlns:a="http://schemas.openxmlformats.org/drawingml/2006/main"/>
-        </p:blipFill>
-        <p:spPr>
-          <a:xfrm xmlns:a="http://schemas.openxmlformats.org/drawingml/2006/main">
-            <a:off x="11372850" y="15939343"/>
-            <a:ext cx="10172700" cy="268189"/>
-          </a:xfrm>
-          <a:prstGeom xmlns:a="http://schemas.openxmlformats.org/drawingml/2006/main" prst="rect">
-            <a:avLst/>
-          </a:prstGeom>
-        </p:spPr>
-      </p:pic>
-      <p:sp>
-        <p:nvSpPr>
-          <p:cNvPr id="118" name="GeneAgent heading">
-            <a:extLst xmlns:a="http://schemas.openxmlformats.org/drawingml/2006/main">
-              <a:ext uri="{FF2B5EF4-FFF2-40B4-BE49-F238E27FC236}">
-                <a16:creationId xmlns:a16="http://schemas.microsoft.com/office/drawing/2014/main" id="{4E8E0B09-4ECE-4037-81B5-C438AC12C810}"/>
-              </a:ext>
-            </a:extLst>
-          </p:cNvPr>
-          <p:cNvSpPr>
-            <a:spLocks xmlns:a="http://schemas.openxmlformats.org/drawingml/2006/main" noGrp="1"/>
-          </p:cNvSpPr>
-          <p:nvPr/>
-        </p:nvSpPr>
-        <p:spPr>
-          <a:xfrm xmlns:a="http://schemas.openxmlformats.org/drawingml/2006/main">
-            <a:off x="11372850" y="17240250"/>
-            <a:ext cx="10172700" cy="457200"/>
-          </a:xfrm>
-          <a:prstGeom xmlns:a="http://schemas.openxmlformats.org/drawingml/2006/main" prst="rect">
-            <a:avLst/>
-          </a:prstGeom>
-          <a:noFill xmlns:a="http://schemas.openxmlformats.org/drawingml/2006/main"/>
-          <a:ln xmlns:a="http://schemas.openxmlformats.org/drawingml/2006/main" w="0">
-            <a:noFill/>
-          </a:ln>
-        </p:spPr>
-        <p:txBody>
-          <a:bodyPr xmlns:a="http://schemas.openxmlformats.org/drawingml/2006/main" wrap="square" lIns="0" tIns="0" rIns="0" bIns="0" anchor="t">
-            <a:noAutofit/>
-          </a:bodyPr>
-          <a:lstStyle xmlns:a="http://schemas.openxmlformats.org/drawingml/2006/main">
-            <a:defPPr algn="l">
-              <a:defRPr sz="2600" b="1">
-                <a:solidFill>
-                  <a:srgbClr val="183B66"/>
-                </a:solidFill>
-                <a:latin typeface="Arial"/>
-                <a:ea typeface="Arial"/>
-                <a:cs typeface="Arial"/>
-              </a:defRPr>
-            </a:defPPr>
-          </a:lstStyle>
-          <a:p xmlns:a="http://schemas.openxmlformats.org/drawingml/2006/main">
-            <a:pPr algn="l">
-              <a:defRPr sz="2600" b="1">
-                <a:solidFill>
-                  <a:srgbClr val="183B66"/>
-                </a:solidFill>
-                <a:latin typeface="Arial"/>
-                <a:ea typeface="Arial"/>
-                <a:cs typeface="Arial"/>
-              </a:defRPr>
-            </a:pPr>
-            <a:r>
-              <a:rPr sz="2600" b="1">
-                <a:solidFill>
-                  <a:srgbClr val="183B66"/>
-                </a:solidFill>
-                <a:latin typeface="Arial"/>
-                <a:ea typeface="Arial"/>
-                <a:cs typeface="Arial"/>
-              </a:rPr>
-              <a:t>Biological reasoning: GeneAgent</a:t>
-            </a:r>
-          </a:p>
-        </p:txBody>
-      </p:sp>
-      <p:sp>
-        <p:nvSpPr>
-          <p:cNvPr id="119" name="GeneAgent explanation">
-            <a:extLst xmlns:a="http://schemas.openxmlformats.org/drawingml/2006/main">
-              <a:ext uri="{FF2B5EF4-FFF2-40B4-BE49-F238E27FC236}">
-                <a16:creationId xmlns:a16="http://schemas.microsoft.com/office/drawing/2014/main" id="{53EF7E42-755F-42A5-9644-ED154536BF7F}"/>
-              </a:ext>
-            </a:extLst>
-          </p:cNvPr>
-          <p:cNvSpPr>
-            <a:spLocks xmlns:a="http://schemas.openxmlformats.org/drawingml/2006/main" noGrp="1"/>
-          </p:cNvSpPr>
-          <p:nvPr/>
-        </p:nvSpPr>
-        <p:spPr>
-          <a:xfrm xmlns:a="http://schemas.openxmlformats.org/drawingml/2006/main">
-            <a:off x="11372850" y="17764125"/>
-            <a:ext cx="10172700" cy="619125"/>
-          </a:xfrm>
-          <a:prstGeom xmlns:a="http://schemas.openxmlformats.org/drawingml/2006/main" prst="rect">
-            <a:avLst/>
-          </a:prstGeom>
-          <a:noFill xmlns:a="http://schemas.openxmlformats.org/drawingml/2006/main"/>
-          <a:ln xmlns:a="http://schemas.openxmlformats.org/drawingml/2006/main" w="0">
-            <a:noFill/>
-          </a:ln>
-        </p:spPr>
-        <p:txBody>
-          <a:bodyPr xmlns:a="http://schemas.openxmlformats.org/drawingml/2006/main" wrap="square" lIns="0" tIns="0" rIns="0" bIns="0" anchor="t">
-            <a:noAutofit/>
-          </a:bodyPr>
-          <a:lstStyle xmlns:a="http://schemas.openxmlformats.org/drawingml/2006/main">
-            <a:defPPr algn="l">
-              <a:defRPr sz="1800" b="0">
-                <a:solidFill>
-                  <a:srgbClr val="344854"/>
-                </a:solidFill>
-                <a:latin typeface="Arial"/>
-                <a:ea typeface="Arial"/>
-                <a:cs typeface="Arial"/>
-              </a:defRPr>
-            </a:defPPr>
-          </a:lstStyle>
-          <a:p xmlns:a="http://schemas.openxmlformats.org/drawingml/2006/main">
-            <a:pPr algn="l">
-              <a:defRPr sz="1800" b="0">
-                <a:solidFill>
-                  <a:srgbClr val="344854"/>
-                </a:solidFill>
-                <a:latin typeface="Arial"/>
-                <a:ea typeface="Arial"/>
-                <a:cs typeface="Arial"/>
-              </a:defRPr>
-            </a:pPr>
-            <a:r>
-              <a:rPr sz="1800" b="0">
-                <a:solidFill>
-                  <a:srgbClr val="344854"/>
-                </a:solidFill>
-                <a:latin typeface="Arial"/>
-                <a:ea typeface="Arial"/>
-                <a:cs typeface="Arial"/>
-              </a:rPr>
-              <a:t>BFT has the best overall text-overlap score among the aligned open-weight models, with the agent pipeline held fixed.</a:t>
-            </a:r>
-          </a:p>
-        </p:txBody>
-      </p:sp>
-      <p:pic>
-        <p:nvPicPr>
-          <p:cNvPr id="120" name="">
-            <a:extLst xmlns:a="http://schemas.openxmlformats.org/drawingml/2006/main">
-              <a:ext uri="{FF2B5EF4-FFF2-40B4-BE49-F238E27FC236}">
-                <a16:creationId xmlns:a16="http://schemas.microsoft.com/office/drawing/2014/main" id="{2F2A192A-16CC-4213-AF55-BF0FB9879E5A}"/>
-              </a:ext>
-            </a:extLst>
-          </p:cNvPr>
-          <p:cNvPicPr>
-            <a:picLocks xmlns:a="http://schemas.openxmlformats.org/drawingml/2006/main" noChangeAspect="1"/>
-          </p:cNvPicPr>
-          <p:nvPr/>
-        </p:nvPicPr>
-        <p:blipFill>
-          <a:blip xmlns:r="http://schemas.openxmlformats.org/officeDocument/2006/relationships" xmlns:a="http://schemas.openxmlformats.org/drawingml/2006/main" r:embed="R95377280ff1543ab"/>
-          <a:stretch xmlns:a="http://schemas.openxmlformats.org/drawingml/2006/main"/>
-        </p:blipFill>
-        <p:spPr>
-          <a:xfrm xmlns:a="http://schemas.openxmlformats.org/drawingml/2006/main">
-            <a:off x="12853013" y="18478500"/>
-            <a:ext cx="7212374" cy="2952750"/>
-          </a:xfrm>
-          <a:prstGeom xmlns:a="http://schemas.openxmlformats.org/drawingml/2006/main" prst="rect">
-            <a:avLst/>
-          </a:prstGeom>
-        </p:spPr>
-      </p:pic>
-      <p:pic>
-        <p:nvPicPr>
-          <p:cNvPr id="121" name="">
-            <a:extLst xmlns:a="http://schemas.openxmlformats.org/drawingml/2006/main">
-              <a:ext uri="{FF2B5EF4-FFF2-40B4-BE49-F238E27FC236}">
-                <a16:creationId xmlns:a16="http://schemas.microsoft.com/office/drawing/2014/main" id="{FF48B1B2-EB84-4E89-AED7-265AE5989E0E}"/>
-              </a:ext>
-            </a:extLst>
-          </p:cNvPr>
-          <p:cNvPicPr>
-            <a:picLocks xmlns:a="http://schemas.openxmlformats.org/drawingml/2006/main" noChangeAspect="1"/>
-          </p:cNvPicPr>
-          <p:nvPr/>
-        </p:nvPicPr>
-        <p:blipFill>
-          <a:blip xmlns:r="http://schemas.openxmlformats.org/officeDocument/2006/relationships" xmlns:a="http://schemas.openxmlformats.org/drawingml/2006/main" r:embed="R4077fbaecc8043ec"/>
-          <a:stretch xmlns:a="http://schemas.openxmlformats.org/drawingml/2006/main"/>
-        </p:blipFill>
-        <p:spPr>
-          <a:xfrm xmlns:a="http://schemas.openxmlformats.org/drawingml/2006/main">
-            <a:off x="11372850" y="21563164"/>
-            <a:ext cx="10172700" cy="212423"/>
-          </a:xfrm>
-          <a:prstGeom xmlns:a="http://schemas.openxmlformats.org/drawingml/2006/main" prst="rect">
-            <a:avLst/>
-          </a:prstGeom>
-        </p:spPr>
-      </p:pic>
-      <p:sp>
-        <p:nvSpPr>
-          <p:cNvPr id="122" name="MMLU heading">
-            <a:extLst xmlns:a="http://schemas.openxmlformats.org/drawingml/2006/main">
-              <a:ext uri="{FF2B5EF4-FFF2-40B4-BE49-F238E27FC236}">
-                <a16:creationId xmlns:a16="http://schemas.microsoft.com/office/drawing/2014/main" id="{A204AB92-B9F5-4D4C-931D-9FBC9AF04FAF}"/>
-              </a:ext>
-            </a:extLst>
-          </p:cNvPr>
-          <p:cNvSpPr>
-            <a:spLocks xmlns:a="http://schemas.openxmlformats.org/drawingml/2006/main" noGrp="1"/>
-          </p:cNvSpPr>
-          <p:nvPr/>
-        </p:nvSpPr>
-        <p:spPr>
-          <a:xfrm xmlns:a="http://schemas.openxmlformats.org/drawingml/2006/main">
-            <a:off x="22078950" y="5715000"/>
-            <a:ext cx="4286250" cy="428625"/>
-          </a:xfrm>
-          <a:prstGeom xmlns:a="http://schemas.openxmlformats.org/drawingml/2006/main" prst="rect">
-            <a:avLst/>
-          </a:prstGeom>
-          <a:noFill xmlns:a="http://schemas.openxmlformats.org/drawingml/2006/main"/>
-          <a:ln xmlns:a="http://schemas.openxmlformats.org/drawingml/2006/main" w="0">
-            <a:noFill/>
-          </a:ln>
-        </p:spPr>
-        <p:txBody>
-          <a:bodyPr xmlns:a="http://schemas.openxmlformats.org/drawingml/2006/main" wrap="square" lIns="0" tIns="0" rIns="0" bIns="0" anchor="t">
-            <a:noAutofit/>
-          </a:bodyPr>
-          <a:lstStyle xmlns:a="http://schemas.openxmlformats.org/drawingml/2006/main">
-            <a:defPPr algn="l">
-              <a:defRPr sz="2400" b="1">
-                <a:solidFill>
-                  <a:srgbClr val="183B66"/>
-                </a:solidFill>
-                <a:latin typeface="Arial"/>
-                <a:ea typeface="Arial"/>
-                <a:cs typeface="Arial"/>
-              </a:defRPr>
-            </a:defPPr>
-          </a:lstStyle>
-          <a:p xmlns:a="http://schemas.openxmlformats.org/drawingml/2006/main">
-            <a:pPr algn="l">
-              <a:defRPr sz="2400" b="1">
-                <a:solidFill>
-                  <a:srgbClr val="183B66"/>
-                </a:solidFill>
-                <a:latin typeface="Arial"/>
-                <a:ea typeface="Arial"/>
-                <a:cs typeface="Arial"/>
-              </a:defRPr>
-            </a:pPr>
-            <a:r>
-              <a:rPr sz="2400" b="1">
-                <a:solidFill>
-                  <a:srgbClr val="183B66"/>
-                </a:solidFill>
-                <a:latin typeface="Arial"/>
-                <a:ea typeface="Arial"/>
-                <a:cs typeface="Arial"/>
-              </a:rPr>
-              <a:t>MMLU (70B)</a:t>
-            </a:r>
-          </a:p>
-        </p:txBody>
-      </p:sp>
-      <p:sp>
-        <p:nvSpPr>
-          <p:cNvPr id="123" name="CMMLU heading">
-            <a:extLst xmlns:a="http://schemas.openxmlformats.org/drawingml/2006/main">
-              <a:ext uri="{FF2B5EF4-FFF2-40B4-BE49-F238E27FC236}">
-                <a16:creationId xmlns:a16="http://schemas.microsoft.com/office/drawing/2014/main" id="{26DAE4BC-0635-4D75-8B4B-81E152451AF0}"/>
-              </a:ext>
-            </a:extLst>
-          </p:cNvPr>
-          <p:cNvSpPr>
-            <a:spLocks xmlns:a="http://schemas.openxmlformats.org/drawingml/2006/main" noGrp="1"/>
-          </p:cNvSpPr>
-          <p:nvPr/>
-        </p:nvSpPr>
-        <p:spPr>
-          <a:xfrm xmlns:a="http://schemas.openxmlformats.org/drawingml/2006/main">
-            <a:off x="26555700" y="5715000"/>
-            <a:ext cx="4191000" cy="428625"/>
-          </a:xfrm>
-          <a:prstGeom xmlns:a="http://schemas.openxmlformats.org/drawingml/2006/main" prst="rect">
-            <a:avLst/>
-          </a:prstGeom>
-          <a:noFill xmlns:a="http://schemas.openxmlformats.org/drawingml/2006/main"/>
-          <a:ln xmlns:a="http://schemas.openxmlformats.org/drawingml/2006/main" w="0">
-            <a:noFill/>
-          </a:ln>
-        </p:spPr>
-        <p:txBody>
-          <a:bodyPr xmlns:a="http://schemas.openxmlformats.org/drawingml/2006/main" wrap="square" lIns="0" tIns="0" rIns="0" bIns="0" anchor="t">
-            <a:noAutofit/>
-          </a:bodyPr>
-          <a:lstStyle xmlns:a="http://schemas.openxmlformats.org/drawingml/2006/main">
-            <a:defPPr algn="l">
-              <a:defRPr sz="2400" b="1">
-                <a:solidFill>
-                  <a:srgbClr val="183B66"/>
-                </a:solidFill>
-                <a:latin typeface="Arial"/>
-                <a:ea typeface="Arial"/>
-                <a:cs typeface="Arial"/>
-              </a:defRPr>
-            </a:defPPr>
-          </a:lstStyle>
-          <a:p xmlns:a="http://schemas.openxmlformats.org/drawingml/2006/main">
-            <a:pPr algn="l">
-              <a:defRPr sz="2400" b="1">
-                <a:solidFill>
-                  <a:srgbClr val="183B66"/>
-                </a:solidFill>
-                <a:latin typeface="Arial"/>
-                <a:ea typeface="Arial"/>
-                <a:cs typeface="Arial"/>
-              </a:defRPr>
-            </a:pPr>
-            <a:r>
-              <a:rPr sz="2400" b="1">
-                <a:solidFill>
-                  <a:srgbClr val="183B66"/>
-                </a:solidFill>
-                <a:latin typeface="Arial"/>
-                <a:ea typeface="Arial"/>
-                <a:cs typeface="Arial"/>
-              </a:rPr>
-              <a:t>CMMLU (70B)</a:t>
-            </a:r>
-          </a:p>
-        </p:txBody>
-      </p:sp>
-      <p:pic>
-        <p:nvPicPr>
-          <p:cNvPr id="124" name="">
-            <a:extLst xmlns:a="http://schemas.openxmlformats.org/drawingml/2006/main">
-              <a:ext uri="{FF2B5EF4-FFF2-40B4-BE49-F238E27FC236}">
-                <a16:creationId xmlns:a16="http://schemas.microsoft.com/office/drawing/2014/main" id="{CEF59BDA-CE13-4C7A-B2CD-394926F21630}"/>
-              </a:ext>
-            </a:extLst>
-          </p:cNvPr>
-          <p:cNvPicPr>
-            <a:picLocks xmlns:a="http://schemas.openxmlformats.org/drawingml/2006/main" noChangeAspect="1"/>
-          </p:cNvPicPr>
-          <p:nvPr/>
-        </p:nvPicPr>
-        <p:blipFill>
-          <a:blip xmlns:r="http://schemas.openxmlformats.org/officeDocument/2006/relationships" xmlns:a="http://schemas.openxmlformats.org/drawingml/2006/main" r:embed="R1d7e80e2a32043f1"/>
-          <a:stretch xmlns:a="http://schemas.openxmlformats.org/drawingml/2006/main"/>
-        </p:blipFill>
-        <p:spPr>
-          <a:xfrm xmlns:a="http://schemas.openxmlformats.org/drawingml/2006/main">
-            <a:off x="22191785" y="6238875"/>
-            <a:ext cx="4060581" cy="3238500"/>
-          </a:xfrm>
-          <a:prstGeom xmlns:a="http://schemas.openxmlformats.org/drawingml/2006/main" prst="rect">
-            <a:avLst/>
-          </a:prstGeom>
-        </p:spPr>
-      </p:pic>
-      <p:pic>
-        <p:nvPicPr>
-          <p:cNvPr id="125" name="">
-            <a:extLst xmlns:a="http://schemas.openxmlformats.org/drawingml/2006/main">
-              <a:ext uri="{FF2B5EF4-FFF2-40B4-BE49-F238E27FC236}">
-                <a16:creationId xmlns:a16="http://schemas.microsoft.com/office/drawing/2014/main" id="{0F476FFD-744F-40FD-A8B3-FE4FB72634A6}"/>
-              </a:ext>
-            </a:extLst>
-          </p:cNvPr>
-          <p:cNvPicPr>
-            <a:picLocks xmlns:a="http://schemas.openxmlformats.org/drawingml/2006/main" noChangeAspect="1"/>
-          </p:cNvPicPr>
-          <p:nvPr/>
-        </p:nvPicPr>
-        <p:blipFill>
-          <a:blip xmlns:r="http://schemas.openxmlformats.org/officeDocument/2006/relationships" xmlns:a="http://schemas.openxmlformats.org/drawingml/2006/main" r:embed="Redba5edd6f624139"/>
-          <a:stretch xmlns:a="http://schemas.openxmlformats.org/drawingml/2006/main"/>
-        </p:blipFill>
-        <p:spPr>
-          <a:xfrm xmlns:a="http://schemas.openxmlformats.org/drawingml/2006/main">
-            <a:off x="26759504" y="6238875"/>
-            <a:ext cx="3783392" cy="3905250"/>
-          </a:xfrm>
-          <a:prstGeom xmlns:a="http://schemas.openxmlformats.org/drawingml/2006/main" prst="rect">
-            <a:avLst/>
-          </a:prstGeom>
-        </p:spPr>
-      </p:pic>
-      <p:pic>
-        <p:nvPicPr>
-          <p:cNvPr id="126" name="">
-            <a:extLst xmlns:a="http://schemas.openxmlformats.org/drawingml/2006/main">
-              <a:ext uri="{FF2B5EF4-FFF2-40B4-BE49-F238E27FC236}">
-                <a16:creationId xmlns:a16="http://schemas.microsoft.com/office/drawing/2014/main" id="{7F8D7A33-9A06-4C11-BBD6-1C9651CA878E}"/>
-              </a:ext>
-            </a:extLst>
-          </p:cNvPr>
-          <p:cNvPicPr>
-            <a:picLocks xmlns:a="http://schemas.openxmlformats.org/drawingml/2006/main" noChangeAspect="1"/>
-          </p:cNvPicPr>
-          <p:nvPr/>
-        </p:nvPicPr>
-        <p:blipFill>
-          <a:blip xmlns:r="http://schemas.openxmlformats.org/officeDocument/2006/relationships" xmlns:a="http://schemas.openxmlformats.org/drawingml/2006/main" r:embed="R0c0d4505daa84a0f"/>
-          <a:stretch xmlns:a="http://schemas.openxmlformats.org/drawingml/2006/main"/>
-        </p:blipFill>
-        <p:spPr>
-          <a:xfrm xmlns:a="http://schemas.openxmlformats.org/drawingml/2006/main">
-            <a:off x="30875037" y="7286625"/>
-            <a:ext cx="1343526" cy="1524000"/>
-          </a:xfrm>
-          <a:prstGeom xmlns:a="http://schemas.openxmlformats.org/drawingml/2006/main" prst="rect">
-            <a:avLst/>
-          </a:prstGeom>
-        </p:spPr>
-      </p:pic>
-      <p:sp>
-        <p:nvSpPr>
-          <p:cNvPr id="127" name="MMLU category explanation">
-            <a:extLst xmlns:a="http://schemas.openxmlformats.org/drawingml/2006/main">
-              <a:ext uri="{FF2B5EF4-FFF2-40B4-BE49-F238E27FC236}">
-                <a16:creationId xmlns:a16="http://schemas.microsoft.com/office/drawing/2014/main" id="{46EF39DF-7B71-45BF-811D-85FC11E0B482}"/>
-              </a:ext>
-            </a:extLst>
-          </p:cNvPr>
-          <p:cNvSpPr>
-            <a:spLocks xmlns:a="http://schemas.openxmlformats.org/drawingml/2006/main" noGrp="1"/>
-          </p:cNvSpPr>
-          <p:nvPr/>
-        </p:nvSpPr>
-        <p:spPr>
-          <a:xfrm xmlns:a="http://schemas.openxmlformats.org/drawingml/2006/main">
-            <a:off x="22078950" y="9620250"/>
-            <a:ext cx="4286250" cy="523875"/>
-          </a:xfrm>
-          <a:prstGeom xmlns:a="http://schemas.openxmlformats.org/drawingml/2006/main" prst="rect">
-            <a:avLst/>
-          </a:prstGeom>
-          <a:noFill xmlns:a="http://schemas.openxmlformats.org/drawingml/2006/main"/>
-          <a:ln xmlns:a="http://schemas.openxmlformats.org/drawingml/2006/main" w="0">
-            <a:noFill/>
-          </a:ln>
-        </p:spPr>
-        <p:txBody>
-          <a:bodyPr xmlns:a="http://schemas.openxmlformats.org/drawingml/2006/main" wrap="square" lIns="0" tIns="0" rIns="0" bIns="0" anchor="t">
-            <a:noAutofit/>
-          </a:bodyPr>
-          <a:lstStyle xmlns:a="http://schemas.openxmlformats.org/drawingml/2006/main">
-            <a:defPPr algn="l">
-              <a:defRPr sz="1600" b="0">
-                <a:solidFill>
-                  <a:srgbClr val="344854"/>
-                </a:solidFill>
-                <a:latin typeface="Arial"/>
-                <a:ea typeface="Arial"/>
-                <a:cs typeface="Arial"/>
-              </a:defRPr>
-            </a:defPPr>
-          </a:lstStyle>
-          <a:p xmlns:a="http://schemas.openxmlformats.org/drawingml/2006/main">
-            <a:pPr algn="l">
-              <a:defRPr sz="1600" b="0">
-                <a:solidFill>
-                  <a:srgbClr val="344854"/>
-                </a:solidFill>
-                <a:latin typeface="Arial"/>
-                <a:ea typeface="Arial"/>
-                <a:cs typeface="Arial"/>
-              </a:defRPr>
-            </a:pPr>
-            <a:r>
-              <a:rPr sz="1600" b="0">
-                <a:solidFill>
-                  <a:srgbClr val="344854"/>
-                </a:solidFill>
-                <a:latin typeface="Arial"/>
-                <a:ea typeface="Arial"/>
-                <a:cs typeface="Arial"/>
-              </a:rPr>
-              <a:t>Categories in both plots: average, STEM,</a:t>
-            </a:r>
-          </a:p>
-          <a:p xmlns:a="http://schemas.openxmlformats.org/drawingml/2006/main">
-            <a:pPr algn="l">
-              <a:defRPr sz="1600" b="0">
-                <a:solidFill>
-                  <a:srgbClr val="344854"/>
-                </a:solidFill>
-                <a:latin typeface="Arial"/>
-                <a:ea typeface="Arial"/>
-                <a:cs typeface="Arial"/>
-              </a:defRPr>
-            </a:pPr>
-            <a:r>
-              <a:rPr sz="1600" b="0">
-                <a:solidFill>
-                  <a:srgbClr val="344854"/>
-                </a:solidFill>
-                <a:latin typeface="Arial"/>
-                <a:ea typeface="Arial"/>
-                <a:cs typeface="Arial"/>
-              </a:rPr>
-              <a:t>social sciences, humanities, other.</a:t>
-            </a:r>
-          </a:p>
-        </p:txBody>
-      </p:sp>
-      <p:pic>
-        <p:nvPicPr>
-          <p:cNvPr id="128" name="">
-            <a:extLst xmlns:a="http://schemas.openxmlformats.org/drawingml/2006/main">
-              <a:ext uri="{FF2B5EF4-FFF2-40B4-BE49-F238E27FC236}">
-                <a16:creationId xmlns:a16="http://schemas.microsoft.com/office/drawing/2014/main" id="{E12B378E-27E2-43A8-890B-A4E30D9D4C41}"/>
-              </a:ext>
-            </a:extLst>
-          </p:cNvPr>
-          <p:cNvPicPr>
-            <a:picLocks xmlns:a="http://schemas.openxmlformats.org/drawingml/2006/main" noChangeAspect="1"/>
-          </p:cNvPicPr>
-          <p:nvPr/>
-        </p:nvPicPr>
-        <p:blipFill>
-          <a:blip xmlns:r="http://schemas.openxmlformats.org/officeDocument/2006/relationships" xmlns:a="http://schemas.openxmlformats.org/drawingml/2006/main" r:embed="Rcbe4c51d48fa463f"/>
-          <a:stretch xmlns:a="http://schemas.openxmlformats.org/drawingml/2006/main"/>
-        </p:blipFill>
-        <p:spPr>
-          <a:xfrm xmlns:a="http://schemas.openxmlformats.org/drawingml/2006/main">
-            <a:off x="22912021" y="12668250"/>
-            <a:ext cx="8506558" cy="4286250"/>
-          </a:xfrm>
-          <a:prstGeom xmlns:a="http://schemas.openxmlformats.org/drawingml/2006/main" prst="rect">
-            <a:avLst/>
-          </a:prstGeom>
-        </p:spPr>
-      </p:pic>
-      <p:pic>
-        <p:nvPicPr>
-          <p:cNvPr id="129" name="">
-            <a:extLst xmlns:a="http://schemas.openxmlformats.org/drawingml/2006/main">
-              <a:ext uri="{FF2B5EF4-FFF2-40B4-BE49-F238E27FC236}">
-                <a16:creationId xmlns:a16="http://schemas.microsoft.com/office/drawing/2014/main" id="{FF0DA3C5-C67F-4BD7-8B8B-A09DAC1EC896}"/>
-              </a:ext>
-            </a:extLst>
-          </p:cNvPr>
-          <p:cNvPicPr>
-            <a:picLocks xmlns:a="http://schemas.openxmlformats.org/drawingml/2006/main" noChangeAspect="1"/>
-          </p:cNvPicPr>
-          <p:nvPr/>
-        </p:nvPicPr>
-        <p:blipFill>
-          <a:blip xmlns:r="http://schemas.openxmlformats.org/officeDocument/2006/relationships" xmlns:a="http://schemas.openxmlformats.org/drawingml/2006/main" r:embed="R9ff4ce81ce0c491d"/>
-          <a:stretch xmlns:a="http://schemas.openxmlformats.org/drawingml/2006/main"/>
-        </p:blipFill>
-        <p:spPr>
-          <a:xfrm xmlns:a="http://schemas.openxmlformats.org/drawingml/2006/main">
-            <a:off x="22291078" y="18526125"/>
+            <a:off x="22291078" y="18764250"/>
             <a:ext cx="9748444" cy="2667000"/>
           </a:xfrm>
           <a:prstGeom xmlns:a="http://schemas.openxmlformats.org/drawingml/2006/main" prst="rect">

</xml_diff>

<commit_message>
Restore complete poster axis labels and CMMLU evidence
</commit_message>
<xml_diff>
--- a/assets/BFT-NeurIPS2026-Poster.pptx
+++ b/assets/BFT-NeurIPS2026-Poster.pptx
@@ -2,13 +2,13 @@
 <file path=ppt/presentation.xml><?xml version="1.0" encoding="utf-8"?>
 <p:presentation xmlns:p="http://schemas.openxmlformats.org/presentationml/2006/main">
   <p:sldMasterIdLst>
-    <p:sldMasterId xmlns:r="http://schemas.openxmlformats.org/officeDocument/2006/relationships" id="2147483648" r:id="R214ee48e4bf74cf6"/>
+    <p:sldMasterId xmlns:r="http://schemas.openxmlformats.org/officeDocument/2006/relationships" id="2147483648" r:id="R11c30b8d24f843d8"/>
   </p:sldMasterIdLst>
   <p:notesMasterIdLst>
-    <p:notesMasterId xmlns:r="http://schemas.openxmlformats.org/officeDocument/2006/relationships" r:id="R2de4414bcfb94c78"/>
+    <p:notesMasterId xmlns:r="http://schemas.openxmlformats.org/officeDocument/2006/relationships" r:id="R4405c6e8417a45e1"/>
   </p:notesMasterIdLst>
   <p:sldIdLst>
-    <p:sldId xmlns:r="http://schemas.openxmlformats.org/officeDocument/2006/relationships" id="256" r:id="Rd28bd3056f344602"/>
+    <p:sldId xmlns:r="http://schemas.openxmlformats.org/officeDocument/2006/relationships" id="256" r:id="R39c8e9106e0c4ce7"/>
   </p:sldIdLst>
   <p:sldSz cx="32918400" cy="21945600"/>
   <p:notesSz cx="6858000" cy="9144000"/>
@@ -646,7 +646,7 @@
           <a:lstStyle xmlns:a="http://schemas.openxmlformats.org/drawingml/2006/main"/>
           <a:p xmlns:a="http://schemas.openxmlformats.org/drawingml/2006/main">
             <a:r>
-              <a:t>Edited from author-selected BFT-NeurIPS2026-Plain-Language-Final-R2.pptx. All scientific visuals are unchanged-pixel crops from supplied camera-ready Figure1-5. Crop boxes and masks of letter-only margins are recorded in .build/poster-paper-figures/crop-manifest.json. Challenge uses Figure1b, motivation Figure1a, method Figure1c, biomedical results Figure2a/b; HealthBench plot is cropped above angled category labels, whose original order is stated in adjacent editable text, general retention original 70B MMLU panel and legend from Figure3a; CMMLU ordering described in text per Results, gene representation Figure4b, single-cell response Figure5. No reconstructed chart, diagram, or evidence table. Native text explains token as word for a broad audience. Main paper Section3 and Results provide scientific claims. General ability is retained better than SFT, not without loss, and DFT forgets least. STEM extension is demonstrated specifically in medicine and biology, not tested across all STEM fields. Gene mean AUC 0.829 vs GenePT0.802, with Lys4 exception. Same text encoder but different profile source. Only profile generation is zero-shot on perturbation datasets. Source: https://arxiv.org/abs/2511.21075 and supplied neurips_2026_arxiv.tex. Logos and original master retained. No displayed equations added.</a:t>
+              <a:t>Edited from author-selected BFT-NeurIPS2026-Plain-Language-Final-R2.pptx. All scientific visuals are unchanged-pixel crops from supplied camera-ready Figure1-5. Crop boxes and masks of letter-only margins are recorded in .build/poster-paper-figures/crop-manifest.json. Challenge uses Figure1b, motivation Figure1a, method Figure1c, biomedical results Figure2a/b; HealthBench retains complete original category labels, general retention original 70B MMLU and CMMLU panels from Figure3a. The original shared category-label strip is duplicated under MMLU so each panel has complete names. Original legend entries are rearranged in two rows without redrawing, gene representation Figure4b, single-cell response Figure5. No reconstructed chart, diagram, or evidence table. Native text explains token as word for a broad audience. Main paper Section3 and Results provide scientific claims. General ability is retained better than SFT, not without loss, and DFT forgets least. STEM extension is demonstrated specifically in medicine and biology, not tested across all STEM fields. Gene mean AUC 0.829 vs GenePT0.802, with Lys4 exception. Same text encoder but different profile source. Only profile generation is zero-shot on perturbation datasets. Source: https://arxiv.org/abs/2511.21075 and supplied neurips_2026_arxiv.tex. Logos and original master retained. No displayed equations added.</a:t>
             </a:r>
           </a:p>
         </p:txBody>
@@ -951,8 +951,8 @@
   </p:cSld>
   <p:clrMap bg1="lt1" tx1="dk1" bg2="lt2" tx2="dk2" accent1="accent1" accent2="accent2" accent3="accent3" accent4="accent4" accent5="accent5" accent6="accent6" hlink="hlink" folHlink="folHlink"/>
   <p:sldLayoutIdLst>
-    <p:sldLayoutId xmlns:r="http://schemas.openxmlformats.org/officeDocument/2006/relationships" id="2147483649" r:id="R287ddb39550a4874"/>
-    <p:sldLayoutId xmlns:r="http://schemas.openxmlformats.org/officeDocument/2006/relationships" id="2147483650" r:id="R9df839cf6168431f"/>
+    <p:sldLayoutId xmlns:r="http://schemas.openxmlformats.org/officeDocument/2006/relationships" id="2147483649" r:id="R46ca334f41e14794"/>
+    <p:sldLayoutId xmlns:r="http://schemas.openxmlformats.org/officeDocument/2006/relationships" id="2147483650" r:id="R21080112d51d4189"/>
   </p:sldLayoutIdLst>
   <p:txStyles>
     <p:titleStyle>
@@ -2443,7 +2443,7 @@
           <p:cNvPr id="54" name="neurips_logo.pdf">
             <a:extLst xmlns:a="http://schemas.openxmlformats.org/drawingml/2006/main">
               <a:ext uri="{FF2B5EF4-FFF2-40B4-BE49-F238E27FC236}">
-                <a16:creationId xmlns:a16="http://schemas.microsoft.com/office/drawing/2014/main" id="{441CBA61-600D-4C16-B917-A545A41D5820}"/>
+                <a16:creationId xmlns:a16="http://schemas.microsoft.com/office/drawing/2014/main" id="{BD7E1E9F-D994-41A8-9C9D-92F714AFE6B1}"/>
               </a:ext>
             </a:extLst>
           </p:cNvPr>
@@ -2453,7 +2453,7 @@
           <p:nvPr/>
         </p:nvPicPr>
         <p:blipFill>
-          <a:blip xmlns:r="http://schemas.openxmlformats.org/officeDocument/2006/relationships" xmlns:a="http://schemas.openxmlformats.org/drawingml/2006/main" r:embed="Rec525c132f9d42e5"/>
+          <a:blip xmlns:r="http://schemas.openxmlformats.org/officeDocument/2006/relationships" xmlns:a="http://schemas.openxmlformats.org/drawingml/2006/main" r:embed="R4c28a572c8994b03"/>
           <a:stretch xmlns:a="http://schemas.openxmlformats.org/drawingml/2006/main">
             <a:fillRect l="0" t="0" r="0" b="0"/>
           </a:stretch>
@@ -2654,7 +2654,7 @@
           <p:cNvPr id="57" name="图片 56">
             <a:extLst xmlns:a="http://schemas.openxmlformats.org/drawingml/2006/main">
               <a:ext uri="{FF2B5EF4-FFF2-40B4-BE49-F238E27FC236}">
-                <a16:creationId xmlns:a16="http://schemas.microsoft.com/office/drawing/2014/main" id="{390DD568-BA3A-4FEF-A944-8D1D9BA4C03C}"/>
+                <a16:creationId xmlns:a16="http://schemas.microsoft.com/office/drawing/2014/main" id="{3145ACD8-04C6-4A7C-98C0-3FE7489021FE}"/>
               </a:ext>
             </a:extLst>
           </p:cNvPr>
@@ -2664,7 +2664,7 @@
           <p:nvPr/>
         </p:nvPicPr>
         <p:blipFill>
-          <a:blip xmlns:r="http://schemas.openxmlformats.org/officeDocument/2006/relationships" xmlns:a="http://schemas.openxmlformats.org/drawingml/2006/main" r:embed="Rf93cbb0572d5483b"/>
+          <a:blip xmlns:r="http://schemas.openxmlformats.org/officeDocument/2006/relationships" xmlns:a="http://schemas.openxmlformats.org/drawingml/2006/main" r:embed="R070826ae0dc04663"/>
           <a:stretch xmlns:a="http://schemas.openxmlformats.org/drawingml/2006/main"/>
         </p:blipFill>
         <p:spPr>
@@ -2682,7 +2682,7 @@
           <p:cNvPr id="58" name="图片 57">
             <a:extLst xmlns:a="http://schemas.openxmlformats.org/drawingml/2006/main">
               <a:ext uri="{FF2B5EF4-FFF2-40B4-BE49-F238E27FC236}">
-                <a16:creationId xmlns:a16="http://schemas.microsoft.com/office/drawing/2014/main" id="{33086AA6-8EB1-44F8-B6B3-46F300349A82}"/>
+                <a16:creationId xmlns:a16="http://schemas.microsoft.com/office/drawing/2014/main" id="{3D7E75AD-67B5-416E-A518-CDB8D1998447}"/>
               </a:ext>
             </a:extLst>
           </p:cNvPr>
@@ -2692,7 +2692,7 @@
           <p:nvPr/>
         </p:nvPicPr>
         <p:blipFill>
-          <a:blip xmlns:r="http://schemas.openxmlformats.org/officeDocument/2006/relationships" xmlns:a="http://schemas.openxmlformats.org/drawingml/2006/main" r:embed="R2e45f85250a044ab"/>
+          <a:blip xmlns:r="http://schemas.openxmlformats.org/officeDocument/2006/relationships" xmlns:a="http://schemas.openxmlformats.org/drawingml/2006/main" r:embed="R634134f6eeba4f28"/>
           <a:stretch xmlns:a="http://schemas.openxmlformats.org/drawingml/2006/main"/>
         </p:blipFill>
         <p:spPr>
@@ -2710,7 +2710,7 @@
           <p:cNvPr id="59" name="图片 58">
             <a:extLst xmlns:a="http://schemas.openxmlformats.org/drawingml/2006/main">
               <a:ext uri="{FF2B5EF4-FFF2-40B4-BE49-F238E27FC236}">
-                <a16:creationId xmlns:a16="http://schemas.microsoft.com/office/drawing/2014/main" id="{E5B04989-64E6-4762-A191-EBA0166DE57F}"/>
+                <a16:creationId xmlns:a16="http://schemas.microsoft.com/office/drawing/2014/main" id="{4805E551-612D-44A9-903E-FC0D1247A041}"/>
               </a:ext>
             </a:extLst>
           </p:cNvPr>
@@ -2720,7 +2720,7 @@
           <p:nvPr/>
         </p:nvPicPr>
         <p:blipFill>
-          <a:blip xmlns:r="http://schemas.openxmlformats.org/officeDocument/2006/relationships" xmlns:a="http://schemas.openxmlformats.org/drawingml/2006/main" r:embed="R334767bfca894947"/>
+          <a:blip xmlns:r="http://schemas.openxmlformats.org/officeDocument/2006/relationships" xmlns:a="http://schemas.openxmlformats.org/drawingml/2006/main" r:embed="R8b2b2a8bde104a96"/>
           <a:stretch xmlns:a="http://schemas.openxmlformats.org/drawingml/2006/main"/>
         </p:blipFill>
         <p:spPr>
@@ -2866,8 +2866,8 @@
         </p:nvSpPr>
         <p:spPr>
           <a:xfrm xmlns:a="http://schemas.openxmlformats.org/drawingml/2006/main">
-            <a:off x="11372850" y="20383500"/>
-            <a:ext cx="10172700" cy="666750"/>
+            <a:off x="11372850" y="20478750"/>
+            <a:ext cx="10172700" cy="857250"/>
           </a:xfrm>
           <a:prstGeom xmlns:a="http://schemas.openxmlformats.org/drawingml/2006/main" prst="rect">
             <a:avLst/>
@@ -2914,7 +2914,7 @@
                 <a:ea typeface="Arial"/>
                 <a:cs typeface="Arial"/>
               </a:rPr>
-              <a:t>CMMLU shows the same retention ordering. Some forgetting remains, and DFT forgets least.</a:t>
+              <a:t>Both benchmarks show less forgetting than SFT and sample-only BFT. Some forgetting remains. DFT forgets least, while BFT offers stronger biomedical adaptation.</a:t>
             </a:r>
           </a:p>
         </p:txBody>
@@ -3490,7 +3490,7 @@
                 <a:ea typeface="Arial"/>
                 <a:cs typeface="Arial"/>
               </a:rPr>
-              <a:t>HealthBench Hard (70B). Categories, left to right: accuracy, communication quality, completeness, context, instruction following.</a:t>
+              <a:t>HealthBench Hard (70B): medical competence across five evaluation dimensions.</a:t>
             </a:r>
           </a:p>
         </p:txBody>
@@ -3511,7 +3511,7 @@
         </p:nvSpPr>
         <p:spPr>
           <a:xfrm xmlns:a="http://schemas.openxmlformats.org/drawingml/2006/main">
-            <a:off x="666750" y="17621250"/>
+            <a:off x="666750" y="17859375"/>
             <a:ext cx="10172700" cy="457200"/>
           </a:xfrm>
           <a:prstGeom xmlns:a="http://schemas.openxmlformats.org/drawingml/2006/main" prst="rect">
@@ -3564,62 +3564,6 @@
           </a:p>
         </p:txBody>
       </p:sp>
-      <p:pic>
-        <p:nvPicPr>
-          <p:cNvPr id="128" name="">
-            <a:extLst xmlns:a="http://schemas.openxmlformats.org/drawingml/2006/main">
-              <a:ext uri="{FF2B5EF4-FFF2-40B4-BE49-F238E27FC236}">
-                <a16:creationId xmlns:a16="http://schemas.microsoft.com/office/drawing/2014/main" id="{495703A7-B984-443F-94BB-28983BAB4A25}"/>
-              </a:ext>
-            </a:extLst>
-          </p:cNvPr>
-          <p:cNvPicPr>
-            <a:picLocks xmlns:a="http://schemas.openxmlformats.org/drawingml/2006/main" noChangeAspect="1"/>
-          </p:cNvPicPr>
-          <p:nvPr/>
-        </p:nvPicPr>
-        <p:blipFill>
-          <a:blip xmlns:r="http://schemas.openxmlformats.org/officeDocument/2006/relationships" xmlns:a="http://schemas.openxmlformats.org/drawingml/2006/main" r:embed="R0bdc39f0fae547bc"/>
-          <a:stretch xmlns:a="http://schemas.openxmlformats.org/drawingml/2006/main"/>
-        </p:blipFill>
-        <p:spPr>
-          <a:xfrm xmlns:a="http://schemas.openxmlformats.org/drawingml/2006/main">
-            <a:off x="2388747" y="5048250"/>
-            <a:ext cx="6728707" cy="1762125"/>
-          </a:xfrm>
-          <a:prstGeom xmlns:a="http://schemas.openxmlformats.org/drawingml/2006/main" prst="rect">
-            <a:avLst/>
-          </a:prstGeom>
-        </p:spPr>
-      </p:pic>
-      <p:pic>
-        <p:nvPicPr>
-          <p:cNvPr id="129" name="">
-            <a:extLst xmlns:a="http://schemas.openxmlformats.org/drawingml/2006/main">
-              <a:ext uri="{FF2B5EF4-FFF2-40B4-BE49-F238E27FC236}">
-                <a16:creationId xmlns:a16="http://schemas.microsoft.com/office/drawing/2014/main" id="{B347CB04-5F97-427A-81C0-2115298846E9}"/>
-              </a:ext>
-            </a:extLst>
-          </p:cNvPr>
-          <p:cNvPicPr>
-            <a:picLocks xmlns:a="http://schemas.openxmlformats.org/drawingml/2006/main" noChangeAspect="1"/>
-          </p:cNvPicPr>
-          <p:nvPr/>
-        </p:nvPicPr>
-        <p:blipFill>
-          <a:blip xmlns:r="http://schemas.openxmlformats.org/officeDocument/2006/relationships" xmlns:a="http://schemas.openxmlformats.org/drawingml/2006/main" r:embed="Rbafdc4b9e53646ff"/>
-          <a:stretch xmlns:a="http://schemas.openxmlformats.org/drawingml/2006/main"/>
-        </p:blipFill>
-        <p:spPr>
-          <a:xfrm xmlns:a="http://schemas.openxmlformats.org/drawingml/2006/main">
-            <a:off x="982510" y="7810500"/>
-            <a:ext cx="4511979" cy="2667000"/>
-          </a:xfrm>
-          <a:prstGeom xmlns:a="http://schemas.openxmlformats.org/drawingml/2006/main" prst="rect">
-            <a:avLst/>
-          </a:prstGeom>
-        </p:spPr>
-      </p:pic>
       <p:sp>
         <p:nvSpPr>
           <p:cNvPr id="130" name="Motivation scope">
@@ -3665,6 +3609,7 @@
           </a:lstStyle>
           <a:p xmlns:a="http://schemas.openxmlformats.org/drawingml/2006/main">
             <a:pPr algn="l">
+              <a:buNone/>
               <a:defRPr sz="1725" b="0">
                 <a:solidFill>
                   <a:srgbClr val="344854"/>
@@ -3688,34 +3633,6 @@
           </a:p>
         </p:txBody>
       </p:sp>
-      <p:pic>
-        <p:nvPicPr>
-          <p:cNvPr id="131" name="">
-            <a:extLst xmlns:a="http://schemas.openxmlformats.org/drawingml/2006/main">
-              <a:ext uri="{FF2B5EF4-FFF2-40B4-BE49-F238E27FC236}">
-                <a16:creationId xmlns:a16="http://schemas.microsoft.com/office/drawing/2014/main" id="{9FD7D50C-495C-4B42-B415-9A7DA668154C}"/>
-              </a:ext>
-            </a:extLst>
-          </p:cNvPr>
-          <p:cNvPicPr>
-            <a:picLocks xmlns:a="http://schemas.openxmlformats.org/drawingml/2006/main" noChangeAspect="1"/>
-          </p:cNvPicPr>
-          <p:nvPr/>
-        </p:nvPicPr>
-        <p:blipFill>
-          <a:blip xmlns:r="http://schemas.openxmlformats.org/officeDocument/2006/relationships" xmlns:a="http://schemas.openxmlformats.org/drawingml/2006/main" r:embed="R3f6be4bc225d4b1b"/>
-          <a:stretch xmlns:a="http://schemas.openxmlformats.org/drawingml/2006/main"/>
-        </p:blipFill>
-        <p:spPr>
-          <a:xfrm xmlns:a="http://schemas.openxmlformats.org/drawingml/2006/main">
-            <a:off x="14524596" y="4810125"/>
-            <a:ext cx="14575309" cy="5238750"/>
-          </a:xfrm>
-          <a:prstGeom xmlns:a="http://schemas.openxmlformats.org/drawingml/2006/main" prst="rect">
-            <a:avLst/>
-          </a:prstGeom>
-        </p:spPr>
-      </p:pic>
       <p:sp>
         <p:nvSpPr>
           <p:cNvPr id="132" name="Results banner">
@@ -3763,6 +3680,7 @@
           </a:lstStyle>
           <a:p xmlns:a="http://schemas.openxmlformats.org/drawingml/2006/main">
             <a:pPr algn="l">
+              <a:buNone/>
               <a:defRPr sz="3225" b="1">
                 <a:solidFill>
                   <a:srgbClr val="FFFFFF"/>
@@ -3786,118 +3704,6 @@
           </a:p>
         </p:txBody>
       </p:sp>
-      <p:pic>
-        <p:nvPicPr>
-          <p:cNvPr id="133" name="">
-            <a:extLst xmlns:a="http://schemas.openxmlformats.org/drawingml/2006/main">
-              <a:ext uri="{FF2B5EF4-FFF2-40B4-BE49-F238E27FC236}">
-                <a16:creationId xmlns:a16="http://schemas.microsoft.com/office/drawing/2014/main" id="{A30C5F74-B96C-4684-9C9F-CCD258080F04}"/>
-              </a:ext>
-            </a:extLst>
-          </p:cNvPr>
-          <p:cNvPicPr>
-            <a:picLocks xmlns:a="http://schemas.openxmlformats.org/drawingml/2006/main" noChangeAspect="1"/>
-          </p:cNvPicPr>
-          <p:nvPr/>
-        </p:nvPicPr>
-        <p:blipFill>
-          <a:blip xmlns:r="http://schemas.openxmlformats.org/officeDocument/2006/relationships" xmlns:a="http://schemas.openxmlformats.org/drawingml/2006/main" r:embed="Rb4bca09aeeae445e"/>
-          <a:stretch xmlns:a="http://schemas.openxmlformats.org/drawingml/2006/main"/>
-        </p:blipFill>
-        <p:spPr>
-          <a:xfrm xmlns:a="http://schemas.openxmlformats.org/drawingml/2006/main">
-            <a:off x="1232279" y="13144500"/>
-            <a:ext cx="9041642" cy="3810000"/>
-          </a:xfrm>
-          <a:prstGeom xmlns:a="http://schemas.openxmlformats.org/drawingml/2006/main" prst="rect">
-            <a:avLst/>
-          </a:prstGeom>
-        </p:spPr>
-      </p:pic>
-      <p:pic>
-        <p:nvPicPr>
-          <p:cNvPr id="134" name="">
-            <a:extLst xmlns:a="http://schemas.openxmlformats.org/drawingml/2006/main">
-              <a:ext uri="{FF2B5EF4-FFF2-40B4-BE49-F238E27FC236}">
-                <a16:creationId xmlns:a16="http://schemas.microsoft.com/office/drawing/2014/main" id="{A669B4B7-3B03-49DC-91EA-DF98075C8381}"/>
-              </a:ext>
-            </a:extLst>
-          </p:cNvPr>
-          <p:cNvPicPr>
-            <a:picLocks xmlns:a="http://schemas.openxmlformats.org/drawingml/2006/main" noChangeAspect="1"/>
-          </p:cNvPicPr>
-          <p:nvPr/>
-        </p:nvPicPr>
-        <p:blipFill>
-          <a:blip xmlns:r="http://schemas.openxmlformats.org/officeDocument/2006/relationships" xmlns:a="http://schemas.openxmlformats.org/drawingml/2006/main" r:embed="R1ebe896ff15348c4"/>
-          <a:stretch xmlns:a="http://schemas.openxmlformats.org/drawingml/2006/main"/>
-        </p:blipFill>
-        <p:spPr>
-          <a:xfrm xmlns:a="http://schemas.openxmlformats.org/drawingml/2006/main">
-            <a:off x="666750" y="17129968"/>
-            <a:ext cx="10172700" cy="268189"/>
-          </a:xfrm>
-          <a:prstGeom xmlns:a="http://schemas.openxmlformats.org/drawingml/2006/main" prst="rect">
-            <a:avLst/>
-          </a:prstGeom>
-        </p:spPr>
-      </p:pic>
-      <p:pic>
-        <p:nvPicPr>
-          <p:cNvPr id="135" name="">
-            <a:extLst xmlns:a="http://schemas.openxmlformats.org/drawingml/2006/main">
-              <a:ext uri="{FF2B5EF4-FFF2-40B4-BE49-F238E27FC236}">
-                <a16:creationId xmlns:a16="http://schemas.microsoft.com/office/drawing/2014/main" id="{378BAD28-E066-4BC4-B4E1-4981D03FA366}"/>
-              </a:ext>
-            </a:extLst>
-          </p:cNvPr>
-          <p:cNvPicPr>
-            <a:picLocks xmlns:a="http://schemas.openxmlformats.org/drawingml/2006/main" noChangeAspect="1"/>
-          </p:cNvPicPr>
-          <p:nvPr/>
-        </p:nvPicPr>
-        <p:blipFill>
-          <a:blip xmlns:r="http://schemas.openxmlformats.org/officeDocument/2006/relationships" xmlns:a="http://schemas.openxmlformats.org/drawingml/2006/main" r:embed="R77f436eac8e94bf6"/>
-          <a:stretch xmlns:a="http://schemas.openxmlformats.org/drawingml/2006/main"/>
-        </p:blipFill>
-        <p:spPr>
-          <a:xfrm xmlns:a="http://schemas.openxmlformats.org/drawingml/2006/main">
-            <a:off x="1681598" y="18192750"/>
-            <a:ext cx="8143003" cy="3333750"/>
-          </a:xfrm>
-          <a:prstGeom xmlns:a="http://schemas.openxmlformats.org/drawingml/2006/main" prst="rect">
-            <a:avLst/>
-          </a:prstGeom>
-        </p:spPr>
-      </p:pic>
-      <p:pic>
-        <p:nvPicPr>
-          <p:cNvPr id="136" name="">
-            <a:extLst xmlns:a="http://schemas.openxmlformats.org/drawingml/2006/main">
-              <a:ext uri="{FF2B5EF4-FFF2-40B4-BE49-F238E27FC236}">
-                <a16:creationId xmlns:a16="http://schemas.microsoft.com/office/drawing/2014/main" id="{B1602355-EBCE-475D-B786-0C4FC77BF84F}"/>
-              </a:ext>
-            </a:extLst>
-          </p:cNvPr>
-          <p:cNvPicPr>
-            <a:picLocks xmlns:a="http://schemas.openxmlformats.org/drawingml/2006/main" noChangeAspect="1"/>
-          </p:cNvPicPr>
-          <p:nvPr/>
-        </p:nvPicPr>
-        <p:blipFill>
-          <a:blip xmlns:r="http://schemas.openxmlformats.org/officeDocument/2006/relationships" xmlns:a="http://schemas.openxmlformats.org/drawingml/2006/main" r:embed="R11a6d1747a074698"/>
-          <a:stretch xmlns:a="http://schemas.openxmlformats.org/drawingml/2006/main"/>
-        </p:blipFill>
-        <p:spPr>
-          <a:xfrm xmlns:a="http://schemas.openxmlformats.org/drawingml/2006/main">
-            <a:off x="666750" y="21634601"/>
-            <a:ext cx="10172700" cy="212423"/>
-          </a:xfrm>
-          <a:prstGeom xmlns:a="http://schemas.openxmlformats.org/drawingml/2006/main" prst="rect">
-            <a:avLst/>
-          </a:prstGeom>
-        </p:spPr>
-      </p:pic>
       <p:sp>
         <p:nvSpPr>
           <p:cNvPr id="137" name="Retention heading">
@@ -3943,6 +3749,7 @@
           </a:lstStyle>
           <a:p xmlns:a="http://schemas.openxmlformats.org/drawingml/2006/main">
             <a:pPr algn="l">
+              <a:buNone/>
               <a:defRPr sz="2600" b="1">
                 <a:solidFill>
                   <a:srgbClr val="183B66"/>
@@ -3983,7 +3790,7 @@
         <p:spPr>
           <a:xfrm xmlns:a="http://schemas.openxmlformats.org/drawingml/2006/main">
             <a:off x="11372850" y="12334875"/>
-            <a:ext cx="10172700" cy="666750"/>
+            <a:ext cx="10172700" cy="714375"/>
           </a:xfrm>
           <a:prstGeom xmlns:a="http://schemas.openxmlformats.org/drawingml/2006/main" prst="rect">
             <a:avLst/>
@@ -4011,6 +3818,7 @@
           </a:lstStyle>
           <a:p xmlns:a="http://schemas.openxmlformats.org/drawingml/2006/main">
             <a:pPr algn="l">
+              <a:buNone/>
               <a:defRPr sz="2025" b="0">
                 <a:solidFill>
                   <a:srgbClr val="344854"/>
@@ -4029,131 +3837,7 @@
                 <a:ea typeface="Arial"/>
                 <a:cs typeface="Arial"/>
               </a:rPr>
-              <a:t>MMLU, 70B: BFT preserves more broad knowledge than SFT while adding biomedical capability.</a:t>
-            </a:r>
-          </a:p>
-        </p:txBody>
-      </p:sp>
-      <p:pic>
-        <p:nvPicPr>
-          <p:cNvPr id="139" name="">
-            <a:extLst xmlns:a="http://schemas.openxmlformats.org/drawingml/2006/main">
-              <a:ext uri="{FF2B5EF4-FFF2-40B4-BE49-F238E27FC236}">
-                <a16:creationId xmlns:a16="http://schemas.microsoft.com/office/drawing/2014/main" id="{15D5A681-40C1-49B5-BD28-E17965A7D9F8}"/>
-              </a:ext>
-            </a:extLst>
-          </p:cNvPr>
-          <p:cNvPicPr>
-            <a:picLocks xmlns:a="http://schemas.openxmlformats.org/drawingml/2006/main" noChangeAspect="1"/>
-          </p:cNvPicPr>
-          <p:nvPr/>
-        </p:nvPicPr>
-        <p:blipFill>
-          <a:blip xmlns:r="http://schemas.openxmlformats.org/officeDocument/2006/relationships" xmlns:a="http://schemas.openxmlformats.org/drawingml/2006/main" r:embed="R848db29787f344ea"/>
-          <a:stretch xmlns:a="http://schemas.openxmlformats.org/drawingml/2006/main"/>
-        </p:blipFill>
-        <p:spPr>
-          <a:xfrm xmlns:a="http://schemas.openxmlformats.org/drawingml/2006/main">
-            <a:off x="11384207" y="13239750"/>
-            <a:ext cx="8121162" cy="6477000"/>
-          </a:xfrm>
-          <a:prstGeom xmlns:a="http://schemas.openxmlformats.org/drawingml/2006/main" prst="rect">
-            <a:avLst/>
-          </a:prstGeom>
-        </p:spPr>
-      </p:pic>
-      <p:pic>
-        <p:nvPicPr>
-          <p:cNvPr id="140" name="">
-            <a:extLst xmlns:a="http://schemas.openxmlformats.org/drawingml/2006/main">
-              <a:ext uri="{FF2B5EF4-FFF2-40B4-BE49-F238E27FC236}">
-                <a16:creationId xmlns:a16="http://schemas.microsoft.com/office/drawing/2014/main" id="{DDC51E73-0540-41F6-BE74-08F562E96039}"/>
-              </a:ext>
-            </a:extLst>
-          </p:cNvPr>
-          <p:cNvPicPr>
-            <a:picLocks xmlns:a="http://schemas.openxmlformats.org/drawingml/2006/main" noChangeAspect="1"/>
-          </p:cNvPicPr>
-          <p:nvPr/>
-        </p:nvPicPr>
-        <p:blipFill>
-          <a:blip xmlns:r="http://schemas.openxmlformats.org/officeDocument/2006/relationships" xmlns:a="http://schemas.openxmlformats.org/drawingml/2006/main" r:embed="Rb7e1a2a8b1ca41e6"/>
-          <a:stretch xmlns:a="http://schemas.openxmlformats.org/drawingml/2006/main"/>
-        </p:blipFill>
-        <p:spPr>
-          <a:xfrm xmlns:a="http://schemas.openxmlformats.org/drawingml/2006/main">
-            <a:off x="19707225" y="15149868"/>
-            <a:ext cx="1838325" cy="2085264"/>
-          </a:xfrm>
-          <a:prstGeom xmlns:a="http://schemas.openxmlformats.org/drawingml/2006/main" prst="rect">
-            <a:avLst/>
-          </a:prstGeom>
-        </p:spPr>
-      </p:pic>
-      <p:sp>
-        <p:nvSpPr>
-          <p:cNvPr id="141" name="Retention categories">
-            <a:extLst xmlns:a="http://schemas.openxmlformats.org/drawingml/2006/main">
-              <a:ext uri="{FF2B5EF4-FFF2-40B4-BE49-F238E27FC236}">
-                <a16:creationId xmlns:a16="http://schemas.microsoft.com/office/drawing/2014/main" id="{86F04A25-518E-4DFB-8073-F1560376E99C}"/>
-              </a:ext>
-            </a:extLst>
-          </p:cNvPr>
-          <p:cNvSpPr>
-            <a:spLocks xmlns:a="http://schemas.openxmlformats.org/drawingml/2006/main" noGrp="1"/>
-          </p:cNvSpPr>
-          <p:nvPr/>
-        </p:nvSpPr>
-        <p:spPr>
-          <a:xfrm xmlns:a="http://schemas.openxmlformats.org/drawingml/2006/main">
-            <a:off x="11372850" y="19907250"/>
-            <a:ext cx="10172700" cy="333375"/>
-          </a:xfrm>
-          <a:prstGeom xmlns:a="http://schemas.openxmlformats.org/drawingml/2006/main" prst="rect">
-            <a:avLst/>
-          </a:prstGeom>
-          <a:noFill xmlns:a="http://schemas.openxmlformats.org/drawingml/2006/main"/>
-          <a:ln xmlns:a="http://schemas.openxmlformats.org/drawingml/2006/main" w="0">
-            <a:noFill/>
-          </a:ln>
-        </p:spPr>
-        <p:txBody>
-          <a:bodyPr xmlns:a="http://schemas.openxmlformats.org/drawingml/2006/main" wrap="square" lIns="0" tIns="0" rIns="0" bIns="0" anchor="t">
-            <a:noAutofit/>
-          </a:bodyPr>
-          <a:lstStyle xmlns:a="http://schemas.openxmlformats.org/drawingml/2006/main">
-            <a:defPPr algn="l">
-              <a:defRPr sz="1725" b="0">
-                <a:solidFill>
-                  <a:srgbClr val="344854"/>
-                </a:solidFill>
-                <a:latin typeface="Arial"/>
-                <a:ea typeface="Arial"/>
-                <a:cs typeface="Arial"/>
-              </a:defRPr>
-            </a:defPPr>
-          </a:lstStyle>
-          <a:p xmlns:a="http://schemas.openxmlformats.org/drawingml/2006/main">
-            <a:pPr algn="l">
-              <a:defRPr sz="1725" b="0">
-                <a:solidFill>
-                  <a:srgbClr val="344854"/>
-                </a:solidFill>
-                <a:latin typeface="Arial"/>
-                <a:ea typeface="Arial"/>
-                <a:cs typeface="Arial"/>
-              </a:defRPr>
-            </a:pPr>
-            <a:r>
-              <a:rPr sz="1725" b="0">
-                <a:solidFill>
-                  <a:srgbClr val="344854"/>
-                </a:solidFill>
-                <a:latin typeface="Arial"/>
-                <a:ea typeface="Arial"/>
-                <a:cs typeface="Arial"/>
-              </a:rPr>
-              <a:t>Categories: average, STEM, social sciences, humanities, other.</a:t>
+              <a:t>MMLU and CMMLU (70B): BFT preserves more general knowledge than SFT while improving biomedical skills.</a:t>
             </a:r>
           </a:p>
         </p:txBody>
@@ -4174,8 +3858,8 @@
         </p:nvSpPr>
         <p:spPr>
           <a:xfrm xmlns:a="http://schemas.openxmlformats.org/drawingml/2006/main">
-            <a:off x="11372850" y="21240750"/>
-            <a:ext cx="10172700" cy="619125"/>
+            <a:off x="11372850" y="21478875"/>
+            <a:ext cx="10172700" cy="428625"/>
           </a:xfrm>
           <a:prstGeom xmlns:a="http://schemas.openxmlformats.org/drawingml/2006/main" prst="rect">
             <a:avLst/>
@@ -4203,6 +3887,7 @@
           </a:lstStyle>
           <a:p xmlns:a="http://schemas.openxmlformats.org/drawingml/2006/main">
             <a:pPr algn="l">
+              <a:buNone/>
               <a:defRPr sz="2100" b="1">
                 <a:solidFill>
                   <a:srgbClr val="0054B8"/>
@@ -4221,7 +3906,7 @@
                 <a:ea typeface="Arial"/>
                 <a:cs typeface="Arial"/>
               </a:rPr>
-              <a:t>A simple training method for STEM adaptation, demonstrated in medicine and biology.</a:t>
+              <a:t>STEM adaptation demonstrated in biomedicine.</a:t>
             </a:r>
           </a:p>
         </p:txBody>
@@ -4231,7 +3916,7 @@
           <p:cNvPr id="143" name="">
             <a:extLst xmlns:a="http://schemas.openxmlformats.org/drawingml/2006/main">
               <a:ext uri="{FF2B5EF4-FFF2-40B4-BE49-F238E27FC236}">
-                <a16:creationId xmlns:a16="http://schemas.microsoft.com/office/drawing/2014/main" id="{A2803D23-BE70-440B-8863-8798E7168990}"/>
+                <a16:creationId xmlns:a16="http://schemas.microsoft.com/office/drawing/2014/main" id="{78610EAA-DB01-415C-A971-7426985C802C}"/>
               </a:ext>
             </a:extLst>
           </p:cNvPr>
@@ -4241,13 +3926,13 @@
           <p:nvPr/>
         </p:nvPicPr>
         <p:blipFill>
-          <a:blip xmlns:r="http://schemas.openxmlformats.org/officeDocument/2006/relationships" xmlns:a="http://schemas.openxmlformats.org/drawingml/2006/main" r:embed="R402613dc89cd4aaa"/>
+          <a:blip xmlns:r="http://schemas.openxmlformats.org/officeDocument/2006/relationships" xmlns:a="http://schemas.openxmlformats.org/drawingml/2006/main" r:embed="Ra77c4f077bd94dbf"/>
           <a:stretch xmlns:a="http://schemas.openxmlformats.org/drawingml/2006/main"/>
         </p:blipFill>
         <p:spPr>
           <a:xfrm xmlns:a="http://schemas.openxmlformats.org/drawingml/2006/main">
-            <a:off x="22628469" y="13096875"/>
-            <a:ext cx="9073662" cy="4572000"/>
+            <a:off x="2388747" y="5048250"/>
+            <a:ext cx="6728707" cy="1762125"/>
           </a:xfrm>
           <a:prstGeom xmlns:a="http://schemas.openxmlformats.org/drawingml/2006/main" prst="rect">
             <a:avLst/>
@@ -4259,7 +3944,7 @@
           <p:cNvPr id="144" name="">
             <a:extLst xmlns:a="http://schemas.openxmlformats.org/drawingml/2006/main">
               <a:ext uri="{FF2B5EF4-FFF2-40B4-BE49-F238E27FC236}">
-                <a16:creationId xmlns:a16="http://schemas.microsoft.com/office/drawing/2014/main" id="{2177B992-79B5-400C-92E7-F1762F9A6BE1}"/>
+                <a16:creationId xmlns:a16="http://schemas.microsoft.com/office/drawing/2014/main" id="{7D939B78-A8B4-4F87-9259-7C55918F5E77}"/>
               </a:ext>
             </a:extLst>
           </p:cNvPr>
@@ -4269,7 +3954,423 @@
           <p:nvPr/>
         </p:nvPicPr>
         <p:blipFill>
-          <a:blip xmlns:r="http://schemas.openxmlformats.org/officeDocument/2006/relationships" xmlns:a="http://schemas.openxmlformats.org/drawingml/2006/main" r:embed="R5d21b097dbfe45b6"/>
+          <a:blip xmlns:r="http://schemas.openxmlformats.org/officeDocument/2006/relationships" xmlns:a="http://schemas.openxmlformats.org/drawingml/2006/main" r:embed="Rde959627e0b047bb"/>
+          <a:stretch xmlns:a="http://schemas.openxmlformats.org/drawingml/2006/main"/>
+        </p:blipFill>
+        <p:spPr>
+          <a:xfrm xmlns:a="http://schemas.openxmlformats.org/drawingml/2006/main">
+            <a:off x="982510" y="7810500"/>
+            <a:ext cx="4511979" cy="2667000"/>
+          </a:xfrm>
+          <a:prstGeom xmlns:a="http://schemas.openxmlformats.org/drawingml/2006/main" prst="rect">
+            <a:avLst/>
+          </a:prstGeom>
+        </p:spPr>
+      </p:pic>
+      <p:pic>
+        <p:nvPicPr>
+          <p:cNvPr id="145" name="">
+            <a:extLst xmlns:a="http://schemas.openxmlformats.org/drawingml/2006/main">
+              <a:ext uri="{FF2B5EF4-FFF2-40B4-BE49-F238E27FC236}">
+                <a16:creationId xmlns:a16="http://schemas.microsoft.com/office/drawing/2014/main" id="{CA287500-86EA-43D3-A5E0-3F8536317FA7}"/>
+              </a:ext>
+            </a:extLst>
+          </p:cNvPr>
+          <p:cNvPicPr>
+            <a:picLocks xmlns:a="http://schemas.openxmlformats.org/drawingml/2006/main" noChangeAspect="1"/>
+          </p:cNvPicPr>
+          <p:nvPr/>
+        </p:nvPicPr>
+        <p:blipFill>
+          <a:blip xmlns:r="http://schemas.openxmlformats.org/officeDocument/2006/relationships" xmlns:a="http://schemas.openxmlformats.org/drawingml/2006/main" r:embed="Rcf7d04324f7d4445"/>
+          <a:stretch xmlns:a="http://schemas.openxmlformats.org/drawingml/2006/main"/>
+        </p:blipFill>
+        <p:spPr>
+          <a:xfrm xmlns:a="http://schemas.openxmlformats.org/drawingml/2006/main">
+            <a:off x="14524596" y="4810125"/>
+            <a:ext cx="14575309" cy="5238750"/>
+          </a:xfrm>
+          <a:prstGeom xmlns:a="http://schemas.openxmlformats.org/drawingml/2006/main" prst="rect">
+            <a:avLst/>
+          </a:prstGeom>
+        </p:spPr>
+      </p:pic>
+      <p:pic>
+        <p:nvPicPr>
+          <p:cNvPr id="146" name="">
+            <a:extLst xmlns:a="http://schemas.openxmlformats.org/drawingml/2006/main">
+              <a:ext uri="{FF2B5EF4-FFF2-40B4-BE49-F238E27FC236}">
+                <a16:creationId xmlns:a16="http://schemas.microsoft.com/office/drawing/2014/main" id="{16560DE0-FD30-4F06-BD78-CDC867BC0C3D}"/>
+              </a:ext>
+            </a:extLst>
+          </p:cNvPr>
+          <p:cNvPicPr>
+            <a:picLocks xmlns:a="http://schemas.openxmlformats.org/drawingml/2006/main" noChangeAspect="1"/>
+          </p:cNvPicPr>
+          <p:nvPr/>
+        </p:nvPicPr>
+        <p:blipFill>
+          <a:blip xmlns:r="http://schemas.openxmlformats.org/officeDocument/2006/relationships" xmlns:a="http://schemas.openxmlformats.org/drawingml/2006/main" r:embed="Rf4aa805f896c48d8"/>
+          <a:stretch xmlns:a="http://schemas.openxmlformats.org/drawingml/2006/main"/>
+        </p:blipFill>
+        <p:spPr>
+          <a:xfrm xmlns:a="http://schemas.openxmlformats.org/drawingml/2006/main">
+            <a:off x="2683218" y="12954000"/>
+            <a:ext cx="6139764" cy="4286250"/>
+          </a:xfrm>
+          <a:prstGeom xmlns:a="http://schemas.openxmlformats.org/drawingml/2006/main" prst="rect">
+            <a:avLst/>
+          </a:prstGeom>
+        </p:spPr>
+      </p:pic>
+      <p:pic>
+        <p:nvPicPr>
+          <p:cNvPr id="147" name="">
+            <a:extLst xmlns:a="http://schemas.openxmlformats.org/drawingml/2006/main">
+              <a:ext uri="{FF2B5EF4-FFF2-40B4-BE49-F238E27FC236}">
+                <a16:creationId xmlns:a16="http://schemas.microsoft.com/office/drawing/2014/main" id="{3BB69827-D364-4F9C-8454-1AFE0BC4E1CD}"/>
+              </a:ext>
+            </a:extLst>
+          </p:cNvPr>
+          <p:cNvPicPr>
+            <a:picLocks xmlns:a="http://schemas.openxmlformats.org/drawingml/2006/main" noChangeAspect="1"/>
+          </p:cNvPicPr>
+          <p:nvPr/>
+        </p:nvPicPr>
+        <p:blipFill>
+          <a:blip xmlns:r="http://schemas.openxmlformats.org/officeDocument/2006/relationships" xmlns:a="http://schemas.openxmlformats.org/drawingml/2006/main" r:embed="Red9660fbf4754542"/>
+          <a:stretch xmlns:a="http://schemas.openxmlformats.org/drawingml/2006/main"/>
+        </p:blipFill>
+        <p:spPr>
+          <a:xfrm xmlns:a="http://schemas.openxmlformats.org/drawingml/2006/main">
+            <a:off x="666750" y="17368093"/>
+            <a:ext cx="10172700" cy="268189"/>
+          </a:xfrm>
+          <a:prstGeom xmlns:a="http://schemas.openxmlformats.org/drawingml/2006/main" prst="rect">
+            <a:avLst/>
+          </a:prstGeom>
+        </p:spPr>
+      </p:pic>
+      <p:pic>
+        <p:nvPicPr>
+          <p:cNvPr id="148" name="">
+            <a:extLst xmlns:a="http://schemas.openxmlformats.org/drawingml/2006/main">
+              <a:ext uri="{FF2B5EF4-FFF2-40B4-BE49-F238E27FC236}">
+                <a16:creationId xmlns:a16="http://schemas.microsoft.com/office/drawing/2014/main" id="{78B137A6-BAB0-45D7-9308-1EF773AE69B9}"/>
+              </a:ext>
+            </a:extLst>
+          </p:cNvPr>
+          <p:cNvPicPr>
+            <a:picLocks xmlns:a="http://schemas.openxmlformats.org/drawingml/2006/main" noChangeAspect="1"/>
+          </p:cNvPicPr>
+          <p:nvPr/>
+        </p:nvPicPr>
+        <p:blipFill>
+          <a:blip xmlns:r="http://schemas.openxmlformats.org/officeDocument/2006/relationships" xmlns:a="http://schemas.openxmlformats.org/drawingml/2006/main" r:embed="Reb46a3f0548a4319"/>
+          <a:stretch xmlns:a="http://schemas.openxmlformats.org/drawingml/2006/main"/>
+        </p:blipFill>
+        <p:spPr>
+          <a:xfrm xmlns:a="http://schemas.openxmlformats.org/drawingml/2006/main">
+            <a:off x="2030584" y="18383250"/>
+            <a:ext cx="7445032" cy="3048000"/>
+          </a:xfrm>
+          <a:prstGeom xmlns:a="http://schemas.openxmlformats.org/drawingml/2006/main" prst="rect">
+            <a:avLst/>
+          </a:prstGeom>
+        </p:spPr>
+      </p:pic>
+      <p:pic>
+        <p:nvPicPr>
+          <p:cNvPr id="149" name="">
+            <a:extLst xmlns:a="http://schemas.openxmlformats.org/drawingml/2006/main">
+              <a:ext uri="{FF2B5EF4-FFF2-40B4-BE49-F238E27FC236}">
+                <a16:creationId xmlns:a16="http://schemas.microsoft.com/office/drawing/2014/main" id="{74F0A866-7F9B-45B1-9751-75D35C2C1544}"/>
+              </a:ext>
+            </a:extLst>
+          </p:cNvPr>
+          <p:cNvPicPr>
+            <a:picLocks xmlns:a="http://schemas.openxmlformats.org/drawingml/2006/main" noChangeAspect="1"/>
+          </p:cNvPicPr>
+          <p:nvPr/>
+        </p:nvPicPr>
+        <p:blipFill>
+          <a:blip xmlns:r="http://schemas.openxmlformats.org/officeDocument/2006/relationships" xmlns:a="http://schemas.openxmlformats.org/drawingml/2006/main" r:embed="R4d100548f1a2423e"/>
+          <a:stretch xmlns:a="http://schemas.openxmlformats.org/drawingml/2006/main"/>
+        </p:blipFill>
+        <p:spPr>
+          <a:xfrm xmlns:a="http://schemas.openxmlformats.org/drawingml/2006/main">
+            <a:off x="666750" y="21610789"/>
+            <a:ext cx="10172700" cy="212423"/>
+          </a:xfrm>
+          <a:prstGeom xmlns:a="http://schemas.openxmlformats.org/drawingml/2006/main" prst="rect">
+            <a:avLst/>
+          </a:prstGeom>
+        </p:spPr>
+      </p:pic>
+      <p:sp>
+        <p:nvSpPr>
+          <p:cNvPr id="150" name="MMLU heading">
+            <a:extLst xmlns:a="http://schemas.openxmlformats.org/drawingml/2006/main">
+              <a:ext uri="{FF2B5EF4-FFF2-40B4-BE49-F238E27FC236}">
+                <a16:creationId xmlns:a16="http://schemas.microsoft.com/office/drawing/2014/main" id="{712472B8-3C56-448E-83C3-EB92C59BC5F5}"/>
+              </a:ext>
+            </a:extLst>
+          </p:cNvPr>
+          <p:cNvSpPr>
+            <a:spLocks xmlns:a="http://schemas.openxmlformats.org/drawingml/2006/main" noGrp="1"/>
+          </p:cNvSpPr>
+          <p:nvPr/>
+        </p:nvSpPr>
+        <p:spPr>
+          <a:xfrm xmlns:a="http://schemas.openxmlformats.org/drawingml/2006/main">
+            <a:off x="11372850" y="13239750"/>
+            <a:ext cx="4895850" cy="381000"/>
+          </a:xfrm>
+          <a:prstGeom xmlns:a="http://schemas.openxmlformats.org/drawingml/2006/main" prst="rect">
+            <a:avLst/>
+          </a:prstGeom>
+          <a:noFill xmlns:a="http://schemas.openxmlformats.org/drawingml/2006/main"/>
+          <a:ln xmlns:a="http://schemas.openxmlformats.org/drawingml/2006/main" w="0">
+            <a:noFill/>
+          </a:ln>
+        </p:spPr>
+        <p:txBody>
+          <a:bodyPr xmlns:a="http://schemas.openxmlformats.org/drawingml/2006/main" wrap="square" lIns="0" tIns="0" rIns="0" bIns="0" anchor="t">
+            <a:noAutofit/>
+          </a:bodyPr>
+          <a:lstStyle xmlns:a="http://schemas.openxmlformats.org/drawingml/2006/main">
+            <a:defPPr algn="l">
+              <a:defRPr sz="2400" b="1">
+                <a:solidFill>
+                  <a:srgbClr val="183B66"/>
+                </a:solidFill>
+                <a:latin typeface="Arial"/>
+                <a:ea typeface="Arial"/>
+                <a:cs typeface="Arial"/>
+              </a:defRPr>
+            </a:defPPr>
+          </a:lstStyle>
+          <a:p xmlns:a="http://schemas.openxmlformats.org/drawingml/2006/main">
+            <a:pPr algn="l">
+              <a:defRPr sz="2400" b="1">
+                <a:solidFill>
+                  <a:srgbClr val="183B66"/>
+                </a:solidFill>
+                <a:latin typeface="Arial"/>
+                <a:ea typeface="Arial"/>
+                <a:cs typeface="Arial"/>
+              </a:defRPr>
+            </a:pPr>
+            <a:r>
+              <a:rPr sz="2400" b="1">
+                <a:solidFill>
+                  <a:srgbClr val="183B66"/>
+                </a:solidFill>
+                <a:latin typeface="Arial"/>
+                <a:ea typeface="Arial"/>
+                <a:cs typeface="Arial"/>
+              </a:rPr>
+              <a:t>MMLU</a:t>
+            </a:r>
+          </a:p>
+        </p:txBody>
+      </p:sp>
+      <p:sp>
+        <p:nvSpPr>
+          <p:cNvPr id="151" name="CMMLU heading">
+            <a:extLst xmlns:a="http://schemas.openxmlformats.org/drawingml/2006/main">
+              <a:ext uri="{FF2B5EF4-FFF2-40B4-BE49-F238E27FC236}">
+                <a16:creationId xmlns:a16="http://schemas.microsoft.com/office/drawing/2014/main" id="{C873389F-B5C6-4CA8-BBE1-0B7446E54773}"/>
+              </a:ext>
+            </a:extLst>
+          </p:cNvPr>
+          <p:cNvSpPr>
+            <a:spLocks xmlns:a="http://schemas.openxmlformats.org/drawingml/2006/main" noGrp="1"/>
+          </p:cNvSpPr>
+          <p:nvPr/>
+        </p:nvSpPr>
+        <p:spPr>
+          <a:xfrm xmlns:a="http://schemas.openxmlformats.org/drawingml/2006/main">
+            <a:off x="16649700" y="13239750"/>
+            <a:ext cx="4895850" cy="381000"/>
+          </a:xfrm>
+          <a:prstGeom xmlns:a="http://schemas.openxmlformats.org/drawingml/2006/main" prst="rect">
+            <a:avLst/>
+          </a:prstGeom>
+          <a:noFill xmlns:a="http://schemas.openxmlformats.org/drawingml/2006/main"/>
+          <a:ln xmlns:a="http://schemas.openxmlformats.org/drawingml/2006/main" w="0">
+            <a:noFill/>
+          </a:ln>
+        </p:spPr>
+        <p:txBody>
+          <a:bodyPr xmlns:a="http://schemas.openxmlformats.org/drawingml/2006/main" wrap="square" lIns="0" tIns="0" rIns="0" bIns="0" anchor="t">
+            <a:noAutofit/>
+          </a:bodyPr>
+          <a:lstStyle xmlns:a="http://schemas.openxmlformats.org/drawingml/2006/main">
+            <a:defPPr algn="l">
+              <a:defRPr sz="2400" b="1">
+                <a:solidFill>
+                  <a:srgbClr val="183B66"/>
+                </a:solidFill>
+                <a:latin typeface="Arial"/>
+                <a:ea typeface="Arial"/>
+                <a:cs typeface="Arial"/>
+              </a:defRPr>
+            </a:defPPr>
+          </a:lstStyle>
+          <a:p xmlns:a="http://schemas.openxmlformats.org/drawingml/2006/main">
+            <a:pPr algn="l">
+              <a:defRPr sz="2400" b="1">
+                <a:solidFill>
+                  <a:srgbClr val="183B66"/>
+                </a:solidFill>
+                <a:latin typeface="Arial"/>
+                <a:ea typeface="Arial"/>
+                <a:cs typeface="Arial"/>
+              </a:defRPr>
+            </a:pPr>
+            <a:r>
+              <a:rPr sz="2400" b="1">
+                <a:solidFill>
+                  <a:srgbClr val="183B66"/>
+                </a:solidFill>
+                <a:latin typeface="Arial"/>
+                <a:ea typeface="Arial"/>
+                <a:cs typeface="Arial"/>
+              </a:rPr>
+              <a:t>CMMLU</a:t>
+            </a:r>
+          </a:p>
+        </p:txBody>
+      </p:sp>
+      <p:pic>
+        <p:nvPicPr>
+          <p:cNvPr id="152" name="">
+            <a:extLst xmlns:a="http://schemas.openxmlformats.org/drawingml/2006/main">
+              <a:ext uri="{FF2B5EF4-FFF2-40B4-BE49-F238E27FC236}">
+                <a16:creationId xmlns:a16="http://schemas.microsoft.com/office/drawing/2014/main" id="{63D89639-9B35-4961-9F0C-304DAC532884}"/>
+              </a:ext>
+            </a:extLst>
+          </p:cNvPr>
+          <p:cNvPicPr>
+            <a:picLocks xmlns:a="http://schemas.openxmlformats.org/drawingml/2006/main" noChangeAspect="1"/>
+          </p:cNvPicPr>
+          <p:nvPr/>
+        </p:nvPicPr>
+        <p:blipFill>
+          <a:blip xmlns:r="http://schemas.openxmlformats.org/officeDocument/2006/relationships" xmlns:a="http://schemas.openxmlformats.org/drawingml/2006/main" r:embed="R452e75a7a7414e62"/>
+          <a:stretch xmlns:a="http://schemas.openxmlformats.org/drawingml/2006/main"/>
+        </p:blipFill>
+        <p:spPr>
+          <a:xfrm xmlns:a="http://schemas.openxmlformats.org/drawingml/2006/main">
+            <a:off x="11372850" y="13781141"/>
+            <a:ext cx="4895850" cy="5203718"/>
+          </a:xfrm>
+          <a:prstGeom xmlns:a="http://schemas.openxmlformats.org/drawingml/2006/main" prst="rect">
+            <a:avLst/>
+          </a:prstGeom>
+        </p:spPr>
+      </p:pic>
+      <p:pic>
+        <p:nvPicPr>
+          <p:cNvPr id="153" name="">
+            <a:extLst xmlns:a="http://schemas.openxmlformats.org/drawingml/2006/main">
+              <a:ext uri="{FF2B5EF4-FFF2-40B4-BE49-F238E27FC236}">
+                <a16:creationId xmlns:a16="http://schemas.microsoft.com/office/drawing/2014/main" id="{C1C076F4-D632-4D0E-AFBA-782D3BCDDE65}"/>
+              </a:ext>
+            </a:extLst>
+          </p:cNvPr>
+          <p:cNvPicPr>
+            <a:picLocks xmlns:a="http://schemas.openxmlformats.org/drawingml/2006/main" noChangeAspect="1"/>
+          </p:cNvPicPr>
+          <p:nvPr/>
+        </p:nvPicPr>
+        <p:blipFill>
+          <a:blip xmlns:r="http://schemas.openxmlformats.org/officeDocument/2006/relationships" xmlns:a="http://schemas.openxmlformats.org/drawingml/2006/main" r:embed="Rca47ef9f77e14748"/>
+          <a:stretch xmlns:a="http://schemas.openxmlformats.org/drawingml/2006/main"/>
+        </p:blipFill>
+        <p:spPr>
+          <a:xfrm xmlns:a="http://schemas.openxmlformats.org/drawingml/2006/main">
+            <a:off x="16649700" y="13856231"/>
+            <a:ext cx="4895850" cy="5053538"/>
+          </a:xfrm>
+          <a:prstGeom xmlns:a="http://schemas.openxmlformats.org/drawingml/2006/main" prst="rect">
+            <a:avLst/>
+          </a:prstGeom>
+        </p:spPr>
+      </p:pic>
+      <p:pic>
+        <p:nvPicPr>
+          <p:cNvPr id="154" name="">
+            <a:extLst xmlns:a="http://schemas.openxmlformats.org/drawingml/2006/main">
+              <a:ext uri="{FF2B5EF4-FFF2-40B4-BE49-F238E27FC236}">
+                <a16:creationId xmlns:a16="http://schemas.microsoft.com/office/drawing/2014/main" id="{6F328951-CC89-476D-9FD2-CA9F579AE454}"/>
+              </a:ext>
+            </a:extLst>
+          </p:cNvPr>
+          <p:cNvPicPr>
+            <a:picLocks xmlns:a="http://schemas.openxmlformats.org/drawingml/2006/main" noChangeAspect="1"/>
+          </p:cNvPicPr>
+          <p:nvPr/>
+        </p:nvPicPr>
+        <p:blipFill>
+          <a:blip xmlns:r="http://schemas.openxmlformats.org/officeDocument/2006/relationships" xmlns:a="http://schemas.openxmlformats.org/drawingml/2006/main" r:embed="R28802150e800448c"/>
+          <a:stretch xmlns:a="http://schemas.openxmlformats.org/drawingml/2006/main"/>
+        </p:blipFill>
+        <p:spPr>
+          <a:xfrm xmlns:a="http://schemas.openxmlformats.org/drawingml/2006/main">
+            <a:off x="12302665" y="19240500"/>
+            <a:ext cx="8313069" cy="1047750"/>
+          </a:xfrm>
+          <a:prstGeom xmlns:a="http://schemas.openxmlformats.org/drawingml/2006/main" prst="rect">
+            <a:avLst/>
+          </a:prstGeom>
+        </p:spPr>
+      </p:pic>
+      <p:pic>
+        <p:nvPicPr>
+          <p:cNvPr id="155" name="">
+            <a:extLst xmlns:a="http://schemas.openxmlformats.org/drawingml/2006/main">
+              <a:ext uri="{FF2B5EF4-FFF2-40B4-BE49-F238E27FC236}">
+                <a16:creationId xmlns:a16="http://schemas.microsoft.com/office/drawing/2014/main" id="{F9B3533D-53A6-46D5-9DEE-87564DDE8633}"/>
+              </a:ext>
+            </a:extLst>
+          </p:cNvPr>
+          <p:cNvPicPr>
+            <a:picLocks xmlns:a="http://schemas.openxmlformats.org/drawingml/2006/main" noChangeAspect="1"/>
+          </p:cNvPicPr>
+          <p:nvPr/>
+        </p:nvPicPr>
+        <p:blipFill>
+          <a:blip xmlns:r="http://schemas.openxmlformats.org/officeDocument/2006/relationships" xmlns:a="http://schemas.openxmlformats.org/drawingml/2006/main" r:embed="Rfafdb010594a4b1a"/>
+          <a:stretch xmlns:a="http://schemas.openxmlformats.org/drawingml/2006/main"/>
+        </p:blipFill>
+        <p:spPr>
+          <a:xfrm xmlns:a="http://schemas.openxmlformats.org/drawingml/2006/main">
+            <a:off x="22628469" y="13096875"/>
+            <a:ext cx="9073662" cy="4572000"/>
+          </a:xfrm>
+          <a:prstGeom xmlns:a="http://schemas.openxmlformats.org/drawingml/2006/main" prst="rect">
+            <a:avLst/>
+          </a:prstGeom>
+        </p:spPr>
+      </p:pic>
+      <p:pic>
+        <p:nvPicPr>
+          <p:cNvPr id="156" name="">
+            <a:extLst xmlns:a="http://schemas.openxmlformats.org/drawingml/2006/main">
+              <a:ext uri="{FF2B5EF4-FFF2-40B4-BE49-F238E27FC236}">
+                <a16:creationId xmlns:a16="http://schemas.microsoft.com/office/drawing/2014/main" id="{44294CA8-DEE7-474E-A6EB-564B7AA509F0}"/>
+              </a:ext>
+            </a:extLst>
+          </p:cNvPr>
+          <p:cNvPicPr>
+            <a:picLocks xmlns:a="http://schemas.openxmlformats.org/drawingml/2006/main" noChangeAspect="1"/>
+          </p:cNvPicPr>
+          <p:nvPr/>
+        </p:nvPicPr>
+        <p:blipFill>
+          <a:blip xmlns:r="http://schemas.openxmlformats.org/officeDocument/2006/relationships" xmlns:a="http://schemas.openxmlformats.org/drawingml/2006/main" r:embed="Ra0c444f8b8b841b0"/>
           <a:stretch xmlns:a="http://schemas.openxmlformats.org/drawingml/2006/main"/>
         </p:blipFill>
         <p:spPr>

</xml_diff>

<commit_message>
Tighten poster method layout using original figure panels
</commit_message>
<xml_diff>
--- a/assets/BFT-NeurIPS2026-Poster.pptx
+++ b/assets/BFT-NeurIPS2026-Poster.pptx
@@ -2,13 +2,13 @@
 <file path=ppt/presentation.xml><?xml version="1.0" encoding="utf-8"?>
 <p:presentation xmlns:p="http://schemas.openxmlformats.org/presentationml/2006/main">
   <p:sldMasterIdLst>
-    <p:sldMasterId xmlns:r="http://schemas.openxmlformats.org/officeDocument/2006/relationships" id="2147483648" r:id="R11c30b8d24f843d8"/>
+    <p:sldMasterId xmlns:r="http://schemas.openxmlformats.org/officeDocument/2006/relationships" id="2147483648" r:id="R845c6bb803934aeb"/>
   </p:sldMasterIdLst>
   <p:notesMasterIdLst>
-    <p:notesMasterId xmlns:r="http://schemas.openxmlformats.org/officeDocument/2006/relationships" r:id="R4405c6e8417a45e1"/>
+    <p:notesMasterId xmlns:r="http://schemas.openxmlformats.org/officeDocument/2006/relationships" r:id="R18bff07f04c646e1"/>
   </p:notesMasterIdLst>
   <p:sldIdLst>
-    <p:sldId xmlns:r="http://schemas.openxmlformats.org/officeDocument/2006/relationships" id="256" r:id="R39c8e9106e0c4ce7"/>
+    <p:sldId xmlns:r="http://schemas.openxmlformats.org/officeDocument/2006/relationships" id="256" r:id="R157d0ada68c24a49"/>
   </p:sldIdLst>
   <p:sldSz cx="32918400" cy="21945600"/>
   <p:notesSz cx="6858000" cy="9144000"/>
@@ -646,7 +646,7 @@
           <a:lstStyle xmlns:a="http://schemas.openxmlformats.org/drawingml/2006/main"/>
           <a:p xmlns:a="http://schemas.openxmlformats.org/drawingml/2006/main">
             <a:r>
-              <a:t>Edited from author-selected BFT-NeurIPS2026-Plain-Language-Final-R2.pptx. All scientific visuals are unchanged-pixel crops from supplied camera-ready Figure1-5. Crop boxes and masks of letter-only margins are recorded in .build/poster-paper-figures/crop-manifest.json. Challenge uses Figure1b, motivation Figure1a, method Figure1c, biomedical results Figure2a/b; HealthBench retains complete original category labels, general retention original 70B MMLU and CMMLU panels from Figure3a. The original shared category-label strip is duplicated under MMLU so each panel has complete names. Original legend entries are rearranged in two rows without redrawing, gene representation Figure4b, single-cell response Figure5. No reconstructed chart, diagram, or evidence table. Native text explains token as word for a broad audience. Main paper Section3 and Results provide scientific claims. General ability is retained better than SFT, not without loss, and DFT forgets least. STEM extension is demonstrated specifically in medicine and biology, not tested across all STEM fields. Gene mean AUC 0.829 vs GenePT0.802, with Lys4 exception. Same text encoder but different profile source. Only profile generation is zero-shot on perturbation datasets. Source: https://arxiv.org/abs/2511.21075 and supplied neurips_2026_arxiv.tex. Logos and original master retained. No displayed equations added.</a:t>
+              <a:t>Edited from author-selected BFT-NeurIPS2026-Plain-Language-Final-R2.pptx. All scientific visuals are unchanged-pixel crops from supplied camera-ready Figure1-5. Crop boxes and masks of letter-only margins are recorded in .build/poster-paper-figures/crop-manifest.json. Challenge uses Figure1b, motivation Figure1a, method Figure1c split into three original-pixel crops (token, sample, combination), see method-crop-manifest.json, biomedical results Figure2a/b; HealthBench retains complete original category labels, general retention original 70B MMLU and CMMLU panels from Figure3a. The original shared category-label strip is duplicated under MMLU so each panel has complete names. Original legend entries are rearranged in two rows without redrawing, gene representation Figure4b, single-cell response Figure5. No reconstructed chart, diagram, or evidence table. Native text explains token as word for a broad audience. Main paper Section3 and Results provide scientific claims. General ability is retained better than SFT, not without loss, and DFT forgets least. STEM extension is demonstrated specifically in medicine and biology, not tested across all STEM fields. Gene mean AUC 0.829 vs GenePT0.802, with Lys4 exception. Same text encoder but different profile source. Only profile generation is zero-shot on perturbation datasets. Source: https://arxiv.org/abs/2511.21075 and supplied neurips_2026_arxiv.tex. Logos and original master retained. No displayed equations added.</a:t>
             </a:r>
           </a:p>
         </p:txBody>
@@ -951,8 +951,8 @@
   </p:cSld>
   <p:clrMap bg1="lt1" tx1="dk1" bg2="lt2" tx2="dk2" accent1="accent1" accent2="accent2" accent3="accent3" accent4="accent4" accent5="accent5" accent6="accent6" hlink="hlink" folHlink="folHlink"/>
   <p:sldLayoutIdLst>
-    <p:sldLayoutId xmlns:r="http://schemas.openxmlformats.org/officeDocument/2006/relationships" id="2147483649" r:id="R46ca334f41e14794"/>
-    <p:sldLayoutId xmlns:r="http://schemas.openxmlformats.org/officeDocument/2006/relationships" id="2147483650" r:id="R21080112d51d4189"/>
+    <p:sldLayoutId xmlns:r="http://schemas.openxmlformats.org/officeDocument/2006/relationships" id="2147483649" r:id="R96e4a2b1d95448d5"/>
+    <p:sldLayoutId xmlns:r="http://schemas.openxmlformats.org/officeDocument/2006/relationships" id="2147483650" r:id="R1b7e4520cbba4bce"/>
   </p:sldLayoutIdLst>
   <p:txStyles>
     <p:titleStyle>
@@ -2132,83 +2132,6 @@
       </p:sp>
       <p:sp>
         <p:nvSpPr>
-          <p:cNvPr id="38" name="TextBox 44">
-            <a:extLst xmlns:a="http://schemas.openxmlformats.org/drawingml/2006/main">
-              <a:ext uri="{FF2B5EF4-FFF2-40B4-BE49-F238E27FC236}">
-                <a16:creationId xmlns:a16="http://schemas.microsoft.com/office/drawing/2014/main" id="{36855CBD-F0F4-4526-87B9-BA127A6E7EB5}"/>
-              </a:ext>
-            </a:extLst>
-          </p:cNvPr>
-          <p:cNvSpPr>
-            <a:spLocks xmlns:a="http://schemas.openxmlformats.org/drawingml/2006/main" noGrp="1"/>
-          </p:cNvSpPr>
-          <p:nvPr/>
-        </p:nvSpPr>
-        <p:spPr>
-          <a:xfrm xmlns:a="http://schemas.openxmlformats.org/drawingml/2006/main">
-            <a:off x="11372850" y="4143375"/>
-            <a:ext cx="20878800" cy="571500"/>
-          </a:xfrm>
-          <a:prstGeom xmlns:a="http://schemas.openxmlformats.org/drawingml/2006/main" prst="rect">
-            <a:avLst/>
-          </a:prstGeom>
-          <a:noFill xmlns:a="http://schemas.openxmlformats.org/drawingml/2006/main"/>
-          <a:ln xmlns:a="http://schemas.openxmlformats.org/drawingml/2006/main" w="0">
-            <a:noFill/>
-          </a:ln>
-        </p:spPr>
-        <p:txBody>
-          <a:bodyPr xmlns:a="http://schemas.openxmlformats.org/drawingml/2006/main" wrap="square" lIns="0" tIns="0" rIns="0" bIns="0" anchor="t">
-            <a:noAutofit/>
-          </a:bodyPr>
-          <a:lstStyle xmlns:a="http://schemas.openxmlformats.org/drawingml/2006/main">
-            <a:defPPr algn="l">
-              <a:defRPr sz="2250" b="0">
-                <a:solidFill>
-                  <a:srgbClr val="344854"/>
-                </a:solidFill>
-                <a:latin typeface="Arial"/>
-                <a:ea typeface="Arial"/>
-                <a:cs typeface="Arial"/>
-              </a:defRPr>
-            </a:defPPr>
-            <a:lvl1pPr>
-              <a:buNone/>
-              <a:defRPr sz="2100">
-                <a:latin typeface="Arial"/>
-                <a:ea typeface="Arial"/>
-                <a:cs typeface="Arial"/>
-              </a:defRPr>
-            </a:lvl1pPr>
-          </a:lstStyle>
-          <a:p xmlns:a="http://schemas.openxmlformats.org/drawingml/2006/main">
-            <a:pPr algn="l">
-              <a:buNone/>
-              <a:defRPr sz="2250" b="0">
-                <a:solidFill>
-                  <a:srgbClr val="344854"/>
-                </a:solidFill>
-                <a:latin typeface="Arial"/>
-                <a:ea typeface="Arial"/>
-                <a:cs typeface="Arial"/>
-              </a:defRPr>
-            </a:pPr>
-            <a:r>
-              <a:rPr sz="2250" b="0">
-                <a:solidFill>
-                  <a:srgbClr val="344854"/>
-                </a:solidFill>
-                <a:latin typeface="Arial"/>
-                <a:ea typeface="Arial"/>
-                <a:cs typeface="Arial"/>
-              </a:rPr>
-              <a:t>A simple change to supervised training: use nearby context to decide which words and training examples deserve more learning attention.</a:t>
-            </a:r>
-          </a:p>
-        </p:txBody>
-      </p:sp>
-      <p:sp>
-        <p:nvSpPr>
           <p:cNvPr id="39" name="TextBox 45">
             <a:extLst xmlns:a="http://schemas.openxmlformats.org/drawingml/2006/main">
               <a:ext uri="{FF2B5EF4-FFF2-40B4-BE49-F238E27FC236}">
@@ -2443,7 +2366,7 @@
           <p:cNvPr id="54" name="neurips_logo.pdf">
             <a:extLst xmlns:a="http://schemas.openxmlformats.org/drawingml/2006/main">
               <a:ext uri="{FF2B5EF4-FFF2-40B4-BE49-F238E27FC236}">
-                <a16:creationId xmlns:a16="http://schemas.microsoft.com/office/drawing/2014/main" id="{BD7E1E9F-D994-41A8-9C9D-92F714AFE6B1}"/>
+                <a16:creationId xmlns:a16="http://schemas.microsoft.com/office/drawing/2014/main" id="{05260ECC-E750-4040-B651-037F69F9B163}"/>
               </a:ext>
             </a:extLst>
           </p:cNvPr>
@@ -2453,7 +2376,7 @@
           <p:nvPr/>
         </p:nvPicPr>
         <p:blipFill>
-          <a:blip xmlns:r="http://schemas.openxmlformats.org/officeDocument/2006/relationships" xmlns:a="http://schemas.openxmlformats.org/drawingml/2006/main" r:embed="R4c28a572c8994b03"/>
+          <a:blip xmlns:r="http://schemas.openxmlformats.org/officeDocument/2006/relationships" xmlns:a="http://schemas.openxmlformats.org/drawingml/2006/main" r:embed="R49a0ba902f5841ee"/>
           <a:stretch xmlns:a="http://schemas.openxmlformats.org/drawingml/2006/main">
             <a:fillRect l="0" t="0" r="0" b="0"/>
           </a:stretch>
@@ -2654,7 +2577,7 @@
           <p:cNvPr id="57" name="图片 56">
             <a:extLst xmlns:a="http://schemas.openxmlformats.org/drawingml/2006/main">
               <a:ext uri="{FF2B5EF4-FFF2-40B4-BE49-F238E27FC236}">
-                <a16:creationId xmlns:a16="http://schemas.microsoft.com/office/drawing/2014/main" id="{3145ACD8-04C6-4A7C-98C0-3FE7489021FE}"/>
+                <a16:creationId xmlns:a16="http://schemas.microsoft.com/office/drawing/2014/main" id="{7467B58B-D24B-4336-BDF2-9530205C749F}"/>
               </a:ext>
             </a:extLst>
           </p:cNvPr>
@@ -2664,7 +2587,7 @@
           <p:nvPr/>
         </p:nvPicPr>
         <p:blipFill>
-          <a:blip xmlns:r="http://schemas.openxmlformats.org/officeDocument/2006/relationships" xmlns:a="http://schemas.openxmlformats.org/drawingml/2006/main" r:embed="R070826ae0dc04663"/>
+          <a:blip xmlns:r="http://schemas.openxmlformats.org/officeDocument/2006/relationships" xmlns:a="http://schemas.openxmlformats.org/drawingml/2006/main" r:embed="R0b191115b5034ada"/>
           <a:stretch xmlns:a="http://schemas.openxmlformats.org/drawingml/2006/main"/>
         </p:blipFill>
         <p:spPr>
@@ -2682,7 +2605,7 @@
           <p:cNvPr id="58" name="图片 57">
             <a:extLst xmlns:a="http://schemas.openxmlformats.org/drawingml/2006/main">
               <a:ext uri="{FF2B5EF4-FFF2-40B4-BE49-F238E27FC236}">
-                <a16:creationId xmlns:a16="http://schemas.microsoft.com/office/drawing/2014/main" id="{3D7E75AD-67B5-416E-A518-CDB8D1998447}"/>
+                <a16:creationId xmlns:a16="http://schemas.microsoft.com/office/drawing/2014/main" id="{975E7E35-00FD-4DA3-AEAA-CAD2B0E16F50}"/>
               </a:ext>
             </a:extLst>
           </p:cNvPr>
@@ -2692,7 +2615,7 @@
           <p:nvPr/>
         </p:nvPicPr>
         <p:blipFill>
-          <a:blip xmlns:r="http://schemas.openxmlformats.org/officeDocument/2006/relationships" xmlns:a="http://schemas.openxmlformats.org/drawingml/2006/main" r:embed="R634134f6eeba4f28"/>
+          <a:blip xmlns:r="http://schemas.openxmlformats.org/officeDocument/2006/relationships" xmlns:a="http://schemas.openxmlformats.org/drawingml/2006/main" r:embed="R0e58f83f18f1418a"/>
           <a:stretch xmlns:a="http://schemas.openxmlformats.org/drawingml/2006/main"/>
         </p:blipFill>
         <p:spPr>
@@ -2710,7 +2633,7 @@
           <p:cNvPr id="59" name="图片 58">
             <a:extLst xmlns:a="http://schemas.openxmlformats.org/drawingml/2006/main">
               <a:ext uri="{FF2B5EF4-FFF2-40B4-BE49-F238E27FC236}">
-                <a16:creationId xmlns:a16="http://schemas.microsoft.com/office/drawing/2014/main" id="{4805E551-612D-44A9-903E-FC0D1247A041}"/>
+                <a16:creationId xmlns:a16="http://schemas.microsoft.com/office/drawing/2014/main" id="{199ED2E3-D3DA-4DDC-93F8-2017A92FCEBF}"/>
               </a:ext>
             </a:extLst>
           </p:cNvPr>
@@ -2720,7 +2643,7 @@
           <p:nvPr/>
         </p:nvPicPr>
         <p:blipFill>
-          <a:blip xmlns:r="http://schemas.openxmlformats.org/officeDocument/2006/relationships" xmlns:a="http://schemas.openxmlformats.org/drawingml/2006/main" r:embed="R8b2b2a8bde104a96"/>
+          <a:blip xmlns:r="http://schemas.openxmlformats.org/officeDocument/2006/relationships" xmlns:a="http://schemas.openxmlformats.org/drawingml/2006/main" r:embed="Rf4563ed2e5d947f7"/>
           <a:stretch xmlns:a="http://schemas.openxmlformats.org/drawingml/2006/main"/>
         </p:blipFill>
         <p:spPr>
@@ -3349,8 +3272,8 @@
         </p:nvSpPr>
         <p:spPr>
           <a:xfrm xmlns:a="http://schemas.openxmlformats.org/drawingml/2006/main">
-            <a:off x="11372850" y="10191750"/>
-            <a:ext cx="20878800" cy="714375"/>
+            <a:off x="11372850" y="10706100"/>
+            <a:ext cx="20878800" cy="304800"/>
           </a:xfrm>
           <a:prstGeom xmlns:a="http://schemas.openxmlformats.org/drawingml/2006/main" prst="rect">
             <a:avLst/>
@@ -3366,7 +3289,7 @@
           </a:bodyPr>
           <a:lstStyle xmlns:a="http://schemas.openxmlformats.org/drawingml/2006/main">
             <a:defPPr algn="l">
-              <a:defRPr sz="2025" b="0">
+              <a:defRPr sz="1950" b="0">
                 <a:solidFill>
                   <a:srgbClr val="344854"/>
                 </a:solidFill>
@@ -3379,7 +3302,7 @@
           <a:p xmlns:a="http://schemas.openxmlformats.org/drawingml/2006/main">
             <a:pPr algn="l">
               <a:buNone/>
-              <a:defRPr sz="2025" b="0">
+              <a:defRPr sz="1950" b="0">
                 <a:solidFill>
                   <a:srgbClr val="344854"/>
                 </a:solidFill>
@@ -3389,7 +3312,7 @@
               </a:defRPr>
             </a:pPr>
             <a:r>
-              <a:rPr sz="2025" b="0">
+              <a:rPr sz="1950" b="0">
                 <a:solidFill>
                   <a:srgbClr val="344854"/>
                 </a:solidFill>
@@ -3397,31 +3320,7 @@
                 <a:ea typeface="Arial"/>
                 <a:cs typeface="Arial"/>
               </a:rPr>
-              <a:t>Left: retain words inside difficult passages. Right: emphasize examples containing hard passages, within a limit.</a:t>
-            </a:r>
-          </a:p>
-          <a:p xmlns:a="http://schemas.openxmlformats.org/drawingml/2006/main">
-            <a:pPr algn="l">
-              <a:buNone/>
-              <a:defRPr sz="2025" b="0">
-                <a:solidFill>
-                  <a:srgbClr val="344854"/>
-                </a:solidFill>
-                <a:latin typeface="Arial"/>
-                <a:ea typeface="Arial"/>
-                <a:cs typeface="Arial"/>
-              </a:defRPr>
-            </a:pPr>
-            <a:r>
-              <a:rPr sz="2025" b="0">
-                <a:solidFill>
-                  <a:srgbClr val="344854"/>
-                </a:solidFill>
-                <a:latin typeface="Arial"/>
-                <a:ea typeface="Arial"/>
-                <a:cs typeface="Arial"/>
-              </a:rPr>
-              <a:t>BFT uses the model’s own confidence, without a reward model or external uncertainty estimator.</a:t>
+              <a:t>Use the model’s own confidence; cap example weights. No reward model or external uncertainty estimator.</a:t>
             </a:r>
           </a:p>
         </p:txBody>
@@ -3911,202 +3810,6 @@
           </a:p>
         </p:txBody>
       </p:sp>
-      <p:pic>
-        <p:nvPicPr>
-          <p:cNvPr id="143" name="">
-            <a:extLst xmlns:a="http://schemas.openxmlformats.org/drawingml/2006/main">
-              <a:ext uri="{FF2B5EF4-FFF2-40B4-BE49-F238E27FC236}">
-                <a16:creationId xmlns:a16="http://schemas.microsoft.com/office/drawing/2014/main" id="{78610EAA-DB01-415C-A971-7426985C802C}"/>
-              </a:ext>
-            </a:extLst>
-          </p:cNvPr>
-          <p:cNvPicPr>
-            <a:picLocks xmlns:a="http://schemas.openxmlformats.org/drawingml/2006/main" noChangeAspect="1"/>
-          </p:cNvPicPr>
-          <p:nvPr/>
-        </p:nvPicPr>
-        <p:blipFill>
-          <a:blip xmlns:r="http://schemas.openxmlformats.org/officeDocument/2006/relationships" xmlns:a="http://schemas.openxmlformats.org/drawingml/2006/main" r:embed="Ra77c4f077bd94dbf"/>
-          <a:stretch xmlns:a="http://schemas.openxmlformats.org/drawingml/2006/main"/>
-        </p:blipFill>
-        <p:spPr>
-          <a:xfrm xmlns:a="http://schemas.openxmlformats.org/drawingml/2006/main">
-            <a:off x="2388747" y="5048250"/>
-            <a:ext cx="6728707" cy="1762125"/>
-          </a:xfrm>
-          <a:prstGeom xmlns:a="http://schemas.openxmlformats.org/drawingml/2006/main" prst="rect">
-            <a:avLst/>
-          </a:prstGeom>
-        </p:spPr>
-      </p:pic>
-      <p:pic>
-        <p:nvPicPr>
-          <p:cNvPr id="144" name="">
-            <a:extLst xmlns:a="http://schemas.openxmlformats.org/drawingml/2006/main">
-              <a:ext uri="{FF2B5EF4-FFF2-40B4-BE49-F238E27FC236}">
-                <a16:creationId xmlns:a16="http://schemas.microsoft.com/office/drawing/2014/main" id="{7D939B78-A8B4-4F87-9259-7C55918F5E77}"/>
-              </a:ext>
-            </a:extLst>
-          </p:cNvPr>
-          <p:cNvPicPr>
-            <a:picLocks xmlns:a="http://schemas.openxmlformats.org/drawingml/2006/main" noChangeAspect="1"/>
-          </p:cNvPicPr>
-          <p:nvPr/>
-        </p:nvPicPr>
-        <p:blipFill>
-          <a:blip xmlns:r="http://schemas.openxmlformats.org/officeDocument/2006/relationships" xmlns:a="http://schemas.openxmlformats.org/drawingml/2006/main" r:embed="Rde959627e0b047bb"/>
-          <a:stretch xmlns:a="http://schemas.openxmlformats.org/drawingml/2006/main"/>
-        </p:blipFill>
-        <p:spPr>
-          <a:xfrm xmlns:a="http://schemas.openxmlformats.org/drawingml/2006/main">
-            <a:off x="982510" y="7810500"/>
-            <a:ext cx="4511979" cy="2667000"/>
-          </a:xfrm>
-          <a:prstGeom xmlns:a="http://schemas.openxmlformats.org/drawingml/2006/main" prst="rect">
-            <a:avLst/>
-          </a:prstGeom>
-        </p:spPr>
-      </p:pic>
-      <p:pic>
-        <p:nvPicPr>
-          <p:cNvPr id="145" name="">
-            <a:extLst xmlns:a="http://schemas.openxmlformats.org/drawingml/2006/main">
-              <a:ext uri="{FF2B5EF4-FFF2-40B4-BE49-F238E27FC236}">
-                <a16:creationId xmlns:a16="http://schemas.microsoft.com/office/drawing/2014/main" id="{CA287500-86EA-43D3-A5E0-3F8536317FA7}"/>
-              </a:ext>
-            </a:extLst>
-          </p:cNvPr>
-          <p:cNvPicPr>
-            <a:picLocks xmlns:a="http://schemas.openxmlformats.org/drawingml/2006/main" noChangeAspect="1"/>
-          </p:cNvPicPr>
-          <p:nvPr/>
-        </p:nvPicPr>
-        <p:blipFill>
-          <a:blip xmlns:r="http://schemas.openxmlformats.org/officeDocument/2006/relationships" xmlns:a="http://schemas.openxmlformats.org/drawingml/2006/main" r:embed="Rcf7d04324f7d4445"/>
-          <a:stretch xmlns:a="http://schemas.openxmlformats.org/drawingml/2006/main"/>
-        </p:blipFill>
-        <p:spPr>
-          <a:xfrm xmlns:a="http://schemas.openxmlformats.org/drawingml/2006/main">
-            <a:off x="14524596" y="4810125"/>
-            <a:ext cx="14575309" cy="5238750"/>
-          </a:xfrm>
-          <a:prstGeom xmlns:a="http://schemas.openxmlformats.org/drawingml/2006/main" prst="rect">
-            <a:avLst/>
-          </a:prstGeom>
-        </p:spPr>
-      </p:pic>
-      <p:pic>
-        <p:nvPicPr>
-          <p:cNvPr id="146" name="">
-            <a:extLst xmlns:a="http://schemas.openxmlformats.org/drawingml/2006/main">
-              <a:ext uri="{FF2B5EF4-FFF2-40B4-BE49-F238E27FC236}">
-                <a16:creationId xmlns:a16="http://schemas.microsoft.com/office/drawing/2014/main" id="{16560DE0-FD30-4F06-BD78-CDC867BC0C3D}"/>
-              </a:ext>
-            </a:extLst>
-          </p:cNvPr>
-          <p:cNvPicPr>
-            <a:picLocks xmlns:a="http://schemas.openxmlformats.org/drawingml/2006/main" noChangeAspect="1"/>
-          </p:cNvPicPr>
-          <p:nvPr/>
-        </p:nvPicPr>
-        <p:blipFill>
-          <a:blip xmlns:r="http://schemas.openxmlformats.org/officeDocument/2006/relationships" xmlns:a="http://schemas.openxmlformats.org/drawingml/2006/main" r:embed="Rf4aa805f896c48d8"/>
-          <a:stretch xmlns:a="http://schemas.openxmlformats.org/drawingml/2006/main"/>
-        </p:blipFill>
-        <p:spPr>
-          <a:xfrm xmlns:a="http://schemas.openxmlformats.org/drawingml/2006/main">
-            <a:off x="2683218" y="12954000"/>
-            <a:ext cx="6139764" cy="4286250"/>
-          </a:xfrm>
-          <a:prstGeom xmlns:a="http://schemas.openxmlformats.org/drawingml/2006/main" prst="rect">
-            <a:avLst/>
-          </a:prstGeom>
-        </p:spPr>
-      </p:pic>
-      <p:pic>
-        <p:nvPicPr>
-          <p:cNvPr id="147" name="">
-            <a:extLst xmlns:a="http://schemas.openxmlformats.org/drawingml/2006/main">
-              <a:ext uri="{FF2B5EF4-FFF2-40B4-BE49-F238E27FC236}">
-                <a16:creationId xmlns:a16="http://schemas.microsoft.com/office/drawing/2014/main" id="{3BB69827-D364-4F9C-8454-1AFE0BC4E1CD}"/>
-              </a:ext>
-            </a:extLst>
-          </p:cNvPr>
-          <p:cNvPicPr>
-            <a:picLocks xmlns:a="http://schemas.openxmlformats.org/drawingml/2006/main" noChangeAspect="1"/>
-          </p:cNvPicPr>
-          <p:nvPr/>
-        </p:nvPicPr>
-        <p:blipFill>
-          <a:blip xmlns:r="http://schemas.openxmlformats.org/officeDocument/2006/relationships" xmlns:a="http://schemas.openxmlformats.org/drawingml/2006/main" r:embed="Red9660fbf4754542"/>
-          <a:stretch xmlns:a="http://schemas.openxmlformats.org/drawingml/2006/main"/>
-        </p:blipFill>
-        <p:spPr>
-          <a:xfrm xmlns:a="http://schemas.openxmlformats.org/drawingml/2006/main">
-            <a:off x="666750" y="17368093"/>
-            <a:ext cx="10172700" cy="268189"/>
-          </a:xfrm>
-          <a:prstGeom xmlns:a="http://schemas.openxmlformats.org/drawingml/2006/main" prst="rect">
-            <a:avLst/>
-          </a:prstGeom>
-        </p:spPr>
-      </p:pic>
-      <p:pic>
-        <p:nvPicPr>
-          <p:cNvPr id="148" name="">
-            <a:extLst xmlns:a="http://schemas.openxmlformats.org/drawingml/2006/main">
-              <a:ext uri="{FF2B5EF4-FFF2-40B4-BE49-F238E27FC236}">
-                <a16:creationId xmlns:a16="http://schemas.microsoft.com/office/drawing/2014/main" id="{78B137A6-BAB0-45D7-9308-1EF773AE69B9}"/>
-              </a:ext>
-            </a:extLst>
-          </p:cNvPr>
-          <p:cNvPicPr>
-            <a:picLocks xmlns:a="http://schemas.openxmlformats.org/drawingml/2006/main" noChangeAspect="1"/>
-          </p:cNvPicPr>
-          <p:nvPr/>
-        </p:nvPicPr>
-        <p:blipFill>
-          <a:blip xmlns:r="http://schemas.openxmlformats.org/officeDocument/2006/relationships" xmlns:a="http://schemas.openxmlformats.org/drawingml/2006/main" r:embed="Reb46a3f0548a4319"/>
-          <a:stretch xmlns:a="http://schemas.openxmlformats.org/drawingml/2006/main"/>
-        </p:blipFill>
-        <p:spPr>
-          <a:xfrm xmlns:a="http://schemas.openxmlformats.org/drawingml/2006/main">
-            <a:off x="2030584" y="18383250"/>
-            <a:ext cx="7445032" cy="3048000"/>
-          </a:xfrm>
-          <a:prstGeom xmlns:a="http://schemas.openxmlformats.org/drawingml/2006/main" prst="rect">
-            <a:avLst/>
-          </a:prstGeom>
-        </p:spPr>
-      </p:pic>
-      <p:pic>
-        <p:nvPicPr>
-          <p:cNvPr id="149" name="">
-            <a:extLst xmlns:a="http://schemas.openxmlformats.org/drawingml/2006/main">
-              <a:ext uri="{FF2B5EF4-FFF2-40B4-BE49-F238E27FC236}">
-                <a16:creationId xmlns:a16="http://schemas.microsoft.com/office/drawing/2014/main" id="{74F0A866-7F9B-45B1-9751-75D35C2C1544}"/>
-              </a:ext>
-            </a:extLst>
-          </p:cNvPr>
-          <p:cNvPicPr>
-            <a:picLocks xmlns:a="http://schemas.openxmlformats.org/drawingml/2006/main" noChangeAspect="1"/>
-          </p:cNvPicPr>
-          <p:nvPr/>
-        </p:nvPicPr>
-        <p:blipFill>
-          <a:blip xmlns:r="http://schemas.openxmlformats.org/officeDocument/2006/relationships" xmlns:a="http://schemas.openxmlformats.org/drawingml/2006/main" r:embed="R4d100548f1a2423e"/>
-          <a:stretch xmlns:a="http://schemas.openxmlformats.org/drawingml/2006/main"/>
-        </p:blipFill>
-        <p:spPr>
-          <a:xfrm xmlns:a="http://schemas.openxmlformats.org/drawingml/2006/main">
-            <a:off x="666750" y="21610789"/>
-            <a:ext cx="10172700" cy="212423"/>
-          </a:xfrm>
-          <a:prstGeom xmlns:a="http://schemas.openxmlformats.org/drawingml/2006/main" prst="rect">
-            <a:avLst/>
-          </a:prstGeom>
-        </p:spPr>
-      </p:pic>
       <p:sp>
         <p:nvSpPr>
           <p:cNvPr id="150" name="MMLU heading">
@@ -4152,6 +3855,7 @@
           </a:lstStyle>
           <a:p xmlns:a="http://schemas.openxmlformats.org/drawingml/2006/main">
             <a:pPr algn="l">
+              <a:buNone/>
               <a:defRPr sz="2400" b="1">
                 <a:solidFill>
                   <a:srgbClr val="183B66"/>
@@ -4220,6 +3924,7 @@
           </a:lstStyle>
           <a:p xmlns:a="http://schemas.openxmlformats.org/drawingml/2006/main">
             <a:pPr algn="l">
+              <a:buNone/>
               <a:defRPr sz="2400" b="1">
                 <a:solidFill>
                   <a:srgbClr val="183B66"/>
@@ -4248,7 +3953,7 @@
           <p:cNvPr id="152" name="">
             <a:extLst xmlns:a="http://schemas.openxmlformats.org/drawingml/2006/main">
               <a:ext uri="{FF2B5EF4-FFF2-40B4-BE49-F238E27FC236}">
-                <a16:creationId xmlns:a16="http://schemas.microsoft.com/office/drawing/2014/main" id="{63D89639-9B35-4961-9F0C-304DAC532884}"/>
+                <a16:creationId xmlns:a16="http://schemas.microsoft.com/office/drawing/2014/main" id="{15245A53-4FBC-4130-A849-68A984630284}"/>
               </a:ext>
             </a:extLst>
           </p:cNvPr>
@@ -4258,13 +3963,13 @@
           <p:nvPr/>
         </p:nvPicPr>
         <p:blipFill>
-          <a:blip xmlns:r="http://schemas.openxmlformats.org/officeDocument/2006/relationships" xmlns:a="http://schemas.openxmlformats.org/drawingml/2006/main" r:embed="R452e75a7a7414e62"/>
+          <a:blip xmlns:r="http://schemas.openxmlformats.org/officeDocument/2006/relationships" xmlns:a="http://schemas.openxmlformats.org/drawingml/2006/main" r:embed="R5fb03de54df64476"/>
           <a:stretch xmlns:a="http://schemas.openxmlformats.org/drawingml/2006/main"/>
         </p:blipFill>
         <p:spPr>
           <a:xfrm xmlns:a="http://schemas.openxmlformats.org/drawingml/2006/main">
-            <a:off x="11372850" y="13781141"/>
-            <a:ext cx="4895850" cy="5203718"/>
+            <a:off x="2388747" y="5048250"/>
+            <a:ext cx="6728707" cy="1762125"/>
           </a:xfrm>
           <a:prstGeom xmlns:a="http://schemas.openxmlformats.org/drawingml/2006/main" prst="rect">
             <a:avLst/>
@@ -4276,7 +3981,7 @@
           <p:cNvPr id="153" name="">
             <a:extLst xmlns:a="http://schemas.openxmlformats.org/drawingml/2006/main">
               <a:ext uri="{FF2B5EF4-FFF2-40B4-BE49-F238E27FC236}">
-                <a16:creationId xmlns:a16="http://schemas.microsoft.com/office/drawing/2014/main" id="{C1C076F4-D632-4D0E-AFBA-782D3BCDDE65}"/>
+                <a16:creationId xmlns:a16="http://schemas.microsoft.com/office/drawing/2014/main" id="{F3BEDC9F-1DEF-4B87-B965-B84555F76AFC}"/>
               </a:ext>
             </a:extLst>
           </p:cNvPr>
@@ -4286,25 +3991,161 @@
           <p:nvPr/>
         </p:nvPicPr>
         <p:blipFill>
-          <a:blip xmlns:r="http://schemas.openxmlformats.org/officeDocument/2006/relationships" xmlns:a="http://schemas.openxmlformats.org/drawingml/2006/main" r:embed="Rca47ef9f77e14748"/>
+          <a:blip xmlns:r="http://schemas.openxmlformats.org/officeDocument/2006/relationships" xmlns:a="http://schemas.openxmlformats.org/drawingml/2006/main" r:embed="R75d8807919e949e4"/>
           <a:stretch xmlns:a="http://schemas.openxmlformats.org/drawingml/2006/main"/>
         </p:blipFill>
         <p:spPr>
           <a:xfrm xmlns:a="http://schemas.openxmlformats.org/drawingml/2006/main">
-            <a:off x="16649700" y="13856231"/>
-            <a:ext cx="4895850" cy="5053538"/>
+            <a:off x="982510" y="7810500"/>
+            <a:ext cx="4511979" cy="2667000"/>
           </a:xfrm>
           <a:prstGeom xmlns:a="http://schemas.openxmlformats.org/drawingml/2006/main" prst="rect">
             <a:avLst/>
           </a:prstGeom>
         </p:spPr>
       </p:pic>
+      <p:sp>
+        <p:nvSpPr>
+          <p:cNvPr id="154" name="Method token step">
+            <a:extLst xmlns:a="http://schemas.openxmlformats.org/drawingml/2006/main">
+              <a:ext uri="{FF2B5EF4-FFF2-40B4-BE49-F238E27FC236}">
+                <a16:creationId xmlns:a16="http://schemas.microsoft.com/office/drawing/2014/main" id="{C25C813D-8AF8-4792-AD8F-6AAA5A6D3AE6}"/>
+              </a:ext>
+            </a:extLst>
+          </p:cNvPr>
+          <p:cNvSpPr>
+            <a:spLocks xmlns:a="http://schemas.openxmlformats.org/drawingml/2006/main" noGrp="1"/>
+          </p:cNvSpPr>
+          <p:nvPr/>
+        </p:nvSpPr>
+        <p:spPr>
+          <a:xfrm xmlns:a="http://schemas.openxmlformats.org/drawingml/2006/main">
+            <a:off x="11372850" y="4143375"/>
+            <a:ext cx="11144250" cy="381000"/>
+          </a:xfrm>
+          <a:prstGeom xmlns:a="http://schemas.openxmlformats.org/drawingml/2006/main" prst="rect">
+            <a:avLst/>
+          </a:prstGeom>
+          <a:noFill xmlns:a="http://schemas.openxmlformats.org/drawingml/2006/main"/>
+          <a:ln xmlns:a="http://schemas.openxmlformats.org/drawingml/2006/main" w="0">
+            <a:noFill/>
+          </a:ln>
+        </p:spPr>
+        <p:txBody>
+          <a:bodyPr xmlns:a="http://schemas.openxmlformats.org/drawingml/2006/main" wrap="square" lIns="0" tIns="0" rIns="0" bIns="0" anchor="t">
+            <a:noAutofit/>
+          </a:bodyPr>
+          <a:lstStyle xmlns:a="http://schemas.openxmlformats.org/drawingml/2006/main">
+            <a:defPPr algn="l">
+              <a:defRPr sz="2325" b="1">
+                <a:solidFill>
+                  <a:srgbClr val="183B66"/>
+                </a:solidFill>
+                <a:latin typeface="Arial"/>
+                <a:ea typeface="Arial"/>
+                <a:cs typeface="Arial"/>
+              </a:defRPr>
+            </a:defPPr>
+          </a:lstStyle>
+          <a:p xmlns:a="http://schemas.openxmlformats.org/drawingml/2006/main">
+            <a:pPr algn="l">
+              <a:defRPr sz="2325" b="1">
+                <a:solidFill>
+                  <a:srgbClr val="183B66"/>
+                </a:solidFill>
+                <a:latin typeface="Arial"/>
+                <a:ea typeface="Arial"/>
+                <a:cs typeface="Arial"/>
+              </a:defRPr>
+            </a:pPr>
+            <a:r>
+              <a:rPr sz="2325" b="1">
+                <a:solidFill>
+                  <a:srgbClr val="183B66"/>
+                </a:solidFill>
+                <a:latin typeface="Arial"/>
+                <a:ea typeface="Arial"/>
+                <a:cs typeface="Arial"/>
+              </a:rPr>
+              <a:t>1  Keep useful words in difficult passages</a:t>
+            </a:r>
+          </a:p>
+        </p:txBody>
+      </p:sp>
+      <p:sp>
+        <p:nvSpPr>
+          <p:cNvPr id="155" name="Method sample step">
+            <a:extLst xmlns:a="http://schemas.openxmlformats.org/drawingml/2006/main">
+              <a:ext uri="{FF2B5EF4-FFF2-40B4-BE49-F238E27FC236}">
+                <a16:creationId xmlns:a16="http://schemas.microsoft.com/office/drawing/2014/main" id="{3D9B32F0-B7F0-4A3D-BDFB-AE124D873115}"/>
+              </a:ext>
+            </a:extLst>
+          </p:cNvPr>
+          <p:cNvSpPr>
+            <a:spLocks xmlns:a="http://schemas.openxmlformats.org/drawingml/2006/main" noGrp="1"/>
+          </p:cNvSpPr>
+          <p:nvPr/>
+        </p:nvSpPr>
+        <p:spPr>
+          <a:xfrm xmlns:a="http://schemas.openxmlformats.org/drawingml/2006/main">
+            <a:off x="22898100" y="4143375"/>
+            <a:ext cx="9353550" cy="381000"/>
+          </a:xfrm>
+          <a:prstGeom xmlns:a="http://schemas.openxmlformats.org/drawingml/2006/main" prst="rect">
+            <a:avLst/>
+          </a:prstGeom>
+          <a:noFill xmlns:a="http://schemas.openxmlformats.org/drawingml/2006/main"/>
+          <a:ln xmlns:a="http://schemas.openxmlformats.org/drawingml/2006/main" w="0">
+            <a:noFill/>
+          </a:ln>
+        </p:spPr>
+        <p:txBody>
+          <a:bodyPr xmlns:a="http://schemas.openxmlformats.org/drawingml/2006/main" wrap="square" lIns="0" tIns="0" rIns="0" bIns="0" anchor="t">
+            <a:noAutofit/>
+          </a:bodyPr>
+          <a:lstStyle xmlns:a="http://schemas.openxmlformats.org/drawingml/2006/main">
+            <a:defPPr algn="l">
+              <a:defRPr sz="2250" b="1">
+                <a:solidFill>
+                  <a:srgbClr val="183B66"/>
+                </a:solidFill>
+                <a:latin typeface="Arial"/>
+                <a:ea typeface="Arial"/>
+                <a:cs typeface="Arial"/>
+              </a:defRPr>
+            </a:defPPr>
+          </a:lstStyle>
+          <a:p xmlns:a="http://schemas.openxmlformats.org/drawingml/2006/main">
+            <a:pPr algn="l">
+              <a:defRPr sz="2250" b="1">
+                <a:solidFill>
+                  <a:srgbClr val="183B66"/>
+                </a:solidFill>
+                <a:latin typeface="Arial"/>
+                <a:ea typeface="Arial"/>
+                <a:cs typeface="Arial"/>
+              </a:defRPr>
+            </a:pPr>
+            <a:r>
+              <a:rPr sz="2250" b="1">
+                <a:solidFill>
+                  <a:srgbClr val="183B66"/>
+                </a:solidFill>
+                <a:latin typeface="Arial"/>
+                <a:ea typeface="Arial"/>
+                <a:cs typeface="Arial"/>
+              </a:rPr>
+              <a:t>2  Prioritize examples with hard passages</a:t>
+            </a:r>
+          </a:p>
+        </p:txBody>
+      </p:sp>
       <p:pic>
         <p:nvPicPr>
-          <p:cNvPr id="154" name="">
-            <a:extLst xmlns:a="http://schemas.openxmlformats.org/drawingml/2006/main">
-              <a:ext uri="{FF2B5EF4-FFF2-40B4-BE49-F238E27FC236}">
-                <a16:creationId xmlns:a16="http://schemas.microsoft.com/office/drawing/2014/main" id="{6F328951-CC89-476D-9FD2-CA9F579AE454}"/>
+          <p:cNvPr id="156" name="">
+            <a:extLst xmlns:a="http://schemas.openxmlformats.org/drawingml/2006/main">
+              <a:ext uri="{FF2B5EF4-FFF2-40B4-BE49-F238E27FC236}">
+                <a16:creationId xmlns:a16="http://schemas.microsoft.com/office/drawing/2014/main" id="{50A24DCC-D02E-4DA8-AB9E-FD85F4B380CE}"/>
               </a:ext>
             </a:extLst>
           </p:cNvPr>
@@ -4314,13 +4155,13 @@
           <p:nvPr/>
         </p:nvPicPr>
         <p:blipFill>
-          <a:blip xmlns:r="http://schemas.openxmlformats.org/officeDocument/2006/relationships" xmlns:a="http://schemas.openxmlformats.org/drawingml/2006/main" r:embed="R28802150e800448c"/>
+          <a:blip xmlns:r="http://schemas.openxmlformats.org/officeDocument/2006/relationships" xmlns:a="http://schemas.openxmlformats.org/drawingml/2006/main" r:embed="R1391f857fd57435a"/>
           <a:stretch xmlns:a="http://schemas.openxmlformats.org/drawingml/2006/main"/>
         </p:blipFill>
         <p:spPr>
           <a:xfrm xmlns:a="http://schemas.openxmlformats.org/drawingml/2006/main">
-            <a:off x="12302665" y="19240500"/>
-            <a:ext cx="8313069" cy="1047750"/>
+            <a:off x="11743320" y="4572000"/>
+            <a:ext cx="10403310" cy="6000750"/>
           </a:xfrm>
           <a:prstGeom xmlns:a="http://schemas.openxmlformats.org/drawingml/2006/main" prst="rect">
             <a:avLst/>
@@ -4329,10 +4170,10 @@
       </p:pic>
       <p:pic>
         <p:nvPicPr>
-          <p:cNvPr id="155" name="">
-            <a:extLst xmlns:a="http://schemas.openxmlformats.org/drawingml/2006/main">
-              <a:ext uri="{FF2B5EF4-FFF2-40B4-BE49-F238E27FC236}">
-                <a16:creationId xmlns:a16="http://schemas.microsoft.com/office/drawing/2014/main" id="{F9B3533D-53A6-46D5-9DEE-87564DDE8633}"/>
+          <p:cNvPr id="157" name="">
+            <a:extLst xmlns:a="http://schemas.openxmlformats.org/drawingml/2006/main">
+              <a:ext uri="{FF2B5EF4-FFF2-40B4-BE49-F238E27FC236}">
+                <a16:creationId xmlns:a16="http://schemas.microsoft.com/office/drawing/2014/main" id="{5463AA77-B922-401E-AF11-EF7FFD230012}"/>
               </a:ext>
             </a:extLst>
           </p:cNvPr>
@@ -4342,25 +4183,93 @@
           <p:nvPr/>
         </p:nvPicPr>
         <p:blipFill>
-          <a:blip xmlns:r="http://schemas.openxmlformats.org/officeDocument/2006/relationships" xmlns:a="http://schemas.openxmlformats.org/drawingml/2006/main" r:embed="Rfafdb010594a4b1a"/>
+          <a:blip xmlns:r="http://schemas.openxmlformats.org/officeDocument/2006/relationships" xmlns:a="http://schemas.openxmlformats.org/drawingml/2006/main" r:embed="R2c76664ac9c84be4"/>
           <a:stretch xmlns:a="http://schemas.openxmlformats.org/drawingml/2006/main"/>
         </p:blipFill>
         <p:spPr>
           <a:xfrm xmlns:a="http://schemas.openxmlformats.org/drawingml/2006/main">
-            <a:off x="22628469" y="13096875"/>
-            <a:ext cx="9073662" cy="4572000"/>
+            <a:off x="22900175" y="4572000"/>
+            <a:ext cx="9349400" cy="3838575"/>
           </a:xfrm>
           <a:prstGeom xmlns:a="http://schemas.openxmlformats.org/drawingml/2006/main" prst="rect">
             <a:avLst/>
           </a:prstGeom>
         </p:spPr>
       </p:pic>
+      <p:sp>
+        <p:nvSpPr>
+          <p:cNvPr id="158" name="Method combine step">
+            <a:extLst xmlns:a="http://schemas.openxmlformats.org/drawingml/2006/main">
+              <a:ext uri="{FF2B5EF4-FFF2-40B4-BE49-F238E27FC236}">
+                <a16:creationId xmlns:a16="http://schemas.microsoft.com/office/drawing/2014/main" id="{5D2AB33A-0942-48BB-B3D1-28F5CBE39AB9}"/>
+              </a:ext>
+            </a:extLst>
+          </p:cNvPr>
+          <p:cNvSpPr>
+            <a:spLocks xmlns:a="http://schemas.openxmlformats.org/drawingml/2006/main" noGrp="1"/>
+          </p:cNvSpPr>
+          <p:nvPr/>
+        </p:nvSpPr>
+        <p:spPr>
+          <a:xfrm xmlns:a="http://schemas.openxmlformats.org/drawingml/2006/main">
+            <a:off x="22898100" y="8429625"/>
+            <a:ext cx="9353550" cy="361950"/>
+          </a:xfrm>
+          <a:prstGeom xmlns:a="http://schemas.openxmlformats.org/drawingml/2006/main" prst="rect">
+            <a:avLst/>
+          </a:prstGeom>
+          <a:noFill xmlns:a="http://schemas.openxmlformats.org/drawingml/2006/main"/>
+          <a:ln xmlns:a="http://schemas.openxmlformats.org/drawingml/2006/main" w="0">
+            <a:noFill/>
+          </a:ln>
+        </p:spPr>
+        <p:txBody>
+          <a:bodyPr xmlns:a="http://schemas.openxmlformats.org/drawingml/2006/main" wrap="square" lIns="0" tIns="0" rIns="0" bIns="0" anchor="t">
+            <a:noAutofit/>
+          </a:bodyPr>
+          <a:lstStyle xmlns:a="http://schemas.openxmlformats.org/drawingml/2006/main">
+            <a:defPPr algn="l">
+              <a:defRPr sz="2175" b="1">
+                <a:solidFill>
+                  <a:srgbClr val="183B66"/>
+                </a:solidFill>
+                <a:latin typeface="Arial"/>
+                <a:ea typeface="Arial"/>
+                <a:cs typeface="Arial"/>
+              </a:defRPr>
+            </a:defPPr>
+          </a:lstStyle>
+          <a:p xmlns:a="http://schemas.openxmlformats.org/drawingml/2006/main">
+            <a:pPr algn="l">
+              <a:defRPr sz="2175" b="1">
+                <a:solidFill>
+                  <a:srgbClr val="183B66"/>
+                </a:solidFill>
+                <a:latin typeface="Arial"/>
+                <a:ea typeface="Arial"/>
+                <a:cs typeface="Arial"/>
+              </a:defRPr>
+            </a:pPr>
+            <a:r>
+              <a:rPr sz="2175" b="1">
+                <a:solidFill>
+                  <a:srgbClr val="183B66"/>
+                </a:solidFill>
+                <a:latin typeface="Arial"/>
+                <a:ea typeface="Arial"/>
+                <a:cs typeface="Arial"/>
+              </a:rPr>
+              <a:t>3  Combine both signals during training</a:t>
+            </a:r>
+          </a:p>
+        </p:txBody>
+      </p:sp>
       <p:pic>
         <p:nvPicPr>
-          <p:cNvPr id="156" name="">
-            <a:extLst xmlns:a="http://schemas.openxmlformats.org/drawingml/2006/main">
-              <a:ext uri="{FF2B5EF4-FFF2-40B4-BE49-F238E27FC236}">
-                <a16:creationId xmlns:a16="http://schemas.microsoft.com/office/drawing/2014/main" id="{44294CA8-DEE7-474E-A6EB-564B7AA509F0}"/>
+          <p:cNvPr id="159" name="">
+            <a:extLst xmlns:a="http://schemas.openxmlformats.org/drawingml/2006/main">
+              <a:ext uri="{FF2B5EF4-FFF2-40B4-BE49-F238E27FC236}">
+                <a16:creationId xmlns:a16="http://schemas.microsoft.com/office/drawing/2014/main" id="{0CC5C9BE-508E-4E0F-A987-0FC6B0A713D7}"/>
               </a:ext>
             </a:extLst>
           </p:cNvPr>
@@ -4370,7 +4279,259 @@
           <p:nvPr/>
         </p:nvPicPr>
         <p:blipFill>
-          <a:blip xmlns:r="http://schemas.openxmlformats.org/officeDocument/2006/relationships" xmlns:a="http://schemas.openxmlformats.org/drawingml/2006/main" r:embed="Ra0c444f8b8b841b0"/>
+          <a:blip xmlns:r="http://schemas.openxmlformats.org/officeDocument/2006/relationships" xmlns:a="http://schemas.openxmlformats.org/drawingml/2006/main" r:embed="R78ae22f38aa84f34"/>
+          <a:stretch xmlns:a="http://schemas.openxmlformats.org/drawingml/2006/main"/>
+        </p:blipFill>
+        <p:spPr>
+          <a:xfrm xmlns:a="http://schemas.openxmlformats.org/drawingml/2006/main">
+            <a:off x="22898100" y="8850584"/>
+            <a:ext cx="9353550" cy="1825083"/>
+          </a:xfrm>
+          <a:prstGeom xmlns:a="http://schemas.openxmlformats.org/drawingml/2006/main" prst="rect">
+            <a:avLst/>
+          </a:prstGeom>
+        </p:spPr>
+      </p:pic>
+      <p:pic>
+        <p:nvPicPr>
+          <p:cNvPr id="160" name="">
+            <a:extLst xmlns:a="http://schemas.openxmlformats.org/drawingml/2006/main">
+              <a:ext uri="{FF2B5EF4-FFF2-40B4-BE49-F238E27FC236}">
+                <a16:creationId xmlns:a16="http://schemas.microsoft.com/office/drawing/2014/main" id="{25FD5A79-3FD0-4A72-B64C-DE970594640E}"/>
+              </a:ext>
+            </a:extLst>
+          </p:cNvPr>
+          <p:cNvPicPr>
+            <a:picLocks xmlns:a="http://schemas.openxmlformats.org/drawingml/2006/main" noChangeAspect="1"/>
+          </p:cNvPicPr>
+          <p:nvPr/>
+        </p:nvPicPr>
+        <p:blipFill>
+          <a:blip xmlns:r="http://schemas.openxmlformats.org/officeDocument/2006/relationships" xmlns:a="http://schemas.openxmlformats.org/drawingml/2006/main" r:embed="R98a98d1d3cd348e6"/>
+          <a:stretch xmlns:a="http://schemas.openxmlformats.org/drawingml/2006/main"/>
+        </p:blipFill>
+        <p:spPr>
+          <a:xfrm xmlns:a="http://schemas.openxmlformats.org/drawingml/2006/main">
+            <a:off x="2683218" y="12954000"/>
+            <a:ext cx="6139764" cy="4286250"/>
+          </a:xfrm>
+          <a:prstGeom xmlns:a="http://schemas.openxmlformats.org/drawingml/2006/main" prst="rect">
+            <a:avLst/>
+          </a:prstGeom>
+        </p:spPr>
+      </p:pic>
+      <p:pic>
+        <p:nvPicPr>
+          <p:cNvPr id="161" name="">
+            <a:extLst xmlns:a="http://schemas.openxmlformats.org/drawingml/2006/main">
+              <a:ext uri="{FF2B5EF4-FFF2-40B4-BE49-F238E27FC236}">
+                <a16:creationId xmlns:a16="http://schemas.microsoft.com/office/drawing/2014/main" id="{90A3F587-403B-44CA-82EF-E3BF412E460A}"/>
+              </a:ext>
+            </a:extLst>
+          </p:cNvPr>
+          <p:cNvPicPr>
+            <a:picLocks xmlns:a="http://schemas.openxmlformats.org/drawingml/2006/main" noChangeAspect="1"/>
+          </p:cNvPicPr>
+          <p:nvPr/>
+        </p:nvPicPr>
+        <p:blipFill>
+          <a:blip xmlns:r="http://schemas.openxmlformats.org/officeDocument/2006/relationships" xmlns:a="http://schemas.openxmlformats.org/drawingml/2006/main" r:embed="Rf37a95beeab345b6"/>
+          <a:stretch xmlns:a="http://schemas.openxmlformats.org/drawingml/2006/main"/>
+        </p:blipFill>
+        <p:spPr>
+          <a:xfrm xmlns:a="http://schemas.openxmlformats.org/drawingml/2006/main">
+            <a:off x="666750" y="17368093"/>
+            <a:ext cx="10172700" cy="268189"/>
+          </a:xfrm>
+          <a:prstGeom xmlns:a="http://schemas.openxmlformats.org/drawingml/2006/main" prst="rect">
+            <a:avLst/>
+          </a:prstGeom>
+        </p:spPr>
+      </p:pic>
+      <p:pic>
+        <p:nvPicPr>
+          <p:cNvPr id="162" name="">
+            <a:extLst xmlns:a="http://schemas.openxmlformats.org/drawingml/2006/main">
+              <a:ext uri="{FF2B5EF4-FFF2-40B4-BE49-F238E27FC236}">
+                <a16:creationId xmlns:a16="http://schemas.microsoft.com/office/drawing/2014/main" id="{E7920504-D29C-42FF-8AE5-3538A66656FF}"/>
+              </a:ext>
+            </a:extLst>
+          </p:cNvPr>
+          <p:cNvPicPr>
+            <a:picLocks xmlns:a="http://schemas.openxmlformats.org/drawingml/2006/main" noChangeAspect="1"/>
+          </p:cNvPicPr>
+          <p:nvPr/>
+        </p:nvPicPr>
+        <p:blipFill>
+          <a:blip xmlns:r="http://schemas.openxmlformats.org/officeDocument/2006/relationships" xmlns:a="http://schemas.openxmlformats.org/drawingml/2006/main" r:embed="Rbe388d153a544bfd"/>
+          <a:stretch xmlns:a="http://schemas.openxmlformats.org/drawingml/2006/main"/>
+        </p:blipFill>
+        <p:spPr>
+          <a:xfrm xmlns:a="http://schemas.openxmlformats.org/drawingml/2006/main">
+            <a:off x="2030584" y="18383250"/>
+            <a:ext cx="7445032" cy="3048000"/>
+          </a:xfrm>
+          <a:prstGeom xmlns:a="http://schemas.openxmlformats.org/drawingml/2006/main" prst="rect">
+            <a:avLst/>
+          </a:prstGeom>
+        </p:spPr>
+      </p:pic>
+      <p:pic>
+        <p:nvPicPr>
+          <p:cNvPr id="163" name="">
+            <a:extLst xmlns:a="http://schemas.openxmlformats.org/drawingml/2006/main">
+              <a:ext uri="{FF2B5EF4-FFF2-40B4-BE49-F238E27FC236}">
+                <a16:creationId xmlns:a16="http://schemas.microsoft.com/office/drawing/2014/main" id="{78BAF997-C506-4B4C-BDD6-307F0169ED29}"/>
+              </a:ext>
+            </a:extLst>
+          </p:cNvPr>
+          <p:cNvPicPr>
+            <a:picLocks xmlns:a="http://schemas.openxmlformats.org/drawingml/2006/main" noChangeAspect="1"/>
+          </p:cNvPicPr>
+          <p:nvPr/>
+        </p:nvPicPr>
+        <p:blipFill>
+          <a:blip xmlns:r="http://schemas.openxmlformats.org/officeDocument/2006/relationships" xmlns:a="http://schemas.openxmlformats.org/drawingml/2006/main" r:embed="R16530a13c4e94fd9"/>
+          <a:stretch xmlns:a="http://schemas.openxmlformats.org/drawingml/2006/main"/>
+        </p:blipFill>
+        <p:spPr>
+          <a:xfrm xmlns:a="http://schemas.openxmlformats.org/drawingml/2006/main">
+            <a:off x="666750" y="21610789"/>
+            <a:ext cx="10172700" cy="212423"/>
+          </a:xfrm>
+          <a:prstGeom xmlns:a="http://schemas.openxmlformats.org/drawingml/2006/main" prst="rect">
+            <a:avLst/>
+          </a:prstGeom>
+        </p:spPr>
+      </p:pic>
+      <p:pic>
+        <p:nvPicPr>
+          <p:cNvPr id="164" name="">
+            <a:extLst xmlns:a="http://schemas.openxmlformats.org/drawingml/2006/main">
+              <a:ext uri="{FF2B5EF4-FFF2-40B4-BE49-F238E27FC236}">
+                <a16:creationId xmlns:a16="http://schemas.microsoft.com/office/drawing/2014/main" id="{6AB30AB8-21FE-486A-9C7F-7B98F0B5C15D}"/>
+              </a:ext>
+            </a:extLst>
+          </p:cNvPr>
+          <p:cNvPicPr>
+            <a:picLocks xmlns:a="http://schemas.openxmlformats.org/drawingml/2006/main" noChangeAspect="1"/>
+          </p:cNvPicPr>
+          <p:nvPr/>
+        </p:nvPicPr>
+        <p:blipFill>
+          <a:blip xmlns:r="http://schemas.openxmlformats.org/officeDocument/2006/relationships" xmlns:a="http://schemas.openxmlformats.org/drawingml/2006/main" r:embed="Rb44ad2998f0c47f6"/>
+          <a:stretch xmlns:a="http://schemas.openxmlformats.org/drawingml/2006/main"/>
+        </p:blipFill>
+        <p:spPr>
+          <a:xfrm xmlns:a="http://schemas.openxmlformats.org/drawingml/2006/main">
+            <a:off x="11372850" y="13781141"/>
+            <a:ext cx="4895850" cy="5203718"/>
+          </a:xfrm>
+          <a:prstGeom xmlns:a="http://schemas.openxmlformats.org/drawingml/2006/main" prst="rect">
+            <a:avLst/>
+          </a:prstGeom>
+        </p:spPr>
+      </p:pic>
+      <p:pic>
+        <p:nvPicPr>
+          <p:cNvPr id="165" name="">
+            <a:extLst xmlns:a="http://schemas.openxmlformats.org/drawingml/2006/main">
+              <a:ext uri="{FF2B5EF4-FFF2-40B4-BE49-F238E27FC236}">
+                <a16:creationId xmlns:a16="http://schemas.microsoft.com/office/drawing/2014/main" id="{743A61CB-E98C-4072-9F81-B55C2FE62109}"/>
+              </a:ext>
+            </a:extLst>
+          </p:cNvPr>
+          <p:cNvPicPr>
+            <a:picLocks xmlns:a="http://schemas.openxmlformats.org/drawingml/2006/main" noChangeAspect="1"/>
+          </p:cNvPicPr>
+          <p:nvPr/>
+        </p:nvPicPr>
+        <p:blipFill>
+          <a:blip xmlns:r="http://schemas.openxmlformats.org/officeDocument/2006/relationships" xmlns:a="http://schemas.openxmlformats.org/drawingml/2006/main" r:embed="Rc156c493d08247f5"/>
+          <a:stretch xmlns:a="http://schemas.openxmlformats.org/drawingml/2006/main"/>
+        </p:blipFill>
+        <p:spPr>
+          <a:xfrm xmlns:a="http://schemas.openxmlformats.org/drawingml/2006/main">
+            <a:off x="16649700" y="13856231"/>
+            <a:ext cx="4895850" cy="5053538"/>
+          </a:xfrm>
+          <a:prstGeom xmlns:a="http://schemas.openxmlformats.org/drawingml/2006/main" prst="rect">
+            <a:avLst/>
+          </a:prstGeom>
+        </p:spPr>
+      </p:pic>
+      <p:pic>
+        <p:nvPicPr>
+          <p:cNvPr id="166" name="">
+            <a:extLst xmlns:a="http://schemas.openxmlformats.org/drawingml/2006/main">
+              <a:ext uri="{FF2B5EF4-FFF2-40B4-BE49-F238E27FC236}">
+                <a16:creationId xmlns:a16="http://schemas.microsoft.com/office/drawing/2014/main" id="{2ABBC8CB-DC85-4C64-9881-979E1135E430}"/>
+              </a:ext>
+            </a:extLst>
+          </p:cNvPr>
+          <p:cNvPicPr>
+            <a:picLocks xmlns:a="http://schemas.openxmlformats.org/drawingml/2006/main" noChangeAspect="1"/>
+          </p:cNvPicPr>
+          <p:nvPr/>
+        </p:nvPicPr>
+        <p:blipFill>
+          <a:blip xmlns:r="http://schemas.openxmlformats.org/officeDocument/2006/relationships" xmlns:a="http://schemas.openxmlformats.org/drawingml/2006/main" r:embed="Rba582007942b4c69"/>
+          <a:stretch xmlns:a="http://schemas.openxmlformats.org/drawingml/2006/main"/>
+        </p:blipFill>
+        <p:spPr>
+          <a:xfrm xmlns:a="http://schemas.openxmlformats.org/drawingml/2006/main">
+            <a:off x="12302665" y="19240500"/>
+            <a:ext cx="8313069" cy="1047750"/>
+          </a:xfrm>
+          <a:prstGeom xmlns:a="http://schemas.openxmlformats.org/drawingml/2006/main" prst="rect">
+            <a:avLst/>
+          </a:prstGeom>
+        </p:spPr>
+      </p:pic>
+      <p:pic>
+        <p:nvPicPr>
+          <p:cNvPr id="167" name="">
+            <a:extLst xmlns:a="http://schemas.openxmlformats.org/drawingml/2006/main">
+              <a:ext uri="{FF2B5EF4-FFF2-40B4-BE49-F238E27FC236}">
+                <a16:creationId xmlns:a16="http://schemas.microsoft.com/office/drawing/2014/main" id="{94B91EE3-6CE0-4C6F-A366-884BCE5029BD}"/>
+              </a:ext>
+            </a:extLst>
+          </p:cNvPr>
+          <p:cNvPicPr>
+            <a:picLocks xmlns:a="http://schemas.openxmlformats.org/drawingml/2006/main" noChangeAspect="1"/>
+          </p:cNvPicPr>
+          <p:nvPr/>
+        </p:nvPicPr>
+        <p:blipFill>
+          <a:blip xmlns:r="http://schemas.openxmlformats.org/officeDocument/2006/relationships" xmlns:a="http://schemas.openxmlformats.org/drawingml/2006/main" r:embed="R499cc5d96da94c7e"/>
+          <a:stretch xmlns:a="http://schemas.openxmlformats.org/drawingml/2006/main"/>
+        </p:blipFill>
+        <p:spPr>
+          <a:xfrm xmlns:a="http://schemas.openxmlformats.org/drawingml/2006/main">
+            <a:off x="22628469" y="13096875"/>
+            <a:ext cx="9073662" cy="4572000"/>
+          </a:xfrm>
+          <a:prstGeom xmlns:a="http://schemas.openxmlformats.org/drawingml/2006/main" prst="rect">
+            <a:avLst/>
+          </a:prstGeom>
+        </p:spPr>
+      </p:pic>
+      <p:pic>
+        <p:nvPicPr>
+          <p:cNvPr id="168" name="">
+            <a:extLst xmlns:a="http://schemas.openxmlformats.org/drawingml/2006/main">
+              <a:ext uri="{FF2B5EF4-FFF2-40B4-BE49-F238E27FC236}">
+                <a16:creationId xmlns:a16="http://schemas.microsoft.com/office/drawing/2014/main" id="{1DB2A0A7-A12E-494D-BADB-EFBDFDD019FC}"/>
+              </a:ext>
+            </a:extLst>
+          </p:cNvPr>
+          <p:cNvPicPr>
+            <a:picLocks xmlns:a="http://schemas.openxmlformats.org/drawingml/2006/main" noChangeAspect="1"/>
+          </p:cNvPicPr>
+          <p:nvPr/>
+        </p:nvPicPr>
+        <p:blipFill>
+          <a:blip xmlns:r="http://schemas.openxmlformats.org/officeDocument/2006/relationships" xmlns:a="http://schemas.openxmlformats.org/drawingml/2006/main" r:embed="Rd07233ad1532423c"/>
           <a:stretch xmlns:a="http://schemas.openxmlformats.org/drawingml/2006/main"/>
         </p:blipFill>
         <p:spPr>

</xml_diff>